<commit_message>
Reduce CLO2 scope to target 80
</commit_message>
<xml_diff>
--- a/presentation/output/CLO2_Secure_Comments.pptx
+++ b/presentation/output/CLO2_Secure_Comments.pptx
@@ -2,19 +2,19 @@
 <file path=ppt/presentation.xml><?xml version="1.0" encoding="utf-8"?>
 <p:presentation xmlns:p="http://schemas.openxmlformats.org/presentationml/2006/main">
   <p:sldMasterIdLst>
-    <p:sldMasterId xmlns:r="http://schemas.openxmlformats.org/officeDocument/2006/relationships" id="2147483648" r:id="Rc56b98f7d17f424e"/>
+    <p:sldMasterId xmlns:r="http://schemas.openxmlformats.org/officeDocument/2006/relationships" id="2147483648" r:id="Rc8ad4114f5074c30"/>
   </p:sldMasterIdLst>
   <p:notesMasterIdLst>
-    <p:notesMasterId xmlns:r="http://schemas.openxmlformats.org/officeDocument/2006/relationships" r:id="Rc7000f8e857d455b"/>
+    <p:notesMasterId xmlns:r="http://schemas.openxmlformats.org/officeDocument/2006/relationships" r:id="R9e7ab8b9b9f04a95"/>
   </p:notesMasterIdLst>
   <p:sldIdLst>
-    <p:sldId xmlns:r="http://schemas.openxmlformats.org/officeDocument/2006/relationships" id="256" r:id="R2fb2f2593d6141df"/>
-    <p:sldId xmlns:r="http://schemas.openxmlformats.org/officeDocument/2006/relationships" id="257" r:id="R117ebd8557284b0c"/>
-    <p:sldId xmlns:r="http://schemas.openxmlformats.org/officeDocument/2006/relationships" id="258" r:id="R49dec3a1c677495d"/>
-    <p:sldId xmlns:r="http://schemas.openxmlformats.org/officeDocument/2006/relationships" id="259" r:id="R641c472206a24302"/>
-    <p:sldId xmlns:r="http://schemas.openxmlformats.org/officeDocument/2006/relationships" id="260" r:id="R545b9994ea7f4f69"/>
-    <p:sldId xmlns:r="http://schemas.openxmlformats.org/officeDocument/2006/relationships" id="261" r:id="Rfee2adadc7e44d9c"/>
-    <p:sldId xmlns:r="http://schemas.openxmlformats.org/officeDocument/2006/relationships" id="262" r:id="Rfb4b56090b0940be"/>
+    <p:sldId xmlns:r="http://schemas.openxmlformats.org/officeDocument/2006/relationships" id="256" r:id="Rcc9a160528884392"/>
+    <p:sldId xmlns:r="http://schemas.openxmlformats.org/officeDocument/2006/relationships" id="257" r:id="R7d8bfcc808df422d"/>
+    <p:sldId xmlns:r="http://schemas.openxmlformats.org/officeDocument/2006/relationships" id="258" r:id="R3a09896cc50c4a1d"/>
+    <p:sldId xmlns:r="http://schemas.openxmlformats.org/officeDocument/2006/relationships" id="259" r:id="R32039f8a391d48ef"/>
+    <p:sldId xmlns:r="http://schemas.openxmlformats.org/officeDocument/2006/relationships" id="260" r:id="Rc2cbb631fca84eb2"/>
+    <p:sldId xmlns:r="http://schemas.openxmlformats.org/officeDocument/2006/relationships" id="261" r:id="R6961d25d21fa4d4c"/>
+    <p:sldId xmlns:r="http://schemas.openxmlformats.org/officeDocument/2006/relationships" id="262" r:id="R805c26a33a494ac6"/>
   </p:sldIdLst>
   <p:sldSz cx="18288000" cy="10287000"/>
   <p:notesSz cx="6858000" cy="9144000"/>
@@ -957,7 +957,7 @@
   </p:cSld>
   <p:clrMap bg1="lt1" tx1="dk1" bg2="lt2" tx2="dk2" accent1="accent1" accent2="accent2" accent3="accent3" accent4="accent4" accent5="accent5" accent6="accent6" hlink="hlink" folHlink="folHlink"/>
   <p:sldLayoutIdLst>
-    <p:sldLayoutId xmlns:r="http://schemas.openxmlformats.org/officeDocument/2006/relationships" id="2147483649" r:id="R96325bcd763d433c"/>
+    <p:sldLayoutId xmlns:r="http://schemas.openxmlformats.org/officeDocument/2006/relationships" id="2147483649" r:id="Rce441f2eedee4b36"/>
   </p:sldLayoutIdLst>
   <p:txStyles>
     <p:titleStyle>
@@ -1256,7 +1256,7 @@
           <p:cNvPr id="1" name="cover-title">
             <a:extLst xmlns:a="http://schemas.openxmlformats.org/drawingml/2006/main">
               <a:ext uri="{FF2B5EF4-FFF2-40B4-BE49-F238E27FC236}">
-                <a16:creationId xmlns:a16="http://schemas.microsoft.com/office/drawing/2014/main" id="{3EEB3EFC-1796-4072-BF06-E0CACF06C903}"/>
+                <a16:creationId xmlns:a16="http://schemas.microsoft.com/office/drawing/2014/main" id="{929E19B3-ACE2-4467-BB18-DA00034DEAF6}"/>
               </a:ext>
             </a:extLst>
           </p:cNvPr>
@@ -1301,7 +1301,7 @@
           <p:cNvPr id="2" name="cover-rule">
             <a:extLst xmlns:a="http://schemas.openxmlformats.org/drawingml/2006/main">
               <a:ext uri="{FF2B5EF4-FFF2-40B4-BE49-F238E27FC236}">
-                <a16:creationId xmlns:a16="http://schemas.microsoft.com/office/drawing/2014/main" id="{7B8D04F4-0904-4558-BBA4-69D4D2C80530}"/>
+                <a16:creationId xmlns:a16="http://schemas.microsoft.com/office/drawing/2014/main" id="{D069ED89-7EB3-4F76-8ECD-897FED236030}"/>
               </a:ext>
             </a:extLst>
           </p:cNvPr>
@@ -1334,7 +1334,7 @@
           <p:cNvPr id="3" name="cover-subtitle">
             <a:extLst xmlns:a="http://schemas.openxmlformats.org/drawingml/2006/main">
               <a:ext uri="{FF2B5EF4-FFF2-40B4-BE49-F238E27FC236}">
-                <a16:creationId xmlns:a16="http://schemas.microsoft.com/office/drawing/2014/main" id="{79038EBC-0149-4686-BF9C-F36EBCB56A14}"/>
+                <a16:creationId xmlns:a16="http://schemas.microsoft.com/office/drawing/2014/main" id="{A4F7FCC8-AD29-4144-BAFF-F35503083F7A}"/>
               </a:ext>
             </a:extLst>
           </p:cNvPr>
@@ -1346,7 +1346,7 @@
         <p:spPr>
           <a:xfrm xmlns:a="http://schemas.openxmlformats.org/drawingml/2006/main">
             <a:off x="1104900" y="2895600"/>
-            <a:ext cx="12192000" cy="781050"/>
+            <a:ext cx="10629900" cy="781050"/>
           </a:xfrm>
           <a:prstGeom xmlns:a="http://schemas.openxmlformats.org/drawingml/2006/main" prst="rect">
             <a:avLst/>
@@ -1369,7 +1369,7 @@
                   <a:srgbClr val="16202A"/>
                 </a:solidFill>
               </a:rPr>
-              <a:t>Pengamanan aplikasi web dengan HTTPS, hash password, prepared statement, validasi input, CSRF, dan mitigasi XSS.</a:t>
+              <a:t>Pengamanan aplikasi web target 80 poin: HTTPS, hash password dengan salt, dan pembatasan input berlebihan.</a:t>
             </a:r>
           </a:p>
         </p:txBody>
@@ -1379,7 +1379,7 @@
           <p:cNvPr id="4" name="cover-context">
             <a:extLst xmlns:a="http://schemas.openxmlformats.org/drawingml/2006/main">
               <a:ext uri="{FF2B5EF4-FFF2-40B4-BE49-F238E27FC236}">
-                <a16:creationId xmlns:a16="http://schemas.microsoft.com/office/drawing/2014/main" id="{5D3FC48B-4DCA-4E94-8515-2A1675EBA5D5}"/>
+                <a16:creationId xmlns:a16="http://schemas.microsoft.com/office/drawing/2014/main" id="{ED879370-D01C-4301-BD7C-141384FCFB3E}"/>
               </a:ext>
             </a:extLst>
           </p:cNvPr>
@@ -1422,7 +1422,7 @@
     </p:spTree>
     <p:extLst>
       <p:ext uri="{BB962C8B-B14F-4D97-AF65-F5344CB8AC3E}">
-        <p14:creationId xmlns:p14="http://schemas.microsoft.com/office/powerpoint/2010/main" val="1015399760"/>
+        <p14:creationId xmlns:p14="http://schemas.microsoft.com/office/powerpoint/2010/main" val="463809684"/>
       </p:ext>
     </p:extLst>
   </p:cSld>
@@ -1446,7 +1446,7 @@
           <p:cNvPr id="1" name="slide-title">
             <a:extLst xmlns:a="http://schemas.openxmlformats.org/drawingml/2006/main">
               <a:ext uri="{FF2B5EF4-FFF2-40B4-BE49-F238E27FC236}">
-                <a16:creationId xmlns:a16="http://schemas.microsoft.com/office/drawing/2014/main" id="{8554708E-1006-43F1-9BF8-53104E2099AB}"/>
+                <a16:creationId xmlns:a16="http://schemas.microsoft.com/office/drawing/2014/main" id="{E4FBD61E-7F12-4A2E-823B-366487DC013C}"/>
               </a:ext>
             </a:extLst>
           </p:cNvPr>
@@ -1491,7 +1491,7 @@
           <p:cNvPr id="2" name="slide-subtitle">
             <a:extLst xmlns:a="http://schemas.openxmlformats.org/drawingml/2006/main">
               <a:ext uri="{FF2B5EF4-FFF2-40B4-BE49-F238E27FC236}">
-                <a16:creationId xmlns:a16="http://schemas.microsoft.com/office/drawing/2014/main" id="{EC39E17C-B0D1-419D-B153-DFF9B5C0CAA7}"/>
+                <a16:creationId xmlns:a16="http://schemas.microsoft.com/office/drawing/2014/main" id="{625D4B27-5368-4606-B956-14A1F540924E}"/>
               </a:ext>
             </a:extLst>
           </p:cNvPr>
@@ -1536,7 +1536,7 @@
           <p:cNvPr id="3" name="bullet-1">
             <a:extLst xmlns:a="http://schemas.openxmlformats.org/drawingml/2006/main">
               <a:ext uri="{FF2B5EF4-FFF2-40B4-BE49-F238E27FC236}">
-                <a16:creationId xmlns:a16="http://schemas.microsoft.com/office/drawing/2014/main" id="{9EA7ABFF-357D-4D88-84CD-5CB9088D6986}"/>
+                <a16:creationId xmlns:a16="http://schemas.microsoft.com/office/drawing/2014/main" id="{188E90B8-D833-4A8B-8837-33378EF66BF4}"/>
               </a:ext>
             </a:extLst>
           </p:cNvPr>
@@ -1581,7 +1581,7 @@
           <p:cNvPr id="4" name="bullet-2">
             <a:extLst xmlns:a="http://schemas.openxmlformats.org/drawingml/2006/main">
               <a:ext uri="{FF2B5EF4-FFF2-40B4-BE49-F238E27FC236}">
-                <a16:creationId xmlns:a16="http://schemas.microsoft.com/office/drawing/2014/main" id="{1BD5D75F-7346-4AD9-B458-9F2A22D5322C}"/>
+                <a16:creationId xmlns:a16="http://schemas.microsoft.com/office/drawing/2014/main" id="{F6135850-08FE-41AA-9E53-9927E4E4E757}"/>
               </a:ext>
             </a:extLst>
           </p:cNvPr>
@@ -1626,7 +1626,7 @@
           <p:cNvPr id="5" name="bullet-3">
             <a:extLst xmlns:a="http://schemas.openxmlformats.org/drawingml/2006/main">
               <a:ext uri="{FF2B5EF4-FFF2-40B4-BE49-F238E27FC236}">
-                <a16:creationId xmlns:a16="http://schemas.microsoft.com/office/drawing/2014/main" id="{DA1AF59B-8367-4CBC-9D4C-B548D9657A56}"/>
+                <a16:creationId xmlns:a16="http://schemas.microsoft.com/office/drawing/2014/main" id="{C401E9AE-9766-4DEF-8D01-2488FBC47933}"/>
               </a:ext>
             </a:extLst>
           </p:cNvPr>
@@ -1671,7 +1671,7 @@
           <p:cNvPr id="6" name="bullet-4">
             <a:extLst xmlns:a="http://schemas.openxmlformats.org/drawingml/2006/main">
               <a:ext uri="{FF2B5EF4-FFF2-40B4-BE49-F238E27FC236}">
-                <a16:creationId xmlns:a16="http://schemas.microsoft.com/office/drawing/2014/main" id="{652FBD70-ABAA-4D85-8F71-58B7530A8041}"/>
+                <a16:creationId xmlns:a16="http://schemas.microsoft.com/office/drawing/2014/main" id="{A291BE1C-EB38-4238-9AC8-AF1F82ED0233}"/>
               </a:ext>
             </a:extLst>
           </p:cNvPr>
@@ -1716,7 +1716,7 @@
           <p:cNvPr id="7" name="footer">
             <a:extLst xmlns:a="http://schemas.openxmlformats.org/drawingml/2006/main">
               <a:ext uri="{FF2B5EF4-FFF2-40B4-BE49-F238E27FC236}">
-                <a16:creationId xmlns:a16="http://schemas.microsoft.com/office/drawing/2014/main" id="{858B846C-356B-41B8-968D-AC309F641840}"/>
+                <a16:creationId xmlns:a16="http://schemas.microsoft.com/office/drawing/2014/main" id="{5D090349-B28A-4726-B864-7002D2B39F6B}"/>
               </a:ext>
             </a:extLst>
           </p:cNvPr>
@@ -1759,7 +1759,7 @@
     </p:spTree>
     <p:extLst>
       <p:ext uri="{BB962C8B-B14F-4D97-AF65-F5344CB8AC3E}">
-        <p14:creationId xmlns:p14="http://schemas.microsoft.com/office/powerpoint/2010/main" val="1529759925"/>
+        <p14:creationId xmlns:p14="http://schemas.microsoft.com/office/powerpoint/2010/main" val="1391107886"/>
       </p:ext>
     </p:extLst>
   </p:cSld>
@@ -1783,7 +1783,7 @@
           <p:cNvPr id="1" name="slide-title">
             <a:extLst xmlns:a="http://schemas.openxmlformats.org/drawingml/2006/main">
               <a:ext uri="{FF2B5EF4-FFF2-40B4-BE49-F238E27FC236}">
-                <a16:creationId xmlns:a16="http://schemas.microsoft.com/office/drawing/2014/main" id="{7FD8DF7B-336B-4788-BB69-6E9053EC19C6}"/>
+                <a16:creationId xmlns:a16="http://schemas.microsoft.com/office/drawing/2014/main" id="{B684E466-0567-40B0-A7BB-0143302B02A5}"/>
               </a:ext>
             </a:extLst>
           </p:cNvPr>
@@ -1828,7 +1828,7 @@
           <p:cNvPr id="2" name="slide-subtitle">
             <a:extLst xmlns:a="http://schemas.openxmlformats.org/drawingml/2006/main">
               <a:ext uri="{FF2B5EF4-FFF2-40B4-BE49-F238E27FC236}">
-                <a16:creationId xmlns:a16="http://schemas.microsoft.com/office/drawing/2014/main" id="{ED580C9E-60EE-424B-940E-422C01BAD14B}"/>
+                <a16:creationId xmlns:a16="http://schemas.microsoft.com/office/drawing/2014/main" id="{F9E193D7-AA70-416F-92D1-A2D6ED4A9498}"/>
               </a:ext>
             </a:extLst>
           </p:cNvPr>
@@ -1873,7 +1873,7 @@
           <p:cNvPr id="3" name="method-HTTPS/TLS">
             <a:extLst xmlns:a="http://schemas.openxmlformats.org/drawingml/2006/main">
               <a:ext uri="{FF2B5EF4-FFF2-40B4-BE49-F238E27FC236}">
-                <a16:creationId xmlns:a16="http://schemas.microsoft.com/office/drawing/2014/main" id="{2247A85A-2B52-4316-BD8B-942B0D973041}"/>
+                <a16:creationId xmlns:a16="http://schemas.microsoft.com/office/drawing/2014/main" id="{B2741C7B-29B2-4746-B9CE-359D40114CB8}"/>
               </a:ext>
             </a:extLst>
           </p:cNvPr>
@@ -1902,7 +1902,7 @@
           <p:cNvPr id="4" name="">
             <a:extLst xmlns:a="http://schemas.openxmlformats.org/drawingml/2006/main">
               <a:ext uri="{FF2B5EF4-FFF2-40B4-BE49-F238E27FC236}">
-                <a16:creationId xmlns:a16="http://schemas.microsoft.com/office/drawing/2014/main" id="{312DBFB1-0221-4AAA-8B9B-D465EDFEC52D}"/>
+                <a16:creationId xmlns:a16="http://schemas.microsoft.com/office/drawing/2014/main" id="{B53C4BF8-F8CB-44B8-B405-0865E56EFE16}"/>
               </a:ext>
             </a:extLst>
           </p:cNvPr>
@@ -1947,7 +1947,7 @@
           <p:cNvPr id="5" name="">
             <a:extLst xmlns:a="http://schemas.openxmlformats.org/drawingml/2006/main">
               <a:ext uri="{FF2B5EF4-FFF2-40B4-BE49-F238E27FC236}">
-                <a16:creationId xmlns:a16="http://schemas.microsoft.com/office/drawing/2014/main" id="{0FEA8E4B-D8FE-49CB-B4D9-FDEF0EF755A1}"/>
+                <a16:creationId xmlns:a16="http://schemas.microsoft.com/office/drawing/2014/main" id="{F7696F86-9B4A-4F99-A389-EA46825EA380}"/>
               </a:ext>
             </a:extLst>
           </p:cNvPr>
@@ -1992,7 +1992,7 @@
           <p:cNvPr id="6" name="method-Hash + salt">
             <a:extLst xmlns:a="http://schemas.openxmlformats.org/drawingml/2006/main">
               <a:ext uri="{FF2B5EF4-FFF2-40B4-BE49-F238E27FC236}">
-                <a16:creationId xmlns:a16="http://schemas.microsoft.com/office/drawing/2014/main" id="{3346C61D-CA9C-425A-BCAA-270357D54619}"/>
+                <a16:creationId xmlns:a16="http://schemas.microsoft.com/office/drawing/2014/main" id="{69ADCED0-A668-4F89-A4AE-AE970D6A2677}"/>
               </a:ext>
             </a:extLst>
           </p:cNvPr>
@@ -2021,7 +2021,7 @@
           <p:cNvPr id="7" name="">
             <a:extLst xmlns:a="http://schemas.openxmlformats.org/drawingml/2006/main">
               <a:ext uri="{FF2B5EF4-FFF2-40B4-BE49-F238E27FC236}">
-                <a16:creationId xmlns:a16="http://schemas.microsoft.com/office/drawing/2014/main" id="{DF6D28FF-C576-48F7-988B-4EE7CDC83929}"/>
+                <a16:creationId xmlns:a16="http://schemas.microsoft.com/office/drawing/2014/main" id="{2503182C-E3FF-4DCF-B492-036EAB565EC3}"/>
               </a:ext>
             </a:extLst>
           </p:cNvPr>
@@ -2066,7 +2066,7 @@
           <p:cNvPr id="8" name="">
             <a:extLst xmlns:a="http://schemas.openxmlformats.org/drawingml/2006/main">
               <a:ext uri="{FF2B5EF4-FFF2-40B4-BE49-F238E27FC236}">
-                <a16:creationId xmlns:a16="http://schemas.microsoft.com/office/drawing/2014/main" id="{6578783D-299D-4BE6-B955-2E0568CF07DB}"/>
+                <a16:creationId xmlns:a16="http://schemas.microsoft.com/office/drawing/2014/main" id="{FE26CCFF-52AD-434F-B31C-81473015C947}"/>
               </a:ext>
             </a:extLst>
           </p:cNvPr>
@@ -2108,10 +2108,10 @@
       </p:sp>
       <p:sp>
         <p:nvSpPr>
-          <p:cNvPr id="9" name="method-SQL injection">
-            <a:extLst xmlns:a="http://schemas.openxmlformats.org/drawingml/2006/main">
-              <a:ext uri="{FF2B5EF4-FFF2-40B4-BE49-F238E27FC236}">
-                <a16:creationId xmlns:a16="http://schemas.microsoft.com/office/drawing/2014/main" id="{89BF21EA-A73C-4505-862F-5E00A0C0D7CB}"/>
+          <p:cNvPr id="9" name="method-HTTPS/TLS">
+            <a:extLst xmlns:a="http://schemas.openxmlformats.org/drawingml/2006/main">
+              <a:ext uri="{FF2B5EF4-FFF2-40B4-BE49-F238E27FC236}">
+                <a16:creationId xmlns:a16="http://schemas.microsoft.com/office/drawing/2014/main" id="{AF8E123D-A8FA-4E77-A877-3E0BBD08A389}"/>
               </a:ext>
             </a:extLst>
           </p:cNvPr>
@@ -2140,7 +2140,7 @@
           <p:cNvPr id="10" name="">
             <a:extLst xmlns:a="http://schemas.openxmlformats.org/drawingml/2006/main">
               <a:ext uri="{FF2B5EF4-FFF2-40B4-BE49-F238E27FC236}">
-                <a16:creationId xmlns:a16="http://schemas.microsoft.com/office/drawing/2014/main" id="{EDEDB2AE-C598-466B-8116-E40B4AB67D93}"/>
+                <a16:creationId xmlns:a16="http://schemas.microsoft.com/office/drawing/2014/main" id="{2B6441F2-68C4-43BD-AD02-EFB82E9BA10D}"/>
               </a:ext>
             </a:extLst>
           </p:cNvPr>
@@ -2175,7 +2175,7 @@
                   <a:srgbClr val="0F766E"/>
                 </a:solidFill>
               </a:rPr>
-              <a:t>SQL injection</a:t>
+              <a:t>HTTPS/TLS</a:t>
             </a:r>
           </a:p>
         </p:txBody>
@@ -2185,7 +2185,7 @@
           <p:cNvPr id="11" name="">
             <a:extLst xmlns:a="http://schemas.openxmlformats.org/drawingml/2006/main">
               <a:ext uri="{FF2B5EF4-FFF2-40B4-BE49-F238E27FC236}">
-                <a16:creationId xmlns:a16="http://schemas.microsoft.com/office/drawing/2014/main" id="{31044952-9C98-4483-8076-08633A55B26E}"/>
+                <a16:creationId xmlns:a16="http://schemas.microsoft.com/office/drawing/2014/main" id="{6C12A0DB-34CD-4556-8433-CD4ACAF36DB3}"/>
               </a:ext>
             </a:extLst>
           </p:cNvPr>
@@ -2220,17 +2220,17 @@
                   <a:srgbClr val="16202A"/>
                 </a:solidFill>
               </a:rPr>
-              <a:t>Query login, signup, komentar, dan admin memakai PDO prepared statement.</a:t>
-            </a:r>
-          </a:p>
-        </p:txBody>
-      </p:sp>
-      <p:sp>
-        <p:nvSpPr>
-          <p:cNvPr id="12" name="method-XSS">
-            <a:extLst xmlns:a="http://schemas.openxmlformats.org/drawingml/2006/main">
-              <a:ext uri="{FF2B5EF4-FFF2-40B4-BE49-F238E27FC236}">
-                <a16:creationId xmlns:a16="http://schemas.microsoft.com/office/drawing/2014/main" id="{D79FB4C7-1FA2-4DD0-A17F-575646817098}"/>
+              <a:t>Apache memakai self-signed certificate RSA 2048-bit untuk demo lokal.</a:t>
+            </a:r>
+          </a:p>
+        </p:txBody>
+      </p:sp>
+      <p:sp>
+        <p:nvSpPr>
+          <p:cNvPr id="12" name="method-Hash + salt">
+            <a:extLst xmlns:a="http://schemas.openxmlformats.org/drawingml/2006/main">
+              <a:ext uri="{FF2B5EF4-FFF2-40B4-BE49-F238E27FC236}">
+                <a16:creationId xmlns:a16="http://schemas.microsoft.com/office/drawing/2014/main" id="{2B8AE0AC-294A-4762-A96D-E73935F1B74C}"/>
               </a:ext>
             </a:extLst>
           </p:cNvPr>
@@ -2259,7 +2259,7 @@
           <p:cNvPr id="13" name="">
             <a:extLst xmlns:a="http://schemas.openxmlformats.org/drawingml/2006/main">
               <a:ext uri="{FF2B5EF4-FFF2-40B4-BE49-F238E27FC236}">
-                <a16:creationId xmlns:a16="http://schemas.microsoft.com/office/drawing/2014/main" id="{0B1DD753-11E8-4A03-9502-01C49D67C723}"/>
+                <a16:creationId xmlns:a16="http://schemas.microsoft.com/office/drawing/2014/main" id="{27BCCC8C-81B9-476B-A38E-04D222EB8BED}"/>
               </a:ext>
             </a:extLst>
           </p:cNvPr>
@@ -2294,7 +2294,7 @@
                   <a:srgbClr val="0F766E"/>
                 </a:solidFill>
               </a:rPr>
-              <a:t>XSS</a:t>
+              <a:t>Hash + salt</a:t>
             </a:r>
           </a:p>
         </p:txBody>
@@ -2304,7 +2304,7 @@
           <p:cNvPr id="14" name="">
             <a:extLst xmlns:a="http://schemas.openxmlformats.org/drawingml/2006/main">
               <a:ext uri="{FF2B5EF4-FFF2-40B4-BE49-F238E27FC236}">
-                <a16:creationId xmlns:a16="http://schemas.microsoft.com/office/drawing/2014/main" id="{3B0BE21D-7D6F-4817-82B3-AA01E69A2DE6}"/>
+                <a16:creationId xmlns:a16="http://schemas.microsoft.com/office/drawing/2014/main" id="{B5FBEEF6-6507-4846-8F8F-1215AD04C2AB}"/>
               </a:ext>
             </a:extLst>
           </p:cNvPr>
@@ -2339,17 +2339,17 @@
                   <a:srgbClr val="16202A"/>
                 </a:solidFill>
               </a:rPr>
-              <a:t>Output database dirender dengan htmlspecialchars() sebelum masuk ke HTML.</a:t>
-            </a:r>
-          </a:p>
-        </p:txBody>
-      </p:sp>
-      <p:sp>
-        <p:nvSpPr>
-          <p:cNvPr id="15" name="method-CSRF">
-            <a:extLst xmlns:a="http://schemas.openxmlformats.org/drawingml/2006/main">
-              <a:ext uri="{FF2B5EF4-FFF2-40B4-BE49-F238E27FC236}">
-                <a16:creationId xmlns:a16="http://schemas.microsoft.com/office/drawing/2014/main" id="{E816F536-0780-42DE-BEDB-498F136FF5AD}"/>
+              <a:t>Password disimpan memakai password_hash() dengan salt otomatis.</a:t>
+            </a:r>
+          </a:p>
+        </p:txBody>
+      </p:sp>
+      <p:sp>
+        <p:nvSpPr>
+          <p:cNvPr id="15" name="method-Input limit">
+            <a:extLst xmlns:a="http://schemas.openxmlformats.org/drawingml/2006/main">
+              <a:ext uri="{FF2B5EF4-FFF2-40B4-BE49-F238E27FC236}">
+                <a16:creationId xmlns:a16="http://schemas.microsoft.com/office/drawing/2014/main" id="{87DC62DD-F4E0-4454-8197-73C09E18CB01}"/>
               </a:ext>
             </a:extLst>
           </p:cNvPr>
@@ -2378,7 +2378,7 @@
           <p:cNvPr id="16" name="">
             <a:extLst xmlns:a="http://schemas.openxmlformats.org/drawingml/2006/main">
               <a:ext uri="{FF2B5EF4-FFF2-40B4-BE49-F238E27FC236}">
-                <a16:creationId xmlns:a16="http://schemas.microsoft.com/office/drawing/2014/main" id="{48A6C577-65BD-4A73-B540-5BA08122AD97}"/>
+                <a16:creationId xmlns:a16="http://schemas.microsoft.com/office/drawing/2014/main" id="{F42BEF1D-8DFD-4078-9061-33AF950C4D39}"/>
               </a:ext>
             </a:extLst>
           </p:cNvPr>
@@ -2413,7 +2413,7 @@
                   <a:srgbClr val="0F766E"/>
                 </a:solidFill>
               </a:rPr>
-              <a:t>CSRF</a:t>
+              <a:t>Input limit</a:t>
             </a:r>
           </a:p>
         </p:txBody>
@@ -2423,7 +2423,7 @@
           <p:cNvPr id="17" name="">
             <a:extLst xmlns:a="http://schemas.openxmlformats.org/drawingml/2006/main">
               <a:ext uri="{FF2B5EF4-FFF2-40B4-BE49-F238E27FC236}">
-                <a16:creationId xmlns:a16="http://schemas.microsoft.com/office/drawing/2014/main" id="{070523A4-CB09-4E43-B66E-65A48CFAF958}"/>
+                <a16:creationId xmlns:a16="http://schemas.microsoft.com/office/drawing/2014/main" id="{4452AFD7-E54C-4DEA-9D48-AD0C39491435}"/>
               </a:ext>
             </a:extLst>
           </p:cNvPr>
@@ -2458,17 +2458,17 @@
                   <a:srgbClr val="16202A"/>
                 </a:solidFill>
               </a:rPr>
-              <a:t>Setiap form POST wajib membawa token acak yang divalidasi server.</a:t>
-            </a:r>
-          </a:p>
-        </p:txBody>
-      </p:sp>
-      <p:sp>
-        <p:nvSpPr>
-          <p:cNvPr id="18" name="method-Brute force">
-            <a:extLst xmlns:a="http://schemas.openxmlformats.org/drawingml/2006/main">
-              <a:ext uri="{FF2B5EF4-FFF2-40B4-BE49-F238E27FC236}">
-                <a16:creationId xmlns:a16="http://schemas.microsoft.com/office/drawing/2014/main" id="{862FF166-960F-41F3-9FB3-38AAE4BE8581}"/>
+              <a:t>Komentar dibatasi maksimal 500 karakter di sisi server.</a:t>
+            </a:r>
+          </a:p>
+        </p:txBody>
+      </p:sp>
+      <p:sp>
+        <p:nvSpPr>
+          <p:cNvPr id="18" name="method-Admin proof">
+            <a:extLst xmlns:a="http://schemas.openxmlformats.org/drawingml/2006/main">
+              <a:ext uri="{FF2B5EF4-FFF2-40B4-BE49-F238E27FC236}">
+                <a16:creationId xmlns:a16="http://schemas.microsoft.com/office/drawing/2014/main" id="{89034156-6421-4C44-8F96-6E8119B23FEC}"/>
               </a:ext>
             </a:extLst>
           </p:cNvPr>
@@ -2497,7 +2497,7 @@
           <p:cNvPr id="19" name="">
             <a:extLst xmlns:a="http://schemas.openxmlformats.org/drawingml/2006/main">
               <a:ext uri="{FF2B5EF4-FFF2-40B4-BE49-F238E27FC236}">
-                <a16:creationId xmlns:a16="http://schemas.microsoft.com/office/drawing/2014/main" id="{C1A6471F-61FF-4CCC-8DF9-C85B788C9CBC}"/>
+                <a16:creationId xmlns:a16="http://schemas.microsoft.com/office/drawing/2014/main" id="{37332735-8D8D-41EB-AF50-80E5836003E9}"/>
               </a:ext>
             </a:extLst>
           </p:cNvPr>
@@ -2532,7 +2532,7 @@
                   <a:srgbClr val="0F766E"/>
                 </a:solidFill>
               </a:rPr>
-              <a:t>Brute force</a:t>
+              <a:t>Admin proof</a:t>
             </a:r>
           </a:p>
         </p:txBody>
@@ -2542,7 +2542,7 @@
           <p:cNvPr id="20" name="">
             <a:extLst xmlns:a="http://schemas.openxmlformats.org/drawingml/2006/main">
               <a:ext uri="{FF2B5EF4-FFF2-40B4-BE49-F238E27FC236}">
-                <a16:creationId xmlns:a16="http://schemas.microsoft.com/office/drawing/2014/main" id="{78C4B50A-B0DF-4DFA-ADCD-A915A3D4E702}"/>
+                <a16:creationId xmlns:a16="http://schemas.microsoft.com/office/drawing/2014/main" id="{476DB9F7-5F92-4EDC-AA1F-1525B2AC2CA3}"/>
               </a:ext>
             </a:extLst>
           </p:cNvPr>
@@ -2577,7 +2577,7 @@
                   <a:srgbClr val="16202A"/>
                 </a:solidFill>
               </a:rPr>
-              <a:t>Login gagal diberi delay sekitar 2 detik sebagai mitigasi dasar.</a:t>
+              <a:t>Panel admin menampilkan hash password, bukan plaintext.</a:t>
             </a:r>
           </a:p>
         </p:txBody>
@@ -2587,7 +2587,7 @@
           <p:cNvPr id="21" name="footer">
             <a:extLst xmlns:a="http://schemas.openxmlformats.org/drawingml/2006/main">
               <a:ext uri="{FF2B5EF4-FFF2-40B4-BE49-F238E27FC236}">
-                <a16:creationId xmlns:a16="http://schemas.microsoft.com/office/drawing/2014/main" id="{18314009-B739-406D-8846-E832AF6EF0FF}"/>
+                <a16:creationId xmlns:a16="http://schemas.microsoft.com/office/drawing/2014/main" id="{261FDF3D-570D-42F9-BD89-00E29BE6D5D7}"/>
               </a:ext>
             </a:extLst>
           </p:cNvPr>
@@ -2630,7 +2630,7 @@
     </p:spTree>
     <p:extLst>
       <p:ext uri="{BB962C8B-B14F-4D97-AF65-F5344CB8AC3E}">
-        <p14:creationId xmlns:p14="http://schemas.microsoft.com/office/powerpoint/2010/main" val="467071224"/>
+        <p14:creationId xmlns:p14="http://schemas.microsoft.com/office/powerpoint/2010/main" val="502690985"/>
       </p:ext>
     </p:extLst>
   </p:cSld>
@@ -2654,7 +2654,7 @@
           <p:cNvPr id="1" name="slide-title">
             <a:extLst xmlns:a="http://schemas.openxmlformats.org/drawingml/2006/main">
               <a:ext uri="{FF2B5EF4-FFF2-40B4-BE49-F238E27FC236}">
-                <a16:creationId xmlns:a16="http://schemas.microsoft.com/office/drawing/2014/main" id="{0409438F-BBDD-4198-A82E-D75E1FF85EA8}"/>
+                <a16:creationId xmlns:a16="http://schemas.microsoft.com/office/drawing/2014/main" id="{9D06C737-51FC-446B-A857-3EE5DBBFF007}"/>
               </a:ext>
             </a:extLst>
           </p:cNvPr>
@@ -2699,7 +2699,7 @@
           <p:cNvPr id="2" name="slide-subtitle">
             <a:extLst xmlns:a="http://schemas.openxmlformats.org/drawingml/2006/main">
               <a:ext uri="{FF2B5EF4-FFF2-40B4-BE49-F238E27FC236}">
-                <a16:creationId xmlns:a16="http://schemas.microsoft.com/office/drawing/2014/main" id="{BCE54C4B-C1A1-46D6-81A2-D2D891933670}"/>
+                <a16:creationId xmlns:a16="http://schemas.microsoft.com/office/drawing/2014/main" id="{5E49AF4B-F1A9-45A3-B0B3-A3E2EA093090}"/>
               </a:ext>
             </a:extLst>
           </p:cNvPr>
@@ -2744,7 +2744,7 @@
           <p:cNvPr id="3" name="method-Browser">
             <a:extLst xmlns:a="http://schemas.openxmlformats.org/drawingml/2006/main">
               <a:ext uri="{FF2B5EF4-FFF2-40B4-BE49-F238E27FC236}">
-                <a16:creationId xmlns:a16="http://schemas.microsoft.com/office/drawing/2014/main" id="{2623860B-42F9-4786-B2EA-C59FBE93D4BB}"/>
+                <a16:creationId xmlns:a16="http://schemas.microsoft.com/office/drawing/2014/main" id="{83F758F1-4787-4C71-8F89-59560BE3318C}"/>
               </a:ext>
             </a:extLst>
           </p:cNvPr>
@@ -2773,7 +2773,7 @@
           <p:cNvPr id="4" name="">
             <a:extLst xmlns:a="http://schemas.openxmlformats.org/drawingml/2006/main">
               <a:ext uri="{FF2B5EF4-FFF2-40B4-BE49-F238E27FC236}">
-                <a16:creationId xmlns:a16="http://schemas.microsoft.com/office/drawing/2014/main" id="{C57C41F5-04F2-4B75-9A02-2A8F5B593D75}"/>
+                <a16:creationId xmlns:a16="http://schemas.microsoft.com/office/drawing/2014/main" id="{A95F0D44-9553-4BED-AA6D-922EE1D6C2BA}"/>
               </a:ext>
             </a:extLst>
           </p:cNvPr>
@@ -2818,7 +2818,7 @@
           <p:cNvPr id="5" name="">
             <a:extLst xmlns:a="http://schemas.openxmlformats.org/drawingml/2006/main">
               <a:ext uri="{FF2B5EF4-FFF2-40B4-BE49-F238E27FC236}">
-                <a16:creationId xmlns:a16="http://schemas.microsoft.com/office/drawing/2014/main" id="{30E12CD4-763A-4A41-87DE-8BF556A14843}"/>
+                <a16:creationId xmlns:a16="http://schemas.microsoft.com/office/drawing/2014/main" id="{93AFCCCC-3ABA-454E-8421-D62C0A873D1E}"/>
               </a:ext>
             </a:extLst>
           </p:cNvPr>
@@ -2863,7 +2863,7 @@
           <p:cNvPr id="6" name="">
             <a:extLst xmlns:a="http://schemas.openxmlformats.org/drawingml/2006/main">
               <a:ext uri="{FF2B5EF4-FFF2-40B4-BE49-F238E27FC236}">
-                <a16:creationId xmlns:a16="http://schemas.microsoft.com/office/drawing/2014/main" id="{F0A2663D-403A-4E44-BF3E-8459533C587D}"/>
+                <a16:creationId xmlns:a16="http://schemas.microsoft.com/office/drawing/2014/main" id="{729C0392-0C39-4A67-9B0A-13AD2CBEFD9B}"/>
               </a:ext>
             </a:extLst>
           </p:cNvPr>
@@ -2908,7 +2908,7 @@
           <p:cNvPr id="7" name="method-Apache + PHP">
             <a:extLst xmlns:a="http://schemas.openxmlformats.org/drawingml/2006/main">
               <a:ext uri="{FF2B5EF4-FFF2-40B4-BE49-F238E27FC236}">
-                <a16:creationId xmlns:a16="http://schemas.microsoft.com/office/drawing/2014/main" id="{F52DD94A-3C00-4A0A-B0DB-FF785AE1776B}"/>
+                <a16:creationId xmlns:a16="http://schemas.microsoft.com/office/drawing/2014/main" id="{E1603C42-2AC0-4D73-BD85-AC188F7FB12D}"/>
               </a:ext>
             </a:extLst>
           </p:cNvPr>
@@ -2937,7 +2937,7 @@
           <p:cNvPr id="8" name="">
             <a:extLst xmlns:a="http://schemas.openxmlformats.org/drawingml/2006/main">
               <a:ext uri="{FF2B5EF4-FFF2-40B4-BE49-F238E27FC236}">
-                <a16:creationId xmlns:a16="http://schemas.microsoft.com/office/drawing/2014/main" id="{6E1A681E-66BF-42C1-8CE7-1BF0BE813F48}"/>
+                <a16:creationId xmlns:a16="http://schemas.microsoft.com/office/drawing/2014/main" id="{36E5CA5C-C3CB-4770-B01E-A50840549DC7}"/>
               </a:ext>
             </a:extLst>
           </p:cNvPr>
@@ -2982,7 +2982,7 @@
           <p:cNvPr id="9" name="">
             <a:extLst xmlns:a="http://schemas.openxmlformats.org/drawingml/2006/main">
               <a:ext uri="{FF2B5EF4-FFF2-40B4-BE49-F238E27FC236}">
-                <a16:creationId xmlns:a16="http://schemas.microsoft.com/office/drawing/2014/main" id="{A5DFF1AB-50A6-42B2-862E-CDA66B8EBC39}"/>
+                <a16:creationId xmlns:a16="http://schemas.microsoft.com/office/drawing/2014/main" id="{B04EDF2C-98FD-45AA-BAAD-363464C7686F}"/>
               </a:ext>
             </a:extLst>
           </p:cNvPr>
@@ -3017,7 +3017,7 @@
                   <a:srgbClr val="16202A"/>
                 </a:solidFill>
               </a:rPr>
-              <a:t>Redirect HTTP ke HTTPS, validasi input, CSRF, dan session hardening.</a:t>
+              <a:t>Redirect HTTP ke HTTPS, autentikasi, dan validasi panjang input.</a:t>
             </a:r>
           </a:p>
         </p:txBody>
@@ -3027,7 +3027,7 @@
           <p:cNvPr id="10" name="">
             <a:extLst xmlns:a="http://schemas.openxmlformats.org/drawingml/2006/main">
               <a:ext uri="{FF2B5EF4-FFF2-40B4-BE49-F238E27FC236}">
-                <a16:creationId xmlns:a16="http://schemas.microsoft.com/office/drawing/2014/main" id="{76E12065-4963-4E94-9442-40A02500337B}"/>
+                <a16:creationId xmlns:a16="http://schemas.microsoft.com/office/drawing/2014/main" id="{7A407B29-B12A-4ADD-B041-6F426A4E7654}"/>
               </a:ext>
             </a:extLst>
           </p:cNvPr>
@@ -3072,7 +3072,7 @@
           <p:cNvPr id="11" name="method-MySQL">
             <a:extLst xmlns:a="http://schemas.openxmlformats.org/drawingml/2006/main">
               <a:ext uri="{FF2B5EF4-FFF2-40B4-BE49-F238E27FC236}">
-                <a16:creationId xmlns:a16="http://schemas.microsoft.com/office/drawing/2014/main" id="{9F440ABF-4158-4626-B213-6E38F5D7E5F8}"/>
+                <a16:creationId xmlns:a16="http://schemas.microsoft.com/office/drawing/2014/main" id="{5DA29511-3FFB-47B8-ACCD-F4C4463F3C59}"/>
               </a:ext>
             </a:extLst>
           </p:cNvPr>
@@ -3101,7 +3101,7 @@
           <p:cNvPr id="12" name="">
             <a:extLst xmlns:a="http://schemas.openxmlformats.org/drawingml/2006/main">
               <a:ext uri="{FF2B5EF4-FFF2-40B4-BE49-F238E27FC236}">
-                <a16:creationId xmlns:a16="http://schemas.microsoft.com/office/drawing/2014/main" id="{D1D7C90D-6FF6-42C4-8491-023468F77C19}"/>
+                <a16:creationId xmlns:a16="http://schemas.microsoft.com/office/drawing/2014/main" id="{2E40ED8C-2B9F-4054-B43C-4DF52C338467}"/>
               </a:ext>
             </a:extLst>
           </p:cNvPr>
@@ -3146,7 +3146,7 @@
           <p:cNvPr id="13" name="">
             <a:extLst xmlns:a="http://schemas.openxmlformats.org/drawingml/2006/main">
               <a:ext uri="{FF2B5EF4-FFF2-40B4-BE49-F238E27FC236}">
-                <a16:creationId xmlns:a16="http://schemas.microsoft.com/office/drawing/2014/main" id="{52EE7AAA-1E8B-42C3-8EB4-DF517046A609}"/>
+                <a16:creationId xmlns:a16="http://schemas.microsoft.com/office/drawing/2014/main" id="{EA1B7A76-2DC4-406B-A111-6FC8C746B6AA}"/>
               </a:ext>
             </a:extLst>
           </p:cNvPr>
@@ -3191,7 +3191,7 @@
           <p:cNvPr id="14" name="network-note">
             <a:extLst xmlns:a="http://schemas.openxmlformats.org/drawingml/2006/main">
               <a:ext uri="{FF2B5EF4-FFF2-40B4-BE49-F238E27FC236}">
-                <a16:creationId xmlns:a16="http://schemas.microsoft.com/office/drawing/2014/main" id="{D888B72D-170B-4420-9523-44453BE856F0}"/>
+                <a16:creationId xmlns:a16="http://schemas.microsoft.com/office/drawing/2014/main" id="{A56FFEC2-21E8-45AC-9C59-65DCADE3A1F8}"/>
               </a:ext>
             </a:extLst>
           </p:cNvPr>
@@ -3236,7 +3236,7 @@
           <p:cNvPr id="15" name="footer">
             <a:extLst xmlns:a="http://schemas.openxmlformats.org/drawingml/2006/main">
               <a:ext uri="{FF2B5EF4-FFF2-40B4-BE49-F238E27FC236}">
-                <a16:creationId xmlns:a16="http://schemas.microsoft.com/office/drawing/2014/main" id="{DDC4A12D-1073-4E4D-8ABD-CE436CCACFC9}"/>
+                <a16:creationId xmlns:a16="http://schemas.microsoft.com/office/drawing/2014/main" id="{8E8CE3C4-3AF0-4599-BB69-D470ADBA74BC}"/>
               </a:ext>
             </a:extLst>
           </p:cNvPr>
@@ -3279,7 +3279,7 @@
     </p:spTree>
     <p:extLst>
       <p:ext uri="{BB962C8B-B14F-4D97-AF65-F5344CB8AC3E}">
-        <p14:creationId xmlns:p14="http://schemas.microsoft.com/office/powerpoint/2010/main" val="1689870407"/>
+        <p14:creationId xmlns:p14="http://schemas.microsoft.com/office/powerpoint/2010/main" val="1892259710"/>
       </p:ext>
     </p:extLst>
   </p:cSld>
@@ -3303,7 +3303,7 @@
           <p:cNvPr id="1" name="slide-title">
             <a:extLst xmlns:a="http://schemas.openxmlformats.org/drawingml/2006/main">
               <a:ext uri="{FF2B5EF4-FFF2-40B4-BE49-F238E27FC236}">
-                <a16:creationId xmlns:a16="http://schemas.microsoft.com/office/drawing/2014/main" id="{4EB667C5-C3D4-450D-AEF0-4F1E1FCA8669}"/>
+                <a16:creationId xmlns:a16="http://schemas.microsoft.com/office/drawing/2014/main" id="{E8D02A8C-514C-4AD1-90D5-DA17587AFDB2}"/>
               </a:ext>
             </a:extLst>
           </p:cNvPr>
@@ -3338,7 +3338,7 @@
                   <a:srgbClr val="16202A"/>
                 </a:solidFill>
               </a:rPr>
-              <a:t>Metode mitigasi kerentanan</a:t>
+              <a:t>Metode mitigasi target 80</a:t>
             </a:r>
           </a:p>
         </p:txBody>
@@ -3348,7 +3348,7 @@
           <p:cNvPr id="2" name="slide-subtitle">
             <a:extLst xmlns:a="http://schemas.openxmlformats.org/drawingml/2006/main">
               <a:ext uri="{FF2B5EF4-FFF2-40B4-BE49-F238E27FC236}">
-                <a16:creationId xmlns:a16="http://schemas.microsoft.com/office/drawing/2014/main" id="{22AB9740-215B-4EAA-889D-F7B9156FBEEE}"/>
+                <a16:creationId xmlns:a16="http://schemas.microsoft.com/office/drawing/2014/main" id="{DF6AE913-35AE-45BD-806B-5B90E9D37F8F}"/>
               </a:ext>
             </a:extLst>
           </p:cNvPr>
@@ -3360,7 +3360,7 @@
         <p:spPr>
           <a:xfrm xmlns:a="http://schemas.openxmlformats.org/drawingml/2006/main">
             <a:off x="914400" y="1485900"/>
-            <a:ext cx="5676900" cy="514350"/>
+            <a:ext cx="6172200" cy="514350"/>
           </a:xfrm>
           <a:prstGeom xmlns:a="http://schemas.openxmlformats.org/drawingml/2006/main" prst="rect">
             <a:avLst/>
@@ -3383,7 +3383,7 @@
                   <a:srgbClr val="5E6B78"/>
                 </a:solidFill>
               </a:rPr>
-              <a:t>Setiap risiko punya kontrol teknis yang bisa ditunjukkan saat demo.</a:t>
+              <a:t>Scope berhenti sampai buffer overflow/input berlebih sesuai target nilai.</a:t>
             </a:r>
           </a:p>
         </p:txBody>
@@ -3393,7 +3393,7 @@
           <p:cNvPr id="3" name="bullet-1">
             <a:extLst xmlns:a="http://schemas.openxmlformats.org/drawingml/2006/main">
               <a:ext uri="{FF2B5EF4-FFF2-40B4-BE49-F238E27FC236}">
-                <a16:creationId xmlns:a16="http://schemas.microsoft.com/office/drawing/2014/main" id="{EAF3F902-378C-4130-8FDD-579F924A1925}"/>
+                <a16:creationId xmlns:a16="http://schemas.microsoft.com/office/drawing/2014/main" id="{74A3CC07-B5F5-4676-B231-8E980CFA4618}"/>
               </a:ext>
             </a:extLst>
           </p:cNvPr>
@@ -3405,7 +3405,7 @@
         <p:spPr>
           <a:xfrm xmlns:a="http://schemas.openxmlformats.org/drawingml/2006/main">
             <a:off x="914400" y="2286000"/>
-            <a:ext cx="7162800" cy="323850"/>
+            <a:ext cx="8020050" cy="647700"/>
           </a:xfrm>
           <a:prstGeom xmlns:a="http://schemas.openxmlformats.org/drawingml/2006/main" prst="rect">
             <a:avLst/>
@@ -3428,7 +3428,7 @@
                   <a:srgbClr val="16202A"/>
                 </a:solidFill>
               </a:rPr>
-              <a:t>1. SQL injection: prepared statement memisahkan query dan data.</a:t>
+              <a:t>1. SSL/TLS: HTTP diarahkan ke HTTPS dan sertifikat memakai RSA 2048-bit.</a:t>
             </a:r>
           </a:p>
         </p:txBody>
@@ -3438,19 +3438,19 @@
           <p:cNvPr id="4" name="bullet-2">
             <a:extLst xmlns:a="http://schemas.openxmlformats.org/drawingml/2006/main">
               <a:ext uri="{FF2B5EF4-FFF2-40B4-BE49-F238E27FC236}">
-                <a16:creationId xmlns:a16="http://schemas.microsoft.com/office/drawing/2014/main" id="{7CB79D0D-247F-4F67-B2A6-8191F9828633}"/>
-              </a:ext>
-            </a:extLst>
-          </p:cNvPr>
-          <p:cNvSpPr>
-            <a:spLocks xmlns:a="http://schemas.openxmlformats.org/drawingml/2006/main" noGrp="1"/>
-          </p:cNvSpPr>
-          <p:nvPr/>
-        </p:nvSpPr>
-        <p:spPr>
-          <a:xfrm xmlns:a="http://schemas.openxmlformats.org/drawingml/2006/main">
-            <a:off x="914400" y="2781300"/>
-            <a:ext cx="6781800" cy="323850"/>
+                <a16:creationId xmlns:a16="http://schemas.microsoft.com/office/drawing/2014/main" id="{CFFF2CD0-751B-4763-B31A-4FB4F860FF23}"/>
+              </a:ext>
+            </a:extLst>
+          </p:cNvPr>
+          <p:cNvSpPr>
+            <a:spLocks xmlns:a="http://schemas.openxmlformats.org/drawingml/2006/main" noGrp="1"/>
+          </p:cNvSpPr>
+          <p:nvPr/>
+        </p:nvSpPr>
+        <p:spPr>
+          <a:xfrm xmlns:a="http://schemas.openxmlformats.org/drawingml/2006/main">
+            <a:off x="914400" y="3105150"/>
+            <a:ext cx="8572500" cy="323850"/>
           </a:xfrm>
           <a:prstGeom xmlns:a="http://schemas.openxmlformats.org/drawingml/2006/main" prst="rect">
             <a:avLst/>
@@ -3473,7 +3473,7 @@
                   <a:srgbClr val="16202A"/>
                 </a:solidFill>
               </a:rPr>
-              <a:t>2. XSS: komentar di-escape sehingga script tampil sebagai teks.</a:t>
+              <a:t>2. Hash + salt: password admin tersimpan sebagai bcrypt hash, bukan plaintext.</a:t>
             </a:r>
           </a:p>
         </p:txBody>
@@ -3483,19 +3483,19 @@
           <p:cNvPr id="5" name="bullet-3">
             <a:extLst xmlns:a="http://schemas.openxmlformats.org/drawingml/2006/main">
               <a:ext uri="{FF2B5EF4-FFF2-40B4-BE49-F238E27FC236}">
-                <a16:creationId xmlns:a16="http://schemas.microsoft.com/office/drawing/2014/main" id="{C5844738-C5D4-4476-ABB6-29EE343E3B29}"/>
-              </a:ext>
-            </a:extLst>
-          </p:cNvPr>
-          <p:cNvSpPr>
-            <a:spLocks xmlns:a="http://schemas.openxmlformats.org/drawingml/2006/main" noGrp="1"/>
-          </p:cNvSpPr>
-          <p:nvPr/>
-        </p:nvSpPr>
-        <p:spPr>
-          <a:xfrm xmlns:a="http://schemas.openxmlformats.org/drawingml/2006/main">
-            <a:off x="914400" y="3276600"/>
-            <a:ext cx="6896100" cy="647700"/>
+                <a16:creationId xmlns:a16="http://schemas.microsoft.com/office/drawing/2014/main" id="{CD45AD73-FB82-4EE4-BC6C-A1FEEDBE9ACC}"/>
+              </a:ext>
+            </a:extLst>
+          </p:cNvPr>
+          <p:cNvSpPr>
+            <a:spLocks xmlns:a="http://schemas.openxmlformats.org/drawingml/2006/main" noGrp="1"/>
+          </p:cNvSpPr>
+          <p:nvPr/>
+        </p:nvSpPr>
+        <p:spPr>
+          <a:xfrm xmlns:a="http://schemas.openxmlformats.org/drawingml/2006/main">
+            <a:off x="914400" y="3600450"/>
+            <a:ext cx="7848600" cy="647700"/>
           </a:xfrm>
           <a:prstGeom xmlns:a="http://schemas.openxmlformats.org/drawingml/2006/main" prst="rect">
             <a:avLst/>
@@ -3518,7 +3518,7 @@
                   <a:srgbClr val="16202A"/>
                 </a:solidFill>
               </a:rPr>
-              <a:t>3. Buffer overflow/input abuse: panjang input dibatasi di server.</a:t>
+              <a:t>3. Buffer overflow/input abuse: komentar lebih dari 500 karakter ditolak.</a:t>
             </a:r>
           </a:p>
         </p:txBody>
@@ -3528,19 +3528,19 @@
           <p:cNvPr id="6" name="bullet-4">
             <a:extLst xmlns:a="http://schemas.openxmlformats.org/drawingml/2006/main">
               <a:ext uri="{FF2B5EF4-FFF2-40B4-BE49-F238E27FC236}">
-                <a16:creationId xmlns:a16="http://schemas.microsoft.com/office/drawing/2014/main" id="{B3C6F452-DFA3-4BF1-80ED-F63C1D8CE21C}"/>
-              </a:ext>
-            </a:extLst>
-          </p:cNvPr>
-          <p:cNvSpPr>
-            <a:spLocks xmlns:a="http://schemas.openxmlformats.org/drawingml/2006/main" noGrp="1"/>
-          </p:cNvSpPr>
-          <p:nvPr/>
-        </p:nvSpPr>
-        <p:spPr>
-          <a:xfrm xmlns:a="http://schemas.openxmlformats.org/drawingml/2006/main">
-            <a:off x="914400" y="4076700"/>
-            <a:ext cx="6800850" cy="323850"/>
+                <a16:creationId xmlns:a16="http://schemas.microsoft.com/office/drawing/2014/main" id="{AC7D88DC-CF3B-4AE3-B006-63D59D518D85}"/>
+              </a:ext>
+            </a:extLst>
+          </p:cNvPr>
+          <p:cNvSpPr>
+            <a:spLocks xmlns:a="http://schemas.openxmlformats.org/drawingml/2006/main" noGrp="1"/>
+          </p:cNvSpPr>
+          <p:nvPr/>
+        </p:nvSpPr>
+        <p:spPr>
+          <a:xfrm xmlns:a="http://schemas.openxmlformats.org/drawingml/2006/main">
+            <a:off x="914400" y="4400550"/>
+            <a:ext cx="8458200" cy="323850"/>
           </a:xfrm>
           <a:prstGeom xmlns:a="http://schemas.openxmlformats.org/drawingml/2006/main" prst="rect">
             <a:avLst/>
@@ -3563,73 +3563,28 @@
                   <a:srgbClr val="16202A"/>
                 </a:solidFill>
               </a:rPr>
-              <a:t>4. Akses admin: role dicek sebelum menampilkan admin panel.</a:t>
-            </a:r>
-          </a:p>
-        </p:txBody>
-      </p:sp>
-      <p:sp>
-        <p:nvSpPr>
-          <p:cNvPr id="7" name="bullet-5">
-            <a:extLst xmlns:a="http://schemas.openxmlformats.org/drawingml/2006/main">
-              <a:ext uri="{FF2B5EF4-FFF2-40B4-BE49-F238E27FC236}">
-                <a16:creationId xmlns:a16="http://schemas.microsoft.com/office/drawing/2014/main" id="{17E8CEFF-FBAF-46D7-BB9A-F74B2D2BB032}"/>
-              </a:ext>
-            </a:extLst>
-          </p:cNvPr>
-          <p:cNvSpPr>
-            <a:spLocks xmlns:a="http://schemas.openxmlformats.org/drawingml/2006/main" noGrp="1"/>
-          </p:cNvSpPr>
-          <p:nvPr/>
-        </p:nvSpPr>
-        <p:spPr>
-          <a:xfrm xmlns:a="http://schemas.openxmlformats.org/drawingml/2006/main">
-            <a:off x="914400" y="4572000"/>
-            <a:ext cx="7658100" cy="647700"/>
-          </a:xfrm>
-          <a:prstGeom xmlns:a="http://schemas.openxmlformats.org/drawingml/2006/main" prst="rect">
-            <a:avLst/>
-          </a:prstGeom>
-        </p:spPr>
-        <p:txBody>
-          <a:bodyPr xmlns:a="http://schemas.openxmlformats.org/drawingml/2006/main" lIns="0" tIns="0" rIns="0" bIns="0"/>
-          <a:lstStyle xmlns:a="http://schemas.openxmlformats.org/drawingml/2006/main"/>
-          <a:p xmlns:a="http://schemas.openxmlformats.org/drawingml/2006/main">
-            <a:pPr>
-              <a:defRPr sz="2100">
-                <a:solidFill>
-                  <a:srgbClr val="16202A"/>
-                </a:solidFill>
-              </a:defRPr>
-            </a:pPr>
-            <a:r>
-              <a:rPr sz="2100">
-                <a:solidFill>
-                  <a:srgbClr val="16202A"/>
-                </a:solidFill>
-              </a:rPr>
-              <a:t>5. Session: cookie HttpOnly, Secure, SameSite Strict, dan regenerate ID.</a:t>
-            </a:r>
-          </a:p>
-        </p:txBody>
-      </p:sp>
-      <p:sp>
-        <p:nvSpPr>
-          <p:cNvPr id="8" name="footer">
-            <a:extLst xmlns:a="http://schemas.openxmlformats.org/drawingml/2006/main">
-              <a:ext uri="{FF2B5EF4-FFF2-40B4-BE49-F238E27FC236}">
-                <a16:creationId xmlns:a16="http://schemas.microsoft.com/office/drawing/2014/main" id="{6509B456-0E6E-4D5E-88CE-B9FBDC3B7B39}"/>
-              </a:ext>
-            </a:extLst>
-          </p:cNvPr>
-          <p:cNvSpPr>
-            <a:spLocks xmlns:a="http://schemas.openxmlformats.org/drawingml/2006/main" noGrp="1"/>
-          </p:cNvSpPr>
-          <p:nvPr/>
-        </p:nvSpPr>
-        <p:spPr>
-          <a:xfrm xmlns:a="http://schemas.openxmlformats.org/drawingml/2006/main">
-            <a:off x="914400" y="5524500"/>
+              <a:t>4. Admin panel: hash password ditampilkan sebagai bukti penyimpanan aman.</a:t>
+            </a:r>
+          </a:p>
+        </p:txBody>
+      </p:sp>
+      <p:sp>
+        <p:nvSpPr>
+          <p:cNvPr id="7" name="footer">
+            <a:extLst xmlns:a="http://schemas.openxmlformats.org/drawingml/2006/main">
+              <a:ext uri="{FF2B5EF4-FFF2-40B4-BE49-F238E27FC236}">
+                <a16:creationId xmlns:a16="http://schemas.microsoft.com/office/drawing/2014/main" id="{0F51693D-0EF4-40D8-AAD8-BC844A564596}"/>
+              </a:ext>
+            </a:extLst>
+          </p:cNvPr>
+          <p:cNvSpPr>
+            <a:spLocks xmlns:a="http://schemas.openxmlformats.org/drawingml/2006/main" noGrp="1"/>
+          </p:cNvSpPr>
+          <p:nvPr/>
+        </p:nvSpPr>
+        <p:spPr>
+          <a:xfrm xmlns:a="http://schemas.openxmlformats.org/drawingml/2006/main">
+            <a:off x="914400" y="5029200"/>
             <a:ext cx="16459200" cy="209550"/>
           </a:xfrm>
           <a:prstGeom xmlns:a="http://schemas.openxmlformats.org/drawingml/2006/main" prst="rect">
@@ -3661,7 +3616,7 @@
     </p:spTree>
     <p:extLst>
       <p:ext uri="{BB962C8B-B14F-4D97-AF65-F5344CB8AC3E}">
-        <p14:creationId xmlns:p14="http://schemas.microsoft.com/office/powerpoint/2010/main" val="1951732245"/>
+        <p14:creationId xmlns:p14="http://schemas.microsoft.com/office/powerpoint/2010/main" val="2026588714"/>
       </p:ext>
     </p:extLst>
   </p:cSld>
@@ -3685,7 +3640,7 @@
           <p:cNvPr id="1" name="slide-title">
             <a:extLst xmlns:a="http://schemas.openxmlformats.org/drawingml/2006/main">
               <a:ext uri="{FF2B5EF4-FFF2-40B4-BE49-F238E27FC236}">
-                <a16:creationId xmlns:a16="http://schemas.microsoft.com/office/drawing/2014/main" id="{CE60FF48-26E7-4FAC-9AF7-975D36F7EC6D}"/>
+                <a16:creationId xmlns:a16="http://schemas.microsoft.com/office/drawing/2014/main" id="{700477CE-EAE7-4F0C-93FD-69C3090B8BE6}"/>
               </a:ext>
             </a:extLst>
           </p:cNvPr>
@@ -3720,7 +3675,7 @@
                   <a:srgbClr val="16202A"/>
                 </a:solidFill>
               </a:rPr>
-              <a:t>Demo uji serangan</a:t>
+              <a:t>Demo uji target</a:t>
             </a:r>
           </a:p>
         </p:txBody>
@@ -3730,7 +3685,7 @@
           <p:cNvPr id="2" name="slide-subtitle">
             <a:extLst xmlns:a="http://schemas.openxmlformats.org/drawingml/2006/main">
               <a:ext uri="{FF2B5EF4-FFF2-40B4-BE49-F238E27FC236}">
-                <a16:creationId xmlns:a16="http://schemas.microsoft.com/office/drawing/2014/main" id="{3ECD14A4-F35D-42C9-97F8-66B4831AFD44}"/>
+                <a16:creationId xmlns:a16="http://schemas.microsoft.com/office/drawing/2014/main" id="{024BFA81-F39D-4724-B244-40F2BC037C5D}"/>
               </a:ext>
             </a:extLst>
           </p:cNvPr>
@@ -3742,7 +3697,7 @@
         <p:spPr>
           <a:xfrm xmlns:a="http://schemas.openxmlformats.org/drawingml/2006/main">
             <a:off x="914400" y="1485900"/>
-            <a:ext cx="4419600" cy="266700"/>
+            <a:ext cx="4743450" cy="514350"/>
           </a:xfrm>
           <a:prstGeom xmlns:a="http://schemas.openxmlformats.org/drawingml/2006/main" prst="rect">
             <a:avLst/>
@@ -3765,7 +3720,7 @@
                   <a:srgbClr val="5E6B78"/>
                 </a:solidFill>
               </a:rPr>
-              <a:t>Urutan demo disiapkan agar sesuai rubrik penilaian.</a:t>
+              <a:t>Urutan demo difokuskan pada tiga kontrol yang diklaim.</a:t>
             </a:r>
           </a:p>
         </p:txBody>
@@ -3775,18 +3730,18 @@
           <p:cNvPr id="3" name="bullet-1">
             <a:extLst xmlns:a="http://schemas.openxmlformats.org/drawingml/2006/main">
               <a:ext uri="{FF2B5EF4-FFF2-40B4-BE49-F238E27FC236}">
-                <a16:creationId xmlns:a16="http://schemas.microsoft.com/office/drawing/2014/main" id="{065A0CCC-BB25-402F-8420-0F16CC5F23E6}"/>
-              </a:ext>
-            </a:extLst>
-          </p:cNvPr>
-          <p:cNvSpPr>
-            <a:spLocks xmlns:a="http://schemas.openxmlformats.org/drawingml/2006/main" noGrp="1"/>
-          </p:cNvSpPr>
-          <p:nvPr/>
-        </p:nvSpPr>
-        <p:spPr>
-          <a:xfrm xmlns:a="http://schemas.openxmlformats.org/drawingml/2006/main">
-            <a:off x="914400" y="2038350"/>
+                <a16:creationId xmlns:a16="http://schemas.microsoft.com/office/drawing/2014/main" id="{11059C8C-2ECC-4C9D-8A68-B696CB54A683}"/>
+              </a:ext>
+            </a:extLst>
+          </p:cNvPr>
+          <p:cNvSpPr>
+            <a:spLocks xmlns:a="http://schemas.openxmlformats.org/drawingml/2006/main" noGrp="1"/>
+          </p:cNvSpPr>
+          <p:nvPr/>
+        </p:nvSpPr>
+        <p:spPr>
+          <a:xfrm xmlns:a="http://schemas.openxmlformats.org/drawingml/2006/main">
+            <a:off x="914400" y="2286000"/>
             <a:ext cx="5238750" cy="647700"/>
           </a:xfrm>
           <a:prstGeom xmlns:a="http://schemas.openxmlformats.org/drawingml/2006/main" prst="rect">
@@ -3820,18 +3775,18 @@
           <p:cNvPr id="4" name="bullet-2">
             <a:extLst xmlns:a="http://schemas.openxmlformats.org/drawingml/2006/main">
               <a:ext uri="{FF2B5EF4-FFF2-40B4-BE49-F238E27FC236}">
-                <a16:creationId xmlns:a16="http://schemas.microsoft.com/office/drawing/2014/main" id="{42E5F656-3D5F-45C4-83DF-7D24F0C50A89}"/>
-              </a:ext>
-            </a:extLst>
-          </p:cNvPr>
-          <p:cNvSpPr>
-            <a:spLocks xmlns:a="http://schemas.openxmlformats.org/drawingml/2006/main" noGrp="1"/>
-          </p:cNvSpPr>
-          <p:nvPr/>
-        </p:nvSpPr>
-        <p:spPr>
-          <a:xfrm xmlns:a="http://schemas.openxmlformats.org/drawingml/2006/main">
-            <a:off x="914400" y="2857500"/>
+                <a16:creationId xmlns:a16="http://schemas.microsoft.com/office/drawing/2014/main" id="{7EE4C92F-112C-4D98-8272-A39B96C42CEE}"/>
+              </a:ext>
+            </a:extLst>
+          </p:cNvPr>
+          <p:cNvSpPr>
+            <a:spLocks xmlns:a="http://schemas.openxmlformats.org/drawingml/2006/main" noGrp="1"/>
+          </p:cNvSpPr>
+          <p:nvPr/>
+        </p:nvSpPr>
+        <p:spPr>
+          <a:xfrm xmlns:a="http://schemas.openxmlformats.org/drawingml/2006/main">
+            <a:off x="914400" y="3105150"/>
             <a:ext cx="6629400" cy="647700"/>
           </a:xfrm>
           <a:prstGeom xmlns:a="http://schemas.openxmlformats.org/drawingml/2006/main" prst="rect">
@@ -3865,19 +3820,19 @@
           <p:cNvPr id="5" name="bullet-3">
             <a:extLst xmlns:a="http://schemas.openxmlformats.org/drawingml/2006/main">
               <a:ext uri="{FF2B5EF4-FFF2-40B4-BE49-F238E27FC236}">
-                <a16:creationId xmlns:a16="http://schemas.microsoft.com/office/drawing/2014/main" id="{C06D56B6-1BDE-44B7-8FAE-6164E4B064B4}"/>
-              </a:ext>
-            </a:extLst>
-          </p:cNvPr>
-          <p:cNvSpPr>
-            <a:spLocks xmlns:a="http://schemas.openxmlformats.org/drawingml/2006/main" noGrp="1"/>
-          </p:cNvSpPr>
-          <p:nvPr/>
-        </p:nvSpPr>
-        <p:spPr>
-          <a:xfrm xmlns:a="http://schemas.openxmlformats.org/drawingml/2006/main">
-            <a:off x="914400" y="3657600"/>
-            <a:ext cx="6534150" cy="647700"/>
+                <a16:creationId xmlns:a16="http://schemas.microsoft.com/office/drawing/2014/main" id="{4108BBD3-2E6A-46ED-AF1C-92AB27F58F50}"/>
+              </a:ext>
+            </a:extLst>
+          </p:cNvPr>
+          <p:cNvSpPr>
+            <a:spLocks xmlns:a="http://schemas.openxmlformats.org/drawingml/2006/main" noGrp="1"/>
+          </p:cNvSpPr>
+          <p:nvPr/>
+        </p:nvSpPr>
+        <p:spPr>
+          <a:xfrm xmlns:a="http://schemas.openxmlformats.org/drawingml/2006/main">
+            <a:off x="914400" y="3905250"/>
+            <a:ext cx="6191250" cy="647700"/>
           </a:xfrm>
           <a:prstGeom xmlns:a="http://schemas.openxmlformats.org/drawingml/2006/main" prst="rect">
             <a:avLst/>
@@ -3900,7 +3855,7 @@
                   <a:srgbClr val="16202A"/>
                 </a:solidFill>
               </a:rPr>
-              <a:t>3. Coba payload SQL injection: ' OR '1'='1 pada mode secure.</a:t>
+              <a:t>3. Buka /admin.php dan tunjukkan kolom password hash.</a:t>
             </a:r>
           </a:p>
         </p:txBody>
@@ -3910,19 +3865,19 @@
           <p:cNvPr id="6" name="bullet-4">
             <a:extLst xmlns:a="http://schemas.openxmlformats.org/drawingml/2006/main">
               <a:ext uri="{FF2B5EF4-FFF2-40B4-BE49-F238E27FC236}">
-                <a16:creationId xmlns:a16="http://schemas.microsoft.com/office/drawing/2014/main" id="{22FFD8F9-E727-4FFF-84CF-0A28947A4428}"/>
-              </a:ext>
-            </a:extLst>
-          </p:cNvPr>
-          <p:cNvSpPr>
-            <a:spLocks xmlns:a="http://schemas.openxmlformats.org/drawingml/2006/main" noGrp="1"/>
-          </p:cNvSpPr>
-          <p:nvPr/>
-        </p:nvSpPr>
-        <p:spPr>
-          <a:xfrm xmlns:a="http://schemas.openxmlformats.org/drawingml/2006/main">
-            <a:off x="914400" y="4476750"/>
-            <a:ext cx="7886700" cy="323850"/>
+                <a16:creationId xmlns:a16="http://schemas.microsoft.com/office/drawing/2014/main" id="{D557BE80-5C83-4139-BD9A-441BE11F890F}"/>
+              </a:ext>
+            </a:extLst>
+          </p:cNvPr>
+          <p:cNvSpPr>
+            <a:spLocks xmlns:a="http://schemas.openxmlformats.org/drawingml/2006/main" noGrp="1"/>
+          </p:cNvSpPr>
+          <p:nvPr/>
+        </p:nvSpPr>
+        <p:spPr>
+          <a:xfrm xmlns:a="http://schemas.openxmlformats.org/drawingml/2006/main">
+            <a:off x="914400" y="4724400"/>
+            <a:ext cx="5467350" cy="647700"/>
           </a:xfrm>
           <a:prstGeom xmlns:a="http://schemas.openxmlformats.org/drawingml/2006/main" prst="rect">
             <a:avLst/>
@@ -3945,7 +3900,7 @@
                   <a:srgbClr val="16202A"/>
                 </a:solidFill>
               </a:rPr>
-              <a:t>4. Kirim komentar &lt;script&gt;alert(1)&lt;/script&gt; dan pastikan tidak dieksekusi.</a:t>
+              <a:t>4. Jelaskan prefix bcrypt $2y$10$ dan segmen salt.</a:t>
             </a:r>
           </a:p>
         </p:txBody>
@@ -3955,19 +3910,19 @@
           <p:cNvPr id="7" name="bullet-5">
             <a:extLst xmlns:a="http://schemas.openxmlformats.org/drawingml/2006/main">
               <a:ext uri="{FF2B5EF4-FFF2-40B4-BE49-F238E27FC236}">
-                <a16:creationId xmlns:a16="http://schemas.microsoft.com/office/drawing/2014/main" id="{81F3FD8D-790B-4651-8523-4BF5DA215AAF}"/>
-              </a:ext>
-            </a:extLst>
-          </p:cNvPr>
-          <p:cNvSpPr>
-            <a:spLocks xmlns:a="http://schemas.openxmlformats.org/drawingml/2006/main" noGrp="1"/>
-          </p:cNvSpPr>
-          <p:nvPr/>
-        </p:nvSpPr>
-        <p:spPr>
-          <a:xfrm xmlns:a="http://schemas.openxmlformats.org/drawingml/2006/main">
-            <a:off x="914400" y="4972050"/>
-            <a:ext cx="7543800" cy="323850"/>
+                <a16:creationId xmlns:a16="http://schemas.microsoft.com/office/drawing/2014/main" id="{7808C57B-590E-4C1C-97E4-B9247F1B247D}"/>
+              </a:ext>
+            </a:extLst>
+          </p:cNvPr>
+          <p:cNvSpPr>
+            <a:spLocks xmlns:a="http://schemas.openxmlformats.org/drawingml/2006/main" noGrp="1"/>
+          </p:cNvSpPr>
+          <p:nvPr/>
+        </p:nvSpPr>
+        <p:spPr>
+          <a:xfrm xmlns:a="http://schemas.openxmlformats.org/drawingml/2006/main">
+            <a:off x="914400" y="5543550"/>
+            <a:ext cx="8001000" cy="323850"/>
           </a:xfrm>
           <a:prstGeom xmlns:a="http://schemas.openxmlformats.org/drawingml/2006/main" prst="rect">
             <a:avLst/>
@@ -3990,7 +3945,7 @@
                   <a:srgbClr val="16202A"/>
                 </a:solidFill>
               </a:rPr>
-              <a:t>5. Kirim komentar lebih dari 500 karakter dan POST tanpa CSRF token.</a:t>
+              <a:t>5. Kirim komentar lebih dari 500 karakter dan tunjukkan penolakan server.</a:t>
             </a:r>
           </a:p>
         </p:txBody>
@@ -4000,18 +3955,18 @@
           <p:cNvPr id="8" name="footer">
             <a:extLst xmlns:a="http://schemas.openxmlformats.org/drawingml/2006/main">
               <a:ext uri="{FF2B5EF4-FFF2-40B4-BE49-F238E27FC236}">
-                <a16:creationId xmlns:a16="http://schemas.microsoft.com/office/drawing/2014/main" id="{3956FDFA-3569-4750-99BA-788F74719DA9}"/>
-              </a:ext>
-            </a:extLst>
-          </p:cNvPr>
-          <p:cNvSpPr>
-            <a:spLocks xmlns:a="http://schemas.openxmlformats.org/drawingml/2006/main" noGrp="1"/>
-          </p:cNvSpPr>
-          <p:nvPr/>
-        </p:nvSpPr>
-        <p:spPr>
-          <a:xfrm xmlns:a="http://schemas.openxmlformats.org/drawingml/2006/main">
-            <a:off x="914400" y="5581650"/>
+                <a16:creationId xmlns:a16="http://schemas.microsoft.com/office/drawing/2014/main" id="{F90006F6-2030-4532-A479-B1C2ADDA2078}"/>
+              </a:ext>
+            </a:extLst>
+          </p:cNvPr>
+          <p:cNvSpPr>
+            <a:spLocks xmlns:a="http://schemas.openxmlformats.org/drawingml/2006/main" noGrp="1"/>
+          </p:cNvSpPr>
+          <p:nvPr/>
+        </p:nvSpPr>
+        <p:spPr>
+          <a:xfrm xmlns:a="http://schemas.openxmlformats.org/drawingml/2006/main">
+            <a:off x="914400" y="6153150"/>
             <a:ext cx="16459200" cy="209550"/>
           </a:xfrm>
           <a:prstGeom xmlns:a="http://schemas.openxmlformats.org/drawingml/2006/main" prst="rect">
@@ -4043,7 +3998,7 @@
     </p:spTree>
     <p:extLst>
       <p:ext uri="{BB962C8B-B14F-4D97-AF65-F5344CB8AC3E}">
-        <p14:creationId xmlns:p14="http://schemas.microsoft.com/office/powerpoint/2010/main" val="720203891"/>
+        <p14:creationId xmlns:p14="http://schemas.microsoft.com/office/powerpoint/2010/main" val="1800308421"/>
       </p:ext>
     </p:extLst>
   </p:cSld>
@@ -4067,7 +4022,7 @@
           <p:cNvPr id="1" name="slide-title">
             <a:extLst xmlns:a="http://schemas.openxmlformats.org/drawingml/2006/main">
               <a:ext uri="{FF2B5EF4-FFF2-40B4-BE49-F238E27FC236}">
-                <a16:creationId xmlns:a16="http://schemas.microsoft.com/office/drawing/2014/main" id="{2441CFCB-422F-4F66-BBE3-8846EF5717E8}"/>
+                <a16:creationId xmlns:a16="http://schemas.microsoft.com/office/drawing/2014/main" id="{3DEDC671-A6C1-4820-AE74-473A121BF61F}"/>
               </a:ext>
             </a:extLst>
           </p:cNvPr>
@@ -4112,7 +4067,7 @@
           <p:cNvPr id="2" name="slide-subtitle">
             <a:extLst xmlns:a="http://schemas.openxmlformats.org/drawingml/2006/main">
               <a:ext uri="{FF2B5EF4-FFF2-40B4-BE49-F238E27FC236}">
-                <a16:creationId xmlns:a16="http://schemas.microsoft.com/office/drawing/2014/main" id="{491DD436-1B13-48AE-A420-361114F55BEC}"/>
+                <a16:creationId xmlns:a16="http://schemas.microsoft.com/office/drawing/2014/main" id="{82FDC04A-5EC0-41B7-9017-3B5F48AC7EFD}"/>
               </a:ext>
             </a:extLst>
           </p:cNvPr>
@@ -4157,7 +4112,7 @@
           <p:cNvPr id="3" name="bullet-1">
             <a:extLst xmlns:a="http://schemas.openxmlformats.org/drawingml/2006/main">
               <a:ext uri="{FF2B5EF4-FFF2-40B4-BE49-F238E27FC236}">
-                <a16:creationId xmlns:a16="http://schemas.microsoft.com/office/drawing/2014/main" id="{3655059E-54BE-49DA-9DA6-2BC24F80C262}"/>
+                <a16:creationId xmlns:a16="http://schemas.microsoft.com/office/drawing/2014/main" id="{749657A5-64D9-405A-A7F9-BE2DA349995A}"/>
               </a:ext>
             </a:extLst>
           </p:cNvPr>
@@ -4169,7 +4124,7 @@
         <p:spPr>
           <a:xfrm xmlns:a="http://schemas.openxmlformats.org/drawingml/2006/main">
             <a:off x="914400" y="2286000"/>
-            <a:ext cx="10039350" cy="647700"/>
+            <a:ext cx="7239000" cy="323850"/>
           </a:xfrm>
           <a:prstGeom xmlns:a="http://schemas.openxmlformats.org/drawingml/2006/main" prst="rect">
             <a:avLst/>
@@ -4192,7 +4147,7 @@
                   <a:srgbClr val="16202A"/>
                 </a:solidFill>
               </a:rPr>
-              <a:t>1. Kontrol utama sudah aktif: HTTPS, hash+salt, SQLi, XSS, CSRF, input limit, brute force delay.</a:t>
+              <a:t>1. Kontrol target 80 aktif: HTTPS, hash+salt, dan pembatasan input.</a:t>
             </a:r>
           </a:p>
         </p:txBody>
@@ -4202,18 +4157,18 @@
           <p:cNvPr id="4" name="bullet-2">
             <a:extLst xmlns:a="http://schemas.openxmlformats.org/drawingml/2006/main">
               <a:ext uri="{FF2B5EF4-FFF2-40B4-BE49-F238E27FC236}">
-                <a16:creationId xmlns:a16="http://schemas.microsoft.com/office/drawing/2014/main" id="{C5D523E6-AC50-4F13-872A-971BF7B3CDED}"/>
-              </a:ext>
-            </a:extLst>
-          </p:cNvPr>
-          <p:cNvSpPr>
-            <a:spLocks xmlns:a="http://schemas.openxmlformats.org/drawingml/2006/main" noGrp="1"/>
-          </p:cNvSpPr>
-          <p:nvPr/>
-        </p:nvSpPr>
-        <p:spPr>
-          <a:xfrm xmlns:a="http://schemas.openxmlformats.org/drawingml/2006/main">
-            <a:off x="914400" y="3105150"/>
+                <a16:creationId xmlns:a16="http://schemas.microsoft.com/office/drawing/2014/main" id="{5E514813-C469-4940-844A-714285BA7C0A}"/>
+              </a:ext>
+            </a:extLst>
+          </p:cNvPr>
+          <p:cNvSpPr>
+            <a:spLocks xmlns:a="http://schemas.openxmlformats.org/drawingml/2006/main" noGrp="1"/>
+          </p:cNvSpPr>
+          <p:nvPr/>
+        </p:nvSpPr>
+        <p:spPr>
+          <a:xfrm xmlns:a="http://schemas.openxmlformats.org/drawingml/2006/main">
+            <a:off x="914400" y="2781300"/>
             <a:ext cx="9944100" cy="647700"/>
           </a:xfrm>
           <a:prstGeom xmlns:a="http://schemas.openxmlformats.org/drawingml/2006/main" prst="rect">
@@ -4247,19 +4202,19 @@
           <p:cNvPr id="5" name="bullet-3">
             <a:extLst xmlns:a="http://schemas.openxmlformats.org/drawingml/2006/main">
               <a:ext uri="{FF2B5EF4-FFF2-40B4-BE49-F238E27FC236}">
-                <a16:creationId xmlns:a16="http://schemas.microsoft.com/office/drawing/2014/main" id="{4A2F39EA-DC81-4A9A-807A-989F4F8B3EDA}"/>
-              </a:ext>
-            </a:extLst>
-          </p:cNvPr>
-          <p:cNvSpPr>
-            <a:spLocks xmlns:a="http://schemas.openxmlformats.org/drawingml/2006/main" noGrp="1"/>
-          </p:cNvSpPr>
-          <p:nvPr/>
-        </p:nvSpPr>
-        <p:spPr>
-          <a:xfrm xmlns:a="http://schemas.openxmlformats.org/drawingml/2006/main">
-            <a:off x="914400" y="3905250"/>
-            <a:ext cx="11811000" cy="323850"/>
+                <a16:creationId xmlns:a16="http://schemas.microsoft.com/office/drawing/2014/main" id="{1E2267E6-3923-4161-9EAF-EEF2B34EAD3B}"/>
+              </a:ext>
+            </a:extLst>
+          </p:cNvPr>
+          <p:cNvSpPr>
+            <a:spLocks xmlns:a="http://schemas.openxmlformats.org/drawingml/2006/main" noGrp="1"/>
+          </p:cNvSpPr>
+          <p:nvPr/>
+        </p:nvSpPr>
+        <p:spPr>
+          <a:xfrm xmlns:a="http://schemas.openxmlformats.org/drawingml/2006/main">
+            <a:off x="914400" y="3600450"/>
+            <a:ext cx="9296400" cy="647700"/>
           </a:xfrm>
           <a:prstGeom xmlns:a="http://schemas.openxmlformats.org/drawingml/2006/main" prst="rect">
             <a:avLst/>
@@ -4282,7 +4237,7 @@
                   <a:srgbClr val="16202A"/>
                 </a:solidFill>
               </a:rPr>
-              <a:t>3. Pengembangan berikutnya: rate limiter berbasis IP, audit log, reset password aman, dan sertifikat CA resmi.</a:t>
+              <a:t>3. Pengembangan berikutnya: audit log, reset password aman, dan sertifikat CA resmi.</a:t>
             </a:r>
           </a:p>
         </p:txBody>
@@ -4292,7 +4247,7 @@
           <p:cNvPr id="6" name="footer">
             <a:extLst xmlns:a="http://schemas.openxmlformats.org/drawingml/2006/main">
               <a:ext uri="{FF2B5EF4-FFF2-40B4-BE49-F238E27FC236}">
-                <a16:creationId xmlns:a16="http://schemas.microsoft.com/office/drawing/2014/main" id="{21791C08-5EB7-4B1A-B546-93826B30EA10}"/>
+                <a16:creationId xmlns:a16="http://schemas.microsoft.com/office/drawing/2014/main" id="{72EEF049-9617-4B7C-9975-AEC798F1DA14}"/>
               </a:ext>
             </a:extLst>
           </p:cNvPr>
@@ -4335,7 +4290,7 @@
     </p:spTree>
     <p:extLst>
       <p:ext uri="{BB962C8B-B14F-4D97-AF65-F5344CB8AC3E}">
-        <p14:creationId xmlns:p14="http://schemas.microsoft.com/office/powerpoint/2010/main" val="2051848520"/>
+        <p14:creationId xmlns:p14="http://schemas.microsoft.com/office/powerpoint/2010/main" val="887994446"/>
       </p:ext>
     </p:extLst>
   </p:cSld>

</xml_diff>

<commit_message>
Sync vulnerable branch target 80 UI
</commit_message>
<xml_diff>
--- a/presentation/output/CLO2_Secure_Comments.pptx
+++ b/presentation/output/CLO2_Secure_Comments.pptx
@@ -2,19 +2,19 @@
 <file path=ppt/presentation.xml><?xml version="1.0" encoding="utf-8"?>
 <p:presentation xmlns:p="http://schemas.openxmlformats.org/presentationml/2006/main">
   <p:sldMasterIdLst>
-    <p:sldMasterId xmlns:r="http://schemas.openxmlformats.org/officeDocument/2006/relationships" id="2147483648" r:id="Rc56b98f7d17f424e"/>
+    <p:sldMasterId xmlns:r="http://schemas.openxmlformats.org/officeDocument/2006/relationships" id="2147483648" r:id="Rc8ad4114f5074c30"/>
   </p:sldMasterIdLst>
   <p:notesMasterIdLst>
-    <p:notesMasterId xmlns:r="http://schemas.openxmlformats.org/officeDocument/2006/relationships" r:id="Rc7000f8e857d455b"/>
+    <p:notesMasterId xmlns:r="http://schemas.openxmlformats.org/officeDocument/2006/relationships" r:id="R9e7ab8b9b9f04a95"/>
   </p:notesMasterIdLst>
   <p:sldIdLst>
-    <p:sldId xmlns:r="http://schemas.openxmlformats.org/officeDocument/2006/relationships" id="256" r:id="R2fb2f2593d6141df"/>
-    <p:sldId xmlns:r="http://schemas.openxmlformats.org/officeDocument/2006/relationships" id="257" r:id="R117ebd8557284b0c"/>
-    <p:sldId xmlns:r="http://schemas.openxmlformats.org/officeDocument/2006/relationships" id="258" r:id="R49dec3a1c677495d"/>
-    <p:sldId xmlns:r="http://schemas.openxmlformats.org/officeDocument/2006/relationships" id="259" r:id="R641c472206a24302"/>
-    <p:sldId xmlns:r="http://schemas.openxmlformats.org/officeDocument/2006/relationships" id="260" r:id="R545b9994ea7f4f69"/>
-    <p:sldId xmlns:r="http://schemas.openxmlformats.org/officeDocument/2006/relationships" id="261" r:id="Rfee2adadc7e44d9c"/>
-    <p:sldId xmlns:r="http://schemas.openxmlformats.org/officeDocument/2006/relationships" id="262" r:id="Rfb4b56090b0940be"/>
+    <p:sldId xmlns:r="http://schemas.openxmlformats.org/officeDocument/2006/relationships" id="256" r:id="Rcc9a160528884392"/>
+    <p:sldId xmlns:r="http://schemas.openxmlformats.org/officeDocument/2006/relationships" id="257" r:id="R7d8bfcc808df422d"/>
+    <p:sldId xmlns:r="http://schemas.openxmlformats.org/officeDocument/2006/relationships" id="258" r:id="R3a09896cc50c4a1d"/>
+    <p:sldId xmlns:r="http://schemas.openxmlformats.org/officeDocument/2006/relationships" id="259" r:id="R32039f8a391d48ef"/>
+    <p:sldId xmlns:r="http://schemas.openxmlformats.org/officeDocument/2006/relationships" id="260" r:id="Rc2cbb631fca84eb2"/>
+    <p:sldId xmlns:r="http://schemas.openxmlformats.org/officeDocument/2006/relationships" id="261" r:id="R6961d25d21fa4d4c"/>
+    <p:sldId xmlns:r="http://schemas.openxmlformats.org/officeDocument/2006/relationships" id="262" r:id="R805c26a33a494ac6"/>
   </p:sldIdLst>
   <p:sldSz cx="18288000" cy="10287000"/>
   <p:notesSz cx="6858000" cy="9144000"/>
@@ -957,7 +957,7 @@
   </p:cSld>
   <p:clrMap bg1="lt1" tx1="dk1" bg2="lt2" tx2="dk2" accent1="accent1" accent2="accent2" accent3="accent3" accent4="accent4" accent5="accent5" accent6="accent6" hlink="hlink" folHlink="folHlink"/>
   <p:sldLayoutIdLst>
-    <p:sldLayoutId xmlns:r="http://schemas.openxmlformats.org/officeDocument/2006/relationships" id="2147483649" r:id="R96325bcd763d433c"/>
+    <p:sldLayoutId xmlns:r="http://schemas.openxmlformats.org/officeDocument/2006/relationships" id="2147483649" r:id="Rce441f2eedee4b36"/>
   </p:sldLayoutIdLst>
   <p:txStyles>
     <p:titleStyle>
@@ -1256,7 +1256,7 @@
           <p:cNvPr id="1" name="cover-title">
             <a:extLst xmlns:a="http://schemas.openxmlformats.org/drawingml/2006/main">
               <a:ext uri="{FF2B5EF4-FFF2-40B4-BE49-F238E27FC236}">
-                <a16:creationId xmlns:a16="http://schemas.microsoft.com/office/drawing/2014/main" id="{3EEB3EFC-1796-4072-BF06-E0CACF06C903}"/>
+                <a16:creationId xmlns:a16="http://schemas.microsoft.com/office/drawing/2014/main" id="{929E19B3-ACE2-4467-BB18-DA00034DEAF6}"/>
               </a:ext>
             </a:extLst>
           </p:cNvPr>
@@ -1301,7 +1301,7 @@
           <p:cNvPr id="2" name="cover-rule">
             <a:extLst xmlns:a="http://schemas.openxmlformats.org/drawingml/2006/main">
               <a:ext uri="{FF2B5EF4-FFF2-40B4-BE49-F238E27FC236}">
-                <a16:creationId xmlns:a16="http://schemas.microsoft.com/office/drawing/2014/main" id="{7B8D04F4-0904-4558-BBA4-69D4D2C80530}"/>
+                <a16:creationId xmlns:a16="http://schemas.microsoft.com/office/drawing/2014/main" id="{D069ED89-7EB3-4F76-8ECD-897FED236030}"/>
               </a:ext>
             </a:extLst>
           </p:cNvPr>
@@ -1334,7 +1334,7 @@
           <p:cNvPr id="3" name="cover-subtitle">
             <a:extLst xmlns:a="http://schemas.openxmlformats.org/drawingml/2006/main">
               <a:ext uri="{FF2B5EF4-FFF2-40B4-BE49-F238E27FC236}">
-                <a16:creationId xmlns:a16="http://schemas.microsoft.com/office/drawing/2014/main" id="{79038EBC-0149-4686-BF9C-F36EBCB56A14}"/>
+                <a16:creationId xmlns:a16="http://schemas.microsoft.com/office/drawing/2014/main" id="{A4F7FCC8-AD29-4144-BAFF-F35503083F7A}"/>
               </a:ext>
             </a:extLst>
           </p:cNvPr>
@@ -1346,7 +1346,7 @@
         <p:spPr>
           <a:xfrm xmlns:a="http://schemas.openxmlformats.org/drawingml/2006/main">
             <a:off x="1104900" y="2895600"/>
-            <a:ext cx="12192000" cy="781050"/>
+            <a:ext cx="10629900" cy="781050"/>
           </a:xfrm>
           <a:prstGeom xmlns:a="http://schemas.openxmlformats.org/drawingml/2006/main" prst="rect">
             <a:avLst/>
@@ -1369,7 +1369,7 @@
                   <a:srgbClr val="16202A"/>
                 </a:solidFill>
               </a:rPr>
-              <a:t>Pengamanan aplikasi web dengan HTTPS, hash password, prepared statement, validasi input, CSRF, dan mitigasi XSS.</a:t>
+              <a:t>Pengamanan aplikasi web target 80 poin: HTTPS, hash password dengan salt, dan pembatasan input berlebihan.</a:t>
             </a:r>
           </a:p>
         </p:txBody>
@@ -1379,7 +1379,7 @@
           <p:cNvPr id="4" name="cover-context">
             <a:extLst xmlns:a="http://schemas.openxmlformats.org/drawingml/2006/main">
               <a:ext uri="{FF2B5EF4-FFF2-40B4-BE49-F238E27FC236}">
-                <a16:creationId xmlns:a16="http://schemas.microsoft.com/office/drawing/2014/main" id="{5D3FC48B-4DCA-4E94-8515-2A1675EBA5D5}"/>
+                <a16:creationId xmlns:a16="http://schemas.microsoft.com/office/drawing/2014/main" id="{ED879370-D01C-4301-BD7C-141384FCFB3E}"/>
               </a:ext>
             </a:extLst>
           </p:cNvPr>
@@ -1422,7 +1422,7 @@
     </p:spTree>
     <p:extLst>
       <p:ext uri="{BB962C8B-B14F-4D97-AF65-F5344CB8AC3E}">
-        <p14:creationId xmlns:p14="http://schemas.microsoft.com/office/powerpoint/2010/main" val="1015399760"/>
+        <p14:creationId xmlns:p14="http://schemas.microsoft.com/office/powerpoint/2010/main" val="463809684"/>
       </p:ext>
     </p:extLst>
   </p:cSld>
@@ -1446,7 +1446,7 @@
           <p:cNvPr id="1" name="slide-title">
             <a:extLst xmlns:a="http://schemas.openxmlformats.org/drawingml/2006/main">
               <a:ext uri="{FF2B5EF4-FFF2-40B4-BE49-F238E27FC236}">
-                <a16:creationId xmlns:a16="http://schemas.microsoft.com/office/drawing/2014/main" id="{8554708E-1006-43F1-9BF8-53104E2099AB}"/>
+                <a16:creationId xmlns:a16="http://schemas.microsoft.com/office/drawing/2014/main" id="{E4FBD61E-7F12-4A2E-823B-366487DC013C}"/>
               </a:ext>
             </a:extLst>
           </p:cNvPr>
@@ -1491,7 +1491,7 @@
           <p:cNvPr id="2" name="slide-subtitle">
             <a:extLst xmlns:a="http://schemas.openxmlformats.org/drawingml/2006/main">
               <a:ext uri="{FF2B5EF4-FFF2-40B4-BE49-F238E27FC236}">
-                <a16:creationId xmlns:a16="http://schemas.microsoft.com/office/drawing/2014/main" id="{EC39E17C-B0D1-419D-B153-DFF9B5C0CAA7}"/>
+                <a16:creationId xmlns:a16="http://schemas.microsoft.com/office/drawing/2014/main" id="{625D4B27-5368-4606-B956-14A1F540924E}"/>
               </a:ext>
             </a:extLst>
           </p:cNvPr>
@@ -1536,7 +1536,7 @@
           <p:cNvPr id="3" name="bullet-1">
             <a:extLst xmlns:a="http://schemas.openxmlformats.org/drawingml/2006/main">
               <a:ext uri="{FF2B5EF4-FFF2-40B4-BE49-F238E27FC236}">
-                <a16:creationId xmlns:a16="http://schemas.microsoft.com/office/drawing/2014/main" id="{9EA7ABFF-357D-4D88-84CD-5CB9088D6986}"/>
+                <a16:creationId xmlns:a16="http://schemas.microsoft.com/office/drawing/2014/main" id="{188E90B8-D833-4A8B-8837-33378EF66BF4}"/>
               </a:ext>
             </a:extLst>
           </p:cNvPr>
@@ -1581,7 +1581,7 @@
           <p:cNvPr id="4" name="bullet-2">
             <a:extLst xmlns:a="http://schemas.openxmlformats.org/drawingml/2006/main">
               <a:ext uri="{FF2B5EF4-FFF2-40B4-BE49-F238E27FC236}">
-                <a16:creationId xmlns:a16="http://schemas.microsoft.com/office/drawing/2014/main" id="{1BD5D75F-7346-4AD9-B458-9F2A22D5322C}"/>
+                <a16:creationId xmlns:a16="http://schemas.microsoft.com/office/drawing/2014/main" id="{F6135850-08FE-41AA-9E53-9927E4E4E757}"/>
               </a:ext>
             </a:extLst>
           </p:cNvPr>
@@ -1626,7 +1626,7 @@
           <p:cNvPr id="5" name="bullet-3">
             <a:extLst xmlns:a="http://schemas.openxmlformats.org/drawingml/2006/main">
               <a:ext uri="{FF2B5EF4-FFF2-40B4-BE49-F238E27FC236}">
-                <a16:creationId xmlns:a16="http://schemas.microsoft.com/office/drawing/2014/main" id="{DA1AF59B-8367-4CBC-9D4C-B548D9657A56}"/>
+                <a16:creationId xmlns:a16="http://schemas.microsoft.com/office/drawing/2014/main" id="{C401E9AE-9766-4DEF-8D01-2488FBC47933}"/>
               </a:ext>
             </a:extLst>
           </p:cNvPr>
@@ -1671,7 +1671,7 @@
           <p:cNvPr id="6" name="bullet-4">
             <a:extLst xmlns:a="http://schemas.openxmlformats.org/drawingml/2006/main">
               <a:ext uri="{FF2B5EF4-FFF2-40B4-BE49-F238E27FC236}">
-                <a16:creationId xmlns:a16="http://schemas.microsoft.com/office/drawing/2014/main" id="{652FBD70-ABAA-4D85-8F71-58B7530A8041}"/>
+                <a16:creationId xmlns:a16="http://schemas.microsoft.com/office/drawing/2014/main" id="{A291BE1C-EB38-4238-9AC8-AF1F82ED0233}"/>
               </a:ext>
             </a:extLst>
           </p:cNvPr>
@@ -1716,7 +1716,7 @@
           <p:cNvPr id="7" name="footer">
             <a:extLst xmlns:a="http://schemas.openxmlformats.org/drawingml/2006/main">
               <a:ext uri="{FF2B5EF4-FFF2-40B4-BE49-F238E27FC236}">
-                <a16:creationId xmlns:a16="http://schemas.microsoft.com/office/drawing/2014/main" id="{858B846C-356B-41B8-968D-AC309F641840}"/>
+                <a16:creationId xmlns:a16="http://schemas.microsoft.com/office/drawing/2014/main" id="{5D090349-B28A-4726-B864-7002D2B39F6B}"/>
               </a:ext>
             </a:extLst>
           </p:cNvPr>
@@ -1759,7 +1759,7 @@
     </p:spTree>
     <p:extLst>
       <p:ext uri="{BB962C8B-B14F-4D97-AF65-F5344CB8AC3E}">
-        <p14:creationId xmlns:p14="http://schemas.microsoft.com/office/powerpoint/2010/main" val="1529759925"/>
+        <p14:creationId xmlns:p14="http://schemas.microsoft.com/office/powerpoint/2010/main" val="1391107886"/>
       </p:ext>
     </p:extLst>
   </p:cSld>
@@ -1783,7 +1783,7 @@
           <p:cNvPr id="1" name="slide-title">
             <a:extLst xmlns:a="http://schemas.openxmlformats.org/drawingml/2006/main">
               <a:ext uri="{FF2B5EF4-FFF2-40B4-BE49-F238E27FC236}">
-                <a16:creationId xmlns:a16="http://schemas.microsoft.com/office/drawing/2014/main" id="{7FD8DF7B-336B-4788-BB69-6E9053EC19C6}"/>
+                <a16:creationId xmlns:a16="http://schemas.microsoft.com/office/drawing/2014/main" id="{B684E466-0567-40B0-A7BB-0143302B02A5}"/>
               </a:ext>
             </a:extLst>
           </p:cNvPr>
@@ -1828,7 +1828,7 @@
           <p:cNvPr id="2" name="slide-subtitle">
             <a:extLst xmlns:a="http://schemas.openxmlformats.org/drawingml/2006/main">
               <a:ext uri="{FF2B5EF4-FFF2-40B4-BE49-F238E27FC236}">
-                <a16:creationId xmlns:a16="http://schemas.microsoft.com/office/drawing/2014/main" id="{ED580C9E-60EE-424B-940E-422C01BAD14B}"/>
+                <a16:creationId xmlns:a16="http://schemas.microsoft.com/office/drawing/2014/main" id="{F9E193D7-AA70-416F-92D1-A2D6ED4A9498}"/>
               </a:ext>
             </a:extLst>
           </p:cNvPr>
@@ -1873,7 +1873,7 @@
           <p:cNvPr id="3" name="method-HTTPS/TLS">
             <a:extLst xmlns:a="http://schemas.openxmlformats.org/drawingml/2006/main">
               <a:ext uri="{FF2B5EF4-FFF2-40B4-BE49-F238E27FC236}">
-                <a16:creationId xmlns:a16="http://schemas.microsoft.com/office/drawing/2014/main" id="{2247A85A-2B52-4316-BD8B-942B0D973041}"/>
+                <a16:creationId xmlns:a16="http://schemas.microsoft.com/office/drawing/2014/main" id="{B2741C7B-29B2-4746-B9CE-359D40114CB8}"/>
               </a:ext>
             </a:extLst>
           </p:cNvPr>
@@ -1902,7 +1902,7 @@
           <p:cNvPr id="4" name="">
             <a:extLst xmlns:a="http://schemas.openxmlformats.org/drawingml/2006/main">
               <a:ext uri="{FF2B5EF4-FFF2-40B4-BE49-F238E27FC236}">
-                <a16:creationId xmlns:a16="http://schemas.microsoft.com/office/drawing/2014/main" id="{312DBFB1-0221-4AAA-8B9B-D465EDFEC52D}"/>
+                <a16:creationId xmlns:a16="http://schemas.microsoft.com/office/drawing/2014/main" id="{B53C4BF8-F8CB-44B8-B405-0865E56EFE16}"/>
               </a:ext>
             </a:extLst>
           </p:cNvPr>
@@ -1947,7 +1947,7 @@
           <p:cNvPr id="5" name="">
             <a:extLst xmlns:a="http://schemas.openxmlformats.org/drawingml/2006/main">
               <a:ext uri="{FF2B5EF4-FFF2-40B4-BE49-F238E27FC236}">
-                <a16:creationId xmlns:a16="http://schemas.microsoft.com/office/drawing/2014/main" id="{0FEA8E4B-D8FE-49CB-B4D9-FDEF0EF755A1}"/>
+                <a16:creationId xmlns:a16="http://schemas.microsoft.com/office/drawing/2014/main" id="{F7696F86-9B4A-4F99-A389-EA46825EA380}"/>
               </a:ext>
             </a:extLst>
           </p:cNvPr>
@@ -1992,7 +1992,7 @@
           <p:cNvPr id="6" name="method-Hash + salt">
             <a:extLst xmlns:a="http://schemas.openxmlformats.org/drawingml/2006/main">
               <a:ext uri="{FF2B5EF4-FFF2-40B4-BE49-F238E27FC236}">
-                <a16:creationId xmlns:a16="http://schemas.microsoft.com/office/drawing/2014/main" id="{3346C61D-CA9C-425A-BCAA-270357D54619}"/>
+                <a16:creationId xmlns:a16="http://schemas.microsoft.com/office/drawing/2014/main" id="{69ADCED0-A668-4F89-A4AE-AE970D6A2677}"/>
               </a:ext>
             </a:extLst>
           </p:cNvPr>
@@ -2021,7 +2021,7 @@
           <p:cNvPr id="7" name="">
             <a:extLst xmlns:a="http://schemas.openxmlformats.org/drawingml/2006/main">
               <a:ext uri="{FF2B5EF4-FFF2-40B4-BE49-F238E27FC236}">
-                <a16:creationId xmlns:a16="http://schemas.microsoft.com/office/drawing/2014/main" id="{DF6D28FF-C576-48F7-988B-4EE7CDC83929}"/>
+                <a16:creationId xmlns:a16="http://schemas.microsoft.com/office/drawing/2014/main" id="{2503182C-E3FF-4DCF-B492-036EAB565EC3}"/>
               </a:ext>
             </a:extLst>
           </p:cNvPr>
@@ -2066,7 +2066,7 @@
           <p:cNvPr id="8" name="">
             <a:extLst xmlns:a="http://schemas.openxmlformats.org/drawingml/2006/main">
               <a:ext uri="{FF2B5EF4-FFF2-40B4-BE49-F238E27FC236}">
-                <a16:creationId xmlns:a16="http://schemas.microsoft.com/office/drawing/2014/main" id="{6578783D-299D-4BE6-B955-2E0568CF07DB}"/>
+                <a16:creationId xmlns:a16="http://schemas.microsoft.com/office/drawing/2014/main" id="{FE26CCFF-52AD-434F-B31C-81473015C947}"/>
               </a:ext>
             </a:extLst>
           </p:cNvPr>
@@ -2108,10 +2108,10 @@
       </p:sp>
       <p:sp>
         <p:nvSpPr>
-          <p:cNvPr id="9" name="method-SQL injection">
-            <a:extLst xmlns:a="http://schemas.openxmlformats.org/drawingml/2006/main">
-              <a:ext uri="{FF2B5EF4-FFF2-40B4-BE49-F238E27FC236}">
-                <a16:creationId xmlns:a16="http://schemas.microsoft.com/office/drawing/2014/main" id="{89BF21EA-A73C-4505-862F-5E00A0C0D7CB}"/>
+          <p:cNvPr id="9" name="method-HTTPS/TLS">
+            <a:extLst xmlns:a="http://schemas.openxmlformats.org/drawingml/2006/main">
+              <a:ext uri="{FF2B5EF4-FFF2-40B4-BE49-F238E27FC236}">
+                <a16:creationId xmlns:a16="http://schemas.microsoft.com/office/drawing/2014/main" id="{AF8E123D-A8FA-4E77-A877-3E0BBD08A389}"/>
               </a:ext>
             </a:extLst>
           </p:cNvPr>
@@ -2140,7 +2140,7 @@
           <p:cNvPr id="10" name="">
             <a:extLst xmlns:a="http://schemas.openxmlformats.org/drawingml/2006/main">
               <a:ext uri="{FF2B5EF4-FFF2-40B4-BE49-F238E27FC236}">
-                <a16:creationId xmlns:a16="http://schemas.microsoft.com/office/drawing/2014/main" id="{EDEDB2AE-C598-466B-8116-E40B4AB67D93}"/>
+                <a16:creationId xmlns:a16="http://schemas.microsoft.com/office/drawing/2014/main" id="{2B6441F2-68C4-43BD-AD02-EFB82E9BA10D}"/>
               </a:ext>
             </a:extLst>
           </p:cNvPr>
@@ -2175,7 +2175,7 @@
                   <a:srgbClr val="0F766E"/>
                 </a:solidFill>
               </a:rPr>
-              <a:t>SQL injection</a:t>
+              <a:t>HTTPS/TLS</a:t>
             </a:r>
           </a:p>
         </p:txBody>
@@ -2185,7 +2185,7 @@
           <p:cNvPr id="11" name="">
             <a:extLst xmlns:a="http://schemas.openxmlformats.org/drawingml/2006/main">
               <a:ext uri="{FF2B5EF4-FFF2-40B4-BE49-F238E27FC236}">
-                <a16:creationId xmlns:a16="http://schemas.microsoft.com/office/drawing/2014/main" id="{31044952-9C98-4483-8076-08633A55B26E}"/>
+                <a16:creationId xmlns:a16="http://schemas.microsoft.com/office/drawing/2014/main" id="{6C12A0DB-34CD-4556-8433-CD4ACAF36DB3}"/>
               </a:ext>
             </a:extLst>
           </p:cNvPr>
@@ -2220,17 +2220,17 @@
                   <a:srgbClr val="16202A"/>
                 </a:solidFill>
               </a:rPr>
-              <a:t>Query login, signup, komentar, dan admin memakai PDO prepared statement.</a:t>
-            </a:r>
-          </a:p>
-        </p:txBody>
-      </p:sp>
-      <p:sp>
-        <p:nvSpPr>
-          <p:cNvPr id="12" name="method-XSS">
-            <a:extLst xmlns:a="http://schemas.openxmlformats.org/drawingml/2006/main">
-              <a:ext uri="{FF2B5EF4-FFF2-40B4-BE49-F238E27FC236}">
-                <a16:creationId xmlns:a16="http://schemas.microsoft.com/office/drawing/2014/main" id="{D79FB4C7-1FA2-4DD0-A17F-575646817098}"/>
+              <a:t>Apache memakai self-signed certificate RSA 2048-bit untuk demo lokal.</a:t>
+            </a:r>
+          </a:p>
+        </p:txBody>
+      </p:sp>
+      <p:sp>
+        <p:nvSpPr>
+          <p:cNvPr id="12" name="method-Hash + salt">
+            <a:extLst xmlns:a="http://schemas.openxmlformats.org/drawingml/2006/main">
+              <a:ext uri="{FF2B5EF4-FFF2-40B4-BE49-F238E27FC236}">
+                <a16:creationId xmlns:a16="http://schemas.microsoft.com/office/drawing/2014/main" id="{2B8AE0AC-294A-4762-A96D-E73935F1B74C}"/>
               </a:ext>
             </a:extLst>
           </p:cNvPr>
@@ -2259,7 +2259,7 @@
           <p:cNvPr id="13" name="">
             <a:extLst xmlns:a="http://schemas.openxmlformats.org/drawingml/2006/main">
               <a:ext uri="{FF2B5EF4-FFF2-40B4-BE49-F238E27FC236}">
-                <a16:creationId xmlns:a16="http://schemas.microsoft.com/office/drawing/2014/main" id="{0B1DD753-11E8-4A03-9502-01C49D67C723}"/>
+                <a16:creationId xmlns:a16="http://schemas.microsoft.com/office/drawing/2014/main" id="{27BCCC8C-81B9-476B-A38E-04D222EB8BED}"/>
               </a:ext>
             </a:extLst>
           </p:cNvPr>
@@ -2294,7 +2294,7 @@
                   <a:srgbClr val="0F766E"/>
                 </a:solidFill>
               </a:rPr>
-              <a:t>XSS</a:t>
+              <a:t>Hash + salt</a:t>
             </a:r>
           </a:p>
         </p:txBody>
@@ -2304,7 +2304,7 @@
           <p:cNvPr id="14" name="">
             <a:extLst xmlns:a="http://schemas.openxmlformats.org/drawingml/2006/main">
               <a:ext uri="{FF2B5EF4-FFF2-40B4-BE49-F238E27FC236}">
-                <a16:creationId xmlns:a16="http://schemas.microsoft.com/office/drawing/2014/main" id="{3B0BE21D-7D6F-4817-82B3-AA01E69A2DE6}"/>
+                <a16:creationId xmlns:a16="http://schemas.microsoft.com/office/drawing/2014/main" id="{B5FBEEF6-6507-4846-8F8F-1215AD04C2AB}"/>
               </a:ext>
             </a:extLst>
           </p:cNvPr>
@@ -2339,17 +2339,17 @@
                   <a:srgbClr val="16202A"/>
                 </a:solidFill>
               </a:rPr>
-              <a:t>Output database dirender dengan htmlspecialchars() sebelum masuk ke HTML.</a:t>
-            </a:r>
-          </a:p>
-        </p:txBody>
-      </p:sp>
-      <p:sp>
-        <p:nvSpPr>
-          <p:cNvPr id="15" name="method-CSRF">
-            <a:extLst xmlns:a="http://schemas.openxmlformats.org/drawingml/2006/main">
-              <a:ext uri="{FF2B5EF4-FFF2-40B4-BE49-F238E27FC236}">
-                <a16:creationId xmlns:a16="http://schemas.microsoft.com/office/drawing/2014/main" id="{E816F536-0780-42DE-BEDB-498F136FF5AD}"/>
+              <a:t>Password disimpan memakai password_hash() dengan salt otomatis.</a:t>
+            </a:r>
+          </a:p>
+        </p:txBody>
+      </p:sp>
+      <p:sp>
+        <p:nvSpPr>
+          <p:cNvPr id="15" name="method-Input limit">
+            <a:extLst xmlns:a="http://schemas.openxmlformats.org/drawingml/2006/main">
+              <a:ext uri="{FF2B5EF4-FFF2-40B4-BE49-F238E27FC236}">
+                <a16:creationId xmlns:a16="http://schemas.microsoft.com/office/drawing/2014/main" id="{87DC62DD-F4E0-4454-8197-73C09E18CB01}"/>
               </a:ext>
             </a:extLst>
           </p:cNvPr>
@@ -2378,7 +2378,7 @@
           <p:cNvPr id="16" name="">
             <a:extLst xmlns:a="http://schemas.openxmlformats.org/drawingml/2006/main">
               <a:ext uri="{FF2B5EF4-FFF2-40B4-BE49-F238E27FC236}">
-                <a16:creationId xmlns:a16="http://schemas.microsoft.com/office/drawing/2014/main" id="{48A6C577-65BD-4A73-B540-5BA08122AD97}"/>
+                <a16:creationId xmlns:a16="http://schemas.microsoft.com/office/drawing/2014/main" id="{F42BEF1D-8DFD-4078-9061-33AF950C4D39}"/>
               </a:ext>
             </a:extLst>
           </p:cNvPr>
@@ -2413,7 +2413,7 @@
                   <a:srgbClr val="0F766E"/>
                 </a:solidFill>
               </a:rPr>
-              <a:t>CSRF</a:t>
+              <a:t>Input limit</a:t>
             </a:r>
           </a:p>
         </p:txBody>
@@ -2423,7 +2423,7 @@
           <p:cNvPr id="17" name="">
             <a:extLst xmlns:a="http://schemas.openxmlformats.org/drawingml/2006/main">
               <a:ext uri="{FF2B5EF4-FFF2-40B4-BE49-F238E27FC236}">
-                <a16:creationId xmlns:a16="http://schemas.microsoft.com/office/drawing/2014/main" id="{070523A4-CB09-4E43-B66E-65A48CFAF958}"/>
+                <a16:creationId xmlns:a16="http://schemas.microsoft.com/office/drawing/2014/main" id="{4452AFD7-E54C-4DEA-9D48-AD0C39491435}"/>
               </a:ext>
             </a:extLst>
           </p:cNvPr>
@@ -2458,17 +2458,17 @@
                   <a:srgbClr val="16202A"/>
                 </a:solidFill>
               </a:rPr>
-              <a:t>Setiap form POST wajib membawa token acak yang divalidasi server.</a:t>
-            </a:r>
-          </a:p>
-        </p:txBody>
-      </p:sp>
-      <p:sp>
-        <p:nvSpPr>
-          <p:cNvPr id="18" name="method-Brute force">
-            <a:extLst xmlns:a="http://schemas.openxmlformats.org/drawingml/2006/main">
-              <a:ext uri="{FF2B5EF4-FFF2-40B4-BE49-F238E27FC236}">
-                <a16:creationId xmlns:a16="http://schemas.microsoft.com/office/drawing/2014/main" id="{862FF166-960F-41F3-9FB3-38AAE4BE8581}"/>
+              <a:t>Komentar dibatasi maksimal 500 karakter di sisi server.</a:t>
+            </a:r>
+          </a:p>
+        </p:txBody>
+      </p:sp>
+      <p:sp>
+        <p:nvSpPr>
+          <p:cNvPr id="18" name="method-Admin proof">
+            <a:extLst xmlns:a="http://schemas.openxmlformats.org/drawingml/2006/main">
+              <a:ext uri="{FF2B5EF4-FFF2-40B4-BE49-F238E27FC236}">
+                <a16:creationId xmlns:a16="http://schemas.microsoft.com/office/drawing/2014/main" id="{89034156-6421-4C44-8F96-6E8119B23FEC}"/>
               </a:ext>
             </a:extLst>
           </p:cNvPr>
@@ -2497,7 +2497,7 @@
           <p:cNvPr id="19" name="">
             <a:extLst xmlns:a="http://schemas.openxmlformats.org/drawingml/2006/main">
               <a:ext uri="{FF2B5EF4-FFF2-40B4-BE49-F238E27FC236}">
-                <a16:creationId xmlns:a16="http://schemas.microsoft.com/office/drawing/2014/main" id="{C1A6471F-61FF-4CCC-8DF9-C85B788C9CBC}"/>
+                <a16:creationId xmlns:a16="http://schemas.microsoft.com/office/drawing/2014/main" id="{37332735-8D8D-41EB-AF50-80E5836003E9}"/>
               </a:ext>
             </a:extLst>
           </p:cNvPr>
@@ -2532,7 +2532,7 @@
                   <a:srgbClr val="0F766E"/>
                 </a:solidFill>
               </a:rPr>
-              <a:t>Brute force</a:t>
+              <a:t>Admin proof</a:t>
             </a:r>
           </a:p>
         </p:txBody>
@@ -2542,7 +2542,7 @@
           <p:cNvPr id="20" name="">
             <a:extLst xmlns:a="http://schemas.openxmlformats.org/drawingml/2006/main">
               <a:ext uri="{FF2B5EF4-FFF2-40B4-BE49-F238E27FC236}">
-                <a16:creationId xmlns:a16="http://schemas.microsoft.com/office/drawing/2014/main" id="{78C4B50A-B0DF-4DFA-ADCD-A915A3D4E702}"/>
+                <a16:creationId xmlns:a16="http://schemas.microsoft.com/office/drawing/2014/main" id="{476DB9F7-5F92-4EDC-AA1F-1525B2AC2CA3}"/>
               </a:ext>
             </a:extLst>
           </p:cNvPr>
@@ -2577,7 +2577,7 @@
                   <a:srgbClr val="16202A"/>
                 </a:solidFill>
               </a:rPr>
-              <a:t>Login gagal diberi delay sekitar 2 detik sebagai mitigasi dasar.</a:t>
+              <a:t>Panel admin menampilkan hash password, bukan plaintext.</a:t>
             </a:r>
           </a:p>
         </p:txBody>
@@ -2587,7 +2587,7 @@
           <p:cNvPr id="21" name="footer">
             <a:extLst xmlns:a="http://schemas.openxmlformats.org/drawingml/2006/main">
               <a:ext uri="{FF2B5EF4-FFF2-40B4-BE49-F238E27FC236}">
-                <a16:creationId xmlns:a16="http://schemas.microsoft.com/office/drawing/2014/main" id="{18314009-B739-406D-8846-E832AF6EF0FF}"/>
+                <a16:creationId xmlns:a16="http://schemas.microsoft.com/office/drawing/2014/main" id="{261FDF3D-570D-42F9-BD89-00E29BE6D5D7}"/>
               </a:ext>
             </a:extLst>
           </p:cNvPr>
@@ -2630,7 +2630,7 @@
     </p:spTree>
     <p:extLst>
       <p:ext uri="{BB962C8B-B14F-4D97-AF65-F5344CB8AC3E}">
-        <p14:creationId xmlns:p14="http://schemas.microsoft.com/office/powerpoint/2010/main" val="467071224"/>
+        <p14:creationId xmlns:p14="http://schemas.microsoft.com/office/powerpoint/2010/main" val="502690985"/>
       </p:ext>
     </p:extLst>
   </p:cSld>
@@ -2654,7 +2654,7 @@
           <p:cNvPr id="1" name="slide-title">
             <a:extLst xmlns:a="http://schemas.openxmlformats.org/drawingml/2006/main">
               <a:ext uri="{FF2B5EF4-FFF2-40B4-BE49-F238E27FC236}">
-                <a16:creationId xmlns:a16="http://schemas.microsoft.com/office/drawing/2014/main" id="{0409438F-BBDD-4198-A82E-D75E1FF85EA8}"/>
+                <a16:creationId xmlns:a16="http://schemas.microsoft.com/office/drawing/2014/main" id="{9D06C737-51FC-446B-A857-3EE5DBBFF007}"/>
               </a:ext>
             </a:extLst>
           </p:cNvPr>
@@ -2699,7 +2699,7 @@
           <p:cNvPr id="2" name="slide-subtitle">
             <a:extLst xmlns:a="http://schemas.openxmlformats.org/drawingml/2006/main">
               <a:ext uri="{FF2B5EF4-FFF2-40B4-BE49-F238E27FC236}">
-                <a16:creationId xmlns:a16="http://schemas.microsoft.com/office/drawing/2014/main" id="{BCE54C4B-C1A1-46D6-81A2-D2D891933670}"/>
+                <a16:creationId xmlns:a16="http://schemas.microsoft.com/office/drawing/2014/main" id="{5E49AF4B-F1A9-45A3-B0B3-A3E2EA093090}"/>
               </a:ext>
             </a:extLst>
           </p:cNvPr>
@@ -2744,7 +2744,7 @@
           <p:cNvPr id="3" name="method-Browser">
             <a:extLst xmlns:a="http://schemas.openxmlformats.org/drawingml/2006/main">
               <a:ext uri="{FF2B5EF4-FFF2-40B4-BE49-F238E27FC236}">
-                <a16:creationId xmlns:a16="http://schemas.microsoft.com/office/drawing/2014/main" id="{2623860B-42F9-4786-B2EA-C59FBE93D4BB}"/>
+                <a16:creationId xmlns:a16="http://schemas.microsoft.com/office/drawing/2014/main" id="{83F758F1-4787-4C71-8F89-59560BE3318C}"/>
               </a:ext>
             </a:extLst>
           </p:cNvPr>
@@ -2773,7 +2773,7 @@
           <p:cNvPr id="4" name="">
             <a:extLst xmlns:a="http://schemas.openxmlformats.org/drawingml/2006/main">
               <a:ext uri="{FF2B5EF4-FFF2-40B4-BE49-F238E27FC236}">
-                <a16:creationId xmlns:a16="http://schemas.microsoft.com/office/drawing/2014/main" id="{C57C41F5-04F2-4B75-9A02-2A8F5B593D75}"/>
+                <a16:creationId xmlns:a16="http://schemas.microsoft.com/office/drawing/2014/main" id="{A95F0D44-9553-4BED-AA6D-922EE1D6C2BA}"/>
               </a:ext>
             </a:extLst>
           </p:cNvPr>
@@ -2818,7 +2818,7 @@
           <p:cNvPr id="5" name="">
             <a:extLst xmlns:a="http://schemas.openxmlformats.org/drawingml/2006/main">
               <a:ext uri="{FF2B5EF4-FFF2-40B4-BE49-F238E27FC236}">
-                <a16:creationId xmlns:a16="http://schemas.microsoft.com/office/drawing/2014/main" id="{30E12CD4-763A-4A41-87DE-8BF556A14843}"/>
+                <a16:creationId xmlns:a16="http://schemas.microsoft.com/office/drawing/2014/main" id="{93AFCCCC-3ABA-454E-8421-D62C0A873D1E}"/>
               </a:ext>
             </a:extLst>
           </p:cNvPr>
@@ -2863,7 +2863,7 @@
           <p:cNvPr id="6" name="">
             <a:extLst xmlns:a="http://schemas.openxmlformats.org/drawingml/2006/main">
               <a:ext uri="{FF2B5EF4-FFF2-40B4-BE49-F238E27FC236}">
-                <a16:creationId xmlns:a16="http://schemas.microsoft.com/office/drawing/2014/main" id="{F0A2663D-403A-4E44-BF3E-8459533C587D}"/>
+                <a16:creationId xmlns:a16="http://schemas.microsoft.com/office/drawing/2014/main" id="{729C0392-0C39-4A67-9B0A-13AD2CBEFD9B}"/>
               </a:ext>
             </a:extLst>
           </p:cNvPr>
@@ -2908,7 +2908,7 @@
           <p:cNvPr id="7" name="method-Apache + PHP">
             <a:extLst xmlns:a="http://schemas.openxmlformats.org/drawingml/2006/main">
               <a:ext uri="{FF2B5EF4-FFF2-40B4-BE49-F238E27FC236}">
-                <a16:creationId xmlns:a16="http://schemas.microsoft.com/office/drawing/2014/main" id="{F52DD94A-3C00-4A0A-B0DB-FF785AE1776B}"/>
+                <a16:creationId xmlns:a16="http://schemas.microsoft.com/office/drawing/2014/main" id="{E1603C42-2AC0-4D73-BD85-AC188F7FB12D}"/>
               </a:ext>
             </a:extLst>
           </p:cNvPr>
@@ -2937,7 +2937,7 @@
           <p:cNvPr id="8" name="">
             <a:extLst xmlns:a="http://schemas.openxmlformats.org/drawingml/2006/main">
               <a:ext uri="{FF2B5EF4-FFF2-40B4-BE49-F238E27FC236}">
-                <a16:creationId xmlns:a16="http://schemas.microsoft.com/office/drawing/2014/main" id="{6E1A681E-66BF-42C1-8CE7-1BF0BE813F48}"/>
+                <a16:creationId xmlns:a16="http://schemas.microsoft.com/office/drawing/2014/main" id="{36E5CA5C-C3CB-4770-B01E-A50840549DC7}"/>
               </a:ext>
             </a:extLst>
           </p:cNvPr>
@@ -2982,7 +2982,7 @@
           <p:cNvPr id="9" name="">
             <a:extLst xmlns:a="http://schemas.openxmlformats.org/drawingml/2006/main">
               <a:ext uri="{FF2B5EF4-FFF2-40B4-BE49-F238E27FC236}">
-                <a16:creationId xmlns:a16="http://schemas.microsoft.com/office/drawing/2014/main" id="{A5DFF1AB-50A6-42B2-862E-CDA66B8EBC39}"/>
+                <a16:creationId xmlns:a16="http://schemas.microsoft.com/office/drawing/2014/main" id="{B04EDF2C-98FD-45AA-BAAD-363464C7686F}"/>
               </a:ext>
             </a:extLst>
           </p:cNvPr>
@@ -3017,7 +3017,7 @@
                   <a:srgbClr val="16202A"/>
                 </a:solidFill>
               </a:rPr>
-              <a:t>Redirect HTTP ke HTTPS, validasi input, CSRF, dan session hardening.</a:t>
+              <a:t>Redirect HTTP ke HTTPS, autentikasi, dan validasi panjang input.</a:t>
             </a:r>
           </a:p>
         </p:txBody>
@@ -3027,7 +3027,7 @@
           <p:cNvPr id="10" name="">
             <a:extLst xmlns:a="http://schemas.openxmlformats.org/drawingml/2006/main">
               <a:ext uri="{FF2B5EF4-FFF2-40B4-BE49-F238E27FC236}">
-                <a16:creationId xmlns:a16="http://schemas.microsoft.com/office/drawing/2014/main" id="{76E12065-4963-4E94-9442-40A02500337B}"/>
+                <a16:creationId xmlns:a16="http://schemas.microsoft.com/office/drawing/2014/main" id="{7A407B29-B12A-4ADD-B041-6F426A4E7654}"/>
               </a:ext>
             </a:extLst>
           </p:cNvPr>
@@ -3072,7 +3072,7 @@
           <p:cNvPr id="11" name="method-MySQL">
             <a:extLst xmlns:a="http://schemas.openxmlformats.org/drawingml/2006/main">
               <a:ext uri="{FF2B5EF4-FFF2-40B4-BE49-F238E27FC236}">
-                <a16:creationId xmlns:a16="http://schemas.microsoft.com/office/drawing/2014/main" id="{9F440ABF-4158-4626-B213-6E38F5D7E5F8}"/>
+                <a16:creationId xmlns:a16="http://schemas.microsoft.com/office/drawing/2014/main" id="{5DA29511-3FFB-47B8-ACCD-F4C4463F3C59}"/>
               </a:ext>
             </a:extLst>
           </p:cNvPr>
@@ -3101,7 +3101,7 @@
           <p:cNvPr id="12" name="">
             <a:extLst xmlns:a="http://schemas.openxmlformats.org/drawingml/2006/main">
               <a:ext uri="{FF2B5EF4-FFF2-40B4-BE49-F238E27FC236}">
-                <a16:creationId xmlns:a16="http://schemas.microsoft.com/office/drawing/2014/main" id="{D1D7C90D-6FF6-42C4-8491-023468F77C19}"/>
+                <a16:creationId xmlns:a16="http://schemas.microsoft.com/office/drawing/2014/main" id="{2E40ED8C-2B9F-4054-B43C-4DF52C338467}"/>
               </a:ext>
             </a:extLst>
           </p:cNvPr>
@@ -3146,7 +3146,7 @@
           <p:cNvPr id="13" name="">
             <a:extLst xmlns:a="http://schemas.openxmlformats.org/drawingml/2006/main">
               <a:ext uri="{FF2B5EF4-FFF2-40B4-BE49-F238E27FC236}">
-                <a16:creationId xmlns:a16="http://schemas.microsoft.com/office/drawing/2014/main" id="{52EE7AAA-1E8B-42C3-8EB4-DF517046A609}"/>
+                <a16:creationId xmlns:a16="http://schemas.microsoft.com/office/drawing/2014/main" id="{EA1B7A76-2DC4-406B-A111-6FC8C746B6AA}"/>
               </a:ext>
             </a:extLst>
           </p:cNvPr>
@@ -3191,7 +3191,7 @@
           <p:cNvPr id="14" name="network-note">
             <a:extLst xmlns:a="http://schemas.openxmlformats.org/drawingml/2006/main">
               <a:ext uri="{FF2B5EF4-FFF2-40B4-BE49-F238E27FC236}">
-                <a16:creationId xmlns:a16="http://schemas.microsoft.com/office/drawing/2014/main" id="{D888B72D-170B-4420-9523-44453BE856F0}"/>
+                <a16:creationId xmlns:a16="http://schemas.microsoft.com/office/drawing/2014/main" id="{A56FFEC2-21E8-45AC-9C59-65DCADE3A1F8}"/>
               </a:ext>
             </a:extLst>
           </p:cNvPr>
@@ -3236,7 +3236,7 @@
           <p:cNvPr id="15" name="footer">
             <a:extLst xmlns:a="http://schemas.openxmlformats.org/drawingml/2006/main">
               <a:ext uri="{FF2B5EF4-FFF2-40B4-BE49-F238E27FC236}">
-                <a16:creationId xmlns:a16="http://schemas.microsoft.com/office/drawing/2014/main" id="{DDC4A12D-1073-4E4D-8ABD-CE436CCACFC9}"/>
+                <a16:creationId xmlns:a16="http://schemas.microsoft.com/office/drawing/2014/main" id="{8E8CE3C4-3AF0-4599-BB69-D470ADBA74BC}"/>
               </a:ext>
             </a:extLst>
           </p:cNvPr>
@@ -3279,7 +3279,7 @@
     </p:spTree>
     <p:extLst>
       <p:ext uri="{BB962C8B-B14F-4D97-AF65-F5344CB8AC3E}">
-        <p14:creationId xmlns:p14="http://schemas.microsoft.com/office/powerpoint/2010/main" val="1689870407"/>
+        <p14:creationId xmlns:p14="http://schemas.microsoft.com/office/powerpoint/2010/main" val="1892259710"/>
       </p:ext>
     </p:extLst>
   </p:cSld>
@@ -3303,7 +3303,7 @@
           <p:cNvPr id="1" name="slide-title">
             <a:extLst xmlns:a="http://schemas.openxmlformats.org/drawingml/2006/main">
               <a:ext uri="{FF2B5EF4-FFF2-40B4-BE49-F238E27FC236}">
-                <a16:creationId xmlns:a16="http://schemas.microsoft.com/office/drawing/2014/main" id="{4EB667C5-C3D4-450D-AEF0-4F1E1FCA8669}"/>
+                <a16:creationId xmlns:a16="http://schemas.microsoft.com/office/drawing/2014/main" id="{E8D02A8C-514C-4AD1-90D5-DA17587AFDB2}"/>
               </a:ext>
             </a:extLst>
           </p:cNvPr>
@@ -3338,7 +3338,7 @@
                   <a:srgbClr val="16202A"/>
                 </a:solidFill>
               </a:rPr>
-              <a:t>Metode mitigasi kerentanan</a:t>
+              <a:t>Metode mitigasi target 80</a:t>
             </a:r>
           </a:p>
         </p:txBody>
@@ -3348,7 +3348,7 @@
           <p:cNvPr id="2" name="slide-subtitle">
             <a:extLst xmlns:a="http://schemas.openxmlformats.org/drawingml/2006/main">
               <a:ext uri="{FF2B5EF4-FFF2-40B4-BE49-F238E27FC236}">
-                <a16:creationId xmlns:a16="http://schemas.microsoft.com/office/drawing/2014/main" id="{22AB9740-215B-4EAA-889D-F7B9156FBEEE}"/>
+                <a16:creationId xmlns:a16="http://schemas.microsoft.com/office/drawing/2014/main" id="{DF6AE913-35AE-45BD-806B-5B90E9D37F8F}"/>
               </a:ext>
             </a:extLst>
           </p:cNvPr>
@@ -3360,7 +3360,7 @@
         <p:spPr>
           <a:xfrm xmlns:a="http://schemas.openxmlformats.org/drawingml/2006/main">
             <a:off x="914400" y="1485900"/>
-            <a:ext cx="5676900" cy="514350"/>
+            <a:ext cx="6172200" cy="514350"/>
           </a:xfrm>
           <a:prstGeom xmlns:a="http://schemas.openxmlformats.org/drawingml/2006/main" prst="rect">
             <a:avLst/>
@@ -3383,7 +3383,7 @@
                   <a:srgbClr val="5E6B78"/>
                 </a:solidFill>
               </a:rPr>
-              <a:t>Setiap risiko punya kontrol teknis yang bisa ditunjukkan saat demo.</a:t>
+              <a:t>Scope berhenti sampai buffer overflow/input berlebih sesuai target nilai.</a:t>
             </a:r>
           </a:p>
         </p:txBody>
@@ -3393,7 +3393,7 @@
           <p:cNvPr id="3" name="bullet-1">
             <a:extLst xmlns:a="http://schemas.openxmlformats.org/drawingml/2006/main">
               <a:ext uri="{FF2B5EF4-FFF2-40B4-BE49-F238E27FC236}">
-                <a16:creationId xmlns:a16="http://schemas.microsoft.com/office/drawing/2014/main" id="{EAF3F902-378C-4130-8FDD-579F924A1925}"/>
+                <a16:creationId xmlns:a16="http://schemas.microsoft.com/office/drawing/2014/main" id="{74A3CC07-B5F5-4676-B231-8E980CFA4618}"/>
               </a:ext>
             </a:extLst>
           </p:cNvPr>
@@ -3405,7 +3405,7 @@
         <p:spPr>
           <a:xfrm xmlns:a="http://schemas.openxmlformats.org/drawingml/2006/main">
             <a:off x="914400" y="2286000"/>
-            <a:ext cx="7162800" cy="323850"/>
+            <a:ext cx="8020050" cy="647700"/>
           </a:xfrm>
           <a:prstGeom xmlns:a="http://schemas.openxmlformats.org/drawingml/2006/main" prst="rect">
             <a:avLst/>
@@ -3428,7 +3428,7 @@
                   <a:srgbClr val="16202A"/>
                 </a:solidFill>
               </a:rPr>
-              <a:t>1. SQL injection: prepared statement memisahkan query dan data.</a:t>
+              <a:t>1. SSL/TLS: HTTP diarahkan ke HTTPS dan sertifikat memakai RSA 2048-bit.</a:t>
             </a:r>
           </a:p>
         </p:txBody>
@@ -3438,19 +3438,19 @@
           <p:cNvPr id="4" name="bullet-2">
             <a:extLst xmlns:a="http://schemas.openxmlformats.org/drawingml/2006/main">
               <a:ext uri="{FF2B5EF4-FFF2-40B4-BE49-F238E27FC236}">
-                <a16:creationId xmlns:a16="http://schemas.microsoft.com/office/drawing/2014/main" id="{7CB79D0D-247F-4F67-B2A6-8191F9828633}"/>
-              </a:ext>
-            </a:extLst>
-          </p:cNvPr>
-          <p:cNvSpPr>
-            <a:spLocks xmlns:a="http://schemas.openxmlformats.org/drawingml/2006/main" noGrp="1"/>
-          </p:cNvSpPr>
-          <p:nvPr/>
-        </p:nvSpPr>
-        <p:spPr>
-          <a:xfrm xmlns:a="http://schemas.openxmlformats.org/drawingml/2006/main">
-            <a:off x="914400" y="2781300"/>
-            <a:ext cx="6781800" cy="323850"/>
+                <a16:creationId xmlns:a16="http://schemas.microsoft.com/office/drawing/2014/main" id="{CFFF2CD0-751B-4763-B31A-4FB4F860FF23}"/>
+              </a:ext>
+            </a:extLst>
+          </p:cNvPr>
+          <p:cNvSpPr>
+            <a:spLocks xmlns:a="http://schemas.openxmlformats.org/drawingml/2006/main" noGrp="1"/>
+          </p:cNvSpPr>
+          <p:nvPr/>
+        </p:nvSpPr>
+        <p:spPr>
+          <a:xfrm xmlns:a="http://schemas.openxmlformats.org/drawingml/2006/main">
+            <a:off x="914400" y="3105150"/>
+            <a:ext cx="8572500" cy="323850"/>
           </a:xfrm>
           <a:prstGeom xmlns:a="http://schemas.openxmlformats.org/drawingml/2006/main" prst="rect">
             <a:avLst/>
@@ -3473,7 +3473,7 @@
                   <a:srgbClr val="16202A"/>
                 </a:solidFill>
               </a:rPr>
-              <a:t>2. XSS: komentar di-escape sehingga script tampil sebagai teks.</a:t>
+              <a:t>2. Hash + salt: password admin tersimpan sebagai bcrypt hash, bukan plaintext.</a:t>
             </a:r>
           </a:p>
         </p:txBody>
@@ -3483,19 +3483,19 @@
           <p:cNvPr id="5" name="bullet-3">
             <a:extLst xmlns:a="http://schemas.openxmlformats.org/drawingml/2006/main">
               <a:ext uri="{FF2B5EF4-FFF2-40B4-BE49-F238E27FC236}">
-                <a16:creationId xmlns:a16="http://schemas.microsoft.com/office/drawing/2014/main" id="{C5844738-C5D4-4476-ABB6-29EE343E3B29}"/>
-              </a:ext>
-            </a:extLst>
-          </p:cNvPr>
-          <p:cNvSpPr>
-            <a:spLocks xmlns:a="http://schemas.openxmlformats.org/drawingml/2006/main" noGrp="1"/>
-          </p:cNvSpPr>
-          <p:nvPr/>
-        </p:nvSpPr>
-        <p:spPr>
-          <a:xfrm xmlns:a="http://schemas.openxmlformats.org/drawingml/2006/main">
-            <a:off x="914400" y="3276600"/>
-            <a:ext cx="6896100" cy="647700"/>
+                <a16:creationId xmlns:a16="http://schemas.microsoft.com/office/drawing/2014/main" id="{CD45AD73-FB82-4EE4-BC6C-A1FEEDBE9ACC}"/>
+              </a:ext>
+            </a:extLst>
+          </p:cNvPr>
+          <p:cNvSpPr>
+            <a:spLocks xmlns:a="http://schemas.openxmlformats.org/drawingml/2006/main" noGrp="1"/>
+          </p:cNvSpPr>
+          <p:nvPr/>
+        </p:nvSpPr>
+        <p:spPr>
+          <a:xfrm xmlns:a="http://schemas.openxmlformats.org/drawingml/2006/main">
+            <a:off x="914400" y="3600450"/>
+            <a:ext cx="7848600" cy="647700"/>
           </a:xfrm>
           <a:prstGeom xmlns:a="http://schemas.openxmlformats.org/drawingml/2006/main" prst="rect">
             <a:avLst/>
@@ -3518,7 +3518,7 @@
                   <a:srgbClr val="16202A"/>
                 </a:solidFill>
               </a:rPr>
-              <a:t>3. Buffer overflow/input abuse: panjang input dibatasi di server.</a:t>
+              <a:t>3. Buffer overflow/input abuse: komentar lebih dari 500 karakter ditolak.</a:t>
             </a:r>
           </a:p>
         </p:txBody>
@@ -3528,19 +3528,19 @@
           <p:cNvPr id="6" name="bullet-4">
             <a:extLst xmlns:a="http://schemas.openxmlformats.org/drawingml/2006/main">
               <a:ext uri="{FF2B5EF4-FFF2-40B4-BE49-F238E27FC236}">
-                <a16:creationId xmlns:a16="http://schemas.microsoft.com/office/drawing/2014/main" id="{B3C6F452-DFA3-4BF1-80ED-F63C1D8CE21C}"/>
-              </a:ext>
-            </a:extLst>
-          </p:cNvPr>
-          <p:cNvSpPr>
-            <a:spLocks xmlns:a="http://schemas.openxmlformats.org/drawingml/2006/main" noGrp="1"/>
-          </p:cNvSpPr>
-          <p:nvPr/>
-        </p:nvSpPr>
-        <p:spPr>
-          <a:xfrm xmlns:a="http://schemas.openxmlformats.org/drawingml/2006/main">
-            <a:off x="914400" y="4076700"/>
-            <a:ext cx="6800850" cy="323850"/>
+                <a16:creationId xmlns:a16="http://schemas.microsoft.com/office/drawing/2014/main" id="{AC7D88DC-CF3B-4AE3-B006-63D59D518D85}"/>
+              </a:ext>
+            </a:extLst>
+          </p:cNvPr>
+          <p:cNvSpPr>
+            <a:spLocks xmlns:a="http://schemas.openxmlformats.org/drawingml/2006/main" noGrp="1"/>
+          </p:cNvSpPr>
+          <p:nvPr/>
+        </p:nvSpPr>
+        <p:spPr>
+          <a:xfrm xmlns:a="http://schemas.openxmlformats.org/drawingml/2006/main">
+            <a:off x="914400" y="4400550"/>
+            <a:ext cx="8458200" cy="323850"/>
           </a:xfrm>
           <a:prstGeom xmlns:a="http://schemas.openxmlformats.org/drawingml/2006/main" prst="rect">
             <a:avLst/>
@@ -3563,73 +3563,28 @@
                   <a:srgbClr val="16202A"/>
                 </a:solidFill>
               </a:rPr>
-              <a:t>4. Akses admin: role dicek sebelum menampilkan admin panel.</a:t>
-            </a:r>
-          </a:p>
-        </p:txBody>
-      </p:sp>
-      <p:sp>
-        <p:nvSpPr>
-          <p:cNvPr id="7" name="bullet-5">
-            <a:extLst xmlns:a="http://schemas.openxmlformats.org/drawingml/2006/main">
-              <a:ext uri="{FF2B5EF4-FFF2-40B4-BE49-F238E27FC236}">
-                <a16:creationId xmlns:a16="http://schemas.microsoft.com/office/drawing/2014/main" id="{17E8CEFF-FBAF-46D7-BB9A-F74B2D2BB032}"/>
-              </a:ext>
-            </a:extLst>
-          </p:cNvPr>
-          <p:cNvSpPr>
-            <a:spLocks xmlns:a="http://schemas.openxmlformats.org/drawingml/2006/main" noGrp="1"/>
-          </p:cNvSpPr>
-          <p:nvPr/>
-        </p:nvSpPr>
-        <p:spPr>
-          <a:xfrm xmlns:a="http://schemas.openxmlformats.org/drawingml/2006/main">
-            <a:off x="914400" y="4572000"/>
-            <a:ext cx="7658100" cy="647700"/>
-          </a:xfrm>
-          <a:prstGeom xmlns:a="http://schemas.openxmlformats.org/drawingml/2006/main" prst="rect">
-            <a:avLst/>
-          </a:prstGeom>
-        </p:spPr>
-        <p:txBody>
-          <a:bodyPr xmlns:a="http://schemas.openxmlformats.org/drawingml/2006/main" lIns="0" tIns="0" rIns="0" bIns="0"/>
-          <a:lstStyle xmlns:a="http://schemas.openxmlformats.org/drawingml/2006/main"/>
-          <a:p xmlns:a="http://schemas.openxmlformats.org/drawingml/2006/main">
-            <a:pPr>
-              <a:defRPr sz="2100">
-                <a:solidFill>
-                  <a:srgbClr val="16202A"/>
-                </a:solidFill>
-              </a:defRPr>
-            </a:pPr>
-            <a:r>
-              <a:rPr sz="2100">
-                <a:solidFill>
-                  <a:srgbClr val="16202A"/>
-                </a:solidFill>
-              </a:rPr>
-              <a:t>5. Session: cookie HttpOnly, Secure, SameSite Strict, dan regenerate ID.</a:t>
-            </a:r>
-          </a:p>
-        </p:txBody>
-      </p:sp>
-      <p:sp>
-        <p:nvSpPr>
-          <p:cNvPr id="8" name="footer">
-            <a:extLst xmlns:a="http://schemas.openxmlformats.org/drawingml/2006/main">
-              <a:ext uri="{FF2B5EF4-FFF2-40B4-BE49-F238E27FC236}">
-                <a16:creationId xmlns:a16="http://schemas.microsoft.com/office/drawing/2014/main" id="{6509B456-0E6E-4D5E-88CE-B9FBDC3B7B39}"/>
-              </a:ext>
-            </a:extLst>
-          </p:cNvPr>
-          <p:cNvSpPr>
-            <a:spLocks xmlns:a="http://schemas.openxmlformats.org/drawingml/2006/main" noGrp="1"/>
-          </p:cNvSpPr>
-          <p:nvPr/>
-        </p:nvSpPr>
-        <p:spPr>
-          <a:xfrm xmlns:a="http://schemas.openxmlformats.org/drawingml/2006/main">
-            <a:off x="914400" y="5524500"/>
+              <a:t>4. Admin panel: hash password ditampilkan sebagai bukti penyimpanan aman.</a:t>
+            </a:r>
+          </a:p>
+        </p:txBody>
+      </p:sp>
+      <p:sp>
+        <p:nvSpPr>
+          <p:cNvPr id="7" name="footer">
+            <a:extLst xmlns:a="http://schemas.openxmlformats.org/drawingml/2006/main">
+              <a:ext uri="{FF2B5EF4-FFF2-40B4-BE49-F238E27FC236}">
+                <a16:creationId xmlns:a16="http://schemas.microsoft.com/office/drawing/2014/main" id="{0F51693D-0EF4-40D8-AAD8-BC844A564596}"/>
+              </a:ext>
+            </a:extLst>
+          </p:cNvPr>
+          <p:cNvSpPr>
+            <a:spLocks xmlns:a="http://schemas.openxmlformats.org/drawingml/2006/main" noGrp="1"/>
+          </p:cNvSpPr>
+          <p:nvPr/>
+        </p:nvSpPr>
+        <p:spPr>
+          <a:xfrm xmlns:a="http://schemas.openxmlformats.org/drawingml/2006/main">
+            <a:off x="914400" y="5029200"/>
             <a:ext cx="16459200" cy="209550"/>
           </a:xfrm>
           <a:prstGeom xmlns:a="http://schemas.openxmlformats.org/drawingml/2006/main" prst="rect">
@@ -3661,7 +3616,7 @@
     </p:spTree>
     <p:extLst>
       <p:ext uri="{BB962C8B-B14F-4D97-AF65-F5344CB8AC3E}">
-        <p14:creationId xmlns:p14="http://schemas.microsoft.com/office/powerpoint/2010/main" val="1951732245"/>
+        <p14:creationId xmlns:p14="http://schemas.microsoft.com/office/powerpoint/2010/main" val="2026588714"/>
       </p:ext>
     </p:extLst>
   </p:cSld>
@@ -3685,7 +3640,7 @@
           <p:cNvPr id="1" name="slide-title">
             <a:extLst xmlns:a="http://schemas.openxmlformats.org/drawingml/2006/main">
               <a:ext uri="{FF2B5EF4-FFF2-40B4-BE49-F238E27FC236}">
-                <a16:creationId xmlns:a16="http://schemas.microsoft.com/office/drawing/2014/main" id="{CE60FF48-26E7-4FAC-9AF7-975D36F7EC6D}"/>
+                <a16:creationId xmlns:a16="http://schemas.microsoft.com/office/drawing/2014/main" id="{700477CE-EAE7-4F0C-93FD-69C3090B8BE6}"/>
               </a:ext>
             </a:extLst>
           </p:cNvPr>
@@ -3720,7 +3675,7 @@
                   <a:srgbClr val="16202A"/>
                 </a:solidFill>
               </a:rPr>
-              <a:t>Demo uji serangan</a:t>
+              <a:t>Demo uji target</a:t>
             </a:r>
           </a:p>
         </p:txBody>
@@ -3730,7 +3685,7 @@
           <p:cNvPr id="2" name="slide-subtitle">
             <a:extLst xmlns:a="http://schemas.openxmlformats.org/drawingml/2006/main">
               <a:ext uri="{FF2B5EF4-FFF2-40B4-BE49-F238E27FC236}">
-                <a16:creationId xmlns:a16="http://schemas.microsoft.com/office/drawing/2014/main" id="{3ECD14A4-F35D-42C9-97F8-66B4831AFD44}"/>
+                <a16:creationId xmlns:a16="http://schemas.microsoft.com/office/drawing/2014/main" id="{024BFA81-F39D-4724-B244-40F2BC037C5D}"/>
               </a:ext>
             </a:extLst>
           </p:cNvPr>
@@ -3742,7 +3697,7 @@
         <p:spPr>
           <a:xfrm xmlns:a="http://schemas.openxmlformats.org/drawingml/2006/main">
             <a:off x="914400" y="1485900"/>
-            <a:ext cx="4419600" cy="266700"/>
+            <a:ext cx="4743450" cy="514350"/>
           </a:xfrm>
           <a:prstGeom xmlns:a="http://schemas.openxmlformats.org/drawingml/2006/main" prst="rect">
             <a:avLst/>
@@ -3765,7 +3720,7 @@
                   <a:srgbClr val="5E6B78"/>
                 </a:solidFill>
               </a:rPr>
-              <a:t>Urutan demo disiapkan agar sesuai rubrik penilaian.</a:t>
+              <a:t>Urutan demo difokuskan pada tiga kontrol yang diklaim.</a:t>
             </a:r>
           </a:p>
         </p:txBody>
@@ -3775,18 +3730,18 @@
           <p:cNvPr id="3" name="bullet-1">
             <a:extLst xmlns:a="http://schemas.openxmlformats.org/drawingml/2006/main">
               <a:ext uri="{FF2B5EF4-FFF2-40B4-BE49-F238E27FC236}">
-                <a16:creationId xmlns:a16="http://schemas.microsoft.com/office/drawing/2014/main" id="{065A0CCC-BB25-402F-8420-0F16CC5F23E6}"/>
-              </a:ext>
-            </a:extLst>
-          </p:cNvPr>
-          <p:cNvSpPr>
-            <a:spLocks xmlns:a="http://schemas.openxmlformats.org/drawingml/2006/main" noGrp="1"/>
-          </p:cNvSpPr>
-          <p:nvPr/>
-        </p:nvSpPr>
-        <p:spPr>
-          <a:xfrm xmlns:a="http://schemas.openxmlformats.org/drawingml/2006/main">
-            <a:off x="914400" y="2038350"/>
+                <a16:creationId xmlns:a16="http://schemas.microsoft.com/office/drawing/2014/main" id="{11059C8C-2ECC-4C9D-8A68-B696CB54A683}"/>
+              </a:ext>
+            </a:extLst>
+          </p:cNvPr>
+          <p:cNvSpPr>
+            <a:spLocks xmlns:a="http://schemas.openxmlformats.org/drawingml/2006/main" noGrp="1"/>
+          </p:cNvSpPr>
+          <p:nvPr/>
+        </p:nvSpPr>
+        <p:spPr>
+          <a:xfrm xmlns:a="http://schemas.openxmlformats.org/drawingml/2006/main">
+            <a:off x="914400" y="2286000"/>
             <a:ext cx="5238750" cy="647700"/>
           </a:xfrm>
           <a:prstGeom xmlns:a="http://schemas.openxmlformats.org/drawingml/2006/main" prst="rect">
@@ -3820,18 +3775,18 @@
           <p:cNvPr id="4" name="bullet-2">
             <a:extLst xmlns:a="http://schemas.openxmlformats.org/drawingml/2006/main">
               <a:ext uri="{FF2B5EF4-FFF2-40B4-BE49-F238E27FC236}">
-                <a16:creationId xmlns:a16="http://schemas.microsoft.com/office/drawing/2014/main" id="{42E5F656-3D5F-45C4-83DF-7D24F0C50A89}"/>
-              </a:ext>
-            </a:extLst>
-          </p:cNvPr>
-          <p:cNvSpPr>
-            <a:spLocks xmlns:a="http://schemas.openxmlformats.org/drawingml/2006/main" noGrp="1"/>
-          </p:cNvSpPr>
-          <p:nvPr/>
-        </p:nvSpPr>
-        <p:spPr>
-          <a:xfrm xmlns:a="http://schemas.openxmlformats.org/drawingml/2006/main">
-            <a:off x="914400" y="2857500"/>
+                <a16:creationId xmlns:a16="http://schemas.microsoft.com/office/drawing/2014/main" id="{7EE4C92F-112C-4D98-8272-A39B96C42CEE}"/>
+              </a:ext>
+            </a:extLst>
+          </p:cNvPr>
+          <p:cNvSpPr>
+            <a:spLocks xmlns:a="http://schemas.openxmlformats.org/drawingml/2006/main" noGrp="1"/>
+          </p:cNvSpPr>
+          <p:nvPr/>
+        </p:nvSpPr>
+        <p:spPr>
+          <a:xfrm xmlns:a="http://schemas.openxmlformats.org/drawingml/2006/main">
+            <a:off x="914400" y="3105150"/>
             <a:ext cx="6629400" cy="647700"/>
           </a:xfrm>
           <a:prstGeom xmlns:a="http://schemas.openxmlformats.org/drawingml/2006/main" prst="rect">
@@ -3865,19 +3820,19 @@
           <p:cNvPr id="5" name="bullet-3">
             <a:extLst xmlns:a="http://schemas.openxmlformats.org/drawingml/2006/main">
               <a:ext uri="{FF2B5EF4-FFF2-40B4-BE49-F238E27FC236}">
-                <a16:creationId xmlns:a16="http://schemas.microsoft.com/office/drawing/2014/main" id="{C06D56B6-1BDE-44B7-8FAE-6164E4B064B4}"/>
-              </a:ext>
-            </a:extLst>
-          </p:cNvPr>
-          <p:cNvSpPr>
-            <a:spLocks xmlns:a="http://schemas.openxmlformats.org/drawingml/2006/main" noGrp="1"/>
-          </p:cNvSpPr>
-          <p:nvPr/>
-        </p:nvSpPr>
-        <p:spPr>
-          <a:xfrm xmlns:a="http://schemas.openxmlformats.org/drawingml/2006/main">
-            <a:off x="914400" y="3657600"/>
-            <a:ext cx="6534150" cy="647700"/>
+                <a16:creationId xmlns:a16="http://schemas.microsoft.com/office/drawing/2014/main" id="{4108BBD3-2E6A-46ED-AF1C-92AB27F58F50}"/>
+              </a:ext>
+            </a:extLst>
+          </p:cNvPr>
+          <p:cNvSpPr>
+            <a:spLocks xmlns:a="http://schemas.openxmlformats.org/drawingml/2006/main" noGrp="1"/>
+          </p:cNvSpPr>
+          <p:nvPr/>
+        </p:nvSpPr>
+        <p:spPr>
+          <a:xfrm xmlns:a="http://schemas.openxmlformats.org/drawingml/2006/main">
+            <a:off x="914400" y="3905250"/>
+            <a:ext cx="6191250" cy="647700"/>
           </a:xfrm>
           <a:prstGeom xmlns:a="http://schemas.openxmlformats.org/drawingml/2006/main" prst="rect">
             <a:avLst/>
@@ -3900,7 +3855,7 @@
                   <a:srgbClr val="16202A"/>
                 </a:solidFill>
               </a:rPr>
-              <a:t>3. Coba payload SQL injection: ' OR '1'='1 pada mode secure.</a:t>
+              <a:t>3. Buka /admin.php dan tunjukkan kolom password hash.</a:t>
             </a:r>
           </a:p>
         </p:txBody>
@@ -3910,19 +3865,19 @@
           <p:cNvPr id="6" name="bullet-4">
             <a:extLst xmlns:a="http://schemas.openxmlformats.org/drawingml/2006/main">
               <a:ext uri="{FF2B5EF4-FFF2-40B4-BE49-F238E27FC236}">
-                <a16:creationId xmlns:a16="http://schemas.microsoft.com/office/drawing/2014/main" id="{22FFD8F9-E727-4FFF-84CF-0A28947A4428}"/>
-              </a:ext>
-            </a:extLst>
-          </p:cNvPr>
-          <p:cNvSpPr>
-            <a:spLocks xmlns:a="http://schemas.openxmlformats.org/drawingml/2006/main" noGrp="1"/>
-          </p:cNvSpPr>
-          <p:nvPr/>
-        </p:nvSpPr>
-        <p:spPr>
-          <a:xfrm xmlns:a="http://schemas.openxmlformats.org/drawingml/2006/main">
-            <a:off x="914400" y="4476750"/>
-            <a:ext cx="7886700" cy="323850"/>
+                <a16:creationId xmlns:a16="http://schemas.microsoft.com/office/drawing/2014/main" id="{D557BE80-5C83-4139-BD9A-441BE11F890F}"/>
+              </a:ext>
+            </a:extLst>
+          </p:cNvPr>
+          <p:cNvSpPr>
+            <a:spLocks xmlns:a="http://schemas.openxmlformats.org/drawingml/2006/main" noGrp="1"/>
+          </p:cNvSpPr>
+          <p:nvPr/>
+        </p:nvSpPr>
+        <p:spPr>
+          <a:xfrm xmlns:a="http://schemas.openxmlformats.org/drawingml/2006/main">
+            <a:off x="914400" y="4724400"/>
+            <a:ext cx="5467350" cy="647700"/>
           </a:xfrm>
           <a:prstGeom xmlns:a="http://schemas.openxmlformats.org/drawingml/2006/main" prst="rect">
             <a:avLst/>
@@ -3945,7 +3900,7 @@
                   <a:srgbClr val="16202A"/>
                 </a:solidFill>
               </a:rPr>
-              <a:t>4. Kirim komentar &lt;script&gt;alert(1)&lt;/script&gt; dan pastikan tidak dieksekusi.</a:t>
+              <a:t>4. Jelaskan prefix bcrypt $2y$10$ dan segmen salt.</a:t>
             </a:r>
           </a:p>
         </p:txBody>
@@ -3955,19 +3910,19 @@
           <p:cNvPr id="7" name="bullet-5">
             <a:extLst xmlns:a="http://schemas.openxmlformats.org/drawingml/2006/main">
               <a:ext uri="{FF2B5EF4-FFF2-40B4-BE49-F238E27FC236}">
-                <a16:creationId xmlns:a16="http://schemas.microsoft.com/office/drawing/2014/main" id="{81F3FD8D-790B-4651-8523-4BF5DA215AAF}"/>
-              </a:ext>
-            </a:extLst>
-          </p:cNvPr>
-          <p:cNvSpPr>
-            <a:spLocks xmlns:a="http://schemas.openxmlformats.org/drawingml/2006/main" noGrp="1"/>
-          </p:cNvSpPr>
-          <p:nvPr/>
-        </p:nvSpPr>
-        <p:spPr>
-          <a:xfrm xmlns:a="http://schemas.openxmlformats.org/drawingml/2006/main">
-            <a:off x="914400" y="4972050"/>
-            <a:ext cx="7543800" cy="323850"/>
+                <a16:creationId xmlns:a16="http://schemas.microsoft.com/office/drawing/2014/main" id="{7808C57B-590E-4C1C-97E4-B9247F1B247D}"/>
+              </a:ext>
+            </a:extLst>
+          </p:cNvPr>
+          <p:cNvSpPr>
+            <a:spLocks xmlns:a="http://schemas.openxmlformats.org/drawingml/2006/main" noGrp="1"/>
+          </p:cNvSpPr>
+          <p:nvPr/>
+        </p:nvSpPr>
+        <p:spPr>
+          <a:xfrm xmlns:a="http://schemas.openxmlformats.org/drawingml/2006/main">
+            <a:off x="914400" y="5543550"/>
+            <a:ext cx="8001000" cy="323850"/>
           </a:xfrm>
           <a:prstGeom xmlns:a="http://schemas.openxmlformats.org/drawingml/2006/main" prst="rect">
             <a:avLst/>
@@ -3990,7 +3945,7 @@
                   <a:srgbClr val="16202A"/>
                 </a:solidFill>
               </a:rPr>
-              <a:t>5. Kirim komentar lebih dari 500 karakter dan POST tanpa CSRF token.</a:t>
+              <a:t>5. Kirim komentar lebih dari 500 karakter dan tunjukkan penolakan server.</a:t>
             </a:r>
           </a:p>
         </p:txBody>
@@ -4000,18 +3955,18 @@
           <p:cNvPr id="8" name="footer">
             <a:extLst xmlns:a="http://schemas.openxmlformats.org/drawingml/2006/main">
               <a:ext uri="{FF2B5EF4-FFF2-40B4-BE49-F238E27FC236}">
-                <a16:creationId xmlns:a16="http://schemas.microsoft.com/office/drawing/2014/main" id="{3956FDFA-3569-4750-99BA-788F74719DA9}"/>
-              </a:ext>
-            </a:extLst>
-          </p:cNvPr>
-          <p:cNvSpPr>
-            <a:spLocks xmlns:a="http://schemas.openxmlformats.org/drawingml/2006/main" noGrp="1"/>
-          </p:cNvSpPr>
-          <p:nvPr/>
-        </p:nvSpPr>
-        <p:spPr>
-          <a:xfrm xmlns:a="http://schemas.openxmlformats.org/drawingml/2006/main">
-            <a:off x="914400" y="5581650"/>
+                <a16:creationId xmlns:a16="http://schemas.microsoft.com/office/drawing/2014/main" id="{F90006F6-2030-4532-A479-B1C2ADDA2078}"/>
+              </a:ext>
+            </a:extLst>
+          </p:cNvPr>
+          <p:cNvSpPr>
+            <a:spLocks xmlns:a="http://schemas.openxmlformats.org/drawingml/2006/main" noGrp="1"/>
+          </p:cNvSpPr>
+          <p:nvPr/>
+        </p:nvSpPr>
+        <p:spPr>
+          <a:xfrm xmlns:a="http://schemas.openxmlformats.org/drawingml/2006/main">
+            <a:off x="914400" y="6153150"/>
             <a:ext cx="16459200" cy="209550"/>
           </a:xfrm>
           <a:prstGeom xmlns:a="http://schemas.openxmlformats.org/drawingml/2006/main" prst="rect">
@@ -4043,7 +3998,7 @@
     </p:spTree>
     <p:extLst>
       <p:ext uri="{BB962C8B-B14F-4D97-AF65-F5344CB8AC3E}">
-        <p14:creationId xmlns:p14="http://schemas.microsoft.com/office/powerpoint/2010/main" val="720203891"/>
+        <p14:creationId xmlns:p14="http://schemas.microsoft.com/office/powerpoint/2010/main" val="1800308421"/>
       </p:ext>
     </p:extLst>
   </p:cSld>
@@ -4067,7 +4022,7 @@
           <p:cNvPr id="1" name="slide-title">
             <a:extLst xmlns:a="http://schemas.openxmlformats.org/drawingml/2006/main">
               <a:ext uri="{FF2B5EF4-FFF2-40B4-BE49-F238E27FC236}">
-                <a16:creationId xmlns:a16="http://schemas.microsoft.com/office/drawing/2014/main" id="{2441CFCB-422F-4F66-BBE3-8846EF5717E8}"/>
+                <a16:creationId xmlns:a16="http://schemas.microsoft.com/office/drawing/2014/main" id="{3DEDC671-A6C1-4820-AE74-473A121BF61F}"/>
               </a:ext>
             </a:extLst>
           </p:cNvPr>
@@ -4112,7 +4067,7 @@
           <p:cNvPr id="2" name="slide-subtitle">
             <a:extLst xmlns:a="http://schemas.openxmlformats.org/drawingml/2006/main">
               <a:ext uri="{FF2B5EF4-FFF2-40B4-BE49-F238E27FC236}">
-                <a16:creationId xmlns:a16="http://schemas.microsoft.com/office/drawing/2014/main" id="{491DD436-1B13-48AE-A420-361114F55BEC}"/>
+                <a16:creationId xmlns:a16="http://schemas.microsoft.com/office/drawing/2014/main" id="{82FDC04A-5EC0-41B7-9017-3B5F48AC7EFD}"/>
               </a:ext>
             </a:extLst>
           </p:cNvPr>
@@ -4157,7 +4112,7 @@
           <p:cNvPr id="3" name="bullet-1">
             <a:extLst xmlns:a="http://schemas.openxmlformats.org/drawingml/2006/main">
               <a:ext uri="{FF2B5EF4-FFF2-40B4-BE49-F238E27FC236}">
-                <a16:creationId xmlns:a16="http://schemas.microsoft.com/office/drawing/2014/main" id="{3655059E-54BE-49DA-9DA6-2BC24F80C262}"/>
+                <a16:creationId xmlns:a16="http://schemas.microsoft.com/office/drawing/2014/main" id="{749657A5-64D9-405A-A7F9-BE2DA349995A}"/>
               </a:ext>
             </a:extLst>
           </p:cNvPr>
@@ -4169,7 +4124,7 @@
         <p:spPr>
           <a:xfrm xmlns:a="http://schemas.openxmlformats.org/drawingml/2006/main">
             <a:off x="914400" y="2286000"/>
-            <a:ext cx="10039350" cy="647700"/>
+            <a:ext cx="7239000" cy="323850"/>
           </a:xfrm>
           <a:prstGeom xmlns:a="http://schemas.openxmlformats.org/drawingml/2006/main" prst="rect">
             <a:avLst/>
@@ -4192,7 +4147,7 @@
                   <a:srgbClr val="16202A"/>
                 </a:solidFill>
               </a:rPr>
-              <a:t>1. Kontrol utama sudah aktif: HTTPS, hash+salt, SQLi, XSS, CSRF, input limit, brute force delay.</a:t>
+              <a:t>1. Kontrol target 80 aktif: HTTPS, hash+salt, dan pembatasan input.</a:t>
             </a:r>
           </a:p>
         </p:txBody>
@@ -4202,18 +4157,18 @@
           <p:cNvPr id="4" name="bullet-2">
             <a:extLst xmlns:a="http://schemas.openxmlformats.org/drawingml/2006/main">
               <a:ext uri="{FF2B5EF4-FFF2-40B4-BE49-F238E27FC236}">
-                <a16:creationId xmlns:a16="http://schemas.microsoft.com/office/drawing/2014/main" id="{C5D523E6-AC50-4F13-872A-971BF7B3CDED}"/>
-              </a:ext>
-            </a:extLst>
-          </p:cNvPr>
-          <p:cNvSpPr>
-            <a:spLocks xmlns:a="http://schemas.openxmlformats.org/drawingml/2006/main" noGrp="1"/>
-          </p:cNvSpPr>
-          <p:nvPr/>
-        </p:nvSpPr>
-        <p:spPr>
-          <a:xfrm xmlns:a="http://schemas.openxmlformats.org/drawingml/2006/main">
-            <a:off x="914400" y="3105150"/>
+                <a16:creationId xmlns:a16="http://schemas.microsoft.com/office/drawing/2014/main" id="{5E514813-C469-4940-844A-714285BA7C0A}"/>
+              </a:ext>
+            </a:extLst>
+          </p:cNvPr>
+          <p:cNvSpPr>
+            <a:spLocks xmlns:a="http://schemas.openxmlformats.org/drawingml/2006/main" noGrp="1"/>
+          </p:cNvSpPr>
+          <p:nvPr/>
+        </p:nvSpPr>
+        <p:spPr>
+          <a:xfrm xmlns:a="http://schemas.openxmlformats.org/drawingml/2006/main">
+            <a:off x="914400" y="2781300"/>
             <a:ext cx="9944100" cy="647700"/>
           </a:xfrm>
           <a:prstGeom xmlns:a="http://schemas.openxmlformats.org/drawingml/2006/main" prst="rect">
@@ -4247,19 +4202,19 @@
           <p:cNvPr id="5" name="bullet-3">
             <a:extLst xmlns:a="http://schemas.openxmlformats.org/drawingml/2006/main">
               <a:ext uri="{FF2B5EF4-FFF2-40B4-BE49-F238E27FC236}">
-                <a16:creationId xmlns:a16="http://schemas.microsoft.com/office/drawing/2014/main" id="{4A2F39EA-DC81-4A9A-807A-989F4F8B3EDA}"/>
-              </a:ext>
-            </a:extLst>
-          </p:cNvPr>
-          <p:cNvSpPr>
-            <a:spLocks xmlns:a="http://schemas.openxmlformats.org/drawingml/2006/main" noGrp="1"/>
-          </p:cNvSpPr>
-          <p:nvPr/>
-        </p:nvSpPr>
-        <p:spPr>
-          <a:xfrm xmlns:a="http://schemas.openxmlformats.org/drawingml/2006/main">
-            <a:off x="914400" y="3905250"/>
-            <a:ext cx="11811000" cy="323850"/>
+                <a16:creationId xmlns:a16="http://schemas.microsoft.com/office/drawing/2014/main" id="{1E2267E6-3923-4161-9EAF-EEF2B34EAD3B}"/>
+              </a:ext>
+            </a:extLst>
+          </p:cNvPr>
+          <p:cNvSpPr>
+            <a:spLocks xmlns:a="http://schemas.openxmlformats.org/drawingml/2006/main" noGrp="1"/>
+          </p:cNvSpPr>
+          <p:nvPr/>
+        </p:nvSpPr>
+        <p:spPr>
+          <a:xfrm xmlns:a="http://schemas.openxmlformats.org/drawingml/2006/main">
+            <a:off x="914400" y="3600450"/>
+            <a:ext cx="9296400" cy="647700"/>
           </a:xfrm>
           <a:prstGeom xmlns:a="http://schemas.openxmlformats.org/drawingml/2006/main" prst="rect">
             <a:avLst/>
@@ -4282,7 +4237,7 @@
                   <a:srgbClr val="16202A"/>
                 </a:solidFill>
               </a:rPr>
-              <a:t>3. Pengembangan berikutnya: rate limiter berbasis IP, audit log, reset password aman, dan sertifikat CA resmi.</a:t>
+              <a:t>3. Pengembangan berikutnya: audit log, reset password aman, dan sertifikat CA resmi.</a:t>
             </a:r>
           </a:p>
         </p:txBody>
@@ -4292,7 +4247,7 @@
           <p:cNvPr id="6" name="footer">
             <a:extLst xmlns:a="http://schemas.openxmlformats.org/drawingml/2006/main">
               <a:ext uri="{FF2B5EF4-FFF2-40B4-BE49-F238E27FC236}">
-                <a16:creationId xmlns:a16="http://schemas.microsoft.com/office/drawing/2014/main" id="{21791C08-5EB7-4B1A-B546-93826B30EA10}"/>
+                <a16:creationId xmlns:a16="http://schemas.microsoft.com/office/drawing/2014/main" id="{72EEF049-9617-4B7C-9975-AEC798F1DA14}"/>
               </a:ext>
             </a:extLst>
           </p:cNvPr>
@@ -4335,7 +4290,7 @@
     </p:spTree>
     <p:extLst>
       <p:ext uri="{BB962C8B-B14F-4D97-AF65-F5344CB8AC3E}">
-        <p14:creationId xmlns:p14="http://schemas.microsoft.com/office/powerpoint/2010/main" val="2051848520"/>
+        <p14:creationId xmlns:p14="http://schemas.microsoft.com/office/powerpoint/2010/main" val="887994446"/>
       </p:ext>
     </p:extLst>
   </p:cSld>

</xml_diff>

<commit_message>
Make vulnerable scenario fully non-secure
</commit_message>
<xml_diff>
--- a/presentation/output/CLO2_Secure_Comments.pptx
+++ b/presentation/output/CLO2_Secure_Comments.pptx
@@ -2,19 +2,19 @@
 <file path=ppt/presentation.xml><?xml version="1.0" encoding="utf-8"?>
 <p:presentation xmlns:p="http://schemas.openxmlformats.org/presentationml/2006/main">
   <p:sldMasterIdLst>
-    <p:sldMasterId xmlns:r="http://schemas.openxmlformats.org/officeDocument/2006/relationships" id="2147483648" r:id="Rc8ad4114f5074c30"/>
+    <p:sldMasterId xmlns:r="http://schemas.openxmlformats.org/officeDocument/2006/relationships" id="2147483648" r:id="R25a9a4b919e44e58"/>
   </p:sldMasterIdLst>
   <p:notesMasterIdLst>
-    <p:notesMasterId xmlns:r="http://schemas.openxmlformats.org/officeDocument/2006/relationships" r:id="R9e7ab8b9b9f04a95"/>
+    <p:notesMasterId xmlns:r="http://schemas.openxmlformats.org/officeDocument/2006/relationships" r:id="R385c2a81f8ee46d7"/>
   </p:notesMasterIdLst>
   <p:sldIdLst>
-    <p:sldId xmlns:r="http://schemas.openxmlformats.org/officeDocument/2006/relationships" id="256" r:id="Rcc9a160528884392"/>
-    <p:sldId xmlns:r="http://schemas.openxmlformats.org/officeDocument/2006/relationships" id="257" r:id="R7d8bfcc808df422d"/>
-    <p:sldId xmlns:r="http://schemas.openxmlformats.org/officeDocument/2006/relationships" id="258" r:id="R3a09896cc50c4a1d"/>
-    <p:sldId xmlns:r="http://schemas.openxmlformats.org/officeDocument/2006/relationships" id="259" r:id="R32039f8a391d48ef"/>
-    <p:sldId xmlns:r="http://schemas.openxmlformats.org/officeDocument/2006/relationships" id="260" r:id="Rc2cbb631fca84eb2"/>
-    <p:sldId xmlns:r="http://schemas.openxmlformats.org/officeDocument/2006/relationships" id="261" r:id="R6961d25d21fa4d4c"/>
-    <p:sldId xmlns:r="http://schemas.openxmlformats.org/officeDocument/2006/relationships" id="262" r:id="R805c26a33a494ac6"/>
+    <p:sldId xmlns:r="http://schemas.openxmlformats.org/officeDocument/2006/relationships" id="256" r:id="R92b1c10a3c63482b"/>
+    <p:sldId xmlns:r="http://schemas.openxmlformats.org/officeDocument/2006/relationships" id="257" r:id="Rd8029ff45ff24826"/>
+    <p:sldId xmlns:r="http://schemas.openxmlformats.org/officeDocument/2006/relationships" id="258" r:id="Rc9e61af8257643cb"/>
+    <p:sldId xmlns:r="http://schemas.openxmlformats.org/officeDocument/2006/relationships" id="259" r:id="R55ce1eb29c2b4e63"/>
+    <p:sldId xmlns:r="http://schemas.openxmlformats.org/officeDocument/2006/relationships" id="260" r:id="Re083ac3a19e3413d"/>
+    <p:sldId xmlns:r="http://schemas.openxmlformats.org/officeDocument/2006/relationships" id="261" r:id="Re457282cb4ee48d3"/>
+    <p:sldId xmlns:r="http://schemas.openxmlformats.org/officeDocument/2006/relationships" id="262" r:id="R43fca7a3a8a046aa"/>
   </p:sldIdLst>
   <p:sldSz cx="18288000" cy="10287000"/>
   <p:notesSz cx="6858000" cy="9144000"/>
@@ -957,7 +957,7 @@
   </p:cSld>
   <p:clrMap bg1="lt1" tx1="dk1" bg2="lt2" tx2="dk2" accent1="accent1" accent2="accent2" accent3="accent3" accent4="accent4" accent5="accent5" accent6="accent6" hlink="hlink" folHlink="folHlink"/>
   <p:sldLayoutIdLst>
-    <p:sldLayoutId xmlns:r="http://schemas.openxmlformats.org/officeDocument/2006/relationships" id="2147483649" r:id="Rce441f2eedee4b36"/>
+    <p:sldLayoutId xmlns:r="http://schemas.openxmlformats.org/officeDocument/2006/relationships" id="2147483649" r:id="Rbe7754cf67334f8d"/>
   </p:sldLayoutIdLst>
   <p:txStyles>
     <p:titleStyle>
@@ -1256,7 +1256,7 @@
           <p:cNvPr id="1" name="cover-title">
             <a:extLst xmlns:a="http://schemas.openxmlformats.org/drawingml/2006/main">
               <a:ext uri="{FF2B5EF4-FFF2-40B4-BE49-F238E27FC236}">
-                <a16:creationId xmlns:a16="http://schemas.microsoft.com/office/drawing/2014/main" id="{929E19B3-ACE2-4467-BB18-DA00034DEAF6}"/>
+                <a16:creationId xmlns:a16="http://schemas.microsoft.com/office/drawing/2014/main" id="{1B61F48F-54BC-4C61-A55C-A64A1E44BD1F}"/>
               </a:ext>
             </a:extLst>
           </p:cNvPr>
@@ -1301,7 +1301,7 @@
           <p:cNvPr id="2" name="cover-rule">
             <a:extLst xmlns:a="http://schemas.openxmlformats.org/drawingml/2006/main">
               <a:ext uri="{FF2B5EF4-FFF2-40B4-BE49-F238E27FC236}">
-                <a16:creationId xmlns:a16="http://schemas.microsoft.com/office/drawing/2014/main" id="{D069ED89-7EB3-4F76-8ECD-897FED236030}"/>
+                <a16:creationId xmlns:a16="http://schemas.microsoft.com/office/drawing/2014/main" id="{7BDDA44D-4A3F-452B-8FB0-49299263AAC5}"/>
               </a:ext>
             </a:extLst>
           </p:cNvPr>
@@ -1334,7 +1334,7 @@
           <p:cNvPr id="3" name="cover-subtitle">
             <a:extLst xmlns:a="http://schemas.openxmlformats.org/drawingml/2006/main">
               <a:ext uri="{FF2B5EF4-FFF2-40B4-BE49-F238E27FC236}">
-                <a16:creationId xmlns:a16="http://schemas.microsoft.com/office/drawing/2014/main" id="{A4F7FCC8-AD29-4144-BAFF-F35503083F7A}"/>
+                <a16:creationId xmlns:a16="http://schemas.microsoft.com/office/drawing/2014/main" id="{7EE045CB-599C-4C1A-A671-7C9FD7D1DC26}"/>
               </a:ext>
             </a:extLst>
           </p:cNvPr>
@@ -1346,7 +1346,7 @@
         <p:spPr>
           <a:xfrm xmlns:a="http://schemas.openxmlformats.org/drawingml/2006/main">
             <a:off x="1104900" y="2895600"/>
-            <a:ext cx="10629900" cy="781050"/>
+            <a:ext cx="11963400" cy="781050"/>
           </a:xfrm>
           <a:prstGeom xmlns:a="http://schemas.openxmlformats.org/drawingml/2006/main" prst="rect">
             <a:avLst/>
@@ -1369,7 +1369,7 @@
                   <a:srgbClr val="16202A"/>
                 </a:solidFill>
               </a:rPr>
-              <a:t>Pengamanan aplikasi web target 80 poin: HTTPS, hash password dengan salt, dan pembatasan input berlebihan.</a:t>
+              <a:t>Skenario aplikasi sebelum pengamanan: password plaintext, SQL injection, XSS, tanpa CSRF, dan tanpa batas input.</a:t>
             </a:r>
           </a:p>
         </p:txBody>
@@ -1379,7 +1379,7 @@
           <p:cNvPr id="4" name="cover-context">
             <a:extLst xmlns:a="http://schemas.openxmlformats.org/drawingml/2006/main">
               <a:ext uri="{FF2B5EF4-FFF2-40B4-BE49-F238E27FC236}">
-                <a16:creationId xmlns:a16="http://schemas.microsoft.com/office/drawing/2014/main" id="{ED879370-D01C-4301-BD7C-141384FCFB3E}"/>
+                <a16:creationId xmlns:a16="http://schemas.microsoft.com/office/drawing/2014/main" id="{C298C413-1A62-44A7-9389-2352B82AC331}"/>
               </a:ext>
             </a:extLst>
           </p:cNvPr>
@@ -1414,7 +1414,7 @@
                   <a:srgbClr val="5E6B78"/>
                 </a:solidFill>
               </a:rPr>
-              <a:t>Projek CLO 2 Keamanan Sistem</a:t>
+              <a:t>Skenario non-secure untuk pembanding branch secure-login</a:t>
             </a:r>
           </a:p>
         </p:txBody>
@@ -1422,7 +1422,7 @@
     </p:spTree>
     <p:extLst>
       <p:ext uri="{BB962C8B-B14F-4D97-AF65-F5344CB8AC3E}">
-        <p14:creationId xmlns:p14="http://schemas.microsoft.com/office/powerpoint/2010/main" val="463809684"/>
+        <p14:creationId xmlns:p14="http://schemas.microsoft.com/office/powerpoint/2010/main" val="464505463"/>
       </p:ext>
     </p:extLst>
   </p:cSld>
@@ -1446,7 +1446,7 @@
           <p:cNvPr id="1" name="slide-title">
             <a:extLst xmlns:a="http://schemas.openxmlformats.org/drawingml/2006/main">
               <a:ext uri="{FF2B5EF4-FFF2-40B4-BE49-F238E27FC236}">
-                <a16:creationId xmlns:a16="http://schemas.microsoft.com/office/drawing/2014/main" id="{E4FBD61E-7F12-4A2E-823B-366487DC013C}"/>
+                <a16:creationId xmlns:a16="http://schemas.microsoft.com/office/drawing/2014/main" id="{CDF04724-A2D9-4C8F-962C-A7CD0C9FD920}"/>
               </a:ext>
             </a:extLst>
           </p:cNvPr>
@@ -1491,7 +1491,7 @@
           <p:cNvPr id="2" name="slide-subtitle">
             <a:extLst xmlns:a="http://schemas.openxmlformats.org/drawingml/2006/main">
               <a:ext uri="{FF2B5EF4-FFF2-40B4-BE49-F238E27FC236}">
-                <a16:creationId xmlns:a16="http://schemas.microsoft.com/office/drawing/2014/main" id="{625D4B27-5368-4606-B956-14A1F540924E}"/>
+                <a16:creationId xmlns:a16="http://schemas.microsoft.com/office/drawing/2014/main" id="{4F7E90AB-8DB7-4575-A33B-C42775B50F15}"/>
               </a:ext>
             </a:extLst>
           </p:cNvPr>
@@ -1503,7 +1503,7 @@
         <p:spPr>
           <a:xfrm xmlns:a="http://schemas.openxmlformats.org/drawingml/2006/main">
             <a:off x="914400" y="1485900"/>
-            <a:ext cx="8477250" cy="514350"/>
+            <a:ext cx="7848600" cy="266700"/>
           </a:xfrm>
           <a:prstGeom xmlns:a="http://schemas.openxmlformats.org/drawingml/2006/main" prst="rect">
             <a:avLst/>
@@ -1526,7 +1526,7 @@
                   <a:srgbClr val="5E6B78"/>
                 </a:solidFill>
               </a:rPr>
-              <a:t>Aplikasi demo komentar publik untuk menunjukkan kontrol keamanan web yang bisa diuji langsung.</a:t>
+              <a:t>Aplikasi komentar publik untuk menunjukkan kondisi sebelum kontrol keamanan diterapkan.</a:t>
             </a:r>
           </a:p>
         </p:txBody>
@@ -1536,18 +1536,18 @@
           <p:cNvPr id="3" name="bullet-1">
             <a:extLst xmlns:a="http://schemas.openxmlformats.org/drawingml/2006/main">
               <a:ext uri="{FF2B5EF4-FFF2-40B4-BE49-F238E27FC236}">
-                <a16:creationId xmlns:a16="http://schemas.microsoft.com/office/drawing/2014/main" id="{188E90B8-D833-4A8B-8837-33378EF66BF4}"/>
-              </a:ext>
-            </a:extLst>
-          </p:cNvPr>
-          <p:cNvSpPr>
-            <a:spLocks xmlns:a="http://schemas.openxmlformats.org/drawingml/2006/main" noGrp="1"/>
-          </p:cNvSpPr>
-          <p:nvPr/>
-        </p:nvSpPr>
-        <p:spPr>
-          <a:xfrm xmlns:a="http://schemas.openxmlformats.org/drawingml/2006/main">
-            <a:off x="914400" y="2286000"/>
+                <a16:creationId xmlns:a16="http://schemas.microsoft.com/office/drawing/2014/main" id="{33252704-2236-4D13-B625-811A44FC5AA4}"/>
+              </a:ext>
+            </a:extLst>
+          </p:cNvPr>
+          <p:cNvSpPr>
+            <a:spLocks xmlns:a="http://schemas.openxmlformats.org/drawingml/2006/main" noGrp="1"/>
+          </p:cNvSpPr>
+          <p:nvPr/>
+        </p:nvSpPr>
+        <p:spPr>
+          <a:xfrm xmlns:a="http://schemas.openxmlformats.org/drawingml/2006/main">
+            <a:off x="914400" y="2038350"/>
             <a:ext cx="5181600" cy="323850"/>
           </a:xfrm>
           <a:prstGeom xmlns:a="http://schemas.openxmlformats.org/drawingml/2006/main" prst="rect">
@@ -1581,18 +1581,18 @@
           <p:cNvPr id="4" name="bullet-2">
             <a:extLst xmlns:a="http://schemas.openxmlformats.org/drawingml/2006/main">
               <a:ext uri="{FF2B5EF4-FFF2-40B4-BE49-F238E27FC236}">
-                <a16:creationId xmlns:a16="http://schemas.microsoft.com/office/drawing/2014/main" id="{F6135850-08FE-41AA-9E53-9927E4E4E757}"/>
-              </a:ext>
-            </a:extLst>
-          </p:cNvPr>
-          <p:cNvSpPr>
-            <a:spLocks xmlns:a="http://schemas.openxmlformats.org/drawingml/2006/main" noGrp="1"/>
-          </p:cNvSpPr>
-          <p:nvPr/>
-        </p:nvSpPr>
-        <p:spPr>
-          <a:xfrm xmlns:a="http://schemas.openxmlformats.org/drawingml/2006/main">
-            <a:off x="914400" y="2781300"/>
+                <a16:creationId xmlns:a16="http://schemas.microsoft.com/office/drawing/2014/main" id="{206CC176-AD12-459E-B075-70473CD0CF17}"/>
+              </a:ext>
+            </a:extLst>
+          </p:cNvPr>
+          <p:cNvSpPr>
+            <a:spLocks xmlns:a="http://schemas.openxmlformats.org/drawingml/2006/main" noGrp="1"/>
+          </p:cNvSpPr>
+          <p:nvPr/>
+        </p:nvSpPr>
+        <p:spPr>
+          <a:xfrm xmlns:a="http://schemas.openxmlformats.org/drawingml/2006/main">
+            <a:off x="914400" y="2533650"/>
             <a:ext cx="4514850" cy="647700"/>
           </a:xfrm>
           <a:prstGeom xmlns:a="http://schemas.openxmlformats.org/drawingml/2006/main" prst="rect">
@@ -1626,18 +1626,18 @@
           <p:cNvPr id="5" name="bullet-3">
             <a:extLst xmlns:a="http://schemas.openxmlformats.org/drawingml/2006/main">
               <a:ext uri="{FF2B5EF4-FFF2-40B4-BE49-F238E27FC236}">
-                <a16:creationId xmlns:a16="http://schemas.microsoft.com/office/drawing/2014/main" id="{C401E9AE-9766-4DEF-8D01-2488FBC47933}"/>
-              </a:ext>
-            </a:extLst>
-          </p:cNvPr>
-          <p:cNvSpPr>
-            <a:spLocks xmlns:a="http://schemas.openxmlformats.org/drawingml/2006/main" noGrp="1"/>
-          </p:cNvSpPr>
-          <p:nvPr/>
-        </p:nvSpPr>
-        <p:spPr>
-          <a:xfrm xmlns:a="http://schemas.openxmlformats.org/drawingml/2006/main">
-            <a:off x="914400" y="3600450"/>
+                <a16:creationId xmlns:a16="http://schemas.microsoft.com/office/drawing/2014/main" id="{4AE86F33-B290-4207-968E-22BDC86B7235}"/>
+              </a:ext>
+            </a:extLst>
+          </p:cNvPr>
+          <p:cNvSpPr>
+            <a:spLocks xmlns:a="http://schemas.openxmlformats.org/drawingml/2006/main" noGrp="1"/>
+          </p:cNvSpPr>
+          <p:nvPr/>
+        </p:nvSpPr>
+        <p:spPr>
+          <a:xfrm xmlns:a="http://schemas.openxmlformats.org/drawingml/2006/main">
+            <a:off x="914400" y="3333750"/>
             <a:ext cx="6172200" cy="647700"/>
           </a:xfrm>
           <a:prstGeom xmlns:a="http://schemas.openxmlformats.org/drawingml/2006/main" prst="rect">
@@ -1671,19 +1671,19 @@
           <p:cNvPr id="6" name="bullet-4">
             <a:extLst xmlns:a="http://schemas.openxmlformats.org/drawingml/2006/main">
               <a:ext uri="{FF2B5EF4-FFF2-40B4-BE49-F238E27FC236}">
-                <a16:creationId xmlns:a16="http://schemas.microsoft.com/office/drawing/2014/main" id="{A291BE1C-EB38-4238-9AC8-AF1F82ED0233}"/>
-              </a:ext>
-            </a:extLst>
-          </p:cNvPr>
-          <p:cNvSpPr>
-            <a:spLocks xmlns:a="http://schemas.openxmlformats.org/drawingml/2006/main" noGrp="1"/>
-          </p:cNvSpPr>
-          <p:nvPr/>
-        </p:nvSpPr>
-        <p:spPr>
-          <a:xfrm xmlns:a="http://schemas.openxmlformats.org/drawingml/2006/main">
-            <a:off x="914400" y="4400550"/>
-            <a:ext cx="5238750" cy="323850"/>
+                <a16:creationId xmlns:a16="http://schemas.microsoft.com/office/drawing/2014/main" id="{B0CCD9F6-03DA-4364-87A7-4AE8849CCE44}"/>
+              </a:ext>
+            </a:extLst>
+          </p:cNvPr>
+          <p:cNvSpPr>
+            <a:spLocks xmlns:a="http://schemas.openxmlformats.org/drawingml/2006/main" noGrp="1"/>
+          </p:cNvSpPr>
+          <p:nvPr/>
+        </p:nvSpPr>
+        <p:spPr>
+          <a:xfrm xmlns:a="http://schemas.openxmlformats.org/drawingml/2006/main">
+            <a:off x="914400" y="4152900"/>
+            <a:ext cx="7315200" cy="647700"/>
           </a:xfrm>
           <a:prstGeom xmlns:a="http://schemas.openxmlformats.org/drawingml/2006/main" prst="rect">
             <a:avLst/>
@@ -1706,7 +1706,7 @@
                   <a:srgbClr val="16202A"/>
                 </a:solidFill>
               </a:rPr>
-              <a:t>4. Demo berjalan lokal dengan Docker Compose.</a:t>
+              <a:t>4. Berjalan lokal dengan Docker Compose dan identitas Nama+NIM.</a:t>
             </a:r>
           </a:p>
         </p:txBody>
@@ -1716,18 +1716,18 @@
           <p:cNvPr id="7" name="footer">
             <a:extLst xmlns:a="http://schemas.openxmlformats.org/drawingml/2006/main">
               <a:ext uri="{FF2B5EF4-FFF2-40B4-BE49-F238E27FC236}">
-                <a16:creationId xmlns:a16="http://schemas.microsoft.com/office/drawing/2014/main" id="{5D090349-B28A-4726-B864-7002D2B39F6B}"/>
-              </a:ext>
-            </a:extLst>
-          </p:cNvPr>
-          <p:cNvSpPr>
-            <a:spLocks xmlns:a="http://schemas.openxmlformats.org/drawingml/2006/main" noGrp="1"/>
-          </p:cNvSpPr>
-          <p:nvPr/>
-        </p:nvSpPr>
-        <p:spPr>
-          <a:xfrm xmlns:a="http://schemas.openxmlformats.org/drawingml/2006/main">
-            <a:off x="914400" y="5029200"/>
+                <a16:creationId xmlns:a16="http://schemas.microsoft.com/office/drawing/2014/main" id="{D34C2AFD-013E-4DED-ABEC-577D2C89741D}"/>
+              </a:ext>
+            </a:extLst>
+          </p:cNvPr>
+          <p:cNvSpPr>
+            <a:spLocks xmlns:a="http://schemas.openxmlformats.org/drawingml/2006/main" noGrp="1"/>
+          </p:cNvSpPr>
+          <p:nvPr/>
+        </p:nvSpPr>
+        <p:spPr>
+          <a:xfrm xmlns:a="http://schemas.openxmlformats.org/drawingml/2006/main">
+            <a:off x="914400" y="5105400"/>
             <a:ext cx="16459200" cy="209550"/>
           </a:xfrm>
           <a:prstGeom xmlns:a="http://schemas.openxmlformats.org/drawingml/2006/main" prst="rect">
@@ -1751,7 +1751,7 @@
                   <a:srgbClr val="5E6B78"/>
                 </a:solidFill>
               </a:rPr>
-              <a:t>CLO 2 Secure Comments | PHP, Apache, MySQL, Docker</a:t>
+              <a:t>CLO 2 Non-Secure Comments | PHP, Apache, MySQL, Docker</a:t>
             </a:r>
           </a:p>
         </p:txBody>
@@ -1759,7 +1759,7 @@
     </p:spTree>
     <p:extLst>
       <p:ext uri="{BB962C8B-B14F-4D97-AF65-F5344CB8AC3E}">
-        <p14:creationId xmlns:p14="http://schemas.microsoft.com/office/powerpoint/2010/main" val="1391107886"/>
+        <p14:creationId xmlns:p14="http://schemas.microsoft.com/office/powerpoint/2010/main" val="481985788"/>
       </p:ext>
     </p:extLst>
   </p:cSld>
@@ -1783,7 +1783,7 @@
           <p:cNvPr id="1" name="slide-title">
             <a:extLst xmlns:a="http://schemas.openxmlformats.org/drawingml/2006/main">
               <a:ext uri="{FF2B5EF4-FFF2-40B4-BE49-F238E27FC236}">
-                <a16:creationId xmlns:a16="http://schemas.microsoft.com/office/drawing/2014/main" id="{B684E466-0567-40B0-A7BB-0143302B02A5}"/>
+                <a16:creationId xmlns:a16="http://schemas.microsoft.com/office/drawing/2014/main" id="{3F6A928A-98CA-4CC0-87E1-654C1682B8B9}"/>
               </a:ext>
             </a:extLst>
           </p:cNvPr>
@@ -1818,7 +1818,7 @@
                   <a:srgbClr val="16202A"/>
                 </a:solidFill>
               </a:rPr>
-              <a:t>Teori keamanan yang dipakai</a:t>
+              <a:t>Kontrol yang dimatikan</a:t>
             </a:r>
           </a:p>
         </p:txBody>
@@ -1828,7 +1828,7 @@
           <p:cNvPr id="2" name="slide-subtitle">
             <a:extLst xmlns:a="http://schemas.openxmlformats.org/drawingml/2006/main">
               <a:ext uri="{FF2B5EF4-FFF2-40B4-BE49-F238E27FC236}">
-                <a16:creationId xmlns:a16="http://schemas.microsoft.com/office/drawing/2014/main" id="{F9E193D7-AA70-416F-92D1-A2D6ED4A9498}"/>
+                <a16:creationId xmlns:a16="http://schemas.microsoft.com/office/drawing/2014/main" id="{CC3E007C-96C8-4E15-A9F1-9EE20C8E0BE5}"/>
               </a:ext>
             </a:extLst>
           </p:cNvPr>
@@ -1840,7 +1840,7 @@
         <p:spPr>
           <a:xfrm xmlns:a="http://schemas.openxmlformats.org/drawingml/2006/main">
             <a:off x="914400" y="1485900"/>
-            <a:ext cx="5410200" cy="514350"/>
+            <a:ext cx="6115050" cy="514350"/>
           </a:xfrm>
           <a:prstGeom xmlns:a="http://schemas.openxmlformats.org/drawingml/2006/main" prst="rect">
             <a:avLst/>
@@ -1863,17 +1863,17 @@
                   <a:srgbClr val="5E6B78"/>
                 </a:solidFill>
               </a:rPr>
-              <a:t>Kontrol dipilih sesuai risiko umum pada aplikasi web sederhana.</a:t>
-            </a:r>
-          </a:p>
-        </p:txBody>
-      </p:sp>
-      <p:sp>
-        <p:nvSpPr>
-          <p:cNvPr id="3" name="method-HTTPS/TLS">
-            <a:extLst xmlns:a="http://schemas.openxmlformats.org/drawingml/2006/main">
-              <a:ext uri="{FF2B5EF4-FFF2-40B4-BE49-F238E27FC236}">
-                <a16:creationId xmlns:a16="http://schemas.microsoft.com/office/drawing/2014/main" id="{B2741C7B-29B2-4746-B9CE-359D40114CB8}"/>
+              <a:t>Branch ini sengaja dibuat rentan untuk menunjukkan risiko aplikasi web.</a:t>
+            </a:r>
+          </a:p>
+        </p:txBody>
+      </p:sp>
+      <p:sp>
+        <p:nvSpPr>
+          <p:cNvPr id="3" name="method-Password plaintext">
+            <a:extLst xmlns:a="http://schemas.openxmlformats.org/drawingml/2006/main">
+              <a:ext uri="{FF2B5EF4-FFF2-40B4-BE49-F238E27FC236}">
+                <a16:creationId xmlns:a16="http://schemas.microsoft.com/office/drawing/2014/main" id="{EFB79A3A-713F-4009-9F1D-EF9E04CDE8B1}"/>
               </a:ext>
             </a:extLst>
           </p:cNvPr>
@@ -1902,7 +1902,7 @@
           <p:cNvPr id="4" name="">
             <a:extLst xmlns:a="http://schemas.openxmlformats.org/drawingml/2006/main">
               <a:ext uri="{FF2B5EF4-FFF2-40B4-BE49-F238E27FC236}">
-                <a16:creationId xmlns:a16="http://schemas.microsoft.com/office/drawing/2014/main" id="{B53C4BF8-F8CB-44B8-B405-0865E56EFE16}"/>
+                <a16:creationId xmlns:a16="http://schemas.microsoft.com/office/drawing/2014/main" id="{BAE2413F-FBB4-444F-B204-F6F0F09C765B}"/>
               </a:ext>
             </a:extLst>
           </p:cNvPr>
@@ -1937,7 +1937,7 @@
                   <a:srgbClr val="0F766E"/>
                 </a:solidFill>
               </a:rPr>
-              <a:t>HTTPS/TLS</a:t>
+              <a:t>Password plaintext</a:t>
             </a:r>
           </a:p>
         </p:txBody>
@@ -1947,7 +1947,7 @@
           <p:cNvPr id="5" name="">
             <a:extLst xmlns:a="http://schemas.openxmlformats.org/drawingml/2006/main">
               <a:ext uri="{FF2B5EF4-FFF2-40B4-BE49-F238E27FC236}">
-                <a16:creationId xmlns:a16="http://schemas.microsoft.com/office/drawing/2014/main" id="{F7696F86-9B4A-4F99-A389-EA46825EA380}"/>
+                <a16:creationId xmlns:a16="http://schemas.microsoft.com/office/drawing/2014/main" id="{4729F6C9-F761-4E98-8948-61B1F41F744F}"/>
               </a:ext>
             </a:extLst>
           </p:cNvPr>
@@ -1982,17 +1982,17 @@
                   <a:srgbClr val="16202A"/>
                 </a:solidFill>
               </a:rPr>
-              <a:t>Mengenkripsi trafik browser ke Apache dengan self-signed certificate RSA 2048-bit.</a:t>
-            </a:r>
-          </a:p>
-        </p:txBody>
-      </p:sp>
-      <p:sp>
-        <p:nvSpPr>
-          <p:cNvPr id="6" name="method-Hash + salt">
-            <a:extLst xmlns:a="http://schemas.openxmlformats.org/drawingml/2006/main">
-              <a:ext uri="{FF2B5EF4-FFF2-40B4-BE49-F238E27FC236}">
-                <a16:creationId xmlns:a16="http://schemas.microsoft.com/office/drawing/2014/main" id="{69ADCED0-A668-4F89-A4AE-AE970D6A2677}"/>
+              <a:t>Password admin dan user disimpan apa adanya tanpa hash dan salt.</a:t>
+            </a:r>
+          </a:p>
+        </p:txBody>
+      </p:sp>
+      <p:sp>
+        <p:nvSpPr>
+          <p:cNvPr id="6" name="method-Raw SQL">
+            <a:extLst xmlns:a="http://schemas.openxmlformats.org/drawingml/2006/main">
+              <a:ext uri="{FF2B5EF4-FFF2-40B4-BE49-F238E27FC236}">
+                <a16:creationId xmlns:a16="http://schemas.microsoft.com/office/drawing/2014/main" id="{435DCEB3-2066-44EA-BD58-4B2BD2747BBE}"/>
               </a:ext>
             </a:extLst>
           </p:cNvPr>
@@ -2021,7 +2021,7 @@
           <p:cNvPr id="7" name="">
             <a:extLst xmlns:a="http://schemas.openxmlformats.org/drawingml/2006/main">
               <a:ext uri="{FF2B5EF4-FFF2-40B4-BE49-F238E27FC236}">
-                <a16:creationId xmlns:a16="http://schemas.microsoft.com/office/drawing/2014/main" id="{2503182C-E3FF-4DCF-B492-036EAB565EC3}"/>
+                <a16:creationId xmlns:a16="http://schemas.microsoft.com/office/drawing/2014/main" id="{37974089-DE10-4E94-9BCE-E1BEBB87BD5C}"/>
               </a:ext>
             </a:extLst>
           </p:cNvPr>
@@ -2056,7 +2056,7 @@
                   <a:srgbClr val="0F766E"/>
                 </a:solidFill>
               </a:rPr>
-              <a:t>Hash + salt</a:t>
+              <a:t>Raw SQL</a:t>
             </a:r>
           </a:p>
         </p:txBody>
@@ -2066,7 +2066,7 @@
           <p:cNvPr id="8" name="">
             <a:extLst xmlns:a="http://schemas.openxmlformats.org/drawingml/2006/main">
               <a:ext uri="{FF2B5EF4-FFF2-40B4-BE49-F238E27FC236}">
-                <a16:creationId xmlns:a16="http://schemas.microsoft.com/office/drawing/2014/main" id="{FE26CCFF-52AD-434F-B31C-81473015C947}"/>
+                <a16:creationId xmlns:a16="http://schemas.microsoft.com/office/drawing/2014/main" id="{CDEB10A2-D3C6-4F06-9741-E69745C48D67}"/>
               </a:ext>
             </a:extLst>
           </p:cNvPr>
@@ -2101,17 +2101,17 @@
                   <a:srgbClr val="16202A"/>
                 </a:solidFill>
               </a:rPr>
-              <a:t>Password disimpan memakai password_hash() dan diverifikasi dengan password_verify().</a:t>
-            </a:r>
-          </a:p>
-        </p:txBody>
-      </p:sp>
-      <p:sp>
-        <p:nvSpPr>
-          <p:cNvPr id="9" name="method-HTTPS/TLS">
-            <a:extLst xmlns:a="http://schemas.openxmlformats.org/drawingml/2006/main">
-              <a:ext uri="{FF2B5EF4-FFF2-40B4-BE49-F238E27FC236}">
-                <a16:creationId xmlns:a16="http://schemas.microsoft.com/office/drawing/2014/main" id="{AF8E123D-A8FA-4E77-A877-3E0BBD08A389}"/>
+              <a:t>Login menyusun query dari input user tanpa prepared statement.</a:t>
+            </a:r>
+          </a:p>
+        </p:txBody>
+      </p:sp>
+      <p:sp>
+        <p:nvSpPr>
+          <p:cNvPr id="9" name="method-No CSRF">
+            <a:extLst xmlns:a="http://schemas.openxmlformats.org/drawingml/2006/main">
+              <a:ext uri="{FF2B5EF4-FFF2-40B4-BE49-F238E27FC236}">
+                <a16:creationId xmlns:a16="http://schemas.microsoft.com/office/drawing/2014/main" id="{3CEA039B-5354-4FBD-A945-A611EFC46C0E}"/>
               </a:ext>
             </a:extLst>
           </p:cNvPr>
@@ -2140,7 +2140,7 @@
           <p:cNvPr id="10" name="">
             <a:extLst xmlns:a="http://schemas.openxmlformats.org/drawingml/2006/main">
               <a:ext uri="{FF2B5EF4-FFF2-40B4-BE49-F238E27FC236}">
-                <a16:creationId xmlns:a16="http://schemas.microsoft.com/office/drawing/2014/main" id="{2B6441F2-68C4-43BD-AD02-EFB82E9BA10D}"/>
+                <a16:creationId xmlns:a16="http://schemas.microsoft.com/office/drawing/2014/main" id="{9328AF0C-7DD0-4EE4-8672-7DC7E543660F}"/>
               </a:ext>
             </a:extLst>
           </p:cNvPr>
@@ -2175,7 +2175,7 @@
                   <a:srgbClr val="0F766E"/>
                 </a:solidFill>
               </a:rPr>
-              <a:t>HTTPS/TLS</a:t>
+              <a:t>No CSRF</a:t>
             </a:r>
           </a:p>
         </p:txBody>
@@ -2185,7 +2185,7 @@
           <p:cNvPr id="11" name="">
             <a:extLst xmlns:a="http://schemas.openxmlformats.org/drawingml/2006/main">
               <a:ext uri="{FF2B5EF4-FFF2-40B4-BE49-F238E27FC236}">
-                <a16:creationId xmlns:a16="http://schemas.microsoft.com/office/drawing/2014/main" id="{6C12A0DB-34CD-4556-8433-CD4ACAF36DB3}"/>
+                <a16:creationId xmlns:a16="http://schemas.microsoft.com/office/drawing/2014/main" id="{EE572396-7683-417D-B1EF-922EA35B2966}"/>
               </a:ext>
             </a:extLst>
           </p:cNvPr>
@@ -2220,17 +2220,17 @@
                   <a:srgbClr val="16202A"/>
                 </a:solidFill>
               </a:rPr>
-              <a:t>Apache memakai self-signed certificate RSA 2048-bit untuk demo lokal.</a:t>
-            </a:r>
-          </a:p>
-        </p:txBody>
-      </p:sp>
-      <p:sp>
-        <p:nvSpPr>
-          <p:cNvPr id="12" name="method-Hash + salt">
-            <a:extLst xmlns:a="http://schemas.openxmlformats.org/drawingml/2006/main">
-              <a:ext uri="{FF2B5EF4-FFF2-40B4-BE49-F238E27FC236}">
-                <a16:creationId xmlns:a16="http://schemas.microsoft.com/office/drawing/2014/main" id="{2B8AE0AC-294A-4762-A96D-E73935F1B74C}"/>
+              <a:t>Form POST tetap diterima meskipun tidak membawa token CSRF.</a:t>
+            </a:r>
+          </a:p>
+        </p:txBody>
+      </p:sp>
+      <p:sp>
+        <p:nvSpPr>
+          <p:cNvPr id="12" name="method-Raw output">
+            <a:extLst xmlns:a="http://schemas.openxmlformats.org/drawingml/2006/main">
+              <a:ext uri="{FF2B5EF4-FFF2-40B4-BE49-F238E27FC236}">
+                <a16:creationId xmlns:a16="http://schemas.microsoft.com/office/drawing/2014/main" id="{107434F7-A1C5-4418-825D-25D2D2C47144}"/>
               </a:ext>
             </a:extLst>
           </p:cNvPr>
@@ -2259,7 +2259,7 @@
           <p:cNvPr id="13" name="">
             <a:extLst xmlns:a="http://schemas.openxmlformats.org/drawingml/2006/main">
               <a:ext uri="{FF2B5EF4-FFF2-40B4-BE49-F238E27FC236}">
-                <a16:creationId xmlns:a16="http://schemas.microsoft.com/office/drawing/2014/main" id="{27BCCC8C-81B9-476B-A38E-04D222EB8BED}"/>
+                <a16:creationId xmlns:a16="http://schemas.microsoft.com/office/drawing/2014/main" id="{187A67EE-AD86-4CAC-8DB3-634F25A3E563}"/>
               </a:ext>
             </a:extLst>
           </p:cNvPr>
@@ -2294,7 +2294,7 @@
                   <a:srgbClr val="0F766E"/>
                 </a:solidFill>
               </a:rPr>
-              <a:t>Hash + salt</a:t>
+              <a:t>Raw output</a:t>
             </a:r>
           </a:p>
         </p:txBody>
@@ -2304,7 +2304,7 @@
           <p:cNvPr id="14" name="">
             <a:extLst xmlns:a="http://schemas.openxmlformats.org/drawingml/2006/main">
               <a:ext uri="{FF2B5EF4-FFF2-40B4-BE49-F238E27FC236}">
-                <a16:creationId xmlns:a16="http://schemas.microsoft.com/office/drawing/2014/main" id="{B5FBEEF6-6507-4846-8F8F-1215AD04C2AB}"/>
+                <a16:creationId xmlns:a16="http://schemas.microsoft.com/office/drawing/2014/main" id="{DAE5B8CC-DDEC-49D1-A705-4AF3F2CF21EE}"/>
               </a:ext>
             </a:extLst>
           </p:cNvPr>
@@ -2339,17 +2339,17 @@
                   <a:srgbClr val="16202A"/>
                 </a:solidFill>
               </a:rPr>
-              <a:t>Password disimpan memakai password_hash() dengan salt otomatis.</a:t>
-            </a:r>
-          </a:p>
-        </p:txBody>
-      </p:sp>
-      <p:sp>
-        <p:nvSpPr>
-          <p:cNvPr id="15" name="method-Input limit">
-            <a:extLst xmlns:a="http://schemas.openxmlformats.org/drawingml/2006/main">
-              <a:ext uri="{FF2B5EF4-FFF2-40B4-BE49-F238E27FC236}">
-                <a16:creationId xmlns:a16="http://schemas.microsoft.com/office/drawing/2014/main" id="{87DC62DD-F4E0-4454-8197-73C09E18CB01}"/>
+              <a:t>Komentar dirender langsung tanpa htmlspecialchars().</a:t>
+            </a:r>
+          </a:p>
+        </p:txBody>
+      </p:sp>
+      <p:sp>
+        <p:nvSpPr>
+          <p:cNvPr id="15" name="method-No input limit">
+            <a:extLst xmlns:a="http://schemas.openxmlformats.org/drawingml/2006/main">
+              <a:ext uri="{FF2B5EF4-FFF2-40B4-BE49-F238E27FC236}">
+                <a16:creationId xmlns:a16="http://schemas.microsoft.com/office/drawing/2014/main" id="{1333E01C-1250-492A-9063-0F7E3EADCA18}"/>
               </a:ext>
             </a:extLst>
           </p:cNvPr>
@@ -2378,7 +2378,7 @@
           <p:cNvPr id="16" name="">
             <a:extLst xmlns:a="http://schemas.openxmlformats.org/drawingml/2006/main">
               <a:ext uri="{FF2B5EF4-FFF2-40B4-BE49-F238E27FC236}">
-                <a16:creationId xmlns:a16="http://schemas.microsoft.com/office/drawing/2014/main" id="{F42BEF1D-8DFD-4078-9061-33AF950C4D39}"/>
+                <a16:creationId xmlns:a16="http://schemas.microsoft.com/office/drawing/2014/main" id="{3D8DF8DE-1127-44E1-8377-A175846C62D9}"/>
               </a:ext>
             </a:extLst>
           </p:cNvPr>
@@ -2413,7 +2413,7 @@
                   <a:srgbClr val="0F766E"/>
                 </a:solidFill>
               </a:rPr>
-              <a:t>Input limit</a:t>
+              <a:t>No input limit</a:t>
             </a:r>
           </a:p>
         </p:txBody>
@@ -2423,7 +2423,7 @@
           <p:cNvPr id="17" name="">
             <a:extLst xmlns:a="http://schemas.openxmlformats.org/drawingml/2006/main">
               <a:ext uri="{FF2B5EF4-FFF2-40B4-BE49-F238E27FC236}">
-                <a16:creationId xmlns:a16="http://schemas.microsoft.com/office/drawing/2014/main" id="{4452AFD7-E54C-4DEA-9D48-AD0C39491435}"/>
+                <a16:creationId xmlns:a16="http://schemas.microsoft.com/office/drawing/2014/main" id="{FDC203F3-7E1F-4C9D-9B53-2D2B908E793A}"/>
               </a:ext>
             </a:extLst>
           </p:cNvPr>
@@ -2458,17 +2458,17 @@
                   <a:srgbClr val="16202A"/>
                 </a:solidFill>
               </a:rPr>
-              <a:t>Komentar dibatasi maksimal 500 karakter di sisi server.</a:t>
-            </a:r>
-          </a:p>
-        </p:txBody>
-      </p:sp>
-      <p:sp>
-        <p:nvSpPr>
-          <p:cNvPr id="18" name="method-Admin proof">
-            <a:extLst xmlns:a="http://schemas.openxmlformats.org/drawingml/2006/main">
-              <a:ext uri="{FF2B5EF4-FFF2-40B4-BE49-F238E27FC236}">
-                <a16:creationId xmlns:a16="http://schemas.microsoft.com/office/drawing/2014/main" id="{89034156-6421-4C44-8F96-6E8119B23FEC}"/>
+              <a:t>Komentar tidak dibatasi 500 karakter di server maupun client.</a:t>
+            </a:r>
+          </a:p>
+        </p:txBody>
+      </p:sp>
+      <p:sp>
+        <p:nvSpPr>
+          <p:cNvPr id="18" name="method-No role check">
+            <a:extLst xmlns:a="http://schemas.openxmlformats.org/drawingml/2006/main">
+              <a:ext uri="{FF2B5EF4-FFF2-40B4-BE49-F238E27FC236}">
+                <a16:creationId xmlns:a16="http://schemas.microsoft.com/office/drawing/2014/main" id="{FDC02E75-A935-434A-B4B0-943AA33759C0}"/>
               </a:ext>
             </a:extLst>
           </p:cNvPr>
@@ -2497,7 +2497,7 @@
           <p:cNvPr id="19" name="">
             <a:extLst xmlns:a="http://schemas.openxmlformats.org/drawingml/2006/main">
               <a:ext uri="{FF2B5EF4-FFF2-40B4-BE49-F238E27FC236}">
-                <a16:creationId xmlns:a16="http://schemas.microsoft.com/office/drawing/2014/main" id="{37332735-8D8D-41EB-AF50-80E5836003E9}"/>
+                <a16:creationId xmlns:a16="http://schemas.microsoft.com/office/drawing/2014/main" id="{CB675959-9323-432E-BD0F-1C794F874AF5}"/>
               </a:ext>
             </a:extLst>
           </p:cNvPr>
@@ -2532,7 +2532,7 @@
                   <a:srgbClr val="0F766E"/>
                 </a:solidFill>
               </a:rPr>
-              <a:t>Admin proof</a:t>
+              <a:t>No role check</a:t>
             </a:r>
           </a:p>
         </p:txBody>
@@ -2542,7 +2542,7 @@
           <p:cNvPr id="20" name="">
             <a:extLst xmlns:a="http://schemas.openxmlformats.org/drawingml/2006/main">
               <a:ext uri="{FF2B5EF4-FFF2-40B4-BE49-F238E27FC236}">
-                <a16:creationId xmlns:a16="http://schemas.microsoft.com/office/drawing/2014/main" id="{476DB9F7-5F92-4EDC-AA1F-1525B2AC2CA3}"/>
+                <a16:creationId xmlns:a16="http://schemas.microsoft.com/office/drawing/2014/main" id="{4B855A9D-5F1C-483A-B29B-CE84F1304CF6}"/>
               </a:ext>
             </a:extLst>
           </p:cNvPr>
@@ -2577,7 +2577,7 @@
                   <a:srgbClr val="16202A"/>
                 </a:solidFill>
               </a:rPr>
-              <a:t>Panel admin menampilkan hash password, bukan plaintext.</a:t>
+              <a:t>Admin panel tidak membatasi akses berdasarkan role.</a:t>
             </a:r>
           </a:p>
         </p:txBody>
@@ -2587,7 +2587,7 @@
           <p:cNvPr id="21" name="footer">
             <a:extLst xmlns:a="http://schemas.openxmlformats.org/drawingml/2006/main">
               <a:ext uri="{FF2B5EF4-FFF2-40B4-BE49-F238E27FC236}">
-                <a16:creationId xmlns:a16="http://schemas.microsoft.com/office/drawing/2014/main" id="{261FDF3D-570D-42F9-BD89-00E29BE6D5D7}"/>
+                <a16:creationId xmlns:a16="http://schemas.microsoft.com/office/drawing/2014/main" id="{8F1EBB15-2697-4120-9116-E46F69695D90}"/>
               </a:ext>
             </a:extLst>
           </p:cNvPr>
@@ -2622,7 +2622,7 @@
                   <a:srgbClr val="5E6B78"/>
                 </a:solidFill>
               </a:rPr>
-              <a:t>CLO 2 Secure Comments | PHP, Apache, MySQL, Docker</a:t>
+              <a:t>CLO 2 Non-Secure Comments | PHP, Apache, MySQL, Docker</a:t>
             </a:r>
           </a:p>
         </p:txBody>
@@ -2630,7 +2630,7 @@
     </p:spTree>
     <p:extLst>
       <p:ext uri="{BB962C8B-B14F-4D97-AF65-F5344CB8AC3E}">
-        <p14:creationId xmlns:p14="http://schemas.microsoft.com/office/powerpoint/2010/main" val="502690985"/>
+        <p14:creationId xmlns:p14="http://schemas.microsoft.com/office/powerpoint/2010/main" val="918312802"/>
       </p:ext>
     </p:extLst>
   </p:cSld>
@@ -2654,7 +2654,7 @@
           <p:cNvPr id="1" name="slide-title">
             <a:extLst xmlns:a="http://schemas.openxmlformats.org/drawingml/2006/main">
               <a:ext uri="{FF2B5EF4-FFF2-40B4-BE49-F238E27FC236}">
-                <a16:creationId xmlns:a16="http://schemas.microsoft.com/office/drawing/2014/main" id="{9D06C737-51FC-446B-A857-3EE5DBBFF007}"/>
+                <a16:creationId xmlns:a16="http://schemas.microsoft.com/office/drawing/2014/main" id="{C6069C8D-0D01-4881-88FC-6E1F2C89A847}"/>
               </a:ext>
             </a:extLst>
           </p:cNvPr>
@@ -2699,7 +2699,7 @@
           <p:cNvPr id="2" name="slide-subtitle">
             <a:extLst xmlns:a="http://schemas.openxmlformats.org/drawingml/2006/main">
               <a:ext uri="{FF2B5EF4-FFF2-40B4-BE49-F238E27FC236}">
-                <a16:creationId xmlns:a16="http://schemas.microsoft.com/office/drawing/2014/main" id="{5E49AF4B-F1A9-45A3-B0B3-A3E2EA093090}"/>
+                <a16:creationId xmlns:a16="http://schemas.microsoft.com/office/drawing/2014/main" id="{5C5BE355-B1C3-40B6-994A-B4E69C6562C7}"/>
               </a:ext>
             </a:extLst>
           </p:cNvPr>
@@ -2711,7 +2711,7 @@
         <p:spPr>
           <a:xfrm xmlns:a="http://schemas.openxmlformats.org/drawingml/2006/main">
             <a:off x="914400" y="1485900"/>
-            <a:ext cx="7867650" cy="514350"/>
+            <a:ext cx="6229350" cy="266700"/>
           </a:xfrm>
           <a:prstGeom xmlns:a="http://schemas.openxmlformats.org/drawingml/2006/main" prst="rect">
             <a:avLst/>
@@ -2734,7 +2734,7 @@
                   <a:srgbClr val="5E6B78"/>
                 </a:solidFill>
               </a:rPr>
-              <a:t>Alur utama: browser masuk lewat HTTPS, PHP memproses request, MySQL menyimpan data.</a:t>
+              <a:t>Alur utama: browser masuk ke Apache/PHP lalu MySQL menyimpan data.</a:t>
             </a:r>
           </a:p>
         </p:txBody>
@@ -2744,18 +2744,182 @@
           <p:cNvPr id="3" name="method-Browser">
             <a:extLst xmlns:a="http://schemas.openxmlformats.org/drawingml/2006/main">
               <a:ext uri="{FF2B5EF4-FFF2-40B4-BE49-F238E27FC236}">
-                <a16:creationId xmlns:a16="http://schemas.microsoft.com/office/drawing/2014/main" id="{83F758F1-4787-4C71-8F89-59560BE3318C}"/>
-              </a:ext>
-            </a:extLst>
-          </p:cNvPr>
-          <p:cNvSpPr>
-            <a:spLocks xmlns:a="http://schemas.openxmlformats.org/drawingml/2006/main" noGrp="1"/>
-          </p:cNvSpPr>
-          <p:nvPr/>
-        </p:nvSpPr>
-        <p:spPr>
-          <a:xfrm xmlns:a="http://schemas.openxmlformats.org/drawingml/2006/main">
-            <a:off x="914400" y="2289810"/>
+                <a16:creationId xmlns:a16="http://schemas.microsoft.com/office/drawing/2014/main" id="{E2225971-41D6-4F0A-AA31-C280A2A94AFA}"/>
+              </a:ext>
+            </a:extLst>
+          </p:cNvPr>
+          <p:cNvSpPr>
+            <a:spLocks xmlns:a="http://schemas.openxmlformats.org/drawingml/2006/main" noGrp="1"/>
+          </p:cNvSpPr>
+          <p:nvPr/>
+        </p:nvSpPr>
+        <p:spPr>
+          <a:xfrm xmlns:a="http://schemas.openxmlformats.org/drawingml/2006/main">
+            <a:off x="914400" y="2038350"/>
+            <a:ext cx="4876800" cy="1074420"/>
+          </a:xfrm>
+          <a:prstGeom xmlns:a="http://schemas.openxmlformats.org/drawingml/2006/main" prst="roundRect">
+            <a:avLst>
+              <a:gd name="adj" fmla="val 7092"/>
+            </a:avLst>
+          </a:prstGeom>
+          <a:solidFill xmlns:a="http://schemas.openxmlformats.org/drawingml/2006/main">
+            <a:srgbClr val="FFFFFF"/>
+          </a:solidFill>
+        </p:spPr>
+      </p:sp>
+      <p:sp>
+        <p:nvSpPr>
+          <p:cNvPr id="4" name="">
+            <a:extLst xmlns:a="http://schemas.openxmlformats.org/drawingml/2006/main">
+              <a:ext uri="{FF2B5EF4-FFF2-40B4-BE49-F238E27FC236}">
+                <a16:creationId xmlns:a16="http://schemas.microsoft.com/office/drawing/2014/main" id="{473E4452-B461-4E28-806B-885E77F42AF7}"/>
+              </a:ext>
+            </a:extLst>
+          </p:cNvPr>
+          <p:cNvSpPr>
+            <a:spLocks xmlns:a="http://schemas.openxmlformats.org/drawingml/2006/main" noGrp="1"/>
+          </p:cNvSpPr>
+          <p:nvPr/>
+        </p:nvSpPr>
+        <p:spPr>
+          <a:xfrm xmlns:a="http://schemas.openxmlformats.org/drawingml/2006/main">
+            <a:off x="1181100" y="2247900"/>
+            <a:ext cx="4343400" cy="323850"/>
+          </a:xfrm>
+          <a:prstGeom xmlns:a="http://schemas.openxmlformats.org/drawingml/2006/main" prst="rect">
+            <a:avLst/>
+          </a:prstGeom>
+        </p:spPr>
+        <p:txBody>
+          <a:bodyPr xmlns:a="http://schemas.openxmlformats.org/drawingml/2006/main" lIns="0" tIns="0" rIns="0" bIns="0"/>
+          <a:lstStyle xmlns:a="http://schemas.openxmlformats.org/drawingml/2006/main"/>
+          <a:p xmlns:a="http://schemas.openxmlformats.org/drawingml/2006/main">
+            <a:pPr>
+              <a:defRPr sz="2100" b="1">
+                <a:solidFill>
+                  <a:srgbClr val="16202A"/>
+                </a:solidFill>
+              </a:defRPr>
+            </a:pPr>
+            <a:r>
+              <a:rPr sz="2100" b="1">
+                <a:solidFill>
+                  <a:srgbClr val="16202A"/>
+                </a:solidFill>
+              </a:rPr>
+              <a:t>Browser</a:t>
+            </a:r>
+          </a:p>
+        </p:txBody>
+      </p:sp>
+      <p:sp>
+        <p:nvSpPr>
+          <p:cNvPr id="5" name="">
+            <a:extLst xmlns:a="http://schemas.openxmlformats.org/drawingml/2006/main">
+              <a:ext uri="{FF2B5EF4-FFF2-40B4-BE49-F238E27FC236}">
+                <a16:creationId xmlns:a16="http://schemas.microsoft.com/office/drawing/2014/main" id="{3D207FB4-0ED6-4813-9632-B85994024C37}"/>
+              </a:ext>
+            </a:extLst>
+          </p:cNvPr>
+          <p:cNvSpPr>
+            <a:spLocks xmlns:a="http://schemas.openxmlformats.org/drawingml/2006/main" noGrp="1"/>
+          </p:cNvSpPr>
+          <p:nvPr/>
+        </p:nvSpPr>
+        <p:spPr>
+          <a:xfrm xmlns:a="http://schemas.openxmlformats.org/drawingml/2006/main">
+            <a:off x="1181100" y="2667000"/>
+            <a:ext cx="4343400" cy="247650"/>
+          </a:xfrm>
+          <a:prstGeom xmlns:a="http://schemas.openxmlformats.org/drawingml/2006/main" prst="rect">
+            <a:avLst/>
+          </a:prstGeom>
+        </p:spPr>
+        <p:txBody>
+          <a:bodyPr xmlns:a="http://schemas.openxmlformats.org/drawingml/2006/main" lIns="0" tIns="0" rIns="0" bIns="0"/>
+          <a:lstStyle xmlns:a="http://schemas.openxmlformats.org/drawingml/2006/main"/>
+          <a:p xmlns:a="http://schemas.openxmlformats.org/drawingml/2006/main">
+            <a:pPr>
+              <a:defRPr sz="1575">
+                <a:solidFill>
+                  <a:srgbClr val="16202A"/>
+                </a:solidFill>
+              </a:defRPr>
+            </a:pPr>
+            <a:r>
+              <a:rPr sz="1575">
+                <a:solidFill>
+                  <a:srgbClr val="16202A"/>
+                </a:solidFill>
+              </a:rPr>
+              <a:t>Membuka localhost:8080 atau localhost:8443.</a:t>
+            </a:r>
+          </a:p>
+        </p:txBody>
+      </p:sp>
+      <p:sp>
+        <p:nvSpPr>
+          <p:cNvPr id="6" name="">
+            <a:extLst xmlns:a="http://schemas.openxmlformats.org/drawingml/2006/main">
+              <a:ext uri="{FF2B5EF4-FFF2-40B4-BE49-F238E27FC236}">
+                <a16:creationId xmlns:a16="http://schemas.microsoft.com/office/drawing/2014/main" id="{E522048F-E4A0-4A6D-AE2C-206FC9479990}"/>
+              </a:ext>
+            </a:extLst>
+          </p:cNvPr>
+          <p:cNvSpPr>
+            <a:spLocks xmlns:a="http://schemas.openxmlformats.org/drawingml/2006/main" noGrp="1"/>
+          </p:cNvSpPr>
+          <p:nvPr/>
+        </p:nvSpPr>
+        <p:spPr>
+          <a:xfrm xmlns:a="http://schemas.openxmlformats.org/drawingml/2006/main">
+            <a:off x="5962650" y="2038350"/>
+            <a:ext cx="571500" cy="514350"/>
+          </a:xfrm>
+          <a:prstGeom xmlns:a="http://schemas.openxmlformats.org/drawingml/2006/main" prst="rect">
+            <a:avLst/>
+          </a:prstGeom>
+        </p:spPr>
+        <p:txBody>
+          <a:bodyPr xmlns:a="http://schemas.openxmlformats.org/drawingml/2006/main" lIns="0" tIns="0" rIns="0" bIns="0"/>
+          <a:lstStyle xmlns:a="http://schemas.openxmlformats.org/drawingml/2006/main"/>
+          <a:p xmlns:a="http://schemas.openxmlformats.org/drawingml/2006/main">
+            <a:pPr>
+              <a:defRPr sz="3300" b="1">
+                <a:solidFill>
+                  <a:srgbClr val="0F766E"/>
+                </a:solidFill>
+              </a:defRPr>
+            </a:pPr>
+            <a:r>
+              <a:rPr sz="3300" b="1">
+                <a:solidFill>
+                  <a:srgbClr val="0F766E"/>
+                </a:solidFill>
+              </a:rPr>
+              <a:t>-&gt;</a:t>
+            </a:r>
+          </a:p>
+        </p:txBody>
+      </p:sp>
+      <p:sp>
+        <p:nvSpPr>
+          <p:cNvPr id="7" name="method-Apache + PHP">
+            <a:extLst xmlns:a="http://schemas.openxmlformats.org/drawingml/2006/main">
+              <a:ext uri="{FF2B5EF4-FFF2-40B4-BE49-F238E27FC236}">
+                <a16:creationId xmlns:a16="http://schemas.microsoft.com/office/drawing/2014/main" id="{F75EE0E7-1117-4DD9-B361-BE3677B33BD9}"/>
+              </a:ext>
+            </a:extLst>
+          </p:cNvPr>
+          <p:cNvSpPr>
+            <a:spLocks xmlns:a="http://schemas.openxmlformats.org/drawingml/2006/main" noGrp="1"/>
+          </p:cNvSpPr>
+          <p:nvPr/>
+        </p:nvSpPr>
+        <p:spPr>
+          <a:xfrm xmlns:a="http://schemas.openxmlformats.org/drawingml/2006/main">
+            <a:off x="6705600" y="2038350"/>
             <a:ext cx="4876800" cy="1314450"/>
           </a:xfrm>
           <a:prstGeom xmlns:a="http://schemas.openxmlformats.org/drawingml/2006/main" prst="roundRect">
@@ -2770,21 +2934,21 @@
       </p:sp>
       <p:sp>
         <p:nvSpPr>
-          <p:cNvPr id="4" name="">
-            <a:extLst xmlns:a="http://schemas.openxmlformats.org/drawingml/2006/main">
-              <a:ext uri="{FF2B5EF4-FFF2-40B4-BE49-F238E27FC236}">
-                <a16:creationId xmlns:a16="http://schemas.microsoft.com/office/drawing/2014/main" id="{A95F0D44-9553-4BED-AA6D-922EE1D6C2BA}"/>
-              </a:ext>
-            </a:extLst>
-          </p:cNvPr>
-          <p:cNvSpPr>
-            <a:spLocks xmlns:a="http://schemas.openxmlformats.org/drawingml/2006/main" noGrp="1"/>
-          </p:cNvSpPr>
-          <p:nvPr/>
-        </p:nvSpPr>
-        <p:spPr>
-          <a:xfrm xmlns:a="http://schemas.openxmlformats.org/drawingml/2006/main">
-            <a:off x="1181100" y="2495550"/>
+          <p:cNvPr id="8" name="">
+            <a:extLst xmlns:a="http://schemas.openxmlformats.org/drawingml/2006/main">
+              <a:ext uri="{FF2B5EF4-FFF2-40B4-BE49-F238E27FC236}">
+                <a16:creationId xmlns:a16="http://schemas.microsoft.com/office/drawing/2014/main" id="{8F25188C-F3FA-4028-884B-5AB44A5D11DA}"/>
+              </a:ext>
+            </a:extLst>
+          </p:cNvPr>
+          <p:cNvSpPr>
+            <a:spLocks xmlns:a="http://schemas.openxmlformats.org/drawingml/2006/main" noGrp="1"/>
+          </p:cNvSpPr>
+          <p:nvPr/>
+        </p:nvSpPr>
+        <p:spPr>
+          <a:xfrm xmlns:a="http://schemas.openxmlformats.org/drawingml/2006/main">
+            <a:off x="6972300" y="2247900"/>
             <a:ext cx="4343400" cy="323850"/>
           </a:xfrm>
           <a:prstGeom xmlns:a="http://schemas.openxmlformats.org/drawingml/2006/main" prst="rect">
@@ -2798,38 +2962,38 @@
             <a:pPr>
               <a:defRPr sz="2100" b="1">
                 <a:solidFill>
-                  <a:srgbClr val="16202A"/>
+                  <a:srgbClr val="115E59"/>
                 </a:solidFill>
               </a:defRPr>
             </a:pPr>
             <a:r>
               <a:rPr sz="2100" b="1">
                 <a:solidFill>
-                  <a:srgbClr val="16202A"/>
-                </a:solidFill>
-              </a:rPr>
-              <a:t>Browser</a:t>
-            </a:r>
-          </a:p>
-        </p:txBody>
-      </p:sp>
-      <p:sp>
-        <p:nvSpPr>
-          <p:cNvPr id="5" name="">
-            <a:extLst xmlns:a="http://schemas.openxmlformats.org/drawingml/2006/main">
-              <a:ext uri="{FF2B5EF4-FFF2-40B4-BE49-F238E27FC236}">
-                <a16:creationId xmlns:a16="http://schemas.microsoft.com/office/drawing/2014/main" id="{93AFCCCC-3ABA-454E-8421-D62C0A873D1E}"/>
-              </a:ext>
-            </a:extLst>
-          </p:cNvPr>
-          <p:cNvSpPr>
-            <a:spLocks xmlns:a="http://schemas.openxmlformats.org/drawingml/2006/main" noGrp="1"/>
-          </p:cNvSpPr>
-          <p:nvPr/>
-        </p:nvSpPr>
-        <p:spPr>
-          <a:xfrm xmlns:a="http://schemas.openxmlformats.org/drawingml/2006/main">
-            <a:off x="1181100" y="2914650"/>
+                  <a:srgbClr val="115E59"/>
+                </a:solidFill>
+              </a:rPr>
+              <a:t>Apache + PHP</a:t>
+            </a:r>
+          </a:p>
+        </p:txBody>
+      </p:sp>
+      <p:sp>
+        <p:nvSpPr>
+          <p:cNvPr id="9" name="">
+            <a:extLst xmlns:a="http://schemas.openxmlformats.org/drawingml/2006/main">
+              <a:ext uri="{FF2B5EF4-FFF2-40B4-BE49-F238E27FC236}">
+                <a16:creationId xmlns:a16="http://schemas.microsoft.com/office/drawing/2014/main" id="{CCD51468-FFB3-4188-B290-9A6BA93CD917}"/>
+              </a:ext>
+            </a:extLst>
+          </p:cNvPr>
+          <p:cNvSpPr>
+            <a:spLocks xmlns:a="http://schemas.openxmlformats.org/drawingml/2006/main" noGrp="1"/>
+          </p:cNvSpPr>
+          <p:nvPr/>
+        </p:nvSpPr>
+        <p:spPr>
+          <a:xfrm xmlns:a="http://schemas.openxmlformats.org/drawingml/2006/main">
+            <a:off x="6972300" y="2667000"/>
             <a:ext cx="4343400" cy="495300"/>
           </a:xfrm>
           <a:prstGeom xmlns:a="http://schemas.openxmlformats.org/drawingml/2006/main" prst="rect">
@@ -2853,28 +3017,28 @@
                   <a:srgbClr val="16202A"/>
                 </a:solidFill>
               </a:rPr>
-              <a:t>Membuka localhost:8443 dan menerima cookie session aman.</a:t>
-            </a:r>
-          </a:p>
-        </p:txBody>
-      </p:sp>
-      <p:sp>
-        <p:nvSpPr>
-          <p:cNvPr id="6" name="">
-            <a:extLst xmlns:a="http://schemas.openxmlformats.org/drawingml/2006/main">
-              <a:ext uri="{FF2B5EF4-FFF2-40B4-BE49-F238E27FC236}">
-                <a16:creationId xmlns:a16="http://schemas.microsoft.com/office/drawing/2014/main" id="{729C0392-0C39-4A67-9B0A-13AD2CBEFD9B}"/>
-              </a:ext>
-            </a:extLst>
-          </p:cNvPr>
-          <p:cNvSpPr>
-            <a:spLocks xmlns:a="http://schemas.openxmlformats.org/drawingml/2006/main" noGrp="1"/>
-          </p:cNvSpPr>
-          <p:nvPr/>
-        </p:nvSpPr>
-        <p:spPr>
-          <a:xfrm xmlns:a="http://schemas.openxmlformats.org/drawingml/2006/main">
-            <a:off x="5962650" y="2286000"/>
+              <a:t>Tidak redirect HTTP, login raw SQL, output raw, dan tanpa batas komentar.</a:t>
+            </a:r>
+          </a:p>
+        </p:txBody>
+      </p:sp>
+      <p:sp>
+        <p:nvSpPr>
+          <p:cNvPr id="10" name="">
+            <a:extLst xmlns:a="http://schemas.openxmlformats.org/drawingml/2006/main">
+              <a:ext uri="{FF2B5EF4-FFF2-40B4-BE49-F238E27FC236}">
+                <a16:creationId xmlns:a16="http://schemas.microsoft.com/office/drawing/2014/main" id="{7A3CD35E-85AA-425A-8E58-F2F2AA10086E}"/>
+              </a:ext>
+            </a:extLst>
+          </p:cNvPr>
+          <p:cNvSpPr>
+            <a:spLocks xmlns:a="http://schemas.openxmlformats.org/drawingml/2006/main" noGrp="1"/>
+          </p:cNvSpPr>
+          <p:nvPr/>
+        </p:nvSpPr>
+        <p:spPr>
+          <a:xfrm xmlns:a="http://schemas.openxmlformats.org/drawingml/2006/main">
+            <a:off x="11753850" y="2038350"/>
             <a:ext cx="571500" cy="514350"/>
           </a:xfrm>
           <a:prstGeom xmlns:a="http://schemas.openxmlformats.org/drawingml/2006/main" prst="rect">
@@ -2905,21 +3069,21 @@
       </p:sp>
       <p:sp>
         <p:nvSpPr>
-          <p:cNvPr id="7" name="method-Apache + PHP">
-            <a:extLst xmlns:a="http://schemas.openxmlformats.org/drawingml/2006/main">
-              <a:ext uri="{FF2B5EF4-FFF2-40B4-BE49-F238E27FC236}">
-                <a16:creationId xmlns:a16="http://schemas.microsoft.com/office/drawing/2014/main" id="{E1603C42-2AC0-4D73-BD85-AC188F7FB12D}"/>
-              </a:ext>
-            </a:extLst>
-          </p:cNvPr>
-          <p:cNvSpPr>
-            <a:spLocks xmlns:a="http://schemas.openxmlformats.org/drawingml/2006/main" noGrp="1"/>
-          </p:cNvSpPr>
-          <p:nvPr/>
-        </p:nvSpPr>
-        <p:spPr>
-          <a:xfrm xmlns:a="http://schemas.openxmlformats.org/drawingml/2006/main">
-            <a:off x="6705600" y="2289810"/>
+          <p:cNvPr id="11" name="method-MySQL">
+            <a:extLst xmlns:a="http://schemas.openxmlformats.org/drawingml/2006/main">
+              <a:ext uri="{FF2B5EF4-FFF2-40B4-BE49-F238E27FC236}">
+                <a16:creationId xmlns:a16="http://schemas.microsoft.com/office/drawing/2014/main" id="{76830C4A-D9D8-4A51-9BB9-8C88F6335DF0}"/>
+              </a:ext>
+            </a:extLst>
+          </p:cNvPr>
+          <p:cNvSpPr>
+            <a:spLocks xmlns:a="http://schemas.openxmlformats.org/drawingml/2006/main" noGrp="1"/>
+          </p:cNvSpPr>
+          <p:nvPr/>
+        </p:nvSpPr>
+        <p:spPr>
+          <a:xfrm xmlns:a="http://schemas.openxmlformats.org/drawingml/2006/main">
+            <a:off x="12496800" y="2038350"/>
             <a:ext cx="4876800" cy="1314450"/>
           </a:xfrm>
           <a:prstGeom xmlns:a="http://schemas.openxmlformats.org/drawingml/2006/main" prst="roundRect">
@@ -2934,21 +3098,21 @@
       </p:sp>
       <p:sp>
         <p:nvSpPr>
-          <p:cNvPr id="8" name="">
-            <a:extLst xmlns:a="http://schemas.openxmlformats.org/drawingml/2006/main">
-              <a:ext uri="{FF2B5EF4-FFF2-40B4-BE49-F238E27FC236}">
-                <a16:creationId xmlns:a16="http://schemas.microsoft.com/office/drawing/2014/main" id="{36E5CA5C-C3CB-4770-B01E-A50840549DC7}"/>
-              </a:ext>
-            </a:extLst>
-          </p:cNvPr>
-          <p:cNvSpPr>
-            <a:spLocks xmlns:a="http://schemas.openxmlformats.org/drawingml/2006/main" noGrp="1"/>
-          </p:cNvSpPr>
-          <p:nvPr/>
-        </p:nvSpPr>
-        <p:spPr>
-          <a:xfrm xmlns:a="http://schemas.openxmlformats.org/drawingml/2006/main">
-            <a:off x="6972300" y="2495550"/>
+          <p:cNvPr id="12" name="">
+            <a:extLst xmlns:a="http://schemas.openxmlformats.org/drawingml/2006/main">
+              <a:ext uri="{FF2B5EF4-FFF2-40B4-BE49-F238E27FC236}">
+                <a16:creationId xmlns:a16="http://schemas.microsoft.com/office/drawing/2014/main" id="{6DE5007C-B177-452C-8CFE-159887699F2B}"/>
+              </a:ext>
+            </a:extLst>
+          </p:cNvPr>
+          <p:cNvSpPr>
+            <a:spLocks xmlns:a="http://schemas.openxmlformats.org/drawingml/2006/main" noGrp="1"/>
+          </p:cNvSpPr>
+          <p:nvPr/>
+        </p:nvSpPr>
+        <p:spPr>
+          <a:xfrm xmlns:a="http://schemas.openxmlformats.org/drawingml/2006/main">
+            <a:off x="12763500" y="2247900"/>
             <a:ext cx="4343400" cy="323850"/>
           </a:xfrm>
           <a:prstGeom xmlns:a="http://schemas.openxmlformats.org/drawingml/2006/main" prst="rect">
@@ -2962,38 +3126,38 @@
             <a:pPr>
               <a:defRPr sz="2100" b="1">
                 <a:solidFill>
-                  <a:srgbClr val="115E59"/>
+                  <a:srgbClr val="16202A"/>
                 </a:solidFill>
               </a:defRPr>
             </a:pPr>
             <a:r>
               <a:rPr sz="2100" b="1">
                 <a:solidFill>
-                  <a:srgbClr val="115E59"/>
-                </a:solidFill>
-              </a:rPr>
-              <a:t>Apache + PHP</a:t>
-            </a:r>
-          </a:p>
-        </p:txBody>
-      </p:sp>
-      <p:sp>
-        <p:nvSpPr>
-          <p:cNvPr id="9" name="">
-            <a:extLst xmlns:a="http://schemas.openxmlformats.org/drawingml/2006/main">
-              <a:ext uri="{FF2B5EF4-FFF2-40B4-BE49-F238E27FC236}">
-                <a16:creationId xmlns:a16="http://schemas.microsoft.com/office/drawing/2014/main" id="{B04EDF2C-98FD-45AA-BAAD-363464C7686F}"/>
-              </a:ext>
-            </a:extLst>
-          </p:cNvPr>
-          <p:cNvSpPr>
-            <a:spLocks xmlns:a="http://schemas.openxmlformats.org/drawingml/2006/main" noGrp="1"/>
-          </p:cNvSpPr>
-          <p:nvPr/>
-        </p:nvSpPr>
-        <p:spPr>
-          <a:xfrm xmlns:a="http://schemas.openxmlformats.org/drawingml/2006/main">
-            <a:off x="6972300" y="2914650"/>
+                  <a:srgbClr val="16202A"/>
+                </a:solidFill>
+              </a:rPr>
+              <a:t>MySQL</a:t>
+            </a:r>
+          </a:p>
+        </p:txBody>
+      </p:sp>
+      <p:sp>
+        <p:nvSpPr>
+          <p:cNvPr id="13" name="">
+            <a:extLst xmlns:a="http://schemas.openxmlformats.org/drawingml/2006/main">
+              <a:ext uri="{FF2B5EF4-FFF2-40B4-BE49-F238E27FC236}">
+                <a16:creationId xmlns:a16="http://schemas.microsoft.com/office/drawing/2014/main" id="{4373CCCD-669A-44C5-BC06-9697654E704C}"/>
+              </a:ext>
+            </a:extLst>
+          </p:cNvPr>
+          <p:cNvSpPr>
+            <a:spLocks xmlns:a="http://schemas.openxmlformats.org/drawingml/2006/main" noGrp="1"/>
+          </p:cNvSpPr>
+          <p:nvPr/>
+        </p:nvSpPr>
+        <p:spPr>
+          <a:xfrm xmlns:a="http://schemas.openxmlformats.org/drawingml/2006/main">
+            <a:off x="12763500" y="2667000"/>
             <a:ext cx="4343400" cy="495300"/>
           </a:xfrm>
           <a:prstGeom xmlns:a="http://schemas.openxmlformats.org/drawingml/2006/main" prst="rect">
@@ -3017,170 +3181,6 @@
                   <a:srgbClr val="16202A"/>
                 </a:solidFill>
               </a:rPr>
-              <a:t>Redirect HTTP ke HTTPS, autentikasi, dan validasi panjang input.</a:t>
-            </a:r>
-          </a:p>
-        </p:txBody>
-      </p:sp>
-      <p:sp>
-        <p:nvSpPr>
-          <p:cNvPr id="10" name="">
-            <a:extLst xmlns:a="http://schemas.openxmlformats.org/drawingml/2006/main">
-              <a:ext uri="{FF2B5EF4-FFF2-40B4-BE49-F238E27FC236}">
-                <a16:creationId xmlns:a16="http://schemas.microsoft.com/office/drawing/2014/main" id="{7A407B29-B12A-4ADD-B041-6F426A4E7654}"/>
-              </a:ext>
-            </a:extLst>
-          </p:cNvPr>
-          <p:cNvSpPr>
-            <a:spLocks xmlns:a="http://schemas.openxmlformats.org/drawingml/2006/main" noGrp="1"/>
-          </p:cNvSpPr>
-          <p:nvPr/>
-        </p:nvSpPr>
-        <p:spPr>
-          <a:xfrm xmlns:a="http://schemas.openxmlformats.org/drawingml/2006/main">
-            <a:off x="11753850" y="2286000"/>
-            <a:ext cx="571500" cy="514350"/>
-          </a:xfrm>
-          <a:prstGeom xmlns:a="http://schemas.openxmlformats.org/drawingml/2006/main" prst="rect">
-            <a:avLst/>
-          </a:prstGeom>
-        </p:spPr>
-        <p:txBody>
-          <a:bodyPr xmlns:a="http://schemas.openxmlformats.org/drawingml/2006/main" lIns="0" tIns="0" rIns="0" bIns="0"/>
-          <a:lstStyle xmlns:a="http://schemas.openxmlformats.org/drawingml/2006/main"/>
-          <a:p xmlns:a="http://schemas.openxmlformats.org/drawingml/2006/main">
-            <a:pPr>
-              <a:defRPr sz="3300" b="1">
-                <a:solidFill>
-                  <a:srgbClr val="0F766E"/>
-                </a:solidFill>
-              </a:defRPr>
-            </a:pPr>
-            <a:r>
-              <a:rPr sz="3300" b="1">
-                <a:solidFill>
-                  <a:srgbClr val="0F766E"/>
-                </a:solidFill>
-              </a:rPr>
-              <a:t>-&gt;</a:t>
-            </a:r>
-          </a:p>
-        </p:txBody>
-      </p:sp>
-      <p:sp>
-        <p:nvSpPr>
-          <p:cNvPr id="11" name="method-MySQL">
-            <a:extLst xmlns:a="http://schemas.openxmlformats.org/drawingml/2006/main">
-              <a:ext uri="{FF2B5EF4-FFF2-40B4-BE49-F238E27FC236}">
-                <a16:creationId xmlns:a16="http://schemas.microsoft.com/office/drawing/2014/main" id="{5DA29511-3FFB-47B8-ACCD-F4C4463F3C59}"/>
-              </a:ext>
-            </a:extLst>
-          </p:cNvPr>
-          <p:cNvSpPr>
-            <a:spLocks xmlns:a="http://schemas.openxmlformats.org/drawingml/2006/main" noGrp="1"/>
-          </p:cNvSpPr>
-          <p:nvPr/>
-        </p:nvSpPr>
-        <p:spPr>
-          <a:xfrm xmlns:a="http://schemas.openxmlformats.org/drawingml/2006/main">
-            <a:off x="12496800" y="2289810"/>
-            <a:ext cx="4876800" cy="1314450"/>
-          </a:xfrm>
-          <a:prstGeom xmlns:a="http://schemas.openxmlformats.org/drawingml/2006/main" prst="roundRect">
-            <a:avLst>
-              <a:gd name="adj" fmla="val 5797"/>
-            </a:avLst>
-          </a:prstGeom>
-          <a:solidFill xmlns:a="http://schemas.openxmlformats.org/drawingml/2006/main">
-            <a:srgbClr val="FFFFFF"/>
-          </a:solidFill>
-        </p:spPr>
-      </p:sp>
-      <p:sp>
-        <p:nvSpPr>
-          <p:cNvPr id="12" name="">
-            <a:extLst xmlns:a="http://schemas.openxmlformats.org/drawingml/2006/main">
-              <a:ext uri="{FF2B5EF4-FFF2-40B4-BE49-F238E27FC236}">
-                <a16:creationId xmlns:a16="http://schemas.microsoft.com/office/drawing/2014/main" id="{2E40ED8C-2B9F-4054-B43C-4DF52C338467}"/>
-              </a:ext>
-            </a:extLst>
-          </p:cNvPr>
-          <p:cNvSpPr>
-            <a:spLocks xmlns:a="http://schemas.openxmlformats.org/drawingml/2006/main" noGrp="1"/>
-          </p:cNvSpPr>
-          <p:nvPr/>
-        </p:nvSpPr>
-        <p:spPr>
-          <a:xfrm xmlns:a="http://schemas.openxmlformats.org/drawingml/2006/main">
-            <a:off x="12763500" y="2495550"/>
-            <a:ext cx="4343400" cy="323850"/>
-          </a:xfrm>
-          <a:prstGeom xmlns:a="http://schemas.openxmlformats.org/drawingml/2006/main" prst="rect">
-            <a:avLst/>
-          </a:prstGeom>
-        </p:spPr>
-        <p:txBody>
-          <a:bodyPr xmlns:a="http://schemas.openxmlformats.org/drawingml/2006/main" lIns="0" tIns="0" rIns="0" bIns="0"/>
-          <a:lstStyle xmlns:a="http://schemas.openxmlformats.org/drawingml/2006/main"/>
-          <a:p xmlns:a="http://schemas.openxmlformats.org/drawingml/2006/main">
-            <a:pPr>
-              <a:defRPr sz="2100" b="1">
-                <a:solidFill>
-                  <a:srgbClr val="16202A"/>
-                </a:solidFill>
-              </a:defRPr>
-            </a:pPr>
-            <a:r>
-              <a:rPr sz="2100" b="1">
-                <a:solidFill>
-                  <a:srgbClr val="16202A"/>
-                </a:solidFill>
-              </a:rPr>
-              <a:t>MySQL</a:t>
-            </a:r>
-          </a:p>
-        </p:txBody>
-      </p:sp>
-      <p:sp>
-        <p:nvSpPr>
-          <p:cNvPr id="13" name="">
-            <a:extLst xmlns:a="http://schemas.openxmlformats.org/drawingml/2006/main">
-              <a:ext uri="{FF2B5EF4-FFF2-40B4-BE49-F238E27FC236}">
-                <a16:creationId xmlns:a16="http://schemas.microsoft.com/office/drawing/2014/main" id="{EA1B7A76-2DC4-406B-A111-6FC8C746B6AA}"/>
-              </a:ext>
-            </a:extLst>
-          </p:cNvPr>
-          <p:cNvSpPr>
-            <a:spLocks xmlns:a="http://schemas.openxmlformats.org/drawingml/2006/main" noGrp="1"/>
-          </p:cNvSpPr>
-          <p:nvPr/>
-        </p:nvSpPr>
-        <p:spPr>
-          <a:xfrm xmlns:a="http://schemas.openxmlformats.org/drawingml/2006/main">
-            <a:off x="12763500" y="2914650"/>
-            <a:ext cx="4343400" cy="495300"/>
-          </a:xfrm>
-          <a:prstGeom xmlns:a="http://schemas.openxmlformats.org/drawingml/2006/main" prst="rect">
-            <a:avLst/>
-          </a:prstGeom>
-        </p:spPr>
-        <p:txBody>
-          <a:bodyPr xmlns:a="http://schemas.openxmlformats.org/drawingml/2006/main" lIns="0" tIns="0" rIns="0" bIns="0"/>
-          <a:lstStyle xmlns:a="http://schemas.openxmlformats.org/drawingml/2006/main"/>
-          <a:p xmlns:a="http://schemas.openxmlformats.org/drawingml/2006/main">
-            <a:pPr>
-              <a:defRPr sz="1575">
-                <a:solidFill>
-                  <a:srgbClr val="16202A"/>
-                </a:solidFill>
-              </a:defRPr>
-            </a:pPr>
-            <a:r>
-              <a:rPr sz="1575">
-                <a:solidFill>
-                  <a:srgbClr val="16202A"/>
-                </a:solidFill>
-              </a:rPr>
               <a:t>Menyimpan tabel users dan comments di network Docker kelas C.</a:t>
             </a:r>
           </a:p>
@@ -3191,18 +3191,18 @@
           <p:cNvPr id="14" name="network-note">
             <a:extLst xmlns:a="http://schemas.openxmlformats.org/drawingml/2006/main">
               <a:ext uri="{FF2B5EF4-FFF2-40B4-BE49-F238E27FC236}">
-                <a16:creationId xmlns:a16="http://schemas.microsoft.com/office/drawing/2014/main" id="{A56FFEC2-21E8-45AC-9C59-65DCADE3A1F8}"/>
-              </a:ext>
-            </a:extLst>
-          </p:cNvPr>
-          <p:cNvSpPr>
-            <a:spLocks xmlns:a="http://schemas.openxmlformats.org/drawingml/2006/main" noGrp="1"/>
-          </p:cNvSpPr>
-          <p:nvPr/>
-        </p:nvSpPr>
-        <p:spPr>
-          <a:xfrm xmlns:a="http://schemas.openxmlformats.org/drawingml/2006/main">
-            <a:off x="914400" y="3905250"/>
+                <a16:creationId xmlns:a16="http://schemas.microsoft.com/office/drawing/2014/main" id="{F0C4340D-796F-4F01-AA32-72928FD05C8A}"/>
+              </a:ext>
+            </a:extLst>
+          </p:cNvPr>
+          <p:cNvSpPr>
+            <a:spLocks xmlns:a="http://schemas.openxmlformats.org/drawingml/2006/main" noGrp="1"/>
+          </p:cNvSpPr>
+          <p:nvPr/>
+        </p:nvSpPr>
+        <p:spPr>
+          <a:xfrm xmlns:a="http://schemas.openxmlformats.org/drawingml/2006/main">
+            <a:off x="914400" y="3657600"/>
             <a:ext cx="16459200" cy="285750"/>
           </a:xfrm>
           <a:prstGeom xmlns:a="http://schemas.openxmlformats.org/drawingml/2006/main" prst="rect">
@@ -3226,7 +3226,7 @@
                   <a:srgbClr val="5E6B78"/>
                 </a:solidFill>
               </a:rPr>
-              <a:t>Docker network: 192.168.240.0/24 | web: 192.168.240.10 | db: 192.168.240.11</a:t>
+              <a:t>Docker network: 192.168.219.0/24 | web: 192.168.219.219 | db: 192.168.219.220</a:t>
             </a:r>
           </a:p>
         </p:txBody>
@@ -3236,18 +3236,18 @@
           <p:cNvPr id="15" name="footer">
             <a:extLst xmlns:a="http://schemas.openxmlformats.org/drawingml/2006/main">
               <a:ext uri="{FF2B5EF4-FFF2-40B4-BE49-F238E27FC236}">
-                <a16:creationId xmlns:a16="http://schemas.microsoft.com/office/drawing/2014/main" id="{8E8CE3C4-3AF0-4599-BB69-D470ADBA74BC}"/>
-              </a:ext>
-            </a:extLst>
-          </p:cNvPr>
-          <p:cNvSpPr>
-            <a:spLocks xmlns:a="http://schemas.openxmlformats.org/drawingml/2006/main" noGrp="1"/>
-          </p:cNvSpPr>
-          <p:nvPr/>
-        </p:nvSpPr>
-        <p:spPr>
-          <a:xfrm xmlns:a="http://schemas.openxmlformats.org/drawingml/2006/main">
-            <a:off x="914400" y="4495800"/>
+                <a16:creationId xmlns:a16="http://schemas.microsoft.com/office/drawing/2014/main" id="{3D79A6A0-5230-4F60-B66B-1F042EEFD748}"/>
+              </a:ext>
+            </a:extLst>
+          </p:cNvPr>
+          <p:cNvSpPr>
+            <a:spLocks xmlns:a="http://schemas.openxmlformats.org/drawingml/2006/main" noGrp="1"/>
+          </p:cNvSpPr>
+          <p:nvPr/>
+        </p:nvSpPr>
+        <p:spPr>
+          <a:xfrm xmlns:a="http://schemas.openxmlformats.org/drawingml/2006/main">
+            <a:off x="914400" y="4229100"/>
             <a:ext cx="16459200" cy="209550"/>
           </a:xfrm>
           <a:prstGeom xmlns:a="http://schemas.openxmlformats.org/drawingml/2006/main" prst="rect">
@@ -3271,7 +3271,7 @@
                   <a:srgbClr val="5E6B78"/>
                 </a:solidFill>
               </a:rPr>
-              <a:t>CLO 2 Secure Comments | PHP, Apache, MySQL, Docker</a:t>
+              <a:t>CLO 2 Non-Secure Comments | PHP, Apache, MySQL, Docker</a:t>
             </a:r>
           </a:p>
         </p:txBody>
@@ -3279,7 +3279,7 @@
     </p:spTree>
     <p:extLst>
       <p:ext uri="{BB962C8B-B14F-4D97-AF65-F5344CB8AC3E}">
-        <p14:creationId xmlns:p14="http://schemas.microsoft.com/office/powerpoint/2010/main" val="1892259710"/>
+        <p14:creationId xmlns:p14="http://schemas.microsoft.com/office/powerpoint/2010/main" val="608279324"/>
       </p:ext>
     </p:extLst>
   </p:cSld>
@@ -3303,7 +3303,7 @@
           <p:cNvPr id="1" name="slide-title">
             <a:extLst xmlns:a="http://schemas.openxmlformats.org/drawingml/2006/main">
               <a:ext uri="{FF2B5EF4-FFF2-40B4-BE49-F238E27FC236}">
-                <a16:creationId xmlns:a16="http://schemas.microsoft.com/office/drawing/2014/main" id="{E8D02A8C-514C-4AD1-90D5-DA17587AFDB2}"/>
+                <a16:creationId xmlns:a16="http://schemas.microsoft.com/office/drawing/2014/main" id="{AFFE35B3-AD29-49E0-AB07-FF3226D2B163}"/>
               </a:ext>
             </a:extLst>
           </p:cNvPr>
@@ -3338,7 +3338,7 @@
                   <a:srgbClr val="16202A"/>
                 </a:solidFill>
               </a:rPr>
-              <a:t>Metode mitigasi target 80</a:t>
+              <a:t>Bukti non-secure</a:t>
             </a:r>
           </a:p>
         </p:txBody>
@@ -3348,7 +3348,7 @@
           <p:cNvPr id="2" name="slide-subtitle">
             <a:extLst xmlns:a="http://schemas.openxmlformats.org/drawingml/2006/main">
               <a:ext uri="{FF2B5EF4-FFF2-40B4-BE49-F238E27FC236}">
-                <a16:creationId xmlns:a16="http://schemas.microsoft.com/office/drawing/2014/main" id="{DF6AE913-35AE-45BD-806B-5B90E9D37F8F}"/>
+                <a16:creationId xmlns:a16="http://schemas.microsoft.com/office/drawing/2014/main" id="{9D37E192-0C8E-4617-9864-BC071489240C}"/>
               </a:ext>
             </a:extLst>
           </p:cNvPr>
@@ -3360,7 +3360,7 @@
         <p:spPr>
           <a:xfrm xmlns:a="http://schemas.openxmlformats.org/drawingml/2006/main">
             <a:off x="914400" y="1485900"/>
-            <a:ext cx="6172200" cy="514350"/>
+            <a:ext cx="4419600" cy="514350"/>
           </a:xfrm>
           <a:prstGeom xmlns:a="http://schemas.openxmlformats.org/drawingml/2006/main" prst="rect">
             <a:avLst/>
@@ -3383,7 +3383,7 @@
                   <a:srgbClr val="5E6B78"/>
                 </a:solidFill>
               </a:rPr>
-              <a:t>Scope berhenti sampai buffer overflow/input berlebih sesuai target nilai.</a:t>
+              <a:t>Setiap demo menunjukkan kontrol yang belum aktif.</a:t>
             </a:r>
           </a:p>
         </p:txBody>
@@ -3393,7 +3393,7 @@
           <p:cNvPr id="3" name="bullet-1">
             <a:extLst xmlns:a="http://schemas.openxmlformats.org/drawingml/2006/main">
               <a:ext uri="{FF2B5EF4-FFF2-40B4-BE49-F238E27FC236}">
-                <a16:creationId xmlns:a16="http://schemas.microsoft.com/office/drawing/2014/main" id="{74A3CC07-B5F5-4676-B231-8E980CFA4618}"/>
+                <a16:creationId xmlns:a16="http://schemas.microsoft.com/office/drawing/2014/main" id="{E66D854A-D683-452F-AF07-462720F5ED8A}"/>
               </a:ext>
             </a:extLst>
           </p:cNvPr>
@@ -3405,7 +3405,7 @@
         <p:spPr>
           <a:xfrm xmlns:a="http://schemas.openxmlformats.org/drawingml/2006/main">
             <a:off x="914400" y="2286000"/>
-            <a:ext cx="8020050" cy="647700"/>
+            <a:ext cx="7905750" cy="323850"/>
           </a:xfrm>
           <a:prstGeom xmlns:a="http://schemas.openxmlformats.org/drawingml/2006/main" prst="rect">
             <a:avLst/>
@@ -3428,7 +3428,7 @@
                   <a:srgbClr val="16202A"/>
                 </a:solidFill>
               </a:rPr>
-              <a:t>1. SSL/TLS: HTTP diarahkan ke HTTPS dan sertifikat memakai RSA 2048-bit.</a:t>
+              <a:t>1. Password admin tampil plaintext sebagai Admin@240! di admin panel.</a:t>
             </a:r>
           </a:p>
         </p:txBody>
@@ -3438,19 +3438,19 @@
           <p:cNvPr id="4" name="bullet-2">
             <a:extLst xmlns:a="http://schemas.openxmlformats.org/drawingml/2006/main">
               <a:ext uri="{FF2B5EF4-FFF2-40B4-BE49-F238E27FC236}">
-                <a16:creationId xmlns:a16="http://schemas.microsoft.com/office/drawing/2014/main" id="{CFFF2CD0-751B-4763-B31A-4FB4F860FF23}"/>
-              </a:ext>
-            </a:extLst>
-          </p:cNvPr>
-          <p:cNvSpPr>
-            <a:spLocks xmlns:a="http://schemas.openxmlformats.org/drawingml/2006/main" noGrp="1"/>
-          </p:cNvSpPr>
-          <p:nvPr/>
-        </p:nvSpPr>
-        <p:spPr>
-          <a:xfrm xmlns:a="http://schemas.openxmlformats.org/drawingml/2006/main">
-            <a:off x="914400" y="3105150"/>
-            <a:ext cx="8572500" cy="323850"/>
+                <a16:creationId xmlns:a16="http://schemas.microsoft.com/office/drawing/2014/main" id="{226D02EA-8081-4705-AB56-BB00F9F38157}"/>
+              </a:ext>
+            </a:extLst>
+          </p:cNvPr>
+          <p:cNvSpPr>
+            <a:spLocks xmlns:a="http://schemas.openxmlformats.org/drawingml/2006/main" noGrp="1"/>
+          </p:cNvSpPr>
+          <p:nvPr/>
+        </p:nvSpPr>
+        <p:spPr>
+          <a:xfrm xmlns:a="http://schemas.openxmlformats.org/drawingml/2006/main">
+            <a:off x="914400" y="2781300"/>
+            <a:ext cx="6629400" cy="323850"/>
           </a:xfrm>
           <a:prstGeom xmlns:a="http://schemas.openxmlformats.org/drawingml/2006/main" prst="rect">
             <a:avLst/>
@@ -3473,7 +3473,7 @@
                   <a:srgbClr val="16202A"/>
                 </a:solidFill>
               </a:rPr>
-              <a:t>2. Hash + salt: password admin tersimpan sebagai bcrypt hash, bukan plaintext.</a:t>
+              <a:t>2. Payload SQL injection di username berhasil melewati login.</a:t>
             </a:r>
           </a:p>
         </p:txBody>
@@ -3483,19 +3483,19 @@
           <p:cNvPr id="5" name="bullet-3">
             <a:extLst xmlns:a="http://schemas.openxmlformats.org/drawingml/2006/main">
               <a:ext uri="{FF2B5EF4-FFF2-40B4-BE49-F238E27FC236}">
-                <a16:creationId xmlns:a16="http://schemas.microsoft.com/office/drawing/2014/main" id="{CD45AD73-FB82-4EE4-BC6C-A1FEEDBE9ACC}"/>
-              </a:ext>
-            </a:extLst>
-          </p:cNvPr>
-          <p:cNvSpPr>
-            <a:spLocks xmlns:a="http://schemas.openxmlformats.org/drawingml/2006/main" noGrp="1"/>
-          </p:cNvSpPr>
-          <p:nvPr/>
-        </p:nvSpPr>
-        <p:spPr>
-          <a:xfrm xmlns:a="http://schemas.openxmlformats.org/drawingml/2006/main">
-            <a:off x="914400" y="3600450"/>
-            <a:ext cx="7848600" cy="647700"/>
+                <a16:creationId xmlns:a16="http://schemas.microsoft.com/office/drawing/2014/main" id="{7F00034D-10B1-40B2-9F15-E7E3130114AD}"/>
+              </a:ext>
+            </a:extLst>
+          </p:cNvPr>
+          <p:cNvSpPr>
+            <a:spLocks xmlns:a="http://schemas.openxmlformats.org/drawingml/2006/main" noGrp="1"/>
+          </p:cNvSpPr>
+          <p:nvPr/>
+        </p:nvSpPr>
+        <p:spPr>
+          <a:xfrm xmlns:a="http://schemas.openxmlformats.org/drawingml/2006/main">
+            <a:off x="914400" y="3276600"/>
+            <a:ext cx="5410200" cy="647700"/>
           </a:xfrm>
           <a:prstGeom xmlns:a="http://schemas.openxmlformats.org/drawingml/2006/main" prst="rect">
             <a:avLst/>
@@ -3518,7 +3518,7 @@
                   <a:srgbClr val="16202A"/>
                 </a:solidFill>
               </a:rPr>
-              <a:t>3. Buffer overflow/input abuse: komentar lebih dari 500 karakter ditolak.</a:t>
+              <a:t>3. Payload XSS pada komentar dieksekusi browser.</a:t>
             </a:r>
           </a:p>
         </p:txBody>
@@ -3528,19 +3528,19 @@
           <p:cNvPr id="6" name="bullet-4">
             <a:extLst xmlns:a="http://schemas.openxmlformats.org/drawingml/2006/main">
               <a:ext uri="{FF2B5EF4-FFF2-40B4-BE49-F238E27FC236}">
-                <a16:creationId xmlns:a16="http://schemas.microsoft.com/office/drawing/2014/main" id="{AC7D88DC-CF3B-4AE3-B006-63D59D518D85}"/>
-              </a:ext>
-            </a:extLst>
-          </p:cNvPr>
-          <p:cNvSpPr>
-            <a:spLocks xmlns:a="http://schemas.openxmlformats.org/drawingml/2006/main" noGrp="1"/>
-          </p:cNvSpPr>
-          <p:nvPr/>
-        </p:nvSpPr>
-        <p:spPr>
-          <a:xfrm xmlns:a="http://schemas.openxmlformats.org/drawingml/2006/main">
-            <a:off x="914400" y="4400550"/>
-            <a:ext cx="8458200" cy="323850"/>
+                <a16:creationId xmlns:a16="http://schemas.microsoft.com/office/drawing/2014/main" id="{DCFFC928-F081-4A35-BBEA-23EBD0850429}"/>
+              </a:ext>
+            </a:extLst>
+          </p:cNvPr>
+          <p:cNvSpPr>
+            <a:spLocks xmlns:a="http://schemas.openxmlformats.org/drawingml/2006/main" noGrp="1"/>
+          </p:cNvSpPr>
+          <p:nvPr/>
+        </p:nvSpPr>
+        <p:spPr>
+          <a:xfrm xmlns:a="http://schemas.openxmlformats.org/drawingml/2006/main">
+            <a:off x="914400" y="4076700"/>
+            <a:ext cx="5676900" cy="647700"/>
           </a:xfrm>
           <a:prstGeom xmlns:a="http://schemas.openxmlformats.org/drawingml/2006/main" prst="rect">
             <a:avLst/>
@@ -3563,7 +3563,7 @@
                   <a:srgbClr val="16202A"/>
                 </a:solidFill>
               </a:rPr>
-              <a:t>4. Admin panel: hash password ditampilkan sebagai bukti penyimpanan aman.</a:t>
+              <a:t>4. Komentar lebih dari 500 karakter tetap tersimpan.</a:t>
             </a:r>
           </a:p>
         </p:txBody>
@@ -3573,7 +3573,7 @@
           <p:cNvPr id="7" name="footer">
             <a:extLst xmlns:a="http://schemas.openxmlformats.org/drawingml/2006/main">
               <a:ext uri="{FF2B5EF4-FFF2-40B4-BE49-F238E27FC236}">
-                <a16:creationId xmlns:a16="http://schemas.microsoft.com/office/drawing/2014/main" id="{0F51693D-0EF4-40D8-AAD8-BC844A564596}"/>
+                <a16:creationId xmlns:a16="http://schemas.microsoft.com/office/drawing/2014/main" id="{13ADD15A-1BF1-4684-82A0-4F4538DBAC2B}"/>
               </a:ext>
             </a:extLst>
           </p:cNvPr>
@@ -3608,7 +3608,7 @@
                   <a:srgbClr val="5E6B78"/>
                 </a:solidFill>
               </a:rPr>
-              <a:t>CLO 2 Secure Comments | PHP, Apache, MySQL, Docker</a:t>
+              <a:t>CLO 2 Non-Secure Comments | PHP, Apache, MySQL, Docker</a:t>
             </a:r>
           </a:p>
         </p:txBody>
@@ -3616,7 +3616,7 @@
     </p:spTree>
     <p:extLst>
       <p:ext uri="{BB962C8B-B14F-4D97-AF65-F5344CB8AC3E}">
-        <p14:creationId xmlns:p14="http://schemas.microsoft.com/office/powerpoint/2010/main" val="2026588714"/>
+        <p14:creationId xmlns:p14="http://schemas.microsoft.com/office/powerpoint/2010/main" val="1456624519"/>
       </p:ext>
     </p:extLst>
   </p:cSld>
@@ -3640,7 +3640,7 @@
           <p:cNvPr id="1" name="slide-title">
             <a:extLst xmlns:a="http://schemas.openxmlformats.org/drawingml/2006/main">
               <a:ext uri="{FF2B5EF4-FFF2-40B4-BE49-F238E27FC236}">
-                <a16:creationId xmlns:a16="http://schemas.microsoft.com/office/drawing/2014/main" id="{700477CE-EAE7-4F0C-93FD-69C3090B8BE6}"/>
+                <a16:creationId xmlns:a16="http://schemas.microsoft.com/office/drawing/2014/main" id="{9AC14E3C-D852-4487-B90D-F1CA6B0EE9E2}"/>
               </a:ext>
             </a:extLst>
           </p:cNvPr>
@@ -3675,7 +3675,7 @@
                   <a:srgbClr val="16202A"/>
                 </a:solidFill>
               </a:rPr>
-              <a:t>Demo uji target</a:t>
+              <a:t>Demo uji rentan</a:t>
             </a:r>
           </a:p>
         </p:txBody>
@@ -3685,7 +3685,7 @@
           <p:cNvPr id="2" name="slide-subtitle">
             <a:extLst xmlns:a="http://schemas.openxmlformats.org/drawingml/2006/main">
               <a:ext uri="{FF2B5EF4-FFF2-40B4-BE49-F238E27FC236}">
-                <a16:creationId xmlns:a16="http://schemas.microsoft.com/office/drawing/2014/main" id="{024BFA81-F39D-4724-B244-40F2BC037C5D}"/>
+                <a16:creationId xmlns:a16="http://schemas.microsoft.com/office/drawing/2014/main" id="{36B7193C-2667-41F3-9B32-112022F19520}"/>
               </a:ext>
             </a:extLst>
           </p:cNvPr>
@@ -3697,7 +3697,7 @@
         <p:spPr>
           <a:xfrm xmlns:a="http://schemas.openxmlformats.org/drawingml/2006/main">
             <a:off x="914400" y="1485900"/>
-            <a:ext cx="4743450" cy="514350"/>
+            <a:ext cx="4610100" cy="514350"/>
           </a:xfrm>
           <a:prstGeom xmlns:a="http://schemas.openxmlformats.org/drawingml/2006/main" prst="rect">
             <a:avLst/>
@@ -3720,7 +3720,7 @@
                   <a:srgbClr val="5E6B78"/>
                 </a:solidFill>
               </a:rPr>
-              <a:t>Urutan demo difokuskan pada tiga kontrol yang diklaim.</a:t>
+              <a:t>Urutan demo difokuskan pada kontrol yang dimatikan.</a:t>
             </a:r>
           </a:p>
         </p:txBody>
@@ -3730,7 +3730,7 @@
           <p:cNvPr id="3" name="bullet-1">
             <a:extLst xmlns:a="http://schemas.openxmlformats.org/drawingml/2006/main">
               <a:ext uri="{FF2B5EF4-FFF2-40B4-BE49-F238E27FC236}">
-                <a16:creationId xmlns:a16="http://schemas.microsoft.com/office/drawing/2014/main" id="{11059C8C-2ECC-4C9D-8A68-B696CB54A683}"/>
+                <a16:creationId xmlns:a16="http://schemas.microsoft.com/office/drawing/2014/main" id="{FCCD9D2E-B2D4-4390-AF22-F4AEAE163056}"/>
               </a:ext>
             </a:extLst>
           </p:cNvPr>
@@ -3742,7 +3742,7 @@
         <p:spPr>
           <a:xfrm xmlns:a="http://schemas.openxmlformats.org/drawingml/2006/main">
             <a:off x="914400" y="2286000"/>
-            <a:ext cx="5238750" cy="647700"/>
+            <a:ext cx="6076950" cy="647700"/>
           </a:xfrm>
           <a:prstGeom xmlns:a="http://schemas.openxmlformats.org/drawingml/2006/main" prst="rect">
             <a:avLst/>
@@ -3765,7 +3765,7 @@
                   <a:srgbClr val="16202A"/>
                 </a:solidFill>
               </a:rPr>
-              <a:t>1. Buka HTTPS dan inspeksi sertifikat self-signed.</a:t>
+              <a:t>1. Buka HTTP dan tunjukkan tidak ada redirect otomatis.</a:t>
             </a:r>
           </a:p>
         </p:txBody>
@@ -3775,7 +3775,7 @@
           <p:cNvPr id="4" name="bullet-2">
             <a:extLst xmlns:a="http://schemas.openxmlformats.org/drawingml/2006/main">
               <a:ext uri="{FF2B5EF4-FFF2-40B4-BE49-F238E27FC236}">
-                <a16:creationId xmlns:a16="http://schemas.microsoft.com/office/drawing/2014/main" id="{7EE4C92F-112C-4D98-8272-A39B96C42CEE}"/>
+                <a16:creationId xmlns:a16="http://schemas.microsoft.com/office/drawing/2014/main" id="{A3C31333-806D-4027-8A7A-E5D67D052F81}"/>
               </a:ext>
             </a:extLst>
           </p:cNvPr>
@@ -3787,7 +3787,7 @@
         <p:spPr>
           <a:xfrm xmlns:a="http://schemas.openxmlformats.org/drawingml/2006/main">
             <a:off x="914400" y="3105150"/>
-            <a:ext cx="6629400" cy="647700"/>
+            <a:ext cx="4972050" cy="323850"/>
           </a:xfrm>
           <a:prstGeom xmlns:a="http://schemas.openxmlformats.org/drawingml/2006/main" prst="rect">
             <a:avLst/>
@@ -3810,7 +3810,7 @@
                   <a:srgbClr val="16202A"/>
                 </a:solidFill>
               </a:rPr>
-              <a:t>2. Akses /comment.php tanpa login, lalu login sebagai admin.</a:t>
+              <a:t>2. Login dengan payload username ' OR '1'='1.</a:t>
             </a:r>
           </a:p>
         </p:txBody>
@@ -3820,19 +3820,19 @@
           <p:cNvPr id="5" name="bullet-3">
             <a:extLst xmlns:a="http://schemas.openxmlformats.org/drawingml/2006/main">
               <a:ext uri="{FF2B5EF4-FFF2-40B4-BE49-F238E27FC236}">
-                <a16:creationId xmlns:a16="http://schemas.microsoft.com/office/drawing/2014/main" id="{4108BBD3-2E6A-46ED-AF1C-92AB27F58F50}"/>
-              </a:ext>
-            </a:extLst>
-          </p:cNvPr>
-          <p:cNvSpPr>
-            <a:spLocks xmlns:a="http://schemas.openxmlformats.org/drawingml/2006/main" noGrp="1"/>
-          </p:cNvSpPr>
-          <p:nvPr/>
-        </p:nvSpPr>
-        <p:spPr>
-          <a:xfrm xmlns:a="http://schemas.openxmlformats.org/drawingml/2006/main">
-            <a:off x="914400" y="3905250"/>
-            <a:ext cx="6191250" cy="647700"/>
+                <a16:creationId xmlns:a16="http://schemas.microsoft.com/office/drawing/2014/main" id="{7158D247-FD00-487C-8AC9-C7E49291DC58}"/>
+              </a:ext>
+            </a:extLst>
+          </p:cNvPr>
+          <p:cNvSpPr>
+            <a:spLocks xmlns:a="http://schemas.openxmlformats.org/drawingml/2006/main" noGrp="1"/>
+          </p:cNvSpPr>
+          <p:nvPr/>
+        </p:nvSpPr>
+        <p:spPr>
+          <a:xfrm xmlns:a="http://schemas.openxmlformats.org/drawingml/2006/main">
+            <a:off x="914400" y="3600450"/>
+            <a:ext cx="5905500" cy="323850"/>
           </a:xfrm>
           <a:prstGeom xmlns:a="http://schemas.openxmlformats.org/drawingml/2006/main" prst="rect">
             <a:avLst/>
@@ -3855,7 +3855,7 @@
                   <a:srgbClr val="16202A"/>
                 </a:solidFill>
               </a:rPr>
-              <a:t>3. Buka /admin.php dan tunjukkan kolom password hash.</a:t>
+              <a:t>3. Buka /admin.php dan tunjukkan password plaintext.</a:t>
             </a:r>
           </a:p>
         </p:txBody>
@@ -3865,19 +3865,19 @@
           <p:cNvPr id="6" name="bullet-4">
             <a:extLst xmlns:a="http://schemas.openxmlformats.org/drawingml/2006/main">
               <a:ext uri="{FF2B5EF4-FFF2-40B4-BE49-F238E27FC236}">
-                <a16:creationId xmlns:a16="http://schemas.microsoft.com/office/drawing/2014/main" id="{D557BE80-5C83-4139-BD9A-441BE11F890F}"/>
-              </a:ext>
-            </a:extLst>
-          </p:cNvPr>
-          <p:cNvSpPr>
-            <a:spLocks xmlns:a="http://schemas.openxmlformats.org/drawingml/2006/main" noGrp="1"/>
-          </p:cNvSpPr>
-          <p:nvPr/>
-        </p:nvSpPr>
-        <p:spPr>
-          <a:xfrm xmlns:a="http://schemas.openxmlformats.org/drawingml/2006/main">
-            <a:off x="914400" y="4724400"/>
-            <a:ext cx="5467350" cy="647700"/>
+                <a16:creationId xmlns:a16="http://schemas.microsoft.com/office/drawing/2014/main" id="{A78D870E-0A77-4EC1-A165-0B00C8377651}"/>
+              </a:ext>
+            </a:extLst>
+          </p:cNvPr>
+          <p:cNvSpPr>
+            <a:spLocks xmlns:a="http://schemas.openxmlformats.org/drawingml/2006/main" noGrp="1"/>
+          </p:cNvSpPr>
+          <p:nvPr/>
+        </p:nvSpPr>
+        <p:spPr>
+          <a:xfrm xmlns:a="http://schemas.openxmlformats.org/drawingml/2006/main">
+            <a:off x="914400" y="4076700"/>
+            <a:ext cx="6477000" cy="323850"/>
           </a:xfrm>
           <a:prstGeom xmlns:a="http://schemas.openxmlformats.org/drawingml/2006/main" prst="rect">
             <a:avLst/>
@@ -3900,7 +3900,7 @@
                   <a:srgbClr val="16202A"/>
                 </a:solidFill>
               </a:rPr>
-              <a:t>4. Jelaskan prefix bcrypt $2y$10$ dan segmen salt.</a:t>
+              <a:t>4. Kirim komentar XSS dan komentar lebih dari 500 karakter.</a:t>
             </a:r>
           </a:p>
         </p:txBody>
@@ -3910,19 +3910,19 @@
           <p:cNvPr id="7" name="bullet-5">
             <a:extLst xmlns:a="http://schemas.openxmlformats.org/drawingml/2006/main">
               <a:ext uri="{FF2B5EF4-FFF2-40B4-BE49-F238E27FC236}">
-                <a16:creationId xmlns:a16="http://schemas.microsoft.com/office/drawing/2014/main" id="{7808C57B-590E-4C1C-97E4-B9247F1B247D}"/>
-              </a:ext>
-            </a:extLst>
-          </p:cNvPr>
-          <p:cNvSpPr>
-            <a:spLocks xmlns:a="http://schemas.openxmlformats.org/drawingml/2006/main" noGrp="1"/>
-          </p:cNvSpPr>
-          <p:nvPr/>
-        </p:nvSpPr>
-        <p:spPr>
-          <a:xfrm xmlns:a="http://schemas.openxmlformats.org/drawingml/2006/main">
-            <a:off x="914400" y="5543550"/>
-            <a:ext cx="8001000" cy="323850"/>
+                <a16:creationId xmlns:a16="http://schemas.microsoft.com/office/drawing/2014/main" id="{9BEC412D-5565-483E-936C-EF7532DE91C2}"/>
+              </a:ext>
+            </a:extLst>
+          </p:cNvPr>
+          <p:cNvSpPr>
+            <a:spLocks xmlns:a="http://schemas.openxmlformats.org/drawingml/2006/main" noGrp="1"/>
+          </p:cNvSpPr>
+          <p:nvPr/>
+        </p:nvSpPr>
+        <p:spPr>
+          <a:xfrm xmlns:a="http://schemas.openxmlformats.org/drawingml/2006/main">
+            <a:off x="914400" y="4572000"/>
+            <a:ext cx="5581650" cy="323850"/>
           </a:xfrm>
           <a:prstGeom xmlns:a="http://schemas.openxmlformats.org/drawingml/2006/main" prst="rect">
             <a:avLst/>
@@ -3945,7 +3945,7 @@
                   <a:srgbClr val="16202A"/>
                 </a:solidFill>
               </a:rPr>
-              <a:t>5. Kirim komentar lebih dari 500 karakter dan tunjukkan penolakan server.</a:t>
+              <a:t>5. Bandingkan hasilnya dengan branch secure-login.</a:t>
             </a:r>
           </a:p>
         </p:txBody>
@@ -3955,18 +3955,18 @@
           <p:cNvPr id="8" name="footer">
             <a:extLst xmlns:a="http://schemas.openxmlformats.org/drawingml/2006/main">
               <a:ext uri="{FF2B5EF4-FFF2-40B4-BE49-F238E27FC236}">
-                <a16:creationId xmlns:a16="http://schemas.microsoft.com/office/drawing/2014/main" id="{F90006F6-2030-4532-A479-B1C2ADDA2078}"/>
-              </a:ext>
-            </a:extLst>
-          </p:cNvPr>
-          <p:cNvSpPr>
-            <a:spLocks xmlns:a="http://schemas.openxmlformats.org/drawingml/2006/main" noGrp="1"/>
-          </p:cNvSpPr>
-          <p:nvPr/>
-        </p:nvSpPr>
-        <p:spPr>
-          <a:xfrm xmlns:a="http://schemas.openxmlformats.org/drawingml/2006/main">
-            <a:off x="914400" y="6153150"/>
+                <a16:creationId xmlns:a16="http://schemas.microsoft.com/office/drawing/2014/main" id="{E427087F-0386-44BC-8A7E-B5A5C4DB3191}"/>
+              </a:ext>
+            </a:extLst>
+          </p:cNvPr>
+          <p:cNvSpPr>
+            <a:spLocks xmlns:a="http://schemas.openxmlformats.org/drawingml/2006/main" noGrp="1"/>
+          </p:cNvSpPr>
+          <p:nvPr/>
+        </p:nvSpPr>
+        <p:spPr>
+          <a:xfrm xmlns:a="http://schemas.openxmlformats.org/drawingml/2006/main">
+            <a:off x="914400" y="5200650"/>
             <a:ext cx="16459200" cy="209550"/>
           </a:xfrm>
           <a:prstGeom xmlns:a="http://schemas.openxmlformats.org/drawingml/2006/main" prst="rect">
@@ -3990,7 +3990,7 @@
                   <a:srgbClr val="5E6B78"/>
                 </a:solidFill>
               </a:rPr>
-              <a:t>CLO 2 Secure Comments | PHP, Apache, MySQL, Docker</a:t>
+              <a:t>CLO 2 Non-Secure Comments | PHP, Apache, MySQL, Docker</a:t>
             </a:r>
           </a:p>
         </p:txBody>
@@ -3998,7 +3998,7 @@
     </p:spTree>
     <p:extLst>
       <p:ext uri="{BB962C8B-B14F-4D97-AF65-F5344CB8AC3E}">
-        <p14:creationId xmlns:p14="http://schemas.microsoft.com/office/powerpoint/2010/main" val="1800308421"/>
+        <p14:creationId xmlns:p14="http://schemas.microsoft.com/office/powerpoint/2010/main" val="991715986"/>
       </p:ext>
     </p:extLst>
   </p:cSld>
@@ -4022,7 +4022,7 @@
           <p:cNvPr id="1" name="slide-title">
             <a:extLst xmlns:a="http://schemas.openxmlformats.org/drawingml/2006/main">
               <a:ext uri="{FF2B5EF4-FFF2-40B4-BE49-F238E27FC236}">
-                <a16:creationId xmlns:a16="http://schemas.microsoft.com/office/drawing/2014/main" id="{3DEDC671-A6C1-4820-AE74-473A121BF61F}"/>
+                <a16:creationId xmlns:a16="http://schemas.microsoft.com/office/drawing/2014/main" id="{A47FC3A8-F79B-4261-9101-2D1AED90B394}"/>
               </a:ext>
             </a:extLst>
           </p:cNvPr>
@@ -4067,7 +4067,7 @@
           <p:cNvPr id="2" name="slide-subtitle">
             <a:extLst xmlns:a="http://schemas.openxmlformats.org/drawingml/2006/main">
               <a:ext uri="{FF2B5EF4-FFF2-40B4-BE49-F238E27FC236}">
-                <a16:creationId xmlns:a16="http://schemas.microsoft.com/office/drawing/2014/main" id="{82FDC04A-5EC0-41B7-9017-3B5F48AC7EFD}"/>
+                <a16:creationId xmlns:a16="http://schemas.microsoft.com/office/drawing/2014/main" id="{182FF9B3-A747-44AD-ABB6-7779BB949142}"/>
               </a:ext>
             </a:extLst>
           </p:cNvPr>
@@ -4079,7 +4079,7 @@
         <p:spPr>
           <a:xfrm xmlns:a="http://schemas.openxmlformats.org/drawingml/2006/main">
             <a:off x="914400" y="1485900"/>
-            <a:ext cx="7296150" cy="514350"/>
+            <a:ext cx="5181600" cy="514350"/>
           </a:xfrm>
           <a:prstGeom xmlns:a="http://schemas.openxmlformats.org/drawingml/2006/main" prst="rect">
             <a:avLst/>
@@ -4102,7 +4102,7 @@
                   <a:srgbClr val="5E6B78"/>
                 </a:solidFill>
               </a:rPr>
-              <a:t>Aplikasi memenuhi kontrol minimum proyek dan masih bisa dikembangkan lebih jauh.</a:t>
+              <a:t>Branch ini menunjukkan kondisi sebelum aplikasi diamankan.</a:t>
             </a:r>
           </a:p>
         </p:txBody>
@@ -4112,7 +4112,7 @@
           <p:cNvPr id="3" name="bullet-1">
             <a:extLst xmlns:a="http://schemas.openxmlformats.org/drawingml/2006/main">
               <a:ext uri="{FF2B5EF4-FFF2-40B4-BE49-F238E27FC236}">
-                <a16:creationId xmlns:a16="http://schemas.microsoft.com/office/drawing/2014/main" id="{749657A5-64D9-405A-A7F9-BE2DA349995A}"/>
+                <a16:creationId xmlns:a16="http://schemas.microsoft.com/office/drawing/2014/main" id="{8D9C32F5-C16B-4533-93F9-CCECA65DB521}"/>
               </a:ext>
             </a:extLst>
           </p:cNvPr>
@@ -4124,7 +4124,7 @@
         <p:spPr>
           <a:xfrm xmlns:a="http://schemas.openxmlformats.org/drawingml/2006/main">
             <a:off x="914400" y="2286000"/>
-            <a:ext cx="7239000" cy="323850"/>
+            <a:ext cx="10896600" cy="647700"/>
           </a:xfrm>
           <a:prstGeom xmlns:a="http://schemas.openxmlformats.org/drawingml/2006/main" prst="rect">
             <a:avLst/>
@@ -4147,7 +4147,7 @@
                   <a:srgbClr val="16202A"/>
                 </a:solidFill>
               </a:rPr>
-              <a:t>1. Kontrol target 80 aktif: HTTPS, hash+salt, dan pembatasan input.</a:t>
+              <a:t>1. Risiko utama terlihat: plaintext password, SQL injection, XSS, CSRF, input berlebih, dan role bypass.</a:t>
             </a:r>
           </a:p>
         </p:txBody>
@@ -4157,19 +4157,19 @@
           <p:cNvPr id="4" name="bullet-2">
             <a:extLst xmlns:a="http://schemas.openxmlformats.org/drawingml/2006/main">
               <a:ext uri="{FF2B5EF4-FFF2-40B4-BE49-F238E27FC236}">
-                <a16:creationId xmlns:a16="http://schemas.microsoft.com/office/drawing/2014/main" id="{5E514813-C469-4940-844A-714285BA7C0A}"/>
-              </a:ext>
-            </a:extLst>
-          </p:cNvPr>
-          <p:cNvSpPr>
-            <a:spLocks xmlns:a="http://schemas.openxmlformats.org/drawingml/2006/main" noGrp="1"/>
-          </p:cNvSpPr>
-          <p:nvPr/>
-        </p:nvSpPr>
-        <p:spPr>
-          <a:xfrm xmlns:a="http://schemas.openxmlformats.org/drawingml/2006/main">
-            <a:off x="914400" y="2781300"/>
-            <a:ext cx="9944100" cy="647700"/>
+                <a16:creationId xmlns:a16="http://schemas.microsoft.com/office/drawing/2014/main" id="{F30C8B34-C973-475F-94C5-86C83E715D11}"/>
+              </a:ext>
+            </a:extLst>
+          </p:cNvPr>
+          <p:cNvSpPr>
+            <a:spLocks xmlns:a="http://schemas.openxmlformats.org/drawingml/2006/main" noGrp="1"/>
+          </p:cNvSpPr>
+          <p:nvPr/>
+        </p:nvSpPr>
+        <p:spPr>
+          <a:xfrm xmlns:a="http://schemas.openxmlformats.org/drawingml/2006/main">
+            <a:off x="914400" y="3105150"/>
+            <a:ext cx="8610600" cy="323850"/>
           </a:xfrm>
           <a:prstGeom xmlns:a="http://schemas.openxmlformats.org/drawingml/2006/main" prst="rect">
             <a:avLst/>
@@ -4192,7 +4192,7 @@
                   <a:srgbClr val="16202A"/>
                 </a:solidFill>
               </a:rPr>
-              <a:t>2. Dokumentasi mencatat cara menjalankan, arsitektur, metode keamanan, dan skenario uji.</a:t>
+              <a:t>2. Branch secure-login menjadi pembanding untuk versi yang sudah diamankan.</a:t>
             </a:r>
           </a:p>
         </p:txBody>
@@ -4202,7 +4202,7 @@
           <p:cNvPr id="5" name="bullet-3">
             <a:extLst xmlns:a="http://schemas.openxmlformats.org/drawingml/2006/main">
               <a:ext uri="{FF2B5EF4-FFF2-40B4-BE49-F238E27FC236}">
-                <a16:creationId xmlns:a16="http://schemas.microsoft.com/office/drawing/2014/main" id="{1E2267E6-3923-4161-9EAF-EEF2B34EAD3B}"/>
+                <a16:creationId xmlns:a16="http://schemas.microsoft.com/office/drawing/2014/main" id="{1E49B78A-B29A-4049-B6BA-E16CF7D1FDA9}"/>
               </a:ext>
             </a:extLst>
           </p:cNvPr>
@@ -4214,7 +4214,7 @@
         <p:spPr>
           <a:xfrm xmlns:a="http://schemas.openxmlformats.org/drawingml/2006/main">
             <a:off x="914400" y="3600450"/>
-            <a:ext cx="9296400" cy="647700"/>
+            <a:ext cx="10953750" cy="323850"/>
           </a:xfrm>
           <a:prstGeom xmlns:a="http://schemas.openxmlformats.org/drawingml/2006/main" prst="rect">
             <a:avLst/>
@@ -4237,7 +4237,7 @@
                   <a:srgbClr val="16202A"/>
                 </a:solidFill>
               </a:rPr>
-              <a:t>3. Pengembangan berikutnya: audit log, reset password aman, dan sertifikat CA resmi.</a:t>
+              <a:t>3. Perbaikan utama: hash+salt, prepared statement, escaping, CSRF token, input limit, dan role check.</a:t>
             </a:r>
           </a:p>
         </p:txBody>
@@ -4247,18 +4247,18 @@
           <p:cNvPr id="6" name="footer">
             <a:extLst xmlns:a="http://schemas.openxmlformats.org/drawingml/2006/main">
               <a:ext uri="{FF2B5EF4-FFF2-40B4-BE49-F238E27FC236}">
-                <a16:creationId xmlns:a16="http://schemas.microsoft.com/office/drawing/2014/main" id="{72EEF049-9617-4B7C-9975-AEC798F1DA14}"/>
-              </a:ext>
-            </a:extLst>
-          </p:cNvPr>
-          <p:cNvSpPr>
-            <a:spLocks xmlns:a="http://schemas.openxmlformats.org/drawingml/2006/main" noGrp="1"/>
-          </p:cNvSpPr>
-          <p:nvPr/>
-        </p:nvSpPr>
-        <p:spPr>
-          <a:xfrm xmlns:a="http://schemas.openxmlformats.org/drawingml/2006/main">
-            <a:off x="914400" y="4533900"/>
+                <a16:creationId xmlns:a16="http://schemas.microsoft.com/office/drawing/2014/main" id="{7AAA1320-2E95-478D-B2D8-B651DC13C1BB}"/>
+              </a:ext>
+            </a:extLst>
+          </p:cNvPr>
+          <p:cNvSpPr>
+            <a:spLocks xmlns:a="http://schemas.openxmlformats.org/drawingml/2006/main" noGrp="1"/>
+          </p:cNvSpPr>
+          <p:nvPr/>
+        </p:nvSpPr>
+        <p:spPr>
+          <a:xfrm xmlns:a="http://schemas.openxmlformats.org/drawingml/2006/main">
+            <a:off x="914400" y="4210050"/>
             <a:ext cx="16459200" cy="209550"/>
           </a:xfrm>
           <a:prstGeom xmlns:a="http://schemas.openxmlformats.org/drawingml/2006/main" prst="rect">
@@ -4282,7 +4282,7 @@
                   <a:srgbClr val="5E6B78"/>
                 </a:solidFill>
               </a:rPr>
-              <a:t>CLO 2 Secure Comments | PHP, Apache, MySQL, Docker</a:t>
+              <a:t>CLO 2 Non-Secure Comments | PHP, Apache, MySQL, Docker</a:t>
             </a:r>
           </a:p>
         </p:txBody>
@@ -4290,7 +4290,7 @@
     </p:spTree>
     <p:extLst>
       <p:ext uri="{BB962C8B-B14F-4D97-AF65-F5344CB8AC3E}">
-        <p14:creationId xmlns:p14="http://schemas.microsoft.com/office/powerpoint/2010/main" val="887994446"/>
+        <p14:creationId xmlns:p14="http://schemas.microsoft.com/office/powerpoint/2010/main" val="14226138"/>
       </p:ext>
     </p:extLst>
   </p:cSld>

</xml_diff>

<commit_message>
Align CLO2 documentation with target 80
</commit_message>
<xml_diff>
--- a/presentation/output/CLO2_Secure_Comments.pptx
+++ b/presentation/output/CLO2_Secure_Comments.pptx
@@ -2,19 +2,19 @@
 <file path=ppt/presentation.xml><?xml version="1.0" encoding="utf-8"?>
 <p:presentation xmlns:p="http://schemas.openxmlformats.org/presentationml/2006/main">
   <p:sldMasterIdLst>
-    <p:sldMasterId xmlns:r="http://schemas.openxmlformats.org/officeDocument/2006/relationships" id="2147483648" r:id="Rc8ad4114f5074c30"/>
+    <p:sldMasterId xmlns:r="http://schemas.openxmlformats.org/officeDocument/2006/relationships" id="2147483648" r:id="Rc8fb613c50804369"/>
   </p:sldMasterIdLst>
   <p:notesMasterIdLst>
-    <p:notesMasterId xmlns:r="http://schemas.openxmlformats.org/officeDocument/2006/relationships" r:id="R9e7ab8b9b9f04a95"/>
+    <p:notesMasterId xmlns:r="http://schemas.openxmlformats.org/officeDocument/2006/relationships" r:id="R9b68a252680d4bab"/>
   </p:notesMasterIdLst>
   <p:sldIdLst>
-    <p:sldId xmlns:r="http://schemas.openxmlformats.org/officeDocument/2006/relationships" id="256" r:id="Rcc9a160528884392"/>
-    <p:sldId xmlns:r="http://schemas.openxmlformats.org/officeDocument/2006/relationships" id="257" r:id="R7d8bfcc808df422d"/>
-    <p:sldId xmlns:r="http://schemas.openxmlformats.org/officeDocument/2006/relationships" id="258" r:id="R3a09896cc50c4a1d"/>
-    <p:sldId xmlns:r="http://schemas.openxmlformats.org/officeDocument/2006/relationships" id="259" r:id="R32039f8a391d48ef"/>
-    <p:sldId xmlns:r="http://schemas.openxmlformats.org/officeDocument/2006/relationships" id="260" r:id="Rc2cbb631fca84eb2"/>
-    <p:sldId xmlns:r="http://schemas.openxmlformats.org/officeDocument/2006/relationships" id="261" r:id="R6961d25d21fa4d4c"/>
-    <p:sldId xmlns:r="http://schemas.openxmlformats.org/officeDocument/2006/relationships" id="262" r:id="R805c26a33a494ac6"/>
+    <p:sldId xmlns:r="http://schemas.openxmlformats.org/officeDocument/2006/relationships" id="256" r:id="R629b93724ef44791"/>
+    <p:sldId xmlns:r="http://schemas.openxmlformats.org/officeDocument/2006/relationships" id="257" r:id="Refbd05200ad14f3c"/>
+    <p:sldId xmlns:r="http://schemas.openxmlformats.org/officeDocument/2006/relationships" id="258" r:id="Rd78f13f7f2644e1c"/>
+    <p:sldId xmlns:r="http://schemas.openxmlformats.org/officeDocument/2006/relationships" id="259" r:id="Raae9687557e54591"/>
+    <p:sldId xmlns:r="http://schemas.openxmlformats.org/officeDocument/2006/relationships" id="260" r:id="R2d07e068b8024826"/>
+    <p:sldId xmlns:r="http://schemas.openxmlformats.org/officeDocument/2006/relationships" id="261" r:id="R126c389a38c14e40"/>
+    <p:sldId xmlns:r="http://schemas.openxmlformats.org/officeDocument/2006/relationships" id="262" r:id="R318b010b38b3407e"/>
   </p:sldIdLst>
   <p:sldSz cx="18288000" cy="10287000"/>
   <p:notesSz cx="6858000" cy="9144000"/>
@@ -957,7 +957,7 @@
   </p:cSld>
   <p:clrMap bg1="lt1" tx1="dk1" bg2="lt2" tx2="dk2" accent1="accent1" accent2="accent2" accent3="accent3" accent4="accent4" accent5="accent5" accent6="accent6" hlink="hlink" folHlink="folHlink"/>
   <p:sldLayoutIdLst>
-    <p:sldLayoutId xmlns:r="http://schemas.openxmlformats.org/officeDocument/2006/relationships" id="2147483649" r:id="Rce441f2eedee4b36"/>
+    <p:sldLayoutId xmlns:r="http://schemas.openxmlformats.org/officeDocument/2006/relationships" id="2147483649" r:id="R7039701a818a4166"/>
   </p:sldLayoutIdLst>
   <p:txStyles>
     <p:titleStyle>
@@ -1256,7 +1256,7 @@
           <p:cNvPr id="1" name="cover-title">
             <a:extLst xmlns:a="http://schemas.openxmlformats.org/drawingml/2006/main">
               <a:ext uri="{FF2B5EF4-FFF2-40B4-BE49-F238E27FC236}">
-                <a16:creationId xmlns:a16="http://schemas.microsoft.com/office/drawing/2014/main" id="{929E19B3-ACE2-4467-BB18-DA00034DEAF6}"/>
+                <a16:creationId xmlns:a16="http://schemas.microsoft.com/office/drawing/2014/main" id="{51F12734-F0B7-4144-914A-F398FB7C78D1}"/>
               </a:ext>
             </a:extLst>
           </p:cNvPr>
@@ -1301,7 +1301,7 @@
           <p:cNvPr id="2" name="cover-rule">
             <a:extLst xmlns:a="http://schemas.openxmlformats.org/drawingml/2006/main">
               <a:ext uri="{FF2B5EF4-FFF2-40B4-BE49-F238E27FC236}">
-                <a16:creationId xmlns:a16="http://schemas.microsoft.com/office/drawing/2014/main" id="{D069ED89-7EB3-4F76-8ECD-897FED236030}"/>
+                <a16:creationId xmlns:a16="http://schemas.microsoft.com/office/drawing/2014/main" id="{5656D574-A3B4-46DD-8642-20DCF5391DBA}"/>
               </a:ext>
             </a:extLst>
           </p:cNvPr>
@@ -1334,7 +1334,7 @@
           <p:cNvPr id="3" name="cover-subtitle">
             <a:extLst xmlns:a="http://schemas.openxmlformats.org/drawingml/2006/main">
               <a:ext uri="{FF2B5EF4-FFF2-40B4-BE49-F238E27FC236}">
-                <a16:creationId xmlns:a16="http://schemas.microsoft.com/office/drawing/2014/main" id="{A4F7FCC8-AD29-4144-BAFF-F35503083F7A}"/>
+                <a16:creationId xmlns:a16="http://schemas.microsoft.com/office/drawing/2014/main" id="{B3E2835D-32D4-4C93-A8B4-A89A3FA84075}"/>
               </a:ext>
             </a:extLst>
           </p:cNvPr>
@@ -1346,7 +1346,7 @@
         <p:spPr>
           <a:xfrm xmlns:a="http://schemas.openxmlformats.org/drawingml/2006/main">
             <a:off x="1104900" y="2895600"/>
-            <a:ext cx="10629900" cy="781050"/>
+            <a:ext cx="11734800" cy="781050"/>
           </a:xfrm>
           <a:prstGeom xmlns:a="http://schemas.openxmlformats.org/drawingml/2006/main" prst="rect">
             <a:avLst/>
@@ -1369,7 +1369,7 @@
                   <a:srgbClr val="16202A"/>
                 </a:solidFill>
               </a:rPr>
-              <a:t>Pengamanan aplikasi web target 80 poin: HTTPS, hash password dengan salt, dan pembatasan input berlebihan.</a:t>
+              <a:t>Pengamanan aplikasi web target 80 poin: HTTPS, hash+salt, input limit, SQL injection, dan XSS.</a:t>
             </a:r>
           </a:p>
         </p:txBody>
@@ -1379,7 +1379,7 @@
           <p:cNvPr id="4" name="cover-context">
             <a:extLst xmlns:a="http://schemas.openxmlformats.org/drawingml/2006/main">
               <a:ext uri="{FF2B5EF4-FFF2-40B4-BE49-F238E27FC236}">
-                <a16:creationId xmlns:a16="http://schemas.microsoft.com/office/drawing/2014/main" id="{ED879370-D01C-4301-BD7C-141384FCFB3E}"/>
+                <a16:creationId xmlns:a16="http://schemas.microsoft.com/office/drawing/2014/main" id="{9D6FFB01-0558-4C58-ADCB-083726B04835}"/>
               </a:ext>
             </a:extLst>
           </p:cNvPr>
@@ -1422,7 +1422,7 @@
     </p:spTree>
     <p:extLst>
       <p:ext uri="{BB962C8B-B14F-4D97-AF65-F5344CB8AC3E}">
-        <p14:creationId xmlns:p14="http://schemas.microsoft.com/office/powerpoint/2010/main" val="463809684"/>
+        <p14:creationId xmlns:p14="http://schemas.microsoft.com/office/powerpoint/2010/main" val="499640552"/>
       </p:ext>
     </p:extLst>
   </p:cSld>
@@ -1446,7 +1446,7 @@
           <p:cNvPr id="1" name="slide-title">
             <a:extLst xmlns:a="http://schemas.openxmlformats.org/drawingml/2006/main">
               <a:ext uri="{FF2B5EF4-FFF2-40B4-BE49-F238E27FC236}">
-                <a16:creationId xmlns:a16="http://schemas.microsoft.com/office/drawing/2014/main" id="{E4FBD61E-7F12-4A2E-823B-366487DC013C}"/>
+                <a16:creationId xmlns:a16="http://schemas.microsoft.com/office/drawing/2014/main" id="{4F0B4325-A480-48C4-8681-F4AA13738510}"/>
               </a:ext>
             </a:extLst>
           </p:cNvPr>
@@ -1491,7 +1491,7 @@
           <p:cNvPr id="2" name="slide-subtitle">
             <a:extLst xmlns:a="http://schemas.openxmlformats.org/drawingml/2006/main">
               <a:ext uri="{FF2B5EF4-FFF2-40B4-BE49-F238E27FC236}">
-                <a16:creationId xmlns:a16="http://schemas.microsoft.com/office/drawing/2014/main" id="{625D4B27-5368-4606-B956-14A1F540924E}"/>
+                <a16:creationId xmlns:a16="http://schemas.microsoft.com/office/drawing/2014/main" id="{6AA23E0B-5794-4A1E-9FA5-F2B176172696}"/>
               </a:ext>
             </a:extLst>
           </p:cNvPr>
@@ -1536,7 +1536,7 @@
           <p:cNvPr id="3" name="bullet-1">
             <a:extLst xmlns:a="http://schemas.openxmlformats.org/drawingml/2006/main">
               <a:ext uri="{FF2B5EF4-FFF2-40B4-BE49-F238E27FC236}">
-                <a16:creationId xmlns:a16="http://schemas.microsoft.com/office/drawing/2014/main" id="{188E90B8-D833-4A8B-8837-33378EF66BF4}"/>
+                <a16:creationId xmlns:a16="http://schemas.microsoft.com/office/drawing/2014/main" id="{DE3988DD-7957-4975-ACCF-BE2025FB08DA}"/>
               </a:ext>
             </a:extLst>
           </p:cNvPr>
@@ -1581,7 +1581,7 @@
           <p:cNvPr id="4" name="bullet-2">
             <a:extLst xmlns:a="http://schemas.openxmlformats.org/drawingml/2006/main">
               <a:ext uri="{FF2B5EF4-FFF2-40B4-BE49-F238E27FC236}">
-                <a16:creationId xmlns:a16="http://schemas.microsoft.com/office/drawing/2014/main" id="{F6135850-08FE-41AA-9E53-9927E4E4E757}"/>
+                <a16:creationId xmlns:a16="http://schemas.microsoft.com/office/drawing/2014/main" id="{8BDF778E-ECD0-4F86-AC61-9751F06622E5}"/>
               </a:ext>
             </a:extLst>
           </p:cNvPr>
@@ -1626,7 +1626,7 @@
           <p:cNvPr id="5" name="bullet-3">
             <a:extLst xmlns:a="http://schemas.openxmlformats.org/drawingml/2006/main">
               <a:ext uri="{FF2B5EF4-FFF2-40B4-BE49-F238E27FC236}">
-                <a16:creationId xmlns:a16="http://schemas.microsoft.com/office/drawing/2014/main" id="{C401E9AE-9766-4DEF-8D01-2488FBC47933}"/>
+                <a16:creationId xmlns:a16="http://schemas.microsoft.com/office/drawing/2014/main" id="{85B0FC3F-8872-48E7-807E-F8E094E41B13}"/>
               </a:ext>
             </a:extLst>
           </p:cNvPr>
@@ -1671,7 +1671,7 @@
           <p:cNvPr id="6" name="bullet-4">
             <a:extLst xmlns:a="http://schemas.openxmlformats.org/drawingml/2006/main">
               <a:ext uri="{FF2B5EF4-FFF2-40B4-BE49-F238E27FC236}">
-                <a16:creationId xmlns:a16="http://schemas.microsoft.com/office/drawing/2014/main" id="{A291BE1C-EB38-4238-9AC8-AF1F82ED0233}"/>
+                <a16:creationId xmlns:a16="http://schemas.microsoft.com/office/drawing/2014/main" id="{CF028671-2D83-44BC-AE1D-907CAC62852A}"/>
               </a:ext>
             </a:extLst>
           </p:cNvPr>
@@ -1716,7 +1716,7 @@
           <p:cNvPr id="7" name="footer">
             <a:extLst xmlns:a="http://schemas.openxmlformats.org/drawingml/2006/main">
               <a:ext uri="{FF2B5EF4-FFF2-40B4-BE49-F238E27FC236}">
-                <a16:creationId xmlns:a16="http://schemas.microsoft.com/office/drawing/2014/main" id="{5D090349-B28A-4726-B864-7002D2B39F6B}"/>
+                <a16:creationId xmlns:a16="http://schemas.microsoft.com/office/drawing/2014/main" id="{0662A0D9-4B48-417D-B68E-A5BFAD27B97D}"/>
               </a:ext>
             </a:extLst>
           </p:cNvPr>
@@ -1759,7 +1759,7 @@
     </p:spTree>
     <p:extLst>
       <p:ext uri="{BB962C8B-B14F-4D97-AF65-F5344CB8AC3E}">
-        <p14:creationId xmlns:p14="http://schemas.microsoft.com/office/powerpoint/2010/main" val="1391107886"/>
+        <p14:creationId xmlns:p14="http://schemas.microsoft.com/office/powerpoint/2010/main" val="199458740"/>
       </p:ext>
     </p:extLst>
   </p:cSld>
@@ -1783,7 +1783,7 @@
           <p:cNvPr id="1" name="slide-title">
             <a:extLst xmlns:a="http://schemas.openxmlformats.org/drawingml/2006/main">
               <a:ext uri="{FF2B5EF4-FFF2-40B4-BE49-F238E27FC236}">
-                <a16:creationId xmlns:a16="http://schemas.microsoft.com/office/drawing/2014/main" id="{B684E466-0567-40B0-A7BB-0143302B02A5}"/>
+                <a16:creationId xmlns:a16="http://schemas.microsoft.com/office/drawing/2014/main" id="{C377EC18-6F89-4D62-9430-D91B47381E19}"/>
               </a:ext>
             </a:extLst>
           </p:cNvPr>
@@ -1828,7 +1828,7 @@
           <p:cNvPr id="2" name="slide-subtitle">
             <a:extLst xmlns:a="http://schemas.openxmlformats.org/drawingml/2006/main">
               <a:ext uri="{FF2B5EF4-FFF2-40B4-BE49-F238E27FC236}">
-                <a16:creationId xmlns:a16="http://schemas.microsoft.com/office/drawing/2014/main" id="{F9E193D7-AA70-416F-92D1-A2D6ED4A9498}"/>
+                <a16:creationId xmlns:a16="http://schemas.microsoft.com/office/drawing/2014/main" id="{C3B99958-434F-4CAD-A993-9F1B7ED6C400}"/>
               </a:ext>
             </a:extLst>
           </p:cNvPr>
@@ -1873,7 +1873,7 @@
           <p:cNvPr id="3" name="method-HTTPS/TLS">
             <a:extLst xmlns:a="http://schemas.openxmlformats.org/drawingml/2006/main">
               <a:ext uri="{FF2B5EF4-FFF2-40B4-BE49-F238E27FC236}">
-                <a16:creationId xmlns:a16="http://schemas.microsoft.com/office/drawing/2014/main" id="{B2741C7B-29B2-4746-B9CE-359D40114CB8}"/>
+                <a16:creationId xmlns:a16="http://schemas.microsoft.com/office/drawing/2014/main" id="{8AB6F01C-96FD-49B1-A8C2-62249E07DEC8}"/>
               </a:ext>
             </a:extLst>
           </p:cNvPr>
@@ -1902,7 +1902,7 @@
           <p:cNvPr id="4" name="">
             <a:extLst xmlns:a="http://schemas.openxmlformats.org/drawingml/2006/main">
               <a:ext uri="{FF2B5EF4-FFF2-40B4-BE49-F238E27FC236}">
-                <a16:creationId xmlns:a16="http://schemas.microsoft.com/office/drawing/2014/main" id="{B53C4BF8-F8CB-44B8-B405-0865E56EFE16}"/>
+                <a16:creationId xmlns:a16="http://schemas.microsoft.com/office/drawing/2014/main" id="{ED18EFC5-CE5D-45F0-B269-1CB6E5D075CE}"/>
               </a:ext>
             </a:extLst>
           </p:cNvPr>
@@ -1947,7 +1947,7 @@
           <p:cNvPr id="5" name="">
             <a:extLst xmlns:a="http://schemas.openxmlformats.org/drawingml/2006/main">
               <a:ext uri="{FF2B5EF4-FFF2-40B4-BE49-F238E27FC236}">
-                <a16:creationId xmlns:a16="http://schemas.microsoft.com/office/drawing/2014/main" id="{F7696F86-9B4A-4F99-A389-EA46825EA380}"/>
+                <a16:creationId xmlns:a16="http://schemas.microsoft.com/office/drawing/2014/main" id="{0D8E4760-E95C-4719-822B-F59FC1B792F2}"/>
               </a:ext>
             </a:extLst>
           </p:cNvPr>
@@ -1992,7 +1992,7 @@
           <p:cNvPr id="6" name="method-Hash + salt">
             <a:extLst xmlns:a="http://schemas.openxmlformats.org/drawingml/2006/main">
               <a:ext uri="{FF2B5EF4-FFF2-40B4-BE49-F238E27FC236}">
-                <a16:creationId xmlns:a16="http://schemas.microsoft.com/office/drawing/2014/main" id="{69ADCED0-A668-4F89-A4AE-AE970D6A2677}"/>
+                <a16:creationId xmlns:a16="http://schemas.microsoft.com/office/drawing/2014/main" id="{5B327487-4C1A-4EA3-AB6A-C051453A041A}"/>
               </a:ext>
             </a:extLst>
           </p:cNvPr>
@@ -2021,7 +2021,7 @@
           <p:cNvPr id="7" name="">
             <a:extLst xmlns:a="http://schemas.openxmlformats.org/drawingml/2006/main">
               <a:ext uri="{FF2B5EF4-FFF2-40B4-BE49-F238E27FC236}">
-                <a16:creationId xmlns:a16="http://schemas.microsoft.com/office/drawing/2014/main" id="{2503182C-E3FF-4DCF-B492-036EAB565EC3}"/>
+                <a16:creationId xmlns:a16="http://schemas.microsoft.com/office/drawing/2014/main" id="{F5FC929C-877F-4735-B6CC-9D7EA8F7800E}"/>
               </a:ext>
             </a:extLst>
           </p:cNvPr>
@@ -2066,7 +2066,7 @@
           <p:cNvPr id="8" name="">
             <a:extLst xmlns:a="http://schemas.openxmlformats.org/drawingml/2006/main">
               <a:ext uri="{FF2B5EF4-FFF2-40B4-BE49-F238E27FC236}">
-                <a16:creationId xmlns:a16="http://schemas.microsoft.com/office/drawing/2014/main" id="{FE26CCFF-52AD-434F-B31C-81473015C947}"/>
+                <a16:creationId xmlns:a16="http://schemas.microsoft.com/office/drawing/2014/main" id="{AA24BE08-1291-4905-86A3-BC736B40FF8C}"/>
               </a:ext>
             </a:extLst>
           </p:cNvPr>
@@ -2108,10 +2108,10 @@
       </p:sp>
       <p:sp>
         <p:nvSpPr>
-          <p:cNvPr id="9" name="method-HTTPS/TLS">
-            <a:extLst xmlns:a="http://schemas.openxmlformats.org/drawingml/2006/main">
-              <a:ext uri="{FF2B5EF4-FFF2-40B4-BE49-F238E27FC236}">
-                <a16:creationId xmlns:a16="http://schemas.microsoft.com/office/drawing/2014/main" id="{AF8E123D-A8FA-4E77-A877-3E0BBD08A389}"/>
+          <p:cNvPr id="9" name="method-Input limit">
+            <a:extLst xmlns:a="http://schemas.openxmlformats.org/drawingml/2006/main">
+              <a:ext uri="{FF2B5EF4-FFF2-40B4-BE49-F238E27FC236}">
+                <a16:creationId xmlns:a16="http://schemas.microsoft.com/office/drawing/2014/main" id="{9A87CFD7-758A-40B6-9473-3E658ABCA73B}"/>
               </a:ext>
             </a:extLst>
           </p:cNvPr>
@@ -2140,7 +2140,7 @@
           <p:cNvPr id="10" name="">
             <a:extLst xmlns:a="http://schemas.openxmlformats.org/drawingml/2006/main">
               <a:ext uri="{FF2B5EF4-FFF2-40B4-BE49-F238E27FC236}">
-                <a16:creationId xmlns:a16="http://schemas.microsoft.com/office/drawing/2014/main" id="{2B6441F2-68C4-43BD-AD02-EFB82E9BA10D}"/>
+                <a16:creationId xmlns:a16="http://schemas.microsoft.com/office/drawing/2014/main" id="{6A84187A-E371-4032-932A-CE61695597FF}"/>
               </a:ext>
             </a:extLst>
           </p:cNvPr>
@@ -2175,7 +2175,7 @@
                   <a:srgbClr val="0F766E"/>
                 </a:solidFill>
               </a:rPr>
-              <a:t>HTTPS/TLS</a:t>
+              <a:t>Input limit</a:t>
             </a:r>
           </a:p>
         </p:txBody>
@@ -2185,7 +2185,7 @@
           <p:cNvPr id="11" name="">
             <a:extLst xmlns:a="http://schemas.openxmlformats.org/drawingml/2006/main">
               <a:ext uri="{FF2B5EF4-FFF2-40B4-BE49-F238E27FC236}">
-                <a16:creationId xmlns:a16="http://schemas.microsoft.com/office/drawing/2014/main" id="{6C12A0DB-34CD-4556-8433-CD4ACAF36DB3}"/>
+                <a16:creationId xmlns:a16="http://schemas.microsoft.com/office/drawing/2014/main" id="{F8042A50-2BAC-47F5-97DA-89D0647D1045}"/>
               </a:ext>
             </a:extLst>
           </p:cNvPr>
@@ -2220,17 +2220,17 @@
                   <a:srgbClr val="16202A"/>
                 </a:solidFill>
               </a:rPr>
-              <a:t>Apache memakai self-signed certificate RSA 2048-bit untuk demo lokal.</a:t>
-            </a:r>
-          </a:p>
-        </p:txBody>
-      </p:sp>
-      <p:sp>
-        <p:nvSpPr>
-          <p:cNvPr id="12" name="method-Hash + salt">
-            <a:extLst xmlns:a="http://schemas.openxmlformats.org/drawingml/2006/main">
-              <a:ext uri="{FF2B5EF4-FFF2-40B4-BE49-F238E27FC236}">
-                <a16:creationId xmlns:a16="http://schemas.microsoft.com/office/drawing/2014/main" id="{2B8AE0AC-294A-4762-A96D-E73935F1B74C}"/>
+              <a:t>Komentar dibatasi maksimal 500 karakter di sisi server.</a:t>
+            </a:r>
+          </a:p>
+        </p:txBody>
+      </p:sp>
+      <p:sp>
+        <p:nvSpPr>
+          <p:cNvPr id="12" name="method-SQL injection">
+            <a:extLst xmlns:a="http://schemas.openxmlformats.org/drawingml/2006/main">
+              <a:ext uri="{FF2B5EF4-FFF2-40B4-BE49-F238E27FC236}">
+                <a16:creationId xmlns:a16="http://schemas.microsoft.com/office/drawing/2014/main" id="{00262577-5F28-4206-AD3D-58483BA16348}"/>
               </a:ext>
             </a:extLst>
           </p:cNvPr>
@@ -2259,7 +2259,7 @@
           <p:cNvPr id="13" name="">
             <a:extLst xmlns:a="http://schemas.openxmlformats.org/drawingml/2006/main">
               <a:ext uri="{FF2B5EF4-FFF2-40B4-BE49-F238E27FC236}">
-                <a16:creationId xmlns:a16="http://schemas.microsoft.com/office/drawing/2014/main" id="{27BCCC8C-81B9-476B-A38E-04D222EB8BED}"/>
+                <a16:creationId xmlns:a16="http://schemas.microsoft.com/office/drawing/2014/main" id="{644712F7-0FE8-4D9D-B02B-12F7614EA304}"/>
               </a:ext>
             </a:extLst>
           </p:cNvPr>
@@ -2294,7 +2294,7 @@
                   <a:srgbClr val="0F766E"/>
                 </a:solidFill>
               </a:rPr>
-              <a:t>Hash + salt</a:t>
+              <a:t>SQL injection</a:t>
             </a:r>
           </a:p>
         </p:txBody>
@@ -2304,7 +2304,7 @@
           <p:cNvPr id="14" name="">
             <a:extLst xmlns:a="http://schemas.openxmlformats.org/drawingml/2006/main">
               <a:ext uri="{FF2B5EF4-FFF2-40B4-BE49-F238E27FC236}">
-                <a16:creationId xmlns:a16="http://schemas.microsoft.com/office/drawing/2014/main" id="{B5FBEEF6-6507-4846-8F8F-1215AD04C2AB}"/>
+                <a16:creationId xmlns:a16="http://schemas.microsoft.com/office/drawing/2014/main" id="{230D9C84-CB7C-497C-BD74-24A045B7356D}"/>
               </a:ext>
             </a:extLst>
           </p:cNvPr>
@@ -2339,17 +2339,17 @@
                   <a:srgbClr val="16202A"/>
                 </a:solidFill>
               </a:rPr>
-              <a:t>Password disimpan memakai password_hash() dengan salt otomatis.</a:t>
-            </a:r>
-          </a:p>
-        </p:txBody>
-      </p:sp>
-      <p:sp>
-        <p:nvSpPr>
-          <p:cNvPr id="15" name="method-Input limit">
-            <a:extLst xmlns:a="http://schemas.openxmlformats.org/drawingml/2006/main">
-              <a:ext uri="{FF2B5EF4-FFF2-40B4-BE49-F238E27FC236}">
-                <a16:creationId xmlns:a16="http://schemas.microsoft.com/office/drawing/2014/main" id="{87DC62DD-F4E0-4454-8197-73C09E18CB01}"/>
+              <a:t>Query login dan komentar memakai prepared statement PDO.</a:t>
+            </a:r>
+          </a:p>
+        </p:txBody>
+      </p:sp>
+      <p:sp>
+        <p:nvSpPr>
+          <p:cNvPr id="15" name="method-XSS">
+            <a:extLst xmlns:a="http://schemas.openxmlformats.org/drawingml/2006/main">
+              <a:ext uri="{FF2B5EF4-FFF2-40B4-BE49-F238E27FC236}">
+                <a16:creationId xmlns:a16="http://schemas.microsoft.com/office/drawing/2014/main" id="{92CD40CA-EC5A-45CD-84CB-C0F542499FBB}"/>
               </a:ext>
             </a:extLst>
           </p:cNvPr>
@@ -2378,7 +2378,7 @@
           <p:cNvPr id="16" name="">
             <a:extLst xmlns:a="http://schemas.openxmlformats.org/drawingml/2006/main">
               <a:ext uri="{FF2B5EF4-FFF2-40B4-BE49-F238E27FC236}">
-                <a16:creationId xmlns:a16="http://schemas.microsoft.com/office/drawing/2014/main" id="{F42BEF1D-8DFD-4078-9061-33AF950C4D39}"/>
+                <a16:creationId xmlns:a16="http://schemas.microsoft.com/office/drawing/2014/main" id="{C3F61196-BA07-4488-A9B7-A9FEBFE67893}"/>
               </a:ext>
             </a:extLst>
           </p:cNvPr>
@@ -2413,7 +2413,7 @@
                   <a:srgbClr val="0F766E"/>
                 </a:solidFill>
               </a:rPr>
-              <a:t>Input limit</a:t>
+              <a:t>XSS</a:t>
             </a:r>
           </a:p>
         </p:txBody>
@@ -2423,7 +2423,7 @@
           <p:cNvPr id="17" name="">
             <a:extLst xmlns:a="http://schemas.openxmlformats.org/drawingml/2006/main">
               <a:ext uri="{FF2B5EF4-FFF2-40B4-BE49-F238E27FC236}">
-                <a16:creationId xmlns:a16="http://schemas.microsoft.com/office/drawing/2014/main" id="{4452AFD7-E54C-4DEA-9D48-AD0C39491435}"/>
+                <a16:creationId xmlns:a16="http://schemas.microsoft.com/office/drawing/2014/main" id="{48FB0B29-EBBF-4BEB-A884-3C5AAE516F76}"/>
               </a:ext>
             </a:extLst>
           </p:cNvPr>
@@ -2458,7 +2458,7 @@
                   <a:srgbClr val="16202A"/>
                 </a:solidFill>
               </a:rPr>
-              <a:t>Komentar dibatasi maksimal 500 karakter di sisi server.</a:t>
+              <a:t>Output komentar di-escape dengan htmlspecialchars().</a:t>
             </a:r>
           </a:p>
         </p:txBody>
@@ -2468,7 +2468,7 @@
           <p:cNvPr id="18" name="method-Admin proof">
             <a:extLst xmlns:a="http://schemas.openxmlformats.org/drawingml/2006/main">
               <a:ext uri="{FF2B5EF4-FFF2-40B4-BE49-F238E27FC236}">
-                <a16:creationId xmlns:a16="http://schemas.microsoft.com/office/drawing/2014/main" id="{89034156-6421-4C44-8F96-6E8119B23FEC}"/>
+                <a16:creationId xmlns:a16="http://schemas.microsoft.com/office/drawing/2014/main" id="{AFD8045A-7B98-43A5-8E4E-992C3ABC2D9E}"/>
               </a:ext>
             </a:extLst>
           </p:cNvPr>
@@ -2497,7 +2497,7 @@
           <p:cNvPr id="19" name="">
             <a:extLst xmlns:a="http://schemas.openxmlformats.org/drawingml/2006/main">
               <a:ext uri="{FF2B5EF4-FFF2-40B4-BE49-F238E27FC236}">
-                <a16:creationId xmlns:a16="http://schemas.microsoft.com/office/drawing/2014/main" id="{37332735-8D8D-41EB-AF50-80E5836003E9}"/>
+                <a16:creationId xmlns:a16="http://schemas.microsoft.com/office/drawing/2014/main" id="{76182BB8-9821-49ED-8077-9E1C07CA378D}"/>
               </a:ext>
             </a:extLst>
           </p:cNvPr>
@@ -2542,7 +2542,7 @@
           <p:cNvPr id="20" name="">
             <a:extLst xmlns:a="http://schemas.openxmlformats.org/drawingml/2006/main">
               <a:ext uri="{FF2B5EF4-FFF2-40B4-BE49-F238E27FC236}">
-                <a16:creationId xmlns:a16="http://schemas.microsoft.com/office/drawing/2014/main" id="{476DB9F7-5F92-4EDC-AA1F-1525B2AC2CA3}"/>
+                <a16:creationId xmlns:a16="http://schemas.microsoft.com/office/drawing/2014/main" id="{10ADE690-5C3F-45A5-B0C8-C619BFB18A46}"/>
               </a:ext>
             </a:extLst>
           </p:cNvPr>
@@ -2587,7 +2587,7 @@
           <p:cNvPr id="21" name="footer">
             <a:extLst xmlns:a="http://schemas.openxmlformats.org/drawingml/2006/main">
               <a:ext uri="{FF2B5EF4-FFF2-40B4-BE49-F238E27FC236}">
-                <a16:creationId xmlns:a16="http://schemas.microsoft.com/office/drawing/2014/main" id="{261FDF3D-570D-42F9-BD89-00E29BE6D5D7}"/>
+                <a16:creationId xmlns:a16="http://schemas.microsoft.com/office/drawing/2014/main" id="{66016CB8-0806-4D12-AB80-0C13DF6A6821}"/>
               </a:ext>
             </a:extLst>
           </p:cNvPr>
@@ -2630,7 +2630,7 @@
     </p:spTree>
     <p:extLst>
       <p:ext uri="{BB962C8B-B14F-4D97-AF65-F5344CB8AC3E}">
-        <p14:creationId xmlns:p14="http://schemas.microsoft.com/office/powerpoint/2010/main" val="502690985"/>
+        <p14:creationId xmlns:p14="http://schemas.microsoft.com/office/powerpoint/2010/main" val="178202425"/>
       </p:ext>
     </p:extLst>
   </p:cSld>
@@ -2654,7 +2654,7 @@
           <p:cNvPr id="1" name="slide-title">
             <a:extLst xmlns:a="http://schemas.openxmlformats.org/drawingml/2006/main">
               <a:ext uri="{FF2B5EF4-FFF2-40B4-BE49-F238E27FC236}">
-                <a16:creationId xmlns:a16="http://schemas.microsoft.com/office/drawing/2014/main" id="{9D06C737-51FC-446B-A857-3EE5DBBFF007}"/>
+                <a16:creationId xmlns:a16="http://schemas.microsoft.com/office/drawing/2014/main" id="{1E9C9CC3-EEA5-48B1-8456-9C0ECF3D92CC}"/>
               </a:ext>
             </a:extLst>
           </p:cNvPr>
@@ -2699,7 +2699,7 @@
           <p:cNvPr id="2" name="slide-subtitle">
             <a:extLst xmlns:a="http://schemas.openxmlformats.org/drawingml/2006/main">
               <a:ext uri="{FF2B5EF4-FFF2-40B4-BE49-F238E27FC236}">
-                <a16:creationId xmlns:a16="http://schemas.microsoft.com/office/drawing/2014/main" id="{5E49AF4B-F1A9-45A3-B0B3-A3E2EA093090}"/>
+                <a16:creationId xmlns:a16="http://schemas.microsoft.com/office/drawing/2014/main" id="{BEC04EDB-1956-47AB-8CFB-023FDBD371C0}"/>
               </a:ext>
             </a:extLst>
           </p:cNvPr>
@@ -2744,7 +2744,7 @@
           <p:cNvPr id="3" name="method-Browser">
             <a:extLst xmlns:a="http://schemas.openxmlformats.org/drawingml/2006/main">
               <a:ext uri="{FF2B5EF4-FFF2-40B4-BE49-F238E27FC236}">
-                <a16:creationId xmlns:a16="http://schemas.microsoft.com/office/drawing/2014/main" id="{83F758F1-4787-4C71-8F89-59560BE3318C}"/>
+                <a16:creationId xmlns:a16="http://schemas.microsoft.com/office/drawing/2014/main" id="{F729F70D-CE94-4EC5-A314-F4735A42A153}"/>
               </a:ext>
             </a:extLst>
           </p:cNvPr>
@@ -2773,7 +2773,7 @@
           <p:cNvPr id="4" name="">
             <a:extLst xmlns:a="http://schemas.openxmlformats.org/drawingml/2006/main">
               <a:ext uri="{FF2B5EF4-FFF2-40B4-BE49-F238E27FC236}">
-                <a16:creationId xmlns:a16="http://schemas.microsoft.com/office/drawing/2014/main" id="{A95F0D44-9553-4BED-AA6D-922EE1D6C2BA}"/>
+                <a16:creationId xmlns:a16="http://schemas.microsoft.com/office/drawing/2014/main" id="{B7D7B133-3A60-4208-B339-DB5624CA1540}"/>
               </a:ext>
             </a:extLst>
           </p:cNvPr>
@@ -2818,7 +2818,7 @@
           <p:cNvPr id="5" name="">
             <a:extLst xmlns:a="http://schemas.openxmlformats.org/drawingml/2006/main">
               <a:ext uri="{FF2B5EF4-FFF2-40B4-BE49-F238E27FC236}">
-                <a16:creationId xmlns:a16="http://schemas.microsoft.com/office/drawing/2014/main" id="{93AFCCCC-3ABA-454E-8421-D62C0A873D1E}"/>
+                <a16:creationId xmlns:a16="http://schemas.microsoft.com/office/drawing/2014/main" id="{6619A050-19E0-4A7F-A8DD-F7DB6C3C594A}"/>
               </a:ext>
             </a:extLst>
           </p:cNvPr>
@@ -2863,7 +2863,7 @@
           <p:cNvPr id="6" name="">
             <a:extLst xmlns:a="http://schemas.openxmlformats.org/drawingml/2006/main">
               <a:ext uri="{FF2B5EF4-FFF2-40B4-BE49-F238E27FC236}">
-                <a16:creationId xmlns:a16="http://schemas.microsoft.com/office/drawing/2014/main" id="{729C0392-0C39-4A67-9B0A-13AD2CBEFD9B}"/>
+                <a16:creationId xmlns:a16="http://schemas.microsoft.com/office/drawing/2014/main" id="{36411A2F-7838-4D1F-953A-C545A1BB0BB0}"/>
               </a:ext>
             </a:extLst>
           </p:cNvPr>
@@ -2908,7 +2908,7 @@
           <p:cNvPr id="7" name="method-Apache + PHP">
             <a:extLst xmlns:a="http://schemas.openxmlformats.org/drawingml/2006/main">
               <a:ext uri="{FF2B5EF4-FFF2-40B4-BE49-F238E27FC236}">
-                <a16:creationId xmlns:a16="http://schemas.microsoft.com/office/drawing/2014/main" id="{E1603C42-2AC0-4D73-BD85-AC188F7FB12D}"/>
+                <a16:creationId xmlns:a16="http://schemas.microsoft.com/office/drawing/2014/main" id="{4390AEB5-C10F-46A7-9072-417519A9C9AA}"/>
               </a:ext>
             </a:extLst>
           </p:cNvPr>
@@ -2937,7 +2937,7 @@
           <p:cNvPr id="8" name="">
             <a:extLst xmlns:a="http://schemas.openxmlformats.org/drawingml/2006/main">
               <a:ext uri="{FF2B5EF4-FFF2-40B4-BE49-F238E27FC236}">
-                <a16:creationId xmlns:a16="http://schemas.microsoft.com/office/drawing/2014/main" id="{36E5CA5C-C3CB-4770-B01E-A50840549DC7}"/>
+                <a16:creationId xmlns:a16="http://schemas.microsoft.com/office/drawing/2014/main" id="{27B7A5E3-C0F2-41F5-9DD0-49029B490EB4}"/>
               </a:ext>
             </a:extLst>
           </p:cNvPr>
@@ -2982,7 +2982,7 @@
           <p:cNvPr id="9" name="">
             <a:extLst xmlns:a="http://schemas.openxmlformats.org/drawingml/2006/main">
               <a:ext uri="{FF2B5EF4-FFF2-40B4-BE49-F238E27FC236}">
-                <a16:creationId xmlns:a16="http://schemas.microsoft.com/office/drawing/2014/main" id="{B04EDF2C-98FD-45AA-BAAD-363464C7686F}"/>
+                <a16:creationId xmlns:a16="http://schemas.microsoft.com/office/drawing/2014/main" id="{9C717D97-07FD-413D-851A-84178A53D217}"/>
               </a:ext>
             </a:extLst>
           </p:cNvPr>
@@ -3017,7 +3017,7 @@
                   <a:srgbClr val="16202A"/>
                 </a:solidFill>
               </a:rPr>
-              <a:t>Redirect HTTP ke HTTPS, autentikasi, dan validasi panjang input.</a:t>
+              <a:t>Redirect HTTP ke HTTPS, autentikasi, validasi input, prepared statement, dan escaping.</a:t>
             </a:r>
           </a:p>
         </p:txBody>
@@ -3027,7 +3027,7 @@
           <p:cNvPr id="10" name="">
             <a:extLst xmlns:a="http://schemas.openxmlformats.org/drawingml/2006/main">
               <a:ext uri="{FF2B5EF4-FFF2-40B4-BE49-F238E27FC236}">
-                <a16:creationId xmlns:a16="http://schemas.microsoft.com/office/drawing/2014/main" id="{7A407B29-B12A-4ADD-B041-6F426A4E7654}"/>
+                <a16:creationId xmlns:a16="http://schemas.microsoft.com/office/drawing/2014/main" id="{6E4818D4-452A-437B-A12F-F403F17BE1A9}"/>
               </a:ext>
             </a:extLst>
           </p:cNvPr>
@@ -3072,7 +3072,7 @@
           <p:cNvPr id="11" name="method-MySQL">
             <a:extLst xmlns:a="http://schemas.openxmlformats.org/drawingml/2006/main">
               <a:ext uri="{FF2B5EF4-FFF2-40B4-BE49-F238E27FC236}">
-                <a16:creationId xmlns:a16="http://schemas.microsoft.com/office/drawing/2014/main" id="{5DA29511-3FFB-47B8-ACCD-F4C4463F3C59}"/>
+                <a16:creationId xmlns:a16="http://schemas.microsoft.com/office/drawing/2014/main" id="{B543D298-C1A1-4F0C-9004-C9767D3B83E5}"/>
               </a:ext>
             </a:extLst>
           </p:cNvPr>
@@ -3101,7 +3101,7 @@
           <p:cNvPr id="12" name="">
             <a:extLst xmlns:a="http://schemas.openxmlformats.org/drawingml/2006/main">
               <a:ext uri="{FF2B5EF4-FFF2-40B4-BE49-F238E27FC236}">
-                <a16:creationId xmlns:a16="http://schemas.microsoft.com/office/drawing/2014/main" id="{2E40ED8C-2B9F-4054-B43C-4DF52C338467}"/>
+                <a16:creationId xmlns:a16="http://schemas.microsoft.com/office/drawing/2014/main" id="{A123CBAA-8284-4FFE-BF54-BA35F6FFE096}"/>
               </a:ext>
             </a:extLst>
           </p:cNvPr>
@@ -3146,7 +3146,7 @@
           <p:cNvPr id="13" name="">
             <a:extLst xmlns:a="http://schemas.openxmlformats.org/drawingml/2006/main">
               <a:ext uri="{FF2B5EF4-FFF2-40B4-BE49-F238E27FC236}">
-                <a16:creationId xmlns:a16="http://schemas.microsoft.com/office/drawing/2014/main" id="{EA1B7A76-2DC4-406B-A111-6FC8C746B6AA}"/>
+                <a16:creationId xmlns:a16="http://schemas.microsoft.com/office/drawing/2014/main" id="{27DA0609-35B3-45BC-832A-61C5392C6CF4}"/>
               </a:ext>
             </a:extLst>
           </p:cNvPr>
@@ -3191,7 +3191,7 @@
           <p:cNvPr id="14" name="network-note">
             <a:extLst xmlns:a="http://schemas.openxmlformats.org/drawingml/2006/main">
               <a:ext uri="{FF2B5EF4-FFF2-40B4-BE49-F238E27FC236}">
-                <a16:creationId xmlns:a16="http://schemas.microsoft.com/office/drawing/2014/main" id="{A56FFEC2-21E8-45AC-9C59-65DCADE3A1F8}"/>
+                <a16:creationId xmlns:a16="http://schemas.microsoft.com/office/drawing/2014/main" id="{CF9147B1-7811-41F2-87E1-BAA1BC1A567E}"/>
               </a:ext>
             </a:extLst>
           </p:cNvPr>
@@ -3226,7 +3226,7 @@
                   <a:srgbClr val="5E6B78"/>
                 </a:solidFill>
               </a:rPr>
-              <a:t>Docker network: 192.168.240.0/24 | web: 192.168.240.10 | db: 192.168.240.11</a:t>
+              <a:t>Docker network: 192.168.219.0/24 | web: 192.168.219.219 | db: 192.168.219.220</a:t>
             </a:r>
           </a:p>
         </p:txBody>
@@ -3236,7 +3236,7 @@
           <p:cNvPr id="15" name="footer">
             <a:extLst xmlns:a="http://schemas.openxmlformats.org/drawingml/2006/main">
               <a:ext uri="{FF2B5EF4-FFF2-40B4-BE49-F238E27FC236}">
-                <a16:creationId xmlns:a16="http://schemas.microsoft.com/office/drawing/2014/main" id="{8E8CE3C4-3AF0-4599-BB69-D470ADBA74BC}"/>
+                <a16:creationId xmlns:a16="http://schemas.microsoft.com/office/drawing/2014/main" id="{8CB6C201-A893-441D-A54C-0A333B70B64D}"/>
               </a:ext>
             </a:extLst>
           </p:cNvPr>
@@ -3279,7 +3279,7 @@
     </p:spTree>
     <p:extLst>
       <p:ext uri="{BB962C8B-B14F-4D97-AF65-F5344CB8AC3E}">
-        <p14:creationId xmlns:p14="http://schemas.microsoft.com/office/powerpoint/2010/main" val="1892259710"/>
+        <p14:creationId xmlns:p14="http://schemas.microsoft.com/office/powerpoint/2010/main" val="2075406580"/>
       </p:ext>
     </p:extLst>
   </p:cSld>
@@ -3303,7 +3303,7 @@
           <p:cNvPr id="1" name="slide-title">
             <a:extLst xmlns:a="http://schemas.openxmlformats.org/drawingml/2006/main">
               <a:ext uri="{FF2B5EF4-FFF2-40B4-BE49-F238E27FC236}">
-                <a16:creationId xmlns:a16="http://schemas.microsoft.com/office/drawing/2014/main" id="{E8D02A8C-514C-4AD1-90D5-DA17587AFDB2}"/>
+                <a16:creationId xmlns:a16="http://schemas.microsoft.com/office/drawing/2014/main" id="{ECE18658-FE32-47F1-BAF9-3D590FDE544E}"/>
               </a:ext>
             </a:extLst>
           </p:cNvPr>
@@ -3348,7 +3348,7 @@
           <p:cNvPr id="2" name="slide-subtitle">
             <a:extLst xmlns:a="http://schemas.openxmlformats.org/drawingml/2006/main">
               <a:ext uri="{FF2B5EF4-FFF2-40B4-BE49-F238E27FC236}">
-                <a16:creationId xmlns:a16="http://schemas.microsoft.com/office/drawing/2014/main" id="{DF6AE913-35AE-45BD-806B-5B90E9D37F8F}"/>
+                <a16:creationId xmlns:a16="http://schemas.microsoft.com/office/drawing/2014/main" id="{095ACFB7-4B2E-4B37-99EB-75600C8E5FF2}"/>
               </a:ext>
             </a:extLst>
           </p:cNvPr>
@@ -3360,7 +3360,7 @@
         <p:spPr>
           <a:xfrm xmlns:a="http://schemas.openxmlformats.org/drawingml/2006/main">
             <a:off x="914400" y="1485900"/>
-            <a:ext cx="6172200" cy="514350"/>
+            <a:ext cx="6019800" cy="514350"/>
           </a:xfrm>
           <a:prstGeom xmlns:a="http://schemas.openxmlformats.org/drawingml/2006/main" prst="rect">
             <a:avLst/>
@@ -3383,7 +3383,7 @@
                   <a:srgbClr val="5E6B78"/>
                 </a:solidFill>
               </a:rPr>
-              <a:t>Scope berhenti sampai buffer overflow/input berlebih sesuai target nilai.</a:t>
+              <a:t>Kontrol disesuaikan dengan rubrik SSL, hash+salt, buffer, SQLi, dan XSS.</a:t>
             </a:r>
           </a:p>
         </p:txBody>
@@ -3393,7 +3393,7 @@
           <p:cNvPr id="3" name="bullet-1">
             <a:extLst xmlns:a="http://schemas.openxmlformats.org/drawingml/2006/main">
               <a:ext uri="{FF2B5EF4-FFF2-40B4-BE49-F238E27FC236}">
-                <a16:creationId xmlns:a16="http://schemas.microsoft.com/office/drawing/2014/main" id="{74A3CC07-B5F5-4676-B231-8E980CFA4618}"/>
+                <a16:creationId xmlns:a16="http://schemas.microsoft.com/office/drawing/2014/main" id="{7DB252C6-272B-493A-8F66-12EC65A02A67}"/>
               </a:ext>
             </a:extLst>
           </p:cNvPr>
@@ -3438,7 +3438,7 @@
           <p:cNvPr id="4" name="bullet-2">
             <a:extLst xmlns:a="http://schemas.openxmlformats.org/drawingml/2006/main">
               <a:ext uri="{FF2B5EF4-FFF2-40B4-BE49-F238E27FC236}">
-                <a16:creationId xmlns:a16="http://schemas.microsoft.com/office/drawing/2014/main" id="{CFFF2CD0-751B-4763-B31A-4FB4F860FF23}"/>
+                <a16:creationId xmlns:a16="http://schemas.microsoft.com/office/drawing/2014/main" id="{2299A9ED-6114-492E-9087-728B8BA783F9}"/>
               </a:ext>
             </a:extLst>
           </p:cNvPr>
@@ -3483,7 +3483,7 @@
           <p:cNvPr id="5" name="bullet-3">
             <a:extLst xmlns:a="http://schemas.openxmlformats.org/drawingml/2006/main">
               <a:ext uri="{FF2B5EF4-FFF2-40B4-BE49-F238E27FC236}">
-                <a16:creationId xmlns:a16="http://schemas.microsoft.com/office/drawing/2014/main" id="{CD45AD73-FB82-4EE4-BC6C-A1FEEDBE9ACC}"/>
+                <a16:creationId xmlns:a16="http://schemas.microsoft.com/office/drawing/2014/main" id="{C37203A9-F7DD-4F16-90AD-D8B3B5ABC582}"/>
               </a:ext>
             </a:extLst>
           </p:cNvPr>
@@ -3528,7 +3528,7 @@
           <p:cNvPr id="6" name="bullet-4">
             <a:extLst xmlns:a="http://schemas.openxmlformats.org/drawingml/2006/main">
               <a:ext uri="{FF2B5EF4-FFF2-40B4-BE49-F238E27FC236}">
-                <a16:creationId xmlns:a16="http://schemas.microsoft.com/office/drawing/2014/main" id="{AC7D88DC-CF3B-4AE3-B006-63D59D518D85}"/>
+                <a16:creationId xmlns:a16="http://schemas.microsoft.com/office/drawing/2014/main" id="{3CD627D6-F2B3-4481-8F6D-F2B5F5EA50F1}"/>
               </a:ext>
             </a:extLst>
           </p:cNvPr>
@@ -3540,7 +3540,7 @@
         <p:spPr>
           <a:xfrm xmlns:a="http://schemas.openxmlformats.org/drawingml/2006/main">
             <a:off x="914400" y="4400550"/>
-            <a:ext cx="8458200" cy="323850"/>
+            <a:ext cx="7124700" cy="647700"/>
           </a:xfrm>
           <a:prstGeom xmlns:a="http://schemas.openxmlformats.org/drawingml/2006/main" prst="rect">
             <a:avLst/>
@@ -3563,28 +3563,73 @@
                   <a:srgbClr val="16202A"/>
                 </a:solidFill>
               </a:rPr>
-              <a:t>4. Admin panel: hash password ditampilkan sebagai bukti penyimpanan aman.</a:t>
-            </a:r>
-          </a:p>
-        </p:txBody>
-      </p:sp>
-      <p:sp>
-        <p:nvSpPr>
-          <p:cNvPr id="7" name="footer">
-            <a:extLst xmlns:a="http://schemas.openxmlformats.org/drawingml/2006/main">
-              <a:ext uri="{FF2B5EF4-FFF2-40B4-BE49-F238E27FC236}">
-                <a16:creationId xmlns:a16="http://schemas.microsoft.com/office/drawing/2014/main" id="{0F51693D-0EF4-40D8-AAD8-BC844A564596}"/>
-              </a:ext>
-            </a:extLst>
-          </p:cNvPr>
-          <p:cNvSpPr>
-            <a:spLocks xmlns:a="http://schemas.openxmlformats.org/drawingml/2006/main" noGrp="1"/>
-          </p:cNvSpPr>
-          <p:nvPr/>
-        </p:nvSpPr>
-        <p:spPr>
-          <a:xfrm xmlns:a="http://schemas.openxmlformats.org/drawingml/2006/main">
-            <a:off x="914400" y="5029200"/>
+              <a:t>4. SQL injection: payload login ditolak karena prepared statement.</a:t>
+            </a:r>
+          </a:p>
+        </p:txBody>
+      </p:sp>
+      <p:sp>
+        <p:nvSpPr>
+          <p:cNvPr id="7" name="bullet-5">
+            <a:extLst xmlns:a="http://schemas.openxmlformats.org/drawingml/2006/main">
+              <a:ext uri="{FF2B5EF4-FFF2-40B4-BE49-F238E27FC236}">
+                <a16:creationId xmlns:a16="http://schemas.microsoft.com/office/drawing/2014/main" id="{D817D374-1072-42F1-9ADC-4C70D09CEB4C}"/>
+              </a:ext>
+            </a:extLst>
+          </p:cNvPr>
+          <p:cNvSpPr>
+            <a:spLocks xmlns:a="http://schemas.openxmlformats.org/drawingml/2006/main" noGrp="1"/>
+          </p:cNvSpPr>
+          <p:nvPr/>
+        </p:nvSpPr>
+        <p:spPr>
+          <a:xfrm xmlns:a="http://schemas.openxmlformats.org/drawingml/2006/main">
+            <a:off x="914400" y="5219700"/>
+            <a:ext cx="7086600" cy="323850"/>
+          </a:xfrm>
+          <a:prstGeom xmlns:a="http://schemas.openxmlformats.org/drawingml/2006/main" prst="rect">
+            <a:avLst/>
+          </a:prstGeom>
+        </p:spPr>
+        <p:txBody>
+          <a:bodyPr xmlns:a="http://schemas.openxmlformats.org/drawingml/2006/main" lIns="0" tIns="0" rIns="0" bIns="0"/>
+          <a:lstStyle xmlns:a="http://schemas.openxmlformats.org/drawingml/2006/main"/>
+          <a:p xmlns:a="http://schemas.openxmlformats.org/drawingml/2006/main">
+            <a:pPr>
+              <a:defRPr sz="2100">
+                <a:solidFill>
+                  <a:srgbClr val="16202A"/>
+                </a:solidFill>
+              </a:defRPr>
+            </a:pPr>
+            <a:r>
+              <a:rPr sz="2100">
+                <a:solidFill>
+                  <a:srgbClr val="16202A"/>
+                </a:solidFill>
+              </a:rPr>
+              <a:t>5. XSS: payload script tampil sebagai teks karena output escaping.</a:t>
+            </a:r>
+          </a:p>
+        </p:txBody>
+      </p:sp>
+      <p:sp>
+        <p:nvSpPr>
+          <p:cNvPr id="8" name="footer">
+            <a:extLst xmlns:a="http://schemas.openxmlformats.org/drawingml/2006/main">
+              <a:ext uri="{FF2B5EF4-FFF2-40B4-BE49-F238E27FC236}">
+                <a16:creationId xmlns:a16="http://schemas.microsoft.com/office/drawing/2014/main" id="{D3C72399-59D5-4C9D-8BF5-10D504A22533}"/>
+              </a:ext>
+            </a:extLst>
+          </p:cNvPr>
+          <p:cNvSpPr>
+            <a:spLocks xmlns:a="http://schemas.openxmlformats.org/drawingml/2006/main" noGrp="1"/>
+          </p:cNvSpPr>
+          <p:nvPr/>
+        </p:nvSpPr>
+        <p:spPr>
+          <a:xfrm xmlns:a="http://schemas.openxmlformats.org/drawingml/2006/main">
+            <a:off x="914400" y="5848350"/>
             <a:ext cx="16459200" cy="209550"/>
           </a:xfrm>
           <a:prstGeom xmlns:a="http://schemas.openxmlformats.org/drawingml/2006/main" prst="rect">
@@ -3616,7 +3661,7 @@
     </p:spTree>
     <p:extLst>
       <p:ext uri="{BB962C8B-B14F-4D97-AF65-F5344CB8AC3E}">
-        <p14:creationId xmlns:p14="http://schemas.microsoft.com/office/powerpoint/2010/main" val="2026588714"/>
+        <p14:creationId xmlns:p14="http://schemas.microsoft.com/office/powerpoint/2010/main" val="1988610830"/>
       </p:ext>
     </p:extLst>
   </p:cSld>
@@ -3640,7 +3685,7 @@
           <p:cNvPr id="1" name="slide-title">
             <a:extLst xmlns:a="http://schemas.openxmlformats.org/drawingml/2006/main">
               <a:ext uri="{FF2B5EF4-FFF2-40B4-BE49-F238E27FC236}">
-                <a16:creationId xmlns:a16="http://schemas.microsoft.com/office/drawing/2014/main" id="{700477CE-EAE7-4F0C-93FD-69C3090B8BE6}"/>
+                <a16:creationId xmlns:a16="http://schemas.microsoft.com/office/drawing/2014/main" id="{C73CB792-FD69-4D7F-9830-F8EBDCC598AC}"/>
               </a:ext>
             </a:extLst>
           </p:cNvPr>
@@ -3685,7 +3730,7 @@
           <p:cNvPr id="2" name="slide-subtitle">
             <a:extLst xmlns:a="http://schemas.openxmlformats.org/drawingml/2006/main">
               <a:ext uri="{FF2B5EF4-FFF2-40B4-BE49-F238E27FC236}">
-                <a16:creationId xmlns:a16="http://schemas.microsoft.com/office/drawing/2014/main" id="{024BFA81-F39D-4724-B244-40F2BC037C5D}"/>
+                <a16:creationId xmlns:a16="http://schemas.microsoft.com/office/drawing/2014/main" id="{2F9A5523-A9C5-4F35-8591-014E5E3B06E2}"/>
               </a:ext>
             </a:extLst>
           </p:cNvPr>
@@ -3697,7 +3742,7 @@
         <p:spPr>
           <a:xfrm xmlns:a="http://schemas.openxmlformats.org/drawingml/2006/main">
             <a:off x="914400" y="1485900"/>
-            <a:ext cx="4743450" cy="514350"/>
+            <a:ext cx="5200650" cy="514350"/>
           </a:xfrm>
           <a:prstGeom xmlns:a="http://schemas.openxmlformats.org/drawingml/2006/main" prst="rect">
             <a:avLst/>
@@ -3720,7 +3765,7 @@
                   <a:srgbClr val="5E6B78"/>
                 </a:solidFill>
               </a:rPr>
-              <a:t>Urutan demo difokuskan pada tiga kontrol yang diklaim.</a:t>
+              <a:t>Urutan demo difokuskan pada kontrol target 80 yang diklaim.</a:t>
             </a:r>
           </a:p>
         </p:txBody>
@@ -3730,7 +3775,7 @@
           <p:cNvPr id="3" name="bullet-1">
             <a:extLst xmlns:a="http://schemas.openxmlformats.org/drawingml/2006/main">
               <a:ext uri="{FF2B5EF4-FFF2-40B4-BE49-F238E27FC236}">
-                <a16:creationId xmlns:a16="http://schemas.microsoft.com/office/drawing/2014/main" id="{11059C8C-2ECC-4C9D-8A68-B696CB54A683}"/>
+                <a16:creationId xmlns:a16="http://schemas.microsoft.com/office/drawing/2014/main" id="{C331ACF5-0BA7-4D01-A064-D0DFB3434B34}"/>
               </a:ext>
             </a:extLst>
           </p:cNvPr>
@@ -3775,7 +3820,7 @@
           <p:cNvPr id="4" name="bullet-2">
             <a:extLst xmlns:a="http://schemas.openxmlformats.org/drawingml/2006/main">
               <a:ext uri="{FF2B5EF4-FFF2-40B4-BE49-F238E27FC236}">
-                <a16:creationId xmlns:a16="http://schemas.microsoft.com/office/drawing/2014/main" id="{7EE4C92F-112C-4D98-8272-A39B96C42CEE}"/>
+                <a16:creationId xmlns:a16="http://schemas.microsoft.com/office/drawing/2014/main" id="{A4686B2F-433C-4519-9256-233598BCEE4B}"/>
               </a:ext>
             </a:extLst>
           </p:cNvPr>
@@ -3820,7 +3865,7 @@
           <p:cNvPr id="5" name="bullet-3">
             <a:extLst xmlns:a="http://schemas.openxmlformats.org/drawingml/2006/main">
               <a:ext uri="{FF2B5EF4-FFF2-40B4-BE49-F238E27FC236}">
-                <a16:creationId xmlns:a16="http://schemas.microsoft.com/office/drawing/2014/main" id="{4108BBD3-2E6A-46ED-AF1C-92AB27F58F50}"/>
+                <a16:creationId xmlns:a16="http://schemas.microsoft.com/office/drawing/2014/main" id="{0014A1E6-61E6-4953-9AFA-4AA1A8999375}"/>
               </a:ext>
             </a:extLst>
           </p:cNvPr>
@@ -3865,7 +3910,7 @@
           <p:cNvPr id="6" name="bullet-4">
             <a:extLst xmlns:a="http://schemas.openxmlformats.org/drawingml/2006/main">
               <a:ext uri="{FF2B5EF4-FFF2-40B4-BE49-F238E27FC236}">
-                <a16:creationId xmlns:a16="http://schemas.microsoft.com/office/drawing/2014/main" id="{D557BE80-5C83-4139-BD9A-441BE11F890F}"/>
+                <a16:creationId xmlns:a16="http://schemas.microsoft.com/office/drawing/2014/main" id="{5DCF82E6-D624-48D4-8C78-31B9373FA026}"/>
               </a:ext>
             </a:extLst>
           </p:cNvPr>
@@ -3910,7 +3955,7 @@
           <p:cNvPr id="7" name="bullet-5">
             <a:extLst xmlns:a="http://schemas.openxmlformats.org/drawingml/2006/main">
               <a:ext uri="{FF2B5EF4-FFF2-40B4-BE49-F238E27FC236}">
-                <a16:creationId xmlns:a16="http://schemas.microsoft.com/office/drawing/2014/main" id="{7808C57B-590E-4C1C-97E4-B9247F1B247D}"/>
+                <a16:creationId xmlns:a16="http://schemas.microsoft.com/office/drawing/2014/main" id="{3679C7D1-5590-48D0-B4C7-25471B455D2C}"/>
               </a:ext>
             </a:extLst>
           </p:cNvPr>
@@ -3952,21 +3997,66 @@
       </p:sp>
       <p:sp>
         <p:nvSpPr>
-          <p:cNvPr id="8" name="footer">
-            <a:extLst xmlns:a="http://schemas.openxmlformats.org/drawingml/2006/main">
-              <a:ext uri="{FF2B5EF4-FFF2-40B4-BE49-F238E27FC236}">
-                <a16:creationId xmlns:a16="http://schemas.microsoft.com/office/drawing/2014/main" id="{F90006F6-2030-4532-A479-B1C2ADDA2078}"/>
-              </a:ext>
-            </a:extLst>
-          </p:cNvPr>
-          <p:cNvSpPr>
-            <a:spLocks xmlns:a="http://schemas.openxmlformats.org/drawingml/2006/main" noGrp="1"/>
-          </p:cNvSpPr>
-          <p:nvPr/>
-        </p:nvSpPr>
-        <p:spPr>
-          <a:xfrm xmlns:a="http://schemas.openxmlformats.org/drawingml/2006/main">
-            <a:off x="914400" y="6153150"/>
+          <p:cNvPr id="8" name="bullet-6">
+            <a:extLst xmlns:a="http://schemas.openxmlformats.org/drawingml/2006/main">
+              <a:ext uri="{FF2B5EF4-FFF2-40B4-BE49-F238E27FC236}">
+                <a16:creationId xmlns:a16="http://schemas.microsoft.com/office/drawing/2014/main" id="{2AC96488-0C07-46D9-AE6D-9203810E674B}"/>
+              </a:ext>
+            </a:extLst>
+          </p:cNvPr>
+          <p:cNvSpPr>
+            <a:spLocks xmlns:a="http://schemas.openxmlformats.org/drawingml/2006/main" noGrp="1"/>
+          </p:cNvSpPr>
+          <p:nvPr/>
+        </p:nvSpPr>
+        <p:spPr>
+          <a:xfrm xmlns:a="http://schemas.openxmlformats.org/drawingml/2006/main">
+            <a:off x="914400" y="6019800"/>
+            <a:ext cx="7543800" cy="647700"/>
+          </a:xfrm>
+          <a:prstGeom xmlns:a="http://schemas.openxmlformats.org/drawingml/2006/main" prst="rect">
+            <a:avLst/>
+          </a:prstGeom>
+        </p:spPr>
+        <p:txBody>
+          <a:bodyPr xmlns:a="http://schemas.openxmlformats.org/drawingml/2006/main" lIns="0" tIns="0" rIns="0" bIns="0"/>
+          <a:lstStyle xmlns:a="http://schemas.openxmlformats.org/drawingml/2006/main"/>
+          <a:p xmlns:a="http://schemas.openxmlformats.org/drawingml/2006/main">
+            <a:pPr>
+              <a:defRPr sz="2100">
+                <a:solidFill>
+                  <a:srgbClr val="16202A"/>
+                </a:solidFill>
+              </a:defRPr>
+            </a:pPr>
+            <a:r>
+              <a:rPr sz="2100">
+                <a:solidFill>
+                  <a:srgbClr val="16202A"/>
+                </a:solidFill>
+              </a:rPr>
+              <a:t>6. Coba payload SQL injection dan XSS, lalu tunjukkan keduanya gagal.</a:t>
+            </a:r>
+          </a:p>
+        </p:txBody>
+      </p:sp>
+      <p:sp>
+        <p:nvSpPr>
+          <p:cNvPr id="9" name="footer">
+            <a:extLst xmlns:a="http://schemas.openxmlformats.org/drawingml/2006/main">
+              <a:ext uri="{FF2B5EF4-FFF2-40B4-BE49-F238E27FC236}">
+                <a16:creationId xmlns:a16="http://schemas.microsoft.com/office/drawing/2014/main" id="{EAEA7BD4-B037-4180-902F-665E830BA6F2}"/>
+              </a:ext>
+            </a:extLst>
+          </p:cNvPr>
+          <p:cNvSpPr>
+            <a:spLocks xmlns:a="http://schemas.openxmlformats.org/drawingml/2006/main" noGrp="1"/>
+          </p:cNvSpPr>
+          <p:nvPr/>
+        </p:nvSpPr>
+        <p:spPr>
+          <a:xfrm xmlns:a="http://schemas.openxmlformats.org/drawingml/2006/main">
+            <a:off x="914400" y="6972300"/>
             <a:ext cx="16459200" cy="209550"/>
           </a:xfrm>
           <a:prstGeom xmlns:a="http://schemas.openxmlformats.org/drawingml/2006/main" prst="rect">
@@ -3998,7 +4088,7 @@
     </p:spTree>
     <p:extLst>
       <p:ext uri="{BB962C8B-B14F-4D97-AF65-F5344CB8AC3E}">
-        <p14:creationId xmlns:p14="http://schemas.microsoft.com/office/powerpoint/2010/main" val="1800308421"/>
+        <p14:creationId xmlns:p14="http://schemas.microsoft.com/office/powerpoint/2010/main" val="371857206"/>
       </p:ext>
     </p:extLst>
   </p:cSld>
@@ -4022,7 +4112,7 @@
           <p:cNvPr id="1" name="slide-title">
             <a:extLst xmlns:a="http://schemas.openxmlformats.org/drawingml/2006/main">
               <a:ext uri="{FF2B5EF4-FFF2-40B4-BE49-F238E27FC236}">
-                <a16:creationId xmlns:a16="http://schemas.microsoft.com/office/drawing/2014/main" id="{3DEDC671-A6C1-4820-AE74-473A121BF61F}"/>
+                <a16:creationId xmlns:a16="http://schemas.microsoft.com/office/drawing/2014/main" id="{F6D23E5F-5D4F-4991-9691-923D0F59D120}"/>
               </a:ext>
             </a:extLst>
           </p:cNvPr>
@@ -4067,7 +4157,7 @@
           <p:cNvPr id="2" name="slide-subtitle">
             <a:extLst xmlns:a="http://schemas.openxmlformats.org/drawingml/2006/main">
               <a:ext uri="{FF2B5EF4-FFF2-40B4-BE49-F238E27FC236}">
-                <a16:creationId xmlns:a16="http://schemas.microsoft.com/office/drawing/2014/main" id="{82FDC04A-5EC0-41B7-9017-3B5F48AC7EFD}"/>
+                <a16:creationId xmlns:a16="http://schemas.microsoft.com/office/drawing/2014/main" id="{5A84B585-3055-4825-AF76-2069AE28EDA1}"/>
               </a:ext>
             </a:extLst>
           </p:cNvPr>
@@ -4112,7 +4202,7 @@
           <p:cNvPr id="3" name="bullet-1">
             <a:extLst xmlns:a="http://schemas.openxmlformats.org/drawingml/2006/main">
               <a:ext uri="{FF2B5EF4-FFF2-40B4-BE49-F238E27FC236}">
-                <a16:creationId xmlns:a16="http://schemas.microsoft.com/office/drawing/2014/main" id="{749657A5-64D9-405A-A7F9-BE2DA349995A}"/>
+                <a16:creationId xmlns:a16="http://schemas.microsoft.com/office/drawing/2014/main" id="{C0044684-0682-449C-8D4E-7115F08D65C5}"/>
               </a:ext>
             </a:extLst>
           </p:cNvPr>
@@ -4124,7 +4214,7 @@
         <p:spPr>
           <a:xfrm xmlns:a="http://schemas.openxmlformats.org/drawingml/2006/main">
             <a:off x="914400" y="2286000"/>
-            <a:ext cx="7239000" cy="323850"/>
+            <a:ext cx="7505700" cy="647700"/>
           </a:xfrm>
           <a:prstGeom xmlns:a="http://schemas.openxmlformats.org/drawingml/2006/main" prst="rect">
             <a:avLst/>
@@ -4147,7 +4237,7 @@
                   <a:srgbClr val="16202A"/>
                 </a:solidFill>
               </a:rPr>
-              <a:t>1. Kontrol target 80 aktif: HTTPS, hash+salt, dan pembatasan input.</a:t>
+              <a:t>1. Kontrol target 80 aktif: HTTPS, hash+salt, input limit, SQLi, dan XSS.</a:t>
             </a:r>
           </a:p>
         </p:txBody>
@@ -4157,18 +4247,18 @@
           <p:cNvPr id="4" name="bullet-2">
             <a:extLst xmlns:a="http://schemas.openxmlformats.org/drawingml/2006/main">
               <a:ext uri="{FF2B5EF4-FFF2-40B4-BE49-F238E27FC236}">
-                <a16:creationId xmlns:a16="http://schemas.microsoft.com/office/drawing/2014/main" id="{5E514813-C469-4940-844A-714285BA7C0A}"/>
-              </a:ext>
-            </a:extLst>
-          </p:cNvPr>
-          <p:cNvSpPr>
-            <a:spLocks xmlns:a="http://schemas.openxmlformats.org/drawingml/2006/main" noGrp="1"/>
-          </p:cNvSpPr>
-          <p:nvPr/>
-        </p:nvSpPr>
-        <p:spPr>
-          <a:xfrm xmlns:a="http://schemas.openxmlformats.org/drawingml/2006/main">
-            <a:off x="914400" y="2781300"/>
+                <a16:creationId xmlns:a16="http://schemas.microsoft.com/office/drawing/2014/main" id="{96E71CF4-B78C-4C56-A3DB-7CAB657F237B}"/>
+              </a:ext>
+            </a:extLst>
+          </p:cNvPr>
+          <p:cNvSpPr>
+            <a:spLocks xmlns:a="http://schemas.openxmlformats.org/drawingml/2006/main" noGrp="1"/>
+          </p:cNvSpPr>
+          <p:nvPr/>
+        </p:nvSpPr>
+        <p:spPr>
+          <a:xfrm xmlns:a="http://schemas.openxmlformats.org/drawingml/2006/main">
+            <a:off x="914400" y="3105150"/>
             <a:ext cx="9944100" cy="647700"/>
           </a:xfrm>
           <a:prstGeom xmlns:a="http://schemas.openxmlformats.org/drawingml/2006/main" prst="rect">
@@ -4202,18 +4292,18 @@
           <p:cNvPr id="5" name="bullet-3">
             <a:extLst xmlns:a="http://schemas.openxmlformats.org/drawingml/2006/main">
               <a:ext uri="{FF2B5EF4-FFF2-40B4-BE49-F238E27FC236}">
-                <a16:creationId xmlns:a16="http://schemas.microsoft.com/office/drawing/2014/main" id="{1E2267E6-3923-4161-9EAF-EEF2B34EAD3B}"/>
-              </a:ext>
-            </a:extLst>
-          </p:cNvPr>
-          <p:cNvSpPr>
-            <a:spLocks xmlns:a="http://schemas.openxmlformats.org/drawingml/2006/main" noGrp="1"/>
-          </p:cNvSpPr>
-          <p:nvPr/>
-        </p:nvSpPr>
-        <p:spPr>
-          <a:xfrm xmlns:a="http://schemas.openxmlformats.org/drawingml/2006/main">
-            <a:off x="914400" y="3600450"/>
+                <a16:creationId xmlns:a16="http://schemas.microsoft.com/office/drawing/2014/main" id="{E05E0848-C52E-40DD-B2C0-48B54BB13DC3}"/>
+              </a:ext>
+            </a:extLst>
+          </p:cNvPr>
+          <p:cNvSpPr>
+            <a:spLocks xmlns:a="http://schemas.openxmlformats.org/drawingml/2006/main" noGrp="1"/>
+          </p:cNvSpPr>
+          <p:nvPr/>
+        </p:nvSpPr>
+        <p:spPr>
+          <a:xfrm xmlns:a="http://schemas.openxmlformats.org/drawingml/2006/main">
+            <a:off x="914400" y="3905250"/>
             <a:ext cx="9296400" cy="647700"/>
           </a:xfrm>
           <a:prstGeom xmlns:a="http://schemas.openxmlformats.org/drawingml/2006/main" prst="rect">
@@ -4247,18 +4337,18 @@
           <p:cNvPr id="6" name="footer">
             <a:extLst xmlns:a="http://schemas.openxmlformats.org/drawingml/2006/main">
               <a:ext uri="{FF2B5EF4-FFF2-40B4-BE49-F238E27FC236}">
-                <a16:creationId xmlns:a16="http://schemas.microsoft.com/office/drawing/2014/main" id="{72EEF049-9617-4B7C-9975-AEC798F1DA14}"/>
-              </a:ext>
-            </a:extLst>
-          </p:cNvPr>
-          <p:cNvSpPr>
-            <a:spLocks xmlns:a="http://schemas.openxmlformats.org/drawingml/2006/main" noGrp="1"/>
-          </p:cNvSpPr>
-          <p:nvPr/>
-        </p:nvSpPr>
-        <p:spPr>
-          <a:xfrm xmlns:a="http://schemas.openxmlformats.org/drawingml/2006/main">
-            <a:off x="914400" y="4533900"/>
+                <a16:creationId xmlns:a16="http://schemas.microsoft.com/office/drawing/2014/main" id="{E7FC1B18-F15C-431F-9AC8-00555F7A56E8}"/>
+              </a:ext>
+            </a:extLst>
+          </p:cNvPr>
+          <p:cNvSpPr>
+            <a:spLocks xmlns:a="http://schemas.openxmlformats.org/drawingml/2006/main" noGrp="1"/>
+          </p:cNvSpPr>
+          <p:nvPr/>
+        </p:nvSpPr>
+        <p:spPr>
+          <a:xfrm xmlns:a="http://schemas.openxmlformats.org/drawingml/2006/main">
+            <a:off x="914400" y="4857750"/>
             <a:ext cx="16459200" cy="209550"/>
           </a:xfrm>
           <a:prstGeom xmlns:a="http://schemas.openxmlformats.org/drawingml/2006/main" prst="rect">
@@ -4290,7 +4380,7 @@
     </p:spTree>
     <p:extLst>
       <p:ext uri="{BB962C8B-B14F-4D97-AF65-F5344CB8AC3E}">
-        <p14:creationId xmlns:p14="http://schemas.microsoft.com/office/powerpoint/2010/main" val="887994446"/>
+        <p14:creationId xmlns:p14="http://schemas.microsoft.com/office/powerpoint/2010/main" val="1679866376"/>
       </p:ext>
     </p:extLst>
   </p:cSld>

</xml_diff>

<commit_message>
Adjust secure branch to target 80 scope
</commit_message>
<xml_diff>
--- a/presentation/output/CLO2_Secure_Comments.pptx
+++ b/presentation/output/CLO2_Secure_Comments.pptx
@@ -2,19 +2,19 @@
 <file path=ppt/presentation.xml><?xml version="1.0" encoding="utf-8"?>
 <p:presentation xmlns:p="http://schemas.openxmlformats.org/presentationml/2006/main">
   <p:sldMasterIdLst>
-    <p:sldMasterId xmlns:r="http://schemas.openxmlformats.org/officeDocument/2006/relationships" id="2147483648" r:id="Rc8fb613c50804369"/>
+    <p:sldMasterId xmlns:r="http://schemas.openxmlformats.org/officeDocument/2006/relationships" id="2147483648" r:id="R788b6b5a537d4312"/>
   </p:sldMasterIdLst>
   <p:notesMasterIdLst>
-    <p:notesMasterId xmlns:r="http://schemas.openxmlformats.org/officeDocument/2006/relationships" r:id="R9b68a252680d4bab"/>
+    <p:notesMasterId xmlns:r="http://schemas.openxmlformats.org/officeDocument/2006/relationships" r:id="R91b3fc6892974d9c"/>
   </p:notesMasterIdLst>
   <p:sldIdLst>
-    <p:sldId xmlns:r="http://schemas.openxmlformats.org/officeDocument/2006/relationships" id="256" r:id="R629b93724ef44791"/>
-    <p:sldId xmlns:r="http://schemas.openxmlformats.org/officeDocument/2006/relationships" id="257" r:id="Refbd05200ad14f3c"/>
-    <p:sldId xmlns:r="http://schemas.openxmlformats.org/officeDocument/2006/relationships" id="258" r:id="Rd78f13f7f2644e1c"/>
-    <p:sldId xmlns:r="http://schemas.openxmlformats.org/officeDocument/2006/relationships" id="259" r:id="Raae9687557e54591"/>
-    <p:sldId xmlns:r="http://schemas.openxmlformats.org/officeDocument/2006/relationships" id="260" r:id="R2d07e068b8024826"/>
-    <p:sldId xmlns:r="http://schemas.openxmlformats.org/officeDocument/2006/relationships" id="261" r:id="R126c389a38c14e40"/>
-    <p:sldId xmlns:r="http://schemas.openxmlformats.org/officeDocument/2006/relationships" id="262" r:id="R318b010b38b3407e"/>
+    <p:sldId xmlns:r="http://schemas.openxmlformats.org/officeDocument/2006/relationships" id="256" r:id="R6467339c6ce64f02"/>
+    <p:sldId xmlns:r="http://schemas.openxmlformats.org/officeDocument/2006/relationships" id="257" r:id="R4f643337f0cd4dac"/>
+    <p:sldId xmlns:r="http://schemas.openxmlformats.org/officeDocument/2006/relationships" id="258" r:id="Rdefce141697248be"/>
+    <p:sldId xmlns:r="http://schemas.openxmlformats.org/officeDocument/2006/relationships" id="259" r:id="R219de9ef7c884330"/>
+    <p:sldId xmlns:r="http://schemas.openxmlformats.org/officeDocument/2006/relationships" id="260" r:id="Re60c64b684e94ab3"/>
+    <p:sldId xmlns:r="http://schemas.openxmlformats.org/officeDocument/2006/relationships" id="261" r:id="R944810e68b1d4557"/>
+    <p:sldId xmlns:r="http://schemas.openxmlformats.org/officeDocument/2006/relationships" id="262" r:id="Rf9db8e9b83884c04"/>
   </p:sldIdLst>
   <p:sldSz cx="18288000" cy="10287000"/>
   <p:notesSz cx="6858000" cy="9144000"/>
@@ -957,7 +957,7 @@
   </p:cSld>
   <p:clrMap bg1="lt1" tx1="dk1" bg2="lt2" tx2="dk2" accent1="accent1" accent2="accent2" accent3="accent3" accent4="accent4" accent5="accent5" accent6="accent6" hlink="hlink" folHlink="folHlink"/>
   <p:sldLayoutIdLst>
-    <p:sldLayoutId xmlns:r="http://schemas.openxmlformats.org/officeDocument/2006/relationships" id="2147483649" r:id="R7039701a818a4166"/>
+    <p:sldLayoutId xmlns:r="http://schemas.openxmlformats.org/officeDocument/2006/relationships" id="2147483649" r:id="R3c44dbea1b404ca8"/>
   </p:sldLayoutIdLst>
   <p:txStyles>
     <p:titleStyle>
@@ -1256,7 +1256,7 @@
           <p:cNvPr id="1" name="cover-title">
             <a:extLst xmlns:a="http://schemas.openxmlformats.org/drawingml/2006/main">
               <a:ext uri="{FF2B5EF4-FFF2-40B4-BE49-F238E27FC236}">
-                <a16:creationId xmlns:a16="http://schemas.microsoft.com/office/drawing/2014/main" id="{51F12734-F0B7-4144-914A-F398FB7C78D1}"/>
+                <a16:creationId xmlns:a16="http://schemas.microsoft.com/office/drawing/2014/main" id="{21D52C8A-6E6D-47AD-A585-4816D5DDCA64}"/>
               </a:ext>
             </a:extLst>
           </p:cNvPr>
@@ -1301,7 +1301,7 @@
           <p:cNvPr id="2" name="cover-rule">
             <a:extLst xmlns:a="http://schemas.openxmlformats.org/drawingml/2006/main">
               <a:ext uri="{FF2B5EF4-FFF2-40B4-BE49-F238E27FC236}">
-                <a16:creationId xmlns:a16="http://schemas.microsoft.com/office/drawing/2014/main" id="{5656D574-A3B4-46DD-8642-20DCF5391DBA}"/>
+                <a16:creationId xmlns:a16="http://schemas.microsoft.com/office/drawing/2014/main" id="{F5EB432A-0549-45B2-A126-A5E7CA91822F}"/>
               </a:ext>
             </a:extLst>
           </p:cNvPr>
@@ -1334,7 +1334,7 @@
           <p:cNvPr id="3" name="cover-subtitle">
             <a:extLst xmlns:a="http://schemas.openxmlformats.org/drawingml/2006/main">
               <a:ext uri="{FF2B5EF4-FFF2-40B4-BE49-F238E27FC236}">
-                <a16:creationId xmlns:a16="http://schemas.microsoft.com/office/drawing/2014/main" id="{B3E2835D-32D4-4C93-A8B4-A89A3FA84075}"/>
+                <a16:creationId xmlns:a16="http://schemas.microsoft.com/office/drawing/2014/main" id="{4FB6B9DD-9532-4BDB-B22B-3E10215B6DE3}"/>
               </a:ext>
             </a:extLst>
           </p:cNvPr>
@@ -1369,7 +1369,7 @@
                   <a:srgbClr val="16202A"/>
                 </a:solidFill>
               </a:rPr>
-              <a:t>Pengamanan aplikasi web target 80 poin: HTTPS, hash+salt, input limit, SQL injection, dan XSS.</a:t>
+              <a:t>Pengamanan aplikasi web target 80 poin: HTTPS, hash+salt, input limit, dan SQL injection.</a:t>
             </a:r>
           </a:p>
         </p:txBody>
@@ -1379,7 +1379,7 @@
           <p:cNvPr id="4" name="cover-context">
             <a:extLst xmlns:a="http://schemas.openxmlformats.org/drawingml/2006/main">
               <a:ext uri="{FF2B5EF4-FFF2-40B4-BE49-F238E27FC236}">
-                <a16:creationId xmlns:a16="http://schemas.microsoft.com/office/drawing/2014/main" id="{9D6FFB01-0558-4C58-ADCB-083726B04835}"/>
+                <a16:creationId xmlns:a16="http://schemas.microsoft.com/office/drawing/2014/main" id="{7091DCEB-D079-4F32-B87E-25C2CC466D80}"/>
               </a:ext>
             </a:extLst>
           </p:cNvPr>
@@ -1422,7 +1422,7 @@
     </p:spTree>
     <p:extLst>
       <p:ext uri="{BB962C8B-B14F-4D97-AF65-F5344CB8AC3E}">
-        <p14:creationId xmlns:p14="http://schemas.microsoft.com/office/powerpoint/2010/main" val="499640552"/>
+        <p14:creationId xmlns:p14="http://schemas.microsoft.com/office/powerpoint/2010/main" val="1677870701"/>
       </p:ext>
     </p:extLst>
   </p:cSld>
@@ -1446,7 +1446,7 @@
           <p:cNvPr id="1" name="slide-title">
             <a:extLst xmlns:a="http://schemas.openxmlformats.org/drawingml/2006/main">
               <a:ext uri="{FF2B5EF4-FFF2-40B4-BE49-F238E27FC236}">
-                <a16:creationId xmlns:a16="http://schemas.microsoft.com/office/drawing/2014/main" id="{4F0B4325-A480-48C4-8681-F4AA13738510}"/>
+                <a16:creationId xmlns:a16="http://schemas.microsoft.com/office/drawing/2014/main" id="{C00A37DC-533B-43C5-9081-B4A04C13FA27}"/>
               </a:ext>
             </a:extLst>
           </p:cNvPr>
@@ -1491,7 +1491,7 @@
           <p:cNvPr id="2" name="slide-subtitle">
             <a:extLst xmlns:a="http://schemas.openxmlformats.org/drawingml/2006/main">
               <a:ext uri="{FF2B5EF4-FFF2-40B4-BE49-F238E27FC236}">
-                <a16:creationId xmlns:a16="http://schemas.microsoft.com/office/drawing/2014/main" id="{6AA23E0B-5794-4A1E-9FA5-F2B176172696}"/>
+                <a16:creationId xmlns:a16="http://schemas.microsoft.com/office/drawing/2014/main" id="{8D2CB92F-CF88-4710-95B4-73EDC4F20A9E}"/>
               </a:ext>
             </a:extLst>
           </p:cNvPr>
@@ -1536,7 +1536,7 @@
           <p:cNvPr id="3" name="bullet-1">
             <a:extLst xmlns:a="http://schemas.openxmlformats.org/drawingml/2006/main">
               <a:ext uri="{FF2B5EF4-FFF2-40B4-BE49-F238E27FC236}">
-                <a16:creationId xmlns:a16="http://schemas.microsoft.com/office/drawing/2014/main" id="{DE3988DD-7957-4975-ACCF-BE2025FB08DA}"/>
+                <a16:creationId xmlns:a16="http://schemas.microsoft.com/office/drawing/2014/main" id="{45D4C1F8-AE8A-4E02-8CC9-1438B1AF1E6F}"/>
               </a:ext>
             </a:extLst>
           </p:cNvPr>
@@ -1581,7 +1581,7 @@
           <p:cNvPr id="4" name="bullet-2">
             <a:extLst xmlns:a="http://schemas.openxmlformats.org/drawingml/2006/main">
               <a:ext uri="{FF2B5EF4-FFF2-40B4-BE49-F238E27FC236}">
-                <a16:creationId xmlns:a16="http://schemas.microsoft.com/office/drawing/2014/main" id="{8BDF778E-ECD0-4F86-AC61-9751F06622E5}"/>
+                <a16:creationId xmlns:a16="http://schemas.microsoft.com/office/drawing/2014/main" id="{B26C5932-062C-4297-A2EA-119640259527}"/>
               </a:ext>
             </a:extLst>
           </p:cNvPr>
@@ -1626,7 +1626,7 @@
           <p:cNvPr id="5" name="bullet-3">
             <a:extLst xmlns:a="http://schemas.openxmlformats.org/drawingml/2006/main">
               <a:ext uri="{FF2B5EF4-FFF2-40B4-BE49-F238E27FC236}">
-                <a16:creationId xmlns:a16="http://schemas.microsoft.com/office/drawing/2014/main" id="{85B0FC3F-8872-48E7-807E-F8E094E41B13}"/>
+                <a16:creationId xmlns:a16="http://schemas.microsoft.com/office/drawing/2014/main" id="{2C73BDE2-2790-4D13-B4E9-D5F080472496}"/>
               </a:ext>
             </a:extLst>
           </p:cNvPr>
@@ -1671,7 +1671,7 @@
           <p:cNvPr id="6" name="bullet-4">
             <a:extLst xmlns:a="http://schemas.openxmlformats.org/drawingml/2006/main">
               <a:ext uri="{FF2B5EF4-FFF2-40B4-BE49-F238E27FC236}">
-                <a16:creationId xmlns:a16="http://schemas.microsoft.com/office/drawing/2014/main" id="{CF028671-2D83-44BC-AE1D-907CAC62852A}"/>
+                <a16:creationId xmlns:a16="http://schemas.microsoft.com/office/drawing/2014/main" id="{76EAEE28-A318-4557-9306-0E21D5C22A32}"/>
               </a:ext>
             </a:extLst>
           </p:cNvPr>
@@ -1716,7 +1716,7 @@
           <p:cNvPr id="7" name="footer">
             <a:extLst xmlns:a="http://schemas.openxmlformats.org/drawingml/2006/main">
               <a:ext uri="{FF2B5EF4-FFF2-40B4-BE49-F238E27FC236}">
-                <a16:creationId xmlns:a16="http://schemas.microsoft.com/office/drawing/2014/main" id="{0662A0D9-4B48-417D-B68E-A5BFAD27B97D}"/>
+                <a16:creationId xmlns:a16="http://schemas.microsoft.com/office/drawing/2014/main" id="{88E3196B-8465-4FAC-A664-FFAC8BF013C3}"/>
               </a:ext>
             </a:extLst>
           </p:cNvPr>
@@ -1759,7 +1759,7 @@
     </p:spTree>
     <p:extLst>
       <p:ext uri="{BB962C8B-B14F-4D97-AF65-F5344CB8AC3E}">
-        <p14:creationId xmlns:p14="http://schemas.microsoft.com/office/powerpoint/2010/main" val="199458740"/>
+        <p14:creationId xmlns:p14="http://schemas.microsoft.com/office/powerpoint/2010/main" val="1737214701"/>
       </p:ext>
     </p:extLst>
   </p:cSld>
@@ -1783,7 +1783,7 @@
           <p:cNvPr id="1" name="slide-title">
             <a:extLst xmlns:a="http://schemas.openxmlformats.org/drawingml/2006/main">
               <a:ext uri="{FF2B5EF4-FFF2-40B4-BE49-F238E27FC236}">
-                <a16:creationId xmlns:a16="http://schemas.microsoft.com/office/drawing/2014/main" id="{C377EC18-6F89-4D62-9430-D91B47381E19}"/>
+                <a16:creationId xmlns:a16="http://schemas.microsoft.com/office/drawing/2014/main" id="{51FF46CD-78BC-4FEA-960C-EF462DE887A3}"/>
               </a:ext>
             </a:extLst>
           </p:cNvPr>
@@ -1828,7 +1828,7 @@
           <p:cNvPr id="2" name="slide-subtitle">
             <a:extLst xmlns:a="http://schemas.openxmlformats.org/drawingml/2006/main">
               <a:ext uri="{FF2B5EF4-FFF2-40B4-BE49-F238E27FC236}">
-                <a16:creationId xmlns:a16="http://schemas.microsoft.com/office/drawing/2014/main" id="{C3B99958-434F-4CAD-A993-9F1B7ED6C400}"/>
+                <a16:creationId xmlns:a16="http://schemas.microsoft.com/office/drawing/2014/main" id="{241A8BAC-F306-40DF-8ABB-3674CBD703E7}"/>
               </a:ext>
             </a:extLst>
           </p:cNvPr>
@@ -1873,7 +1873,7 @@
           <p:cNvPr id="3" name="method-HTTPS/TLS">
             <a:extLst xmlns:a="http://schemas.openxmlformats.org/drawingml/2006/main">
               <a:ext uri="{FF2B5EF4-FFF2-40B4-BE49-F238E27FC236}">
-                <a16:creationId xmlns:a16="http://schemas.microsoft.com/office/drawing/2014/main" id="{8AB6F01C-96FD-49B1-A8C2-62249E07DEC8}"/>
+                <a16:creationId xmlns:a16="http://schemas.microsoft.com/office/drawing/2014/main" id="{21934897-2343-4FB8-A06E-07B9ED6DF8F6}"/>
               </a:ext>
             </a:extLst>
           </p:cNvPr>
@@ -1902,7 +1902,7 @@
           <p:cNvPr id="4" name="">
             <a:extLst xmlns:a="http://schemas.openxmlformats.org/drawingml/2006/main">
               <a:ext uri="{FF2B5EF4-FFF2-40B4-BE49-F238E27FC236}">
-                <a16:creationId xmlns:a16="http://schemas.microsoft.com/office/drawing/2014/main" id="{ED18EFC5-CE5D-45F0-B269-1CB6E5D075CE}"/>
+                <a16:creationId xmlns:a16="http://schemas.microsoft.com/office/drawing/2014/main" id="{E1FF2E53-7685-43EE-8448-93176E269F19}"/>
               </a:ext>
             </a:extLst>
           </p:cNvPr>
@@ -1947,7 +1947,7 @@
           <p:cNvPr id="5" name="">
             <a:extLst xmlns:a="http://schemas.openxmlformats.org/drawingml/2006/main">
               <a:ext uri="{FF2B5EF4-FFF2-40B4-BE49-F238E27FC236}">
-                <a16:creationId xmlns:a16="http://schemas.microsoft.com/office/drawing/2014/main" id="{0D8E4760-E95C-4719-822B-F59FC1B792F2}"/>
+                <a16:creationId xmlns:a16="http://schemas.microsoft.com/office/drawing/2014/main" id="{C798843F-7BE9-4575-9472-946003DB3722}"/>
               </a:ext>
             </a:extLst>
           </p:cNvPr>
@@ -1992,7 +1992,7 @@
           <p:cNvPr id="6" name="method-Hash + salt">
             <a:extLst xmlns:a="http://schemas.openxmlformats.org/drawingml/2006/main">
               <a:ext uri="{FF2B5EF4-FFF2-40B4-BE49-F238E27FC236}">
-                <a16:creationId xmlns:a16="http://schemas.microsoft.com/office/drawing/2014/main" id="{5B327487-4C1A-4EA3-AB6A-C051453A041A}"/>
+                <a16:creationId xmlns:a16="http://schemas.microsoft.com/office/drawing/2014/main" id="{0D3962FF-A42A-47BE-B6E2-629EFF2C556B}"/>
               </a:ext>
             </a:extLst>
           </p:cNvPr>
@@ -2021,7 +2021,7 @@
           <p:cNvPr id="7" name="">
             <a:extLst xmlns:a="http://schemas.openxmlformats.org/drawingml/2006/main">
               <a:ext uri="{FF2B5EF4-FFF2-40B4-BE49-F238E27FC236}">
-                <a16:creationId xmlns:a16="http://schemas.microsoft.com/office/drawing/2014/main" id="{F5FC929C-877F-4735-B6CC-9D7EA8F7800E}"/>
+                <a16:creationId xmlns:a16="http://schemas.microsoft.com/office/drawing/2014/main" id="{A51F27DC-0020-477B-BBE0-A526D6ABDE43}"/>
               </a:ext>
             </a:extLst>
           </p:cNvPr>
@@ -2066,7 +2066,7 @@
           <p:cNvPr id="8" name="">
             <a:extLst xmlns:a="http://schemas.openxmlformats.org/drawingml/2006/main">
               <a:ext uri="{FF2B5EF4-FFF2-40B4-BE49-F238E27FC236}">
-                <a16:creationId xmlns:a16="http://schemas.microsoft.com/office/drawing/2014/main" id="{AA24BE08-1291-4905-86A3-BC736B40FF8C}"/>
+                <a16:creationId xmlns:a16="http://schemas.microsoft.com/office/drawing/2014/main" id="{C6FF879B-1686-42C4-AD5E-3CE611A8B2F8}"/>
               </a:ext>
             </a:extLst>
           </p:cNvPr>
@@ -2111,7 +2111,7 @@
           <p:cNvPr id="9" name="method-Input limit">
             <a:extLst xmlns:a="http://schemas.openxmlformats.org/drawingml/2006/main">
               <a:ext uri="{FF2B5EF4-FFF2-40B4-BE49-F238E27FC236}">
-                <a16:creationId xmlns:a16="http://schemas.microsoft.com/office/drawing/2014/main" id="{9A87CFD7-758A-40B6-9473-3E658ABCA73B}"/>
+                <a16:creationId xmlns:a16="http://schemas.microsoft.com/office/drawing/2014/main" id="{454D515C-AF06-488C-B1FB-6F0793C671B8}"/>
               </a:ext>
             </a:extLst>
           </p:cNvPr>
@@ -2140,7 +2140,7 @@
           <p:cNvPr id="10" name="">
             <a:extLst xmlns:a="http://schemas.openxmlformats.org/drawingml/2006/main">
               <a:ext uri="{FF2B5EF4-FFF2-40B4-BE49-F238E27FC236}">
-                <a16:creationId xmlns:a16="http://schemas.microsoft.com/office/drawing/2014/main" id="{6A84187A-E371-4032-932A-CE61695597FF}"/>
+                <a16:creationId xmlns:a16="http://schemas.microsoft.com/office/drawing/2014/main" id="{D8404DCD-34F0-4849-9EC7-3C2189A2AA8D}"/>
               </a:ext>
             </a:extLst>
           </p:cNvPr>
@@ -2185,7 +2185,7 @@
           <p:cNvPr id="11" name="">
             <a:extLst xmlns:a="http://schemas.openxmlformats.org/drawingml/2006/main">
               <a:ext uri="{FF2B5EF4-FFF2-40B4-BE49-F238E27FC236}">
-                <a16:creationId xmlns:a16="http://schemas.microsoft.com/office/drawing/2014/main" id="{F8042A50-2BAC-47F5-97DA-89D0647D1045}"/>
+                <a16:creationId xmlns:a16="http://schemas.microsoft.com/office/drawing/2014/main" id="{56151799-F033-4206-B70D-FDF5AE0065A9}"/>
               </a:ext>
             </a:extLst>
           </p:cNvPr>
@@ -2230,7 +2230,7 @@
           <p:cNvPr id="12" name="method-SQL injection">
             <a:extLst xmlns:a="http://schemas.openxmlformats.org/drawingml/2006/main">
               <a:ext uri="{FF2B5EF4-FFF2-40B4-BE49-F238E27FC236}">
-                <a16:creationId xmlns:a16="http://schemas.microsoft.com/office/drawing/2014/main" id="{00262577-5F28-4206-AD3D-58483BA16348}"/>
+                <a16:creationId xmlns:a16="http://schemas.microsoft.com/office/drawing/2014/main" id="{35D6C354-E8FA-4534-9A20-ABF5809CC2B8}"/>
               </a:ext>
             </a:extLst>
           </p:cNvPr>
@@ -2259,7 +2259,7 @@
           <p:cNvPr id="13" name="">
             <a:extLst xmlns:a="http://schemas.openxmlformats.org/drawingml/2006/main">
               <a:ext uri="{FF2B5EF4-FFF2-40B4-BE49-F238E27FC236}">
-                <a16:creationId xmlns:a16="http://schemas.microsoft.com/office/drawing/2014/main" id="{644712F7-0FE8-4D9D-B02B-12F7614EA304}"/>
+                <a16:creationId xmlns:a16="http://schemas.microsoft.com/office/drawing/2014/main" id="{A3246C49-41B9-4EFC-8C8F-EA8801D29D55}"/>
               </a:ext>
             </a:extLst>
           </p:cNvPr>
@@ -2304,7 +2304,7 @@
           <p:cNvPr id="14" name="">
             <a:extLst xmlns:a="http://schemas.openxmlformats.org/drawingml/2006/main">
               <a:ext uri="{FF2B5EF4-FFF2-40B4-BE49-F238E27FC236}">
-                <a16:creationId xmlns:a16="http://schemas.microsoft.com/office/drawing/2014/main" id="{230D9C84-CB7C-497C-BD74-24A045B7356D}"/>
+                <a16:creationId xmlns:a16="http://schemas.microsoft.com/office/drawing/2014/main" id="{55E79837-DF73-43C7-95E6-420335DDBCE5}"/>
               </a:ext>
             </a:extLst>
           </p:cNvPr>
@@ -2346,10 +2346,10 @@
       </p:sp>
       <p:sp>
         <p:nvSpPr>
-          <p:cNvPr id="15" name="method-XSS">
-            <a:extLst xmlns:a="http://schemas.openxmlformats.org/drawingml/2006/main">
-              <a:ext uri="{FF2B5EF4-FFF2-40B4-BE49-F238E27FC236}">
-                <a16:creationId xmlns:a16="http://schemas.microsoft.com/office/drawing/2014/main" id="{92CD40CA-EC5A-45CD-84CB-C0F542499FBB}"/>
+          <p:cNvPr id="15" name="method-Admin proof">
+            <a:extLst xmlns:a="http://schemas.openxmlformats.org/drawingml/2006/main">
+              <a:ext uri="{FF2B5EF4-FFF2-40B4-BE49-F238E27FC236}">
+                <a16:creationId xmlns:a16="http://schemas.microsoft.com/office/drawing/2014/main" id="{C61F511A-1540-4E4F-B173-D1CA7B858F30}"/>
               </a:ext>
             </a:extLst>
           </p:cNvPr>
@@ -2378,7 +2378,7 @@
           <p:cNvPr id="16" name="">
             <a:extLst xmlns:a="http://schemas.openxmlformats.org/drawingml/2006/main">
               <a:ext uri="{FF2B5EF4-FFF2-40B4-BE49-F238E27FC236}">
-                <a16:creationId xmlns:a16="http://schemas.microsoft.com/office/drawing/2014/main" id="{C3F61196-BA07-4488-A9B7-A9FEBFE67893}"/>
+                <a16:creationId xmlns:a16="http://schemas.microsoft.com/office/drawing/2014/main" id="{DE8DA3A2-2C06-423B-B216-2B8662B0E548}"/>
               </a:ext>
             </a:extLst>
           </p:cNvPr>
@@ -2413,7 +2413,7 @@
                   <a:srgbClr val="0F766E"/>
                 </a:solidFill>
               </a:rPr>
-              <a:t>XSS</a:t>
+              <a:t>Admin proof</a:t>
             </a:r>
           </a:p>
         </p:txBody>
@@ -2423,7 +2423,7 @@
           <p:cNvPr id="17" name="">
             <a:extLst xmlns:a="http://schemas.openxmlformats.org/drawingml/2006/main">
               <a:ext uri="{FF2B5EF4-FFF2-40B4-BE49-F238E27FC236}">
-                <a16:creationId xmlns:a16="http://schemas.microsoft.com/office/drawing/2014/main" id="{48FB0B29-EBBF-4BEB-A884-3C5AAE516F76}"/>
+                <a16:creationId xmlns:a16="http://schemas.microsoft.com/office/drawing/2014/main" id="{F5B199BF-86C0-4B47-99BD-943EB6FE3BEC}"/>
               </a:ext>
             </a:extLst>
           </p:cNvPr>
@@ -2458,17 +2458,17 @@
                   <a:srgbClr val="16202A"/>
                 </a:solidFill>
               </a:rPr>
-              <a:t>Output komentar di-escape dengan htmlspecialchars().</a:t>
-            </a:r>
-          </a:p>
-        </p:txBody>
-      </p:sp>
-      <p:sp>
-        <p:nvSpPr>
-          <p:cNvPr id="18" name="method-Admin proof">
-            <a:extLst xmlns:a="http://schemas.openxmlformats.org/drawingml/2006/main">
-              <a:ext uri="{FF2B5EF4-FFF2-40B4-BE49-F238E27FC236}">
-                <a16:creationId xmlns:a16="http://schemas.microsoft.com/office/drawing/2014/main" id="{AFD8045A-7B98-43A5-8E4E-992C3ABC2D9E}"/>
+              <a:t>Panel admin menampilkan hash password, bukan plaintext.</a:t>
+            </a:r>
+          </a:p>
+        </p:txBody>
+      </p:sp>
+      <p:sp>
+        <p:nvSpPr>
+          <p:cNvPr id="18" name="method-Scope">
+            <a:extLst xmlns:a="http://schemas.openxmlformats.org/drawingml/2006/main">
+              <a:ext uri="{FF2B5EF4-FFF2-40B4-BE49-F238E27FC236}">
+                <a16:creationId xmlns:a16="http://schemas.microsoft.com/office/drawing/2014/main" id="{19EB60B7-E0AD-4C84-AAB5-643B3F89CA28}"/>
               </a:ext>
             </a:extLst>
           </p:cNvPr>
@@ -2497,7 +2497,7 @@
           <p:cNvPr id="19" name="">
             <a:extLst xmlns:a="http://schemas.openxmlformats.org/drawingml/2006/main">
               <a:ext uri="{FF2B5EF4-FFF2-40B4-BE49-F238E27FC236}">
-                <a16:creationId xmlns:a16="http://schemas.microsoft.com/office/drawing/2014/main" id="{76182BB8-9821-49ED-8077-9E1C07CA378D}"/>
+                <a16:creationId xmlns:a16="http://schemas.microsoft.com/office/drawing/2014/main" id="{2EF8AC26-6613-424C-884F-5EDA704DE875}"/>
               </a:ext>
             </a:extLst>
           </p:cNvPr>
@@ -2532,7 +2532,7 @@
                   <a:srgbClr val="0F766E"/>
                 </a:solidFill>
               </a:rPr>
-              <a:t>Admin proof</a:t>
+              <a:t>Scope</a:t>
             </a:r>
           </a:p>
         </p:txBody>
@@ -2542,7 +2542,7 @@
           <p:cNvPr id="20" name="">
             <a:extLst xmlns:a="http://schemas.openxmlformats.org/drawingml/2006/main">
               <a:ext uri="{FF2B5EF4-FFF2-40B4-BE49-F238E27FC236}">
-                <a16:creationId xmlns:a16="http://schemas.microsoft.com/office/drawing/2014/main" id="{10ADE690-5C3F-45A5-B0C8-C619BFB18A46}"/>
+                <a16:creationId xmlns:a16="http://schemas.microsoft.com/office/drawing/2014/main" id="{282C0F74-E2BF-4E4E-BA6D-F41CFEB6880E}"/>
               </a:ext>
             </a:extLst>
           </p:cNvPr>
@@ -2577,7 +2577,7 @@
                   <a:srgbClr val="16202A"/>
                 </a:solidFill>
               </a:rPr>
-              <a:t>Panel admin menampilkan hash password, bukan plaintext.</a:t>
+              <a:t>XSS dan brute force tidak diklaim pada target 80 ini.</a:t>
             </a:r>
           </a:p>
         </p:txBody>
@@ -2587,7 +2587,7 @@
           <p:cNvPr id="21" name="footer">
             <a:extLst xmlns:a="http://schemas.openxmlformats.org/drawingml/2006/main">
               <a:ext uri="{FF2B5EF4-FFF2-40B4-BE49-F238E27FC236}">
-                <a16:creationId xmlns:a16="http://schemas.microsoft.com/office/drawing/2014/main" id="{66016CB8-0806-4D12-AB80-0C13DF6A6821}"/>
+                <a16:creationId xmlns:a16="http://schemas.microsoft.com/office/drawing/2014/main" id="{899F20FD-4D8C-4494-9683-1C972C8DC473}"/>
               </a:ext>
             </a:extLst>
           </p:cNvPr>
@@ -2630,7 +2630,7 @@
     </p:spTree>
     <p:extLst>
       <p:ext uri="{BB962C8B-B14F-4D97-AF65-F5344CB8AC3E}">
-        <p14:creationId xmlns:p14="http://schemas.microsoft.com/office/powerpoint/2010/main" val="178202425"/>
+        <p14:creationId xmlns:p14="http://schemas.microsoft.com/office/powerpoint/2010/main" val="678765143"/>
       </p:ext>
     </p:extLst>
   </p:cSld>
@@ -2654,7 +2654,7 @@
           <p:cNvPr id="1" name="slide-title">
             <a:extLst xmlns:a="http://schemas.openxmlformats.org/drawingml/2006/main">
               <a:ext uri="{FF2B5EF4-FFF2-40B4-BE49-F238E27FC236}">
-                <a16:creationId xmlns:a16="http://schemas.microsoft.com/office/drawing/2014/main" id="{1E9C9CC3-EEA5-48B1-8456-9C0ECF3D92CC}"/>
+                <a16:creationId xmlns:a16="http://schemas.microsoft.com/office/drawing/2014/main" id="{DE930620-7966-43BE-85D0-7A9B153F4A23}"/>
               </a:ext>
             </a:extLst>
           </p:cNvPr>
@@ -2699,7 +2699,7 @@
           <p:cNvPr id="2" name="slide-subtitle">
             <a:extLst xmlns:a="http://schemas.openxmlformats.org/drawingml/2006/main">
               <a:ext uri="{FF2B5EF4-FFF2-40B4-BE49-F238E27FC236}">
-                <a16:creationId xmlns:a16="http://schemas.microsoft.com/office/drawing/2014/main" id="{BEC04EDB-1956-47AB-8CFB-023FDBD371C0}"/>
+                <a16:creationId xmlns:a16="http://schemas.microsoft.com/office/drawing/2014/main" id="{BC018CFE-0B91-4EE3-A06A-07D49B2BE258}"/>
               </a:ext>
             </a:extLst>
           </p:cNvPr>
@@ -2744,7 +2744,7 @@
           <p:cNvPr id="3" name="method-Browser">
             <a:extLst xmlns:a="http://schemas.openxmlformats.org/drawingml/2006/main">
               <a:ext uri="{FF2B5EF4-FFF2-40B4-BE49-F238E27FC236}">
-                <a16:creationId xmlns:a16="http://schemas.microsoft.com/office/drawing/2014/main" id="{F729F70D-CE94-4EC5-A314-F4735A42A153}"/>
+                <a16:creationId xmlns:a16="http://schemas.microsoft.com/office/drawing/2014/main" id="{8C4A51FC-4228-4E23-A04C-DD4E5BAF1704}"/>
               </a:ext>
             </a:extLst>
           </p:cNvPr>
@@ -2773,7 +2773,7 @@
           <p:cNvPr id="4" name="">
             <a:extLst xmlns:a="http://schemas.openxmlformats.org/drawingml/2006/main">
               <a:ext uri="{FF2B5EF4-FFF2-40B4-BE49-F238E27FC236}">
-                <a16:creationId xmlns:a16="http://schemas.microsoft.com/office/drawing/2014/main" id="{B7D7B133-3A60-4208-B339-DB5624CA1540}"/>
+                <a16:creationId xmlns:a16="http://schemas.microsoft.com/office/drawing/2014/main" id="{CC61B4E5-22B3-491D-AA85-752061725B07}"/>
               </a:ext>
             </a:extLst>
           </p:cNvPr>
@@ -2818,7 +2818,7 @@
           <p:cNvPr id="5" name="">
             <a:extLst xmlns:a="http://schemas.openxmlformats.org/drawingml/2006/main">
               <a:ext uri="{FF2B5EF4-FFF2-40B4-BE49-F238E27FC236}">
-                <a16:creationId xmlns:a16="http://schemas.microsoft.com/office/drawing/2014/main" id="{6619A050-19E0-4A7F-A8DD-F7DB6C3C594A}"/>
+                <a16:creationId xmlns:a16="http://schemas.microsoft.com/office/drawing/2014/main" id="{A86F9BBF-2F9A-4D11-BD00-5124B939496A}"/>
               </a:ext>
             </a:extLst>
           </p:cNvPr>
@@ -2863,7 +2863,7 @@
           <p:cNvPr id="6" name="">
             <a:extLst xmlns:a="http://schemas.openxmlformats.org/drawingml/2006/main">
               <a:ext uri="{FF2B5EF4-FFF2-40B4-BE49-F238E27FC236}">
-                <a16:creationId xmlns:a16="http://schemas.microsoft.com/office/drawing/2014/main" id="{36411A2F-7838-4D1F-953A-C545A1BB0BB0}"/>
+                <a16:creationId xmlns:a16="http://schemas.microsoft.com/office/drawing/2014/main" id="{E213FBA2-A701-4833-9FD9-4883D2527B93}"/>
               </a:ext>
             </a:extLst>
           </p:cNvPr>
@@ -2908,7 +2908,7 @@
           <p:cNvPr id="7" name="method-Apache + PHP">
             <a:extLst xmlns:a="http://schemas.openxmlformats.org/drawingml/2006/main">
               <a:ext uri="{FF2B5EF4-FFF2-40B4-BE49-F238E27FC236}">
-                <a16:creationId xmlns:a16="http://schemas.microsoft.com/office/drawing/2014/main" id="{4390AEB5-C10F-46A7-9072-417519A9C9AA}"/>
+                <a16:creationId xmlns:a16="http://schemas.microsoft.com/office/drawing/2014/main" id="{6019414D-5D86-4738-817C-55882EB99590}"/>
               </a:ext>
             </a:extLst>
           </p:cNvPr>
@@ -2937,7 +2937,7 @@
           <p:cNvPr id="8" name="">
             <a:extLst xmlns:a="http://schemas.openxmlformats.org/drawingml/2006/main">
               <a:ext uri="{FF2B5EF4-FFF2-40B4-BE49-F238E27FC236}">
-                <a16:creationId xmlns:a16="http://schemas.microsoft.com/office/drawing/2014/main" id="{27B7A5E3-C0F2-41F5-9DD0-49029B490EB4}"/>
+                <a16:creationId xmlns:a16="http://schemas.microsoft.com/office/drawing/2014/main" id="{D617BA03-A3F3-40CC-9F69-85CCDD1BE165}"/>
               </a:ext>
             </a:extLst>
           </p:cNvPr>
@@ -2982,7 +2982,7 @@
           <p:cNvPr id="9" name="">
             <a:extLst xmlns:a="http://schemas.openxmlformats.org/drawingml/2006/main">
               <a:ext uri="{FF2B5EF4-FFF2-40B4-BE49-F238E27FC236}">
-                <a16:creationId xmlns:a16="http://schemas.microsoft.com/office/drawing/2014/main" id="{9C717D97-07FD-413D-851A-84178A53D217}"/>
+                <a16:creationId xmlns:a16="http://schemas.microsoft.com/office/drawing/2014/main" id="{5073FB58-512A-44E4-B8C9-EC3EE164AF61}"/>
               </a:ext>
             </a:extLst>
           </p:cNvPr>
@@ -3017,7 +3017,7 @@
                   <a:srgbClr val="16202A"/>
                 </a:solidFill>
               </a:rPr>
-              <a:t>Redirect HTTP ke HTTPS, autentikasi, validasi input, prepared statement, dan escaping.</a:t>
+              <a:t>Redirect HTTP ke HTTPS, autentikasi, validasi input, dan prepared statement.</a:t>
             </a:r>
           </a:p>
         </p:txBody>
@@ -3027,7 +3027,7 @@
           <p:cNvPr id="10" name="">
             <a:extLst xmlns:a="http://schemas.openxmlformats.org/drawingml/2006/main">
               <a:ext uri="{FF2B5EF4-FFF2-40B4-BE49-F238E27FC236}">
-                <a16:creationId xmlns:a16="http://schemas.microsoft.com/office/drawing/2014/main" id="{6E4818D4-452A-437B-A12F-F403F17BE1A9}"/>
+                <a16:creationId xmlns:a16="http://schemas.microsoft.com/office/drawing/2014/main" id="{CFEFF341-655F-4A86-8121-1E82F246C6C1}"/>
               </a:ext>
             </a:extLst>
           </p:cNvPr>
@@ -3072,7 +3072,7 @@
           <p:cNvPr id="11" name="method-MySQL">
             <a:extLst xmlns:a="http://schemas.openxmlformats.org/drawingml/2006/main">
               <a:ext uri="{FF2B5EF4-FFF2-40B4-BE49-F238E27FC236}">
-                <a16:creationId xmlns:a16="http://schemas.microsoft.com/office/drawing/2014/main" id="{B543D298-C1A1-4F0C-9004-C9767D3B83E5}"/>
+                <a16:creationId xmlns:a16="http://schemas.microsoft.com/office/drawing/2014/main" id="{B7DA00CF-F0C8-4FD1-92C2-6CCA290C5120}"/>
               </a:ext>
             </a:extLst>
           </p:cNvPr>
@@ -3101,7 +3101,7 @@
           <p:cNvPr id="12" name="">
             <a:extLst xmlns:a="http://schemas.openxmlformats.org/drawingml/2006/main">
               <a:ext uri="{FF2B5EF4-FFF2-40B4-BE49-F238E27FC236}">
-                <a16:creationId xmlns:a16="http://schemas.microsoft.com/office/drawing/2014/main" id="{A123CBAA-8284-4FFE-BF54-BA35F6FFE096}"/>
+                <a16:creationId xmlns:a16="http://schemas.microsoft.com/office/drawing/2014/main" id="{AD19FA38-75EA-4A91-841F-B7C4A5541650}"/>
               </a:ext>
             </a:extLst>
           </p:cNvPr>
@@ -3146,7 +3146,7 @@
           <p:cNvPr id="13" name="">
             <a:extLst xmlns:a="http://schemas.openxmlformats.org/drawingml/2006/main">
               <a:ext uri="{FF2B5EF4-FFF2-40B4-BE49-F238E27FC236}">
-                <a16:creationId xmlns:a16="http://schemas.microsoft.com/office/drawing/2014/main" id="{27DA0609-35B3-45BC-832A-61C5392C6CF4}"/>
+                <a16:creationId xmlns:a16="http://schemas.microsoft.com/office/drawing/2014/main" id="{E15313CA-0DB3-4C29-AE56-B99730094D55}"/>
               </a:ext>
             </a:extLst>
           </p:cNvPr>
@@ -3191,7 +3191,7 @@
           <p:cNvPr id="14" name="network-note">
             <a:extLst xmlns:a="http://schemas.openxmlformats.org/drawingml/2006/main">
               <a:ext uri="{FF2B5EF4-FFF2-40B4-BE49-F238E27FC236}">
-                <a16:creationId xmlns:a16="http://schemas.microsoft.com/office/drawing/2014/main" id="{CF9147B1-7811-41F2-87E1-BAA1BC1A567E}"/>
+                <a16:creationId xmlns:a16="http://schemas.microsoft.com/office/drawing/2014/main" id="{6FE02F7C-67B2-49E3-B629-9085A2613CC6}"/>
               </a:ext>
             </a:extLst>
           </p:cNvPr>
@@ -3236,7 +3236,7 @@
           <p:cNvPr id="15" name="footer">
             <a:extLst xmlns:a="http://schemas.openxmlformats.org/drawingml/2006/main">
               <a:ext uri="{FF2B5EF4-FFF2-40B4-BE49-F238E27FC236}">
-                <a16:creationId xmlns:a16="http://schemas.microsoft.com/office/drawing/2014/main" id="{8CB6C201-A893-441D-A54C-0A333B70B64D}"/>
+                <a16:creationId xmlns:a16="http://schemas.microsoft.com/office/drawing/2014/main" id="{917A5F98-8526-4165-AF40-1717C0F81A30}"/>
               </a:ext>
             </a:extLst>
           </p:cNvPr>
@@ -3279,7 +3279,7 @@
     </p:spTree>
     <p:extLst>
       <p:ext uri="{BB962C8B-B14F-4D97-AF65-F5344CB8AC3E}">
-        <p14:creationId xmlns:p14="http://schemas.microsoft.com/office/powerpoint/2010/main" val="2075406580"/>
+        <p14:creationId xmlns:p14="http://schemas.microsoft.com/office/powerpoint/2010/main" val="1168845844"/>
       </p:ext>
     </p:extLst>
   </p:cSld>
@@ -3303,7 +3303,7 @@
           <p:cNvPr id="1" name="slide-title">
             <a:extLst xmlns:a="http://schemas.openxmlformats.org/drawingml/2006/main">
               <a:ext uri="{FF2B5EF4-FFF2-40B4-BE49-F238E27FC236}">
-                <a16:creationId xmlns:a16="http://schemas.microsoft.com/office/drawing/2014/main" id="{ECE18658-FE32-47F1-BAF9-3D590FDE544E}"/>
+                <a16:creationId xmlns:a16="http://schemas.microsoft.com/office/drawing/2014/main" id="{600AB41A-998D-4BBE-81AB-21E178A973B0}"/>
               </a:ext>
             </a:extLst>
           </p:cNvPr>
@@ -3348,7 +3348,7 @@
           <p:cNvPr id="2" name="slide-subtitle">
             <a:extLst xmlns:a="http://schemas.openxmlformats.org/drawingml/2006/main">
               <a:ext uri="{FF2B5EF4-FFF2-40B4-BE49-F238E27FC236}">
-                <a16:creationId xmlns:a16="http://schemas.microsoft.com/office/drawing/2014/main" id="{095ACFB7-4B2E-4B37-99EB-75600C8E5FF2}"/>
+                <a16:creationId xmlns:a16="http://schemas.microsoft.com/office/drawing/2014/main" id="{8E9A94DE-D9AE-466E-A1D1-0D21E40D4A73}"/>
               </a:ext>
             </a:extLst>
           </p:cNvPr>
@@ -3360,7 +3360,7 @@
         <p:spPr>
           <a:xfrm xmlns:a="http://schemas.openxmlformats.org/drawingml/2006/main">
             <a:off x="914400" y="1485900"/>
-            <a:ext cx="6019800" cy="514350"/>
+            <a:ext cx="5619750" cy="514350"/>
           </a:xfrm>
           <a:prstGeom xmlns:a="http://schemas.openxmlformats.org/drawingml/2006/main" prst="rect">
             <a:avLst/>
@@ -3383,7 +3383,7 @@
                   <a:srgbClr val="5E6B78"/>
                 </a:solidFill>
               </a:rPr>
-              <a:t>Kontrol disesuaikan dengan rubrik SSL, hash+salt, buffer, SQLi, dan XSS.</a:t>
+              <a:t>Kontrol disesuaikan dengan rubrik SSL, hash+salt, buffer, dan SQLi.</a:t>
             </a:r>
           </a:p>
         </p:txBody>
@@ -3393,7 +3393,7 @@
           <p:cNvPr id="3" name="bullet-1">
             <a:extLst xmlns:a="http://schemas.openxmlformats.org/drawingml/2006/main">
               <a:ext uri="{FF2B5EF4-FFF2-40B4-BE49-F238E27FC236}">
-                <a16:creationId xmlns:a16="http://schemas.microsoft.com/office/drawing/2014/main" id="{7DB252C6-272B-493A-8F66-12EC65A02A67}"/>
+                <a16:creationId xmlns:a16="http://schemas.microsoft.com/office/drawing/2014/main" id="{E2F513D2-E175-43A8-B6DE-F556CCF6C266}"/>
               </a:ext>
             </a:extLst>
           </p:cNvPr>
@@ -3438,7 +3438,7 @@
           <p:cNvPr id="4" name="bullet-2">
             <a:extLst xmlns:a="http://schemas.openxmlformats.org/drawingml/2006/main">
               <a:ext uri="{FF2B5EF4-FFF2-40B4-BE49-F238E27FC236}">
-                <a16:creationId xmlns:a16="http://schemas.microsoft.com/office/drawing/2014/main" id="{2299A9ED-6114-492E-9087-728B8BA783F9}"/>
+                <a16:creationId xmlns:a16="http://schemas.microsoft.com/office/drawing/2014/main" id="{1D4C7371-C9DD-4EE7-97EB-1CCCE875C5D0}"/>
               </a:ext>
             </a:extLst>
           </p:cNvPr>
@@ -3483,7 +3483,7 @@
           <p:cNvPr id="5" name="bullet-3">
             <a:extLst xmlns:a="http://schemas.openxmlformats.org/drawingml/2006/main">
               <a:ext uri="{FF2B5EF4-FFF2-40B4-BE49-F238E27FC236}">
-                <a16:creationId xmlns:a16="http://schemas.microsoft.com/office/drawing/2014/main" id="{C37203A9-F7DD-4F16-90AD-D8B3B5ABC582}"/>
+                <a16:creationId xmlns:a16="http://schemas.microsoft.com/office/drawing/2014/main" id="{2916530A-30B2-4EB5-9EDC-BA4822669368}"/>
               </a:ext>
             </a:extLst>
           </p:cNvPr>
@@ -3528,7 +3528,7 @@
           <p:cNvPr id="6" name="bullet-4">
             <a:extLst xmlns:a="http://schemas.openxmlformats.org/drawingml/2006/main">
               <a:ext uri="{FF2B5EF4-FFF2-40B4-BE49-F238E27FC236}">
-                <a16:creationId xmlns:a16="http://schemas.microsoft.com/office/drawing/2014/main" id="{3CD627D6-F2B3-4481-8F6D-F2B5F5EA50F1}"/>
+                <a16:creationId xmlns:a16="http://schemas.microsoft.com/office/drawing/2014/main" id="{5063A0E3-BA3E-4029-A233-12DDAF2BEABE}"/>
               </a:ext>
             </a:extLst>
           </p:cNvPr>
@@ -3573,7 +3573,7 @@
           <p:cNvPr id="7" name="bullet-5">
             <a:extLst xmlns:a="http://schemas.openxmlformats.org/drawingml/2006/main">
               <a:ext uri="{FF2B5EF4-FFF2-40B4-BE49-F238E27FC236}">
-                <a16:creationId xmlns:a16="http://schemas.microsoft.com/office/drawing/2014/main" id="{D817D374-1072-42F1-9ADC-4C70D09CEB4C}"/>
+                <a16:creationId xmlns:a16="http://schemas.microsoft.com/office/drawing/2014/main" id="{19027267-7DE2-4BDC-8573-86189C1CA38E}"/>
               </a:ext>
             </a:extLst>
           </p:cNvPr>
@@ -3585,7 +3585,7 @@
         <p:spPr>
           <a:xfrm xmlns:a="http://schemas.openxmlformats.org/drawingml/2006/main">
             <a:off x="914400" y="5219700"/>
-            <a:ext cx="7086600" cy="323850"/>
+            <a:ext cx="5848350" cy="647700"/>
           </a:xfrm>
           <a:prstGeom xmlns:a="http://schemas.openxmlformats.org/drawingml/2006/main" prst="rect">
             <a:avLst/>
@@ -3608,7 +3608,7 @@
                   <a:srgbClr val="16202A"/>
                 </a:solidFill>
               </a:rPr>
-              <a:t>5. XSS: payload script tampil sebagai teks karena output escaping.</a:t>
+              <a:t>5. XSS dan brute force tidak diklaim pada target 80 ini.</a:t>
             </a:r>
           </a:p>
         </p:txBody>
@@ -3618,18 +3618,18 @@
           <p:cNvPr id="8" name="footer">
             <a:extLst xmlns:a="http://schemas.openxmlformats.org/drawingml/2006/main">
               <a:ext uri="{FF2B5EF4-FFF2-40B4-BE49-F238E27FC236}">
-                <a16:creationId xmlns:a16="http://schemas.microsoft.com/office/drawing/2014/main" id="{D3C72399-59D5-4C9D-8BF5-10D504A22533}"/>
-              </a:ext>
-            </a:extLst>
-          </p:cNvPr>
-          <p:cNvSpPr>
-            <a:spLocks xmlns:a="http://schemas.openxmlformats.org/drawingml/2006/main" noGrp="1"/>
-          </p:cNvSpPr>
-          <p:nvPr/>
-        </p:nvSpPr>
-        <p:spPr>
-          <a:xfrm xmlns:a="http://schemas.openxmlformats.org/drawingml/2006/main">
-            <a:off x="914400" y="5848350"/>
+                <a16:creationId xmlns:a16="http://schemas.microsoft.com/office/drawing/2014/main" id="{67750E0D-1165-4E6F-8F37-F083E4787394}"/>
+              </a:ext>
+            </a:extLst>
+          </p:cNvPr>
+          <p:cNvSpPr>
+            <a:spLocks xmlns:a="http://schemas.openxmlformats.org/drawingml/2006/main" noGrp="1"/>
+          </p:cNvSpPr>
+          <p:nvPr/>
+        </p:nvSpPr>
+        <p:spPr>
+          <a:xfrm xmlns:a="http://schemas.openxmlformats.org/drawingml/2006/main">
+            <a:off x="914400" y="6153150"/>
             <a:ext cx="16459200" cy="209550"/>
           </a:xfrm>
           <a:prstGeom xmlns:a="http://schemas.openxmlformats.org/drawingml/2006/main" prst="rect">
@@ -3661,7 +3661,7 @@
     </p:spTree>
     <p:extLst>
       <p:ext uri="{BB962C8B-B14F-4D97-AF65-F5344CB8AC3E}">
-        <p14:creationId xmlns:p14="http://schemas.microsoft.com/office/powerpoint/2010/main" val="1988610830"/>
+        <p14:creationId xmlns:p14="http://schemas.microsoft.com/office/powerpoint/2010/main" val="2146909731"/>
       </p:ext>
     </p:extLst>
   </p:cSld>
@@ -3685,7 +3685,7 @@
           <p:cNvPr id="1" name="slide-title">
             <a:extLst xmlns:a="http://schemas.openxmlformats.org/drawingml/2006/main">
               <a:ext uri="{FF2B5EF4-FFF2-40B4-BE49-F238E27FC236}">
-                <a16:creationId xmlns:a16="http://schemas.microsoft.com/office/drawing/2014/main" id="{C73CB792-FD69-4D7F-9830-F8EBDCC598AC}"/>
+                <a16:creationId xmlns:a16="http://schemas.microsoft.com/office/drawing/2014/main" id="{81D6262A-E2A5-41CF-B55F-B1DA52B5C414}"/>
               </a:ext>
             </a:extLst>
           </p:cNvPr>
@@ -3730,7 +3730,7 @@
           <p:cNvPr id="2" name="slide-subtitle">
             <a:extLst xmlns:a="http://schemas.openxmlformats.org/drawingml/2006/main">
               <a:ext uri="{FF2B5EF4-FFF2-40B4-BE49-F238E27FC236}">
-                <a16:creationId xmlns:a16="http://schemas.microsoft.com/office/drawing/2014/main" id="{2F9A5523-A9C5-4F35-8591-014E5E3B06E2}"/>
+                <a16:creationId xmlns:a16="http://schemas.microsoft.com/office/drawing/2014/main" id="{0060C2A5-F431-4E0B-8E95-E0D5C290BC1D}"/>
               </a:ext>
             </a:extLst>
           </p:cNvPr>
@@ -3775,7 +3775,7 @@
           <p:cNvPr id="3" name="bullet-1">
             <a:extLst xmlns:a="http://schemas.openxmlformats.org/drawingml/2006/main">
               <a:ext uri="{FF2B5EF4-FFF2-40B4-BE49-F238E27FC236}">
-                <a16:creationId xmlns:a16="http://schemas.microsoft.com/office/drawing/2014/main" id="{C331ACF5-0BA7-4D01-A064-D0DFB3434B34}"/>
+                <a16:creationId xmlns:a16="http://schemas.microsoft.com/office/drawing/2014/main" id="{BDE6CF48-7BE8-4372-A77D-1FD185962057}"/>
               </a:ext>
             </a:extLst>
           </p:cNvPr>
@@ -3820,7 +3820,7 @@
           <p:cNvPr id="4" name="bullet-2">
             <a:extLst xmlns:a="http://schemas.openxmlformats.org/drawingml/2006/main">
               <a:ext uri="{FF2B5EF4-FFF2-40B4-BE49-F238E27FC236}">
-                <a16:creationId xmlns:a16="http://schemas.microsoft.com/office/drawing/2014/main" id="{A4686B2F-433C-4519-9256-233598BCEE4B}"/>
+                <a16:creationId xmlns:a16="http://schemas.microsoft.com/office/drawing/2014/main" id="{3E05A8A8-CF64-4D8D-8AFC-EE02069B36F2}"/>
               </a:ext>
             </a:extLst>
           </p:cNvPr>
@@ -3865,7 +3865,7 @@
           <p:cNvPr id="5" name="bullet-3">
             <a:extLst xmlns:a="http://schemas.openxmlformats.org/drawingml/2006/main">
               <a:ext uri="{FF2B5EF4-FFF2-40B4-BE49-F238E27FC236}">
-                <a16:creationId xmlns:a16="http://schemas.microsoft.com/office/drawing/2014/main" id="{0014A1E6-61E6-4953-9AFA-4AA1A8999375}"/>
+                <a16:creationId xmlns:a16="http://schemas.microsoft.com/office/drawing/2014/main" id="{7B39BA17-6A10-446A-8DEE-BA3E3F60A83D}"/>
               </a:ext>
             </a:extLst>
           </p:cNvPr>
@@ -3910,7 +3910,7 @@
           <p:cNvPr id="6" name="bullet-4">
             <a:extLst xmlns:a="http://schemas.openxmlformats.org/drawingml/2006/main">
               <a:ext uri="{FF2B5EF4-FFF2-40B4-BE49-F238E27FC236}">
-                <a16:creationId xmlns:a16="http://schemas.microsoft.com/office/drawing/2014/main" id="{5DCF82E6-D624-48D4-8C78-31B9373FA026}"/>
+                <a16:creationId xmlns:a16="http://schemas.microsoft.com/office/drawing/2014/main" id="{832682B9-808D-418A-BE3F-D4E042FF887D}"/>
               </a:ext>
             </a:extLst>
           </p:cNvPr>
@@ -3955,7 +3955,7 @@
           <p:cNvPr id="7" name="bullet-5">
             <a:extLst xmlns:a="http://schemas.openxmlformats.org/drawingml/2006/main">
               <a:ext uri="{FF2B5EF4-FFF2-40B4-BE49-F238E27FC236}">
-                <a16:creationId xmlns:a16="http://schemas.microsoft.com/office/drawing/2014/main" id="{3679C7D1-5590-48D0-B4C7-25471B455D2C}"/>
+                <a16:creationId xmlns:a16="http://schemas.microsoft.com/office/drawing/2014/main" id="{A0CD24C3-08BF-4A74-B6FA-D1A3E7F64C29}"/>
               </a:ext>
             </a:extLst>
           </p:cNvPr>
@@ -4000,7 +4000,7 @@
           <p:cNvPr id="8" name="bullet-6">
             <a:extLst xmlns:a="http://schemas.openxmlformats.org/drawingml/2006/main">
               <a:ext uri="{FF2B5EF4-FFF2-40B4-BE49-F238E27FC236}">
-                <a16:creationId xmlns:a16="http://schemas.microsoft.com/office/drawing/2014/main" id="{2AC96488-0C07-46D9-AE6D-9203810E674B}"/>
+                <a16:creationId xmlns:a16="http://schemas.microsoft.com/office/drawing/2014/main" id="{31C98A3F-43B8-4E9C-A35E-357C3A85C4DB}"/>
               </a:ext>
             </a:extLst>
           </p:cNvPr>
@@ -4012,7 +4012,7 @@
         <p:spPr>
           <a:xfrm xmlns:a="http://schemas.openxmlformats.org/drawingml/2006/main">
             <a:off x="914400" y="6019800"/>
-            <a:ext cx="7543800" cy="647700"/>
+            <a:ext cx="6076950" cy="647700"/>
           </a:xfrm>
           <a:prstGeom xmlns:a="http://schemas.openxmlformats.org/drawingml/2006/main" prst="rect">
             <a:avLst/>
@@ -4035,7 +4035,7 @@
                   <a:srgbClr val="16202A"/>
                 </a:solidFill>
               </a:rPr>
-              <a:t>6. Coba payload SQL injection dan XSS, lalu tunjukkan keduanya gagal.</a:t>
+              <a:t>6. Coba payload SQL injection dan tunjukkan login gagal.</a:t>
             </a:r>
           </a:p>
         </p:txBody>
@@ -4045,7 +4045,7 @@
           <p:cNvPr id="9" name="footer">
             <a:extLst xmlns:a="http://schemas.openxmlformats.org/drawingml/2006/main">
               <a:ext uri="{FF2B5EF4-FFF2-40B4-BE49-F238E27FC236}">
-                <a16:creationId xmlns:a16="http://schemas.microsoft.com/office/drawing/2014/main" id="{EAEA7BD4-B037-4180-902F-665E830BA6F2}"/>
+                <a16:creationId xmlns:a16="http://schemas.microsoft.com/office/drawing/2014/main" id="{DF6406F2-76B3-4091-8206-D54E6D9B331C}"/>
               </a:ext>
             </a:extLst>
           </p:cNvPr>
@@ -4088,7 +4088,7 @@
     </p:spTree>
     <p:extLst>
       <p:ext uri="{BB962C8B-B14F-4D97-AF65-F5344CB8AC3E}">
-        <p14:creationId xmlns:p14="http://schemas.microsoft.com/office/powerpoint/2010/main" val="371857206"/>
+        <p14:creationId xmlns:p14="http://schemas.microsoft.com/office/powerpoint/2010/main" val="402795844"/>
       </p:ext>
     </p:extLst>
   </p:cSld>
@@ -4112,7 +4112,7 @@
           <p:cNvPr id="1" name="slide-title">
             <a:extLst xmlns:a="http://schemas.openxmlformats.org/drawingml/2006/main">
               <a:ext uri="{FF2B5EF4-FFF2-40B4-BE49-F238E27FC236}">
-                <a16:creationId xmlns:a16="http://schemas.microsoft.com/office/drawing/2014/main" id="{F6D23E5F-5D4F-4991-9691-923D0F59D120}"/>
+                <a16:creationId xmlns:a16="http://schemas.microsoft.com/office/drawing/2014/main" id="{40D7F484-36CB-4F62-9C5C-3E89CB093BD2}"/>
               </a:ext>
             </a:extLst>
           </p:cNvPr>
@@ -4157,7 +4157,7 @@
           <p:cNvPr id="2" name="slide-subtitle">
             <a:extLst xmlns:a="http://schemas.openxmlformats.org/drawingml/2006/main">
               <a:ext uri="{FF2B5EF4-FFF2-40B4-BE49-F238E27FC236}">
-                <a16:creationId xmlns:a16="http://schemas.microsoft.com/office/drawing/2014/main" id="{5A84B585-3055-4825-AF76-2069AE28EDA1}"/>
+                <a16:creationId xmlns:a16="http://schemas.microsoft.com/office/drawing/2014/main" id="{A3A61456-FF29-4F74-A19E-FD8923010713}"/>
               </a:ext>
             </a:extLst>
           </p:cNvPr>
@@ -4202,7 +4202,7 @@
           <p:cNvPr id="3" name="bullet-1">
             <a:extLst xmlns:a="http://schemas.openxmlformats.org/drawingml/2006/main">
               <a:ext uri="{FF2B5EF4-FFF2-40B4-BE49-F238E27FC236}">
-                <a16:creationId xmlns:a16="http://schemas.microsoft.com/office/drawing/2014/main" id="{C0044684-0682-449C-8D4E-7115F08D65C5}"/>
+                <a16:creationId xmlns:a16="http://schemas.microsoft.com/office/drawing/2014/main" id="{7044391D-0753-43BE-814C-5DE2BFD81CA9}"/>
               </a:ext>
             </a:extLst>
           </p:cNvPr>
@@ -4214,7 +4214,7 @@
         <p:spPr>
           <a:xfrm xmlns:a="http://schemas.openxmlformats.org/drawingml/2006/main">
             <a:off x="914400" y="2286000"/>
-            <a:ext cx="7505700" cy="647700"/>
+            <a:ext cx="6991350" cy="647700"/>
           </a:xfrm>
           <a:prstGeom xmlns:a="http://schemas.openxmlformats.org/drawingml/2006/main" prst="rect">
             <a:avLst/>
@@ -4237,7 +4237,7 @@
                   <a:srgbClr val="16202A"/>
                 </a:solidFill>
               </a:rPr>
-              <a:t>1. Kontrol target 80 aktif: HTTPS, hash+salt, input limit, SQLi, dan XSS.</a:t>
+              <a:t>1. Kontrol target 80 aktif: HTTPS, hash+salt, input limit, dan SQLi.</a:t>
             </a:r>
           </a:p>
         </p:txBody>
@@ -4247,7 +4247,7 @@
           <p:cNvPr id="4" name="bullet-2">
             <a:extLst xmlns:a="http://schemas.openxmlformats.org/drawingml/2006/main">
               <a:ext uri="{FF2B5EF4-FFF2-40B4-BE49-F238E27FC236}">
-                <a16:creationId xmlns:a16="http://schemas.microsoft.com/office/drawing/2014/main" id="{96E71CF4-B78C-4C56-A3DB-7CAB657F237B}"/>
+                <a16:creationId xmlns:a16="http://schemas.microsoft.com/office/drawing/2014/main" id="{82CE8D8C-4D93-4D5B-9995-B3C29044BC4B}"/>
               </a:ext>
             </a:extLst>
           </p:cNvPr>
@@ -4292,7 +4292,7 @@
           <p:cNvPr id="5" name="bullet-3">
             <a:extLst xmlns:a="http://schemas.openxmlformats.org/drawingml/2006/main">
               <a:ext uri="{FF2B5EF4-FFF2-40B4-BE49-F238E27FC236}">
-                <a16:creationId xmlns:a16="http://schemas.microsoft.com/office/drawing/2014/main" id="{E05E0848-C52E-40DD-B2C0-48B54BB13DC3}"/>
+                <a16:creationId xmlns:a16="http://schemas.microsoft.com/office/drawing/2014/main" id="{6CE3C206-68F2-418C-AF1D-FE133D483E15}"/>
               </a:ext>
             </a:extLst>
           </p:cNvPr>
@@ -4337,7 +4337,7 @@
           <p:cNvPr id="6" name="footer">
             <a:extLst xmlns:a="http://schemas.openxmlformats.org/drawingml/2006/main">
               <a:ext uri="{FF2B5EF4-FFF2-40B4-BE49-F238E27FC236}">
-                <a16:creationId xmlns:a16="http://schemas.microsoft.com/office/drawing/2014/main" id="{E7FC1B18-F15C-431F-9AC8-00555F7A56E8}"/>
+                <a16:creationId xmlns:a16="http://schemas.microsoft.com/office/drawing/2014/main" id="{9DC9EB62-A1E2-4160-9C79-125963EAB682}"/>
               </a:ext>
             </a:extLst>
           </p:cNvPr>
@@ -4380,7 +4380,7 @@
     </p:spTree>
     <p:extLst>
       <p:ext uri="{BB962C8B-B14F-4D97-AF65-F5344CB8AC3E}">
-        <p14:creationId xmlns:p14="http://schemas.microsoft.com/office/powerpoint/2010/main" val="1679866376"/>
+        <p14:creationId xmlns:p14="http://schemas.microsoft.com/office/powerpoint/2010/main" val="473220855"/>
       </p:ext>
     </p:extLst>
   </p:cSld>

</xml_diff>